<commit_message>
Unify section diagram backgrounds and enable full-size image links
</commit_message>
<xml_diff>
--- a/public/data/statement-diagrams/statement-diagrams.pptx
+++ b/public/data/statement-diagrams/statement-diagrams.pptx
@@ -2,16 +2,16 @@
 <file path=ppt/presentation.xml><?xml version="1.0" encoding="utf-8"?>
 <p:presentation xmlns:p="http://schemas.openxmlformats.org/presentationml/2006/main">
   <p:sldMasterIdLst>
-    <p:sldMasterId xmlns:r="http://schemas.openxmlformats.org/officeDocument/2006/relationships" id="2147483648" r:id="Rd4b2b9beadf84b27"/>
+    <p:sldMasterId xmlns:r="http://schemas.openxmlformats.org/officeDocument/2006/relationships" id="2147483648" r:id="Rbca3071d395b4c4d"/>
   </p:sldMasterIdLst>
   <p:notesMasterIdLst>
-    <p:notesMasterId xmlns:r="http://schemas.openxmlformats.org/officeDocument/2006/relationships" r:id="R100055c3c7454f04"/>
+    <p:notesMasterId xmlns:r="http://schemas.openxmlformats.org/officeDocument/2006/relationships" r:id="R73a5df89d3794562"/>
   </p:notesMasterIdLst>
   <p:sldIdLst>
-    <p:sldId xmlns:r="http://schemas.openxmlformats.org/officeDocument/2006/relationships" id="256" r:id="R1d4817399874443b"/>
-    <p:sldId xmlns:r="http://schemas.openxmlformats.org/officeDocument/2006/relationships" id="257" r:id="R72fc32d638444e21"/>
-    <p:sldId xmlns:r="http://schemas.openxmlformats.org/officeDocument/2006/relationships" id="258" r:id="R02eb172ac2d64fdc"/>
-    <p:sldId xmlns:r="http://schemas.openxmlformats.org/officeDocument/2006/relationships" id="259" r:id="R11d16865722c486d"/>
+    <p:sldId xmlns:r="http://schemas.openxmlformats.org/officeDocument/2006/relationships" id="256" r:id="R2f8304cd73054eff"/>
+    <p:sldId xmlns:r="http://schemas.openxmlformats.org/officeDocument/2006/relationships" id="257" r:id="Rc23c832bf7fd47fe"/>
+    <p:sldId xmlns:r="http://schemas.openxmlformats.org/officeDocument/2006/relationships" id="258" r:id="R889ee02f71a34c14"/>
+    <p:sldId xmlns:r="http://schemas.openxmlformats.org/officeDocument/2006/relationships" id="259" r:id="Ra2ee8e9ea0e34e78"/>
   </p:sldIdLst>
   <p:sldSz cx="17916525" cy="10344150"/>
   <p:notesSz cx="6858000" cy="9144000"/>
@@ -723,7 +723,7 @@
   </p:cSld>
   <p:clrMap bg1="lt1" tx1="dk1" bg2="lt2" tx2="dk2" accent1="accent1" accent2="accent2" accent3="accent3" accent4="accent4" accent5="accent5" accent6="accent6" hlink="hlink" folHlink="folHlink"/>
   <p:sldLayoutIdLst>
-    <p:sldLayoutId xmlns:r="http://schemas.openxmlformats.org/officeDocument/2006/relationships" id="2147483649" r:id="R933be37ade7843cc"/>
+    <p:sldLayoutId xmlns:r="http://schemas.openxmlformats.org/officeDocument/2006/relationships" id="2147483649" r:id="R92d4c3da0bf347eb"/>
   </p:sldLayoutIdLst>
   <p:txStyles>
     <p:titleStyle>
@@ -1274,7 +1274,7 @@
           <p:cNvPr id="85" name="Reliable AI Agents Under Human Control">
             <a:extLst xmlns:a="http://schemas.openxmlformats.org/drawingml/2006/main">
               <a:ext uri="{FF2B5EF4-FFF2-40B4-BE49-F238E27FC236}">
-                <a16:creationId xmlns:a16="http://schemas.microsoft.com/office/drawing/2014/main" id="{7C010C66-0389-4552-86F8-6E8EB31F5A01}"/>
+                <a16:creationId xmlns:a16="http://schemas.microsoft.com/office/drawing/2014/main" id="{F541E00E-93CE-4914-8F13-3D0317740F86}"/>
               </a:ext>
             </a:extLst>
           </p:cNvPr>
@@ -1331,7 +1331,7 @@
           <p:cNvPr id="2" name="A proposed research agenda for actions, system updates, and dele">
             <a:extLst xmlns:a="http://schemas.openxmlformats.org/drawingml/2006/main">
               <a:ext uri="{FF2B5EF4-FFF2-40B4-BE49-F238E27FC236}">
-                <a16:creationId xmlns:a16="http://schemas.microsoft.com/office/drawing/2014/main" id="{88977193-E159-452B-9C18-47F20C7E995E}"/>
+                <a16:creationId xmlns:a16="http://schemas.microsoft.com/office/drawing/2014/main" id="{A1BAC1C2-DEE4-4202-81E1-34424DF46F27}"/>
               </a:ext>
             </a:extLst>
           </p:cNvPr>
@@ -1388,7 +1388,7 @@
           <p:cNvPr id="3" name="Editable boundary">
             <a:extLst xmlns:a="http://schemas.openxmlformats.org/drawingml/2006/main">
               <a:ext uri="{FF2B5EF4-FFF2-40B4-BE49-F238E27FC236}">
-                <a16:creationId xmlns:a16="http://schemas.microsoft.com/office/drawing/2014/main" id="{BECBB875-4A6B-476C-B305-21AE4845B7DE}"/>
+                <a16:creationId xmlns:a16="http://schemas.microsoft.com/office/drawing/2014/main" id="{2D6344F7-59C1-4A70-8A54-77B0866BC768}"/>
               </a:ext>
             </a:extLst>
           </p:cNvPr>
@@ -1421,7 +1421,7 @@
           <p:cNvPr id="4" name="Editable boundary">
             <a:extLst xmlns:a="http://schemas.openxmlformats.org/drawingml/2006/main">
               <a:ext uri="{FF2B5EF4-FFF2-40B4-BE49-F238E27FC236}">
-                <a16:creationId xmlns:a16="http://schemas.microsoft.com/office/drawing/2014/main" id="{D4E40C57-0068-45BC-B889-0584A1AD6E7D}"/>
+                <a16:creationId xmlns:a16="http://schemas.microsoft.com/office/drawing/2014/main" id="{6129F0E2-132A-45F4-B4A1-7D56C5B0521B}"/>
               </a:ext>
             </a:extLst>
           </p:cNvPr>
@@ -1454,7 +1454,7 @@
           <p:cNvPr id="5" name="Human–Agent Interaction">
             <a:extLst xmlns:a="http://schemas.openxmlformats.org/drawingml/2006/main">
               <a:ext uri="{FF2B5EF4-FFF2-40B4-BE49-F238E27FC236}">
-                <a16:creationId xmlns:a16="http://schemas.microsoft.com/office/drawing/2014/main" id="{18A7153E-49F3-4CB2-BB8C-1DB7864EA7ED}"/>
+                <a16:creationId xmlns:a16="http://schemas.microsoft.com/office/drawing/2014/main" id="{9930446E-F202-4203-93AA-7C6583CC278B}"/>
               </a:ext>
             </a:extLst>
           </p:cNvPr>
@@ -1511,7 +1511,7 @@
           <p:cNvPr id="6" name="Agent–Agent Collaboration">
             <a:extLst xmlns:a="http://schemas.openxmlformats.org/drawingml/2006/main">
               <a:ext uri="{FF2B5EF4-FFF2-40B4-BE49-F238E27FC236}">
-                <a16:creationId xmlns:a16="http://schemas.microsoft.com/office/drawing/2014/main" id="{90BE166A-F805-4066-8651-6F51122A5C74}"/>
+                <a16:creationId xmlns:a16="http://schemas.microsoft.com/office/drawing/2014/main" id="{C1826997-3102-459E-B4FC-AFDDAA9E4FF9}"/>
               </a:ext>
             </a:extLst>
           </p:cNvPr>
@@ -1572,7 +1572,7 @@
           <p:nvPr/>
         </p:nvPicPr>
         <p:blipFill>
-          <a:blip xmlns:r="http://schemas.openxmlformats.org/officeDocument/2006/relationships" xmlns:a="http://schemas.openxmlformats.org/drawingml/2006/main" r:embed="Rb8ea008a9b6149ab"/>
+          <a:blip xmlns:r="http://schemas.openxmlformats.org/officeDocument/2006/relationships" xmlns:a="http://schemas.openxmlformats.org/drawingml/2006/main" r:embed="Rd37ac12176e94266"/>
           <a:stretch xmlns:a="http://schemas.openxmlformats.org/drawingml/2006/main"/>
         </p:blipFill>
         <p:spPr>
@@ -1594,7 +1594,7 @@
           <p:nvPr/>
         </p:nvPicPr>
         <p:blipFill>
-          <a:blip xmlns:r="http://schemas.openxmlformats.org/officeDocument/2006/relationships" xmlns:a="http://schemas.openxmlformats.org/drawingml/2006/main" r:embed="Rb745a1813fdf4151"/>
+          <a:blip xmlns:r="http://schemas.openxmlformats.org/officeDocument/2006/relationships" xmlns:a="http://schemas.openxmlformats.org/drawingml/2006/main" r:embed="R20f5c4631ac24f88"/>
           <a:stretch xmlns:a="http://schemas.openxmlformats.org/drawingml/2006/main"/>
         </p:blipFill>
         <p:spPr>
@@ -1616,7 +1616,7 @@
           <p:nvPr/>
         </p:nvPicPr>
         <p:blipFill>
-          <a:blip xmlns:r="http://schemas.openxmlformats.org/officeDocument/2006/relationships" xmlns:a="http://schemas.openxmlformats.org/drawingml/2006/main" r:embed="R0b3bd1e933e1432a"/>
+          <a:blip xmlns:r="http://schemas.openxmlformats.org/officeDocument/2006/relationships" xmlns:a="http://schemas.openxmlformats.org/drawingml/2006/main" r:embed="R753c113c9fbe4335"/>
           <a:stretch xmlns:a="http://schemas.openxmlformats.org/drawingml/2006/main"/>
         </p:blipFill>
         <p:spPr>
@@ -1638,7 +1638,7 @@
           <p:nvPr/>
         </p:nvPicPr>
         <p:blipFill>
-          <a:blip xmlns:r="http://schemas.openxmlformats.org/officeDocument/2006/relationships" xmlns:a="http://schemas.openxmlformats.org/drawingml/2006/main" r:embed="R7470f3fbb51342ed"/>
+          <a:blip xmlns:r="http://schemas.openxmlformats.org/officeDocument/2006/relationships" xmlns:a="http://schemas.openxmlformats.org/drawingml/2006/main" r:embed="R6cdd35ac4b41436b"/>
           <a:stretch xmlns:a="http://schemas.openxmlformats.org/drawingml/2006/main"/>
         </p:blipFill>
         <p:spPr>
@@ -1656,7 +1656,7 @@
           <p:cNvPr id="11" name="Human">
             <a:extLst xmlns:a="http://schemas.openxmlformats.org/drawingml/2006/main">
               <a:ext uri="{FF2B5EF4-FFF2-40B4-BE49-F238E27FC236}">
-                <a16:creationId xmlns:a16="http://schemas.microsoft.com/office/drawing/2014/main" id="{DE6A4282-E9AA-4AA2-9BE6-DF26A4C9A54B}"/>
+                <a16:creationId xmlns:a16="http://schemas.microsoft.com/office/drawing/2014/main" id="{02415D4D-44F3-41D4-84F2-D03A5C8CC463}"/>
               </a:ext>
             </a:extLst>
           </p:cNvPr>
@@ -1713,7 +1713,7 @@
           <p:cNvPr id="12" name="AI agent">
             <a:extLst xmlns:a="http://schemas.openxmlformats.org/drawingml/2006/main">
               <a:ext uri="{FF2B5EF4-FFF2-40B4-BE49-F238E27FC236}">
-                <a16:creationId xmlns:a16="http://schemas.microsoft.com/office/drawing/2014/main" id="{973CC4AD-B973-4ACE-B7FD-97275B2F4CF9}"/>
+                <a16:creationId xmlns:a16="http://schemas.microsoft.com/office/drawing/2014/main" id="{898ED6D7-B892-4713-85FF-C08CEF2FDEAF}"/>
               </a:ext>
             </a:extLst>
           </p:cNvPr>
@@ -1770,7 +1770,7 @@
           <p:cNvPr id="13" name="Agent A">
             <a:extLst xmlns:a="http://schemas.openxmlformats.org/drawingml/2006/main">
               <a:ext uri="{FF2B5EF4-FFF2-40B4-BE49-F238E27FC236}">
-                <a16:creationId xmlns:a16="http://schemas.microsoft.com/office/drawing/2014/main" id="{3A90201A-E50C-40DA-821D-BA3D61DE738B}"/>
+                <a16:creationId xmlns:a16="http://schemas.microsoft.com/office/drawing/2014/main" id="{65725406-44A8-496F-9BC6-7183CE12AE79}"/>
               </a:ext>
             </a:extLst>
           </p:cNvPr>
@@ -1827,7 +1827,7 @@
           <p:cNvPr id="14" name="Agent B">
             <a:extLst xmlns:a="http://schemas.openxmlformats.org/drawingml/2006/main">
               <a:ext uri="{FF2B5EF4-FFF2-40B4-BE49-F238E27FC236}">
-                <a16:creationId xmlns:a16="http://schemas.microsoft.com/office/drawing/2014/main" id="{2ED8D931-C5AE-487D-AF51-5C8F9C289FEF}"/>
+                <a16:creationId xmlns:a16="http://schemas.microsoft.com/office/drawing/2014/main" id="{685B5718-358B-4E00-A343-0DB1860F4E4E}"/>
               </a:ext>
             </a:extLst>
           </p:cNvPr>
@@ -1884,7 +1884,7 @@
           <p:cNvPr id="15" name="Task + authorized scope">
             <a:extLst xmlns:a="http://schemas.openxmlformats.org/drawingml/2006/main">
               <a:ext uri="{FF2B5EF4-FFF2-40B4-BE49-F238E27FC236}">
-                <a16:creationId xmlns:a16="http://schemas.microsoft.com/office/drawing/2014/main" id="{87A77615-578D-4145-BBCA-BF06490FBE46}"/>
+                <a16:creationId xmlns:a16="http://schemas.microsoft.com/office/drawing/2014/main" id="{EA448735-003B-48D0-B036-C4F2BFE3D25F}"/>
               </a:ext>
             </a:extLst>
           </p:cNvPr>
@@ -1941,7 +1941,7 @@
           <p:cNvPr id="16" name="Editable flow path">
             <a:extLst xmlns:a="http://schemas.openxmlformats.org/drawingml/2006/main">
               <a:ext uri="{FF2B5EF4-FFF2-40B4-BE49-F238E27FC236}">
-                <a16:creationId xmlns:a16="http://schemas.microsoft.com/office/drawing/2014/main" id="{6B5725E4-F2F0-407B-A2DB-4322846E72FE}"/>
+                <a16:creationId xmlns:a16="http://schemas.microsoft.com/office/drawing/2014/main" id="{8544126D-417E-4D37-81EF-37CBBE629317}"/>
               </a:ext>
             </a:extLst>
           </p:cNvPr>
@@ -1981,7 +1981,7 @@
           <p:cNvPr id="17" name="Editable arrowhead">
             <a:extLst xmlns:a="http://schemas.openxmlformats.org/drawingml/2006/main">
               <a:ext uri="{FF2B5EF4-FFF2-40B4-BE49-F238E27FC236}">
-                <a16:creationId xmlns:a16="http://schemas.microsoft.com/office/drawing/2014/main" id="{BB510973-5DC8-4E12-A24B-CBB627BED026}"/>
+                <a16:creationId xmlns:a16="http://schemas.microsoft.com/office/drawing/2014/main" id="{F38B4851-2B91-47BB-99C1-B7D96556539B}"/>
               </a:ext>
             </a:extLst>
           </p:cNvPr>
@@ -2024,7 +2024,7 @@
           <p:cNvPr id="18" name="Editable flow path">
             <a:extLst xmlns:a="http://schemas.openxmlformats.org/drawingml/2006/main">
               <a:ext uri="{FF2B5EF4-FFF2-40B4-BE49-F238E27FC236}">
-                <a16:creationId xmlns:a16="http://schemas.microsoft.com/office/drawing/2014/main" id="{A8F464A7-8532-4F04-9B10-215939E4A747}"/>
+                <a16:creationId xmlns:a16="http://schemas.microsoft.com/office/drawing/2014/main" id="{30EF0F97-AAE4-408A-B17D-642EC36007A7}"/>
               </a:ext>
             </a:extLst>
           </p:cNvPr>
@@ -2064,7 +2064,7 @@
           <p:cNvPr id="19" name="Editable arrowhead">
             <a:extLst xmlns:a="http://schemas.openxmlformats.org/drawingml/2006/main">
               <a:ext uri="{FF2B5EF4-FFF2-40B4-BE49-F238E27FC236}">
-                <a16:creationId xmlns:a16="http://schemas.microsoft.com/office/drawing/2014/main" id="{B9A78B6C-8126-4257-B71B-2502D6798ADF}"/>
+                <a16:creationId xmlns:a16="http://schemas.microsoft.com/office/drawing/2014/main" id="{93C6DD90-B069-4C05-8D0B-99AD736F1D12}"/>
               </a:ext>
             </a:extLst>
           </p:cNvPr>
@@ -2107,7 +2107,7 @@
           <p:cNvPr id="20" name="Action proposal + evidence">
             <a:extLst xmlns:a="http://schemas.openxmlformats.org/drawingml/2006/main">
               <a:ext uri="{FF2B5EF4-FFF2-40B4-BE49-F238E27FC236}">
-                <a16:creationId xmlns:a16="http://schemas.microsoft.com/office/drawing/2014/main" id="{EAF05EEF-0B97-4592-94F5-4866F02F3216}"/>
+                <a16:creationId xmlns:a16="http://schemas.microsoft.com/office/drawing/2014/main" id="{226AA0A1-729D-4415-943E-A9C6FA583A88}"/>
               </a:ext>
             </a:extLst>
           </p:cNvPr>
@@ -2164,7 +2164,7 @@
           <p:cNvPr id="21" name="Subtask + data + constraints">
             <a:extLst xmlns:a="http://schemas.openxmlformats.org/drawingml/2006/main">
               <a:ext uri="{FF2B5EF4-FFF2-40B4-BE49-F238E27FC236}">
-                <a16:creationId xmlns:a16="http://schemas.microsoft.com/office/drawing/2014/main" id="{B9CDBF56-D582-44E0-ADC6-8ED92D010944}"/>
+                <a16:creationId xmlns:a16="http://schemas.microsoft.com/office/drawing/2014/main" id="{0137091F-7FE4-4732-A20E-8EB90D7D3F4F}"/>
               </a:ext>
             </a:extLst>
           </p:cNvPr>
@@ -2221,7 +2221,7 @@
           <p:cNvPr id="22" name="Editable flow path">
             <a:extLst xmlns:a="http://schemas.openxmlformats.org/drawingml/2006/main">
               <a:ext uri="{FF2B5EF4-FFF2-40B4-BE49-F238E27FC236}">
-                <a16:creationId xmlns:a16="http://schemas.microsoft.com/office/drawing/2014/main" id="{CCD55726-6EC5-43E2-B06E-0076A8A989F3}"/>
+                <a16:creationId xmlns:a16="http://schemas.microsoft.com/office/drawing/2014/main" id="{57AFC192-DE1A-4000-BF05-B0C0918B761C}"/>
               </a:ext>
             </a:extLst>
           </p:cNvPr>
@@ -2261,7 +2261,7 @@
           <p:cNvPr id="23" name="Editable arrowhead">
             <a:extLst xmlns:a="http://schemas.openxmlformats.org/drawingml/2006/main">
               <a:ext uri="{FF2B5EF4-FFF2-40B4-BE49-F238E27FC236}">
-                <a16:creationId xmlns:a16="http://schemas.microsoft.com/office/drawing/2014/main" id="{03700B64-3315-4DB3-9556-E8DE126A6F27}"/>
+                <a16:creationId xmlns:a16="http://schemas.microsoft.com/office/drawing/2014/main" id="{1C495C38-7C7B-4B6B-BE05-BF2A0E00FF5B}"/>
               </a:ext>
             </a:extLst>
           </p:cNvPr>
@@ -2304,7 +2304,7 @@
           <p:cNvPr id="24" name="Editable flow path">
             <a:extLst xmlns:a="http://schemas.openxmlformats.org/drawingml/2006/main">
               <a:ext uri="{FF2B5EF4-FFF2-40B4-BE49-F238E27FC236}">
-                <a16:creationId xmlns:a16="http://schemas.microsoft.com/office/drawing/2014/main" id="{64F93547-D2A6-4242-B6DC-B42B4FD8A177}"/>
+                <a16:creationId xmlns:a16="http://schemas.microsoft.com/office/drawing/2014/main" id="{52C54361-7765-4CA0-BBEB-6B3E0A4AC5BE}"/>
               </a:ext>
             </a:extLst>
           </p:cNvPr>
@@ -2344,7 +2344,7 @@
           <p:cNvPr id="25" name="Editable arrowhead">
             <a:extLst xmlns:a="http://schemas.openxmlformats.org/drawingml/2006/main">
               <a:ext uri="{FF2B5EF4-FFF2-40B4-BE49-F238E27FC236}">
-                <a16:creationId xmlns:a16="http://schemas.microsoft.com/office/drawing/2014/main" id="{3BFCD736-E4BF-439A-B6F0-6D5F3E275E93}"/>
+                <a16:creationId xmlns:a16="http://schemas.microsoft.com/office/drawing/2014/main" id="{F75577C5-59E0-49F0-9CDF-E9D2B5AE0888}"/>
               </a:ext>
             </a:extLst>
           </p:cNvPr>
@@ -2387,7 +2387,7 @@
           <p:cNvPr id="26" name="Proposal + evidence + status">
             <a:extLst xmlns:a="http://schemas.openxmlformats.org/drawingml/2006/main">
               <a:ext uri="{FF2B5EF4-FFF2-40B4-BE49-F238E27FC236}">
-                <a16:creationId xmlns:a16="http://schemas.microsoft.com/office/drawing/2014/main" id="{6A75542F-A56B-4FCD-BFE6-A18A944F922F}"/>
+                <a16:creationId xmlns:a16="http://schemas.microsoft.com/office/drawing/2014/main" id="{6E38C956-F935-4274-9B89-99F07C4B12A2}"/>
               </a:ext>
             </a:extLst>
           </p:cNvPr>
@@ -2444,7 +2444,7 @@
           <p:cNvPr id="27" name="Editable boundary">
             <a:extLst xmlns:a="http://schemas.openxmlformats.org/drawingml/2006/main">
               <a:ext uri="{FF2B5EF4-FFF2-40B4-BE49-F238E27FC236}">
-                <a16:creationId xmlns:a16="http://schemas.microsoft.com/office/drawing/2014/main" id="{A0DCF679-723E-4D91-BB16-AB51DDE60CBE}"/>
+                <a16:creationId xmlns:a16="http://schemas.microsoft.com/office/drawing/2014/main" id="{CE65DF32-913D-48D6-A246-D62EBA60F7A0}"/>
               </a:ext>
             </a:extLst>
           </p:cNvPr>
@@ -2477,7 +2477,7 @@
           <p:cNvPr id="28" name="Editable boundary">
             <a:extLst xmlns:a="http://schemas.openxmlformats.org/drawingml/2006/main">
               <a:ext uri="{FF2B5EF4-FFF2-40B4-BE49-F238E27FC236}">
-                <a16:creationId xmlns:a16="http://schemas.microsoft.com/office/drawing/2014/main" id="{18B46462-3920-4707-BABD-29DFF619F201}"/>
+                <a16:creationId xmlns:a16="http://schemas.microsoft.com/office/drawing/2014/main" id="{7DB26436-F0DD-4141-B6BC-F16FA3FEA8F7}"/>
               </a:ext>
             </a:extLst>
           </p:cNvPr>
@@ -2510,7 +2510,7 @@
           <p:cNvPr id="29" name="I">
             <a:extLst xmlns:a="http://schemas.openxmlformats.org/drawingml/2006/main">
               <a:ext uri="{FF2B5EF4-FFF2-40B4-BE49-F238E27FC236}">
-                <a16:creationId xmlns:a16="http://schemas.microsoft.com/office/drawing/2014/main" id="{027FECE3-72E4-4F71-B3B8-F9BDD0B5E541}"/>
+                <a16:creationId xmlns:a16="http://schemas.microsoft.com/office/drawing/2014/main" id="{3BFBB24B-43C0-47DB-A0E6-6885A0BFEA8B}"/>
               </a:ext>
             </a:extLst>
           </p:cNvPr>
@@ -2567,7 +2567,7 @@
           <p:cNvPr id="30" name="Check proposed actions against approved requirements">
             <a:extLst xmlns:a="http://schemas.openxmlformats.org/drawingml/2006/main">
               <a:ext uri="{FF2B5EF4-FFF2-40B4-BE49-F238E27FC236}">
-                <a16:creationId xmlns:a16="http://schemas.microsoft.com/office/drawing/2014/main" id="{D0D54E28-F5A4-4E51-8ADF-7B0D8F89E7A2}"/>
+                <a16:creationId xmlns:a16="http://schemas.microsoft.com/office/drawing/2014/main" id="{A7E05D7E-6144-4E9E-B30D-85FC9D7AB326}"/>
               </a:ext>
             </a:extLst>
           </p:cNvPr>
@@ -2624,7 +2624,7 @@
           <p:cNvPr id="31" name="Editable boundary">
             <a:extLst xmlns:a="http://schemas.openxmlformats.org/drawingml/2006/main">
               <a:ext uri="{FF2B5EF4-FFF2-40B4-BE49-F238E27FC236}">
-                <a16:creationId xmlns:a16="http://schemas.microsoft.com/office/drawing/2014/main" id="{CCA70040-507B-44AB-B9CE-1E33DF005E51}"/>
+                <a16:creationId xmlns:a16="http://schemas.microsoft.com/office/drawing/2014/main" id="{E73FD651-E6D9-47B1-859D-104D2ADB98EB}"/>
               </a:ext>
             </a:extLst>
           </p:cNvPr>
@@ -2657,7 +2657,7 @@
           <p:cNvPr id="32" name="Editable boundary">
             <a:extLst xmlns:a="http://schemas.openxmlformats.org/drawingml/2006/main">
               <a:ext uri="{FF2B5EF4-FFF2-40B4-BE49-F238E27FC236}">
-                <a16:creationId xmlns:a16="http://schemas.microsoft.com/office/drawing/2014/main" id="{90C5A85F-38F5-467A-BB4E-0368A7FB16B5}"/>
+                <a16:creationId xmlns:a16="http://schemas.microsoft.com/office/drawing/2014/main" id="{B1043525-115F-4031-A7BA-CDFBCA87D80C}"/>
               </a:ext>
             </a:extLst>
           </p:cNvPr>
@@ -2690,7 +2690,7 @@
           <p:cNvPr id="33" name="II">
             <a:extLst xmlns:a="http://schemas.openxmlformats.org/drawingml/2006/main">
               <a:ext uri="{FF2B5EF4-FFF2-40B4-BE49-F238E27FC236}">
-                <a16:creationId xmlns:a16="http://schemas.microsoft.com/office/drawing/2014/main" id="{BA1EAFF8-2D34-4C13-A288-6AADF529BAEC}"/>
+                <a16:creationId xmlns:a16="http://schemas.microsoft.com/office/drawing/2014/main" id="{BF7A318D-DD8E-4637-96CC-106F956818AA}"/>
               </a:ext>
             </a:extLst>
           </p:cNvPr>
@@ -2747,7 +2747,7 @@
           <p:cNvPr id="34" name="Evaluate security and reliability after system updates">
             <a:extLst xmlns:a="http://schemas.openxmlformats.org/drawingml/2006/main">
               <a:ext uri="{FF2B5EF4-FFF2-40B4-BE49-F238E27FC236}">
-                <a16:creationId xmlns:a16="http://schemas.microsoft.com/office/drawing/2014/main" id="{E1E9FF91-C9BF-4CE2-89FC-9043D32C4003}"/>
+                <a16:creationId xmlns:a16="http://schemas.microsoft.com/office/drawing/2014/main" id="{BC6FAEA7-5E05-418A-8171-84F651EE1839}"/>
               </a:ext>
             </a:extLst>
           </p:cNvPr>
@@ -2804,7 +2804,7 @@
           <p:cNvPr id="35" name="Editable boundary">
             <a:extLst xmlns:a="http://schemas.openxmlformats.org/drawingml/2006/main">
               <a:ext uri="{FF2B5EF4-FFF2-40B4-BE49-F238E27FC236}">
-                <a16:creationId xmlns:a16="http://schemas.microsoft.com/office/drawing/2014/main" id="{2633C748-023B-4643-934F-FF5F96F61C79}"/>
+                <a16:creationId xmlns:a16="http://schemas.microsoft.com/office/drawing/2014/main" id="{2B2BED98-B3B5-4832-98B6-DCEDFB6B11D9}"/>
               </a:ext>
             </a:extLst>
           </p:cNvPr>
@@ -2837,7 +2837,7 @@
           <p:cNvPr id="36" name="Editable boundary">
             <a:extLst xmlns:a="http://schemas.openxmlformats.org/drawingml/2006/main">
               <a:ext uri="{FF2B5EF4-FFF2-40B4-BE49-F238E27FC236}">
-                <a16:creationId xmlns:a16="http://schemas.microsoft.com/office/drawing/2014/main" id="{113B4FB1-05AA-4BA6-B18D-231155619217}"/>
+                <a16:creationId xmlns:a16="http://schemas.microsoft.com/office/drawing/2014/main" id="{3F1376D3-7BCC-47CA-AA24-3D67A4288462}"/>
               </a:ext>
             </a:extLst>
           </p:cNvPr>
@@ -2870,7 +2870,7 @@
           <p:cNvPr id="37" name="III">
             <a:extLst xmlns:a="http://schemas.openxmlformats.org/drawingml/2006/main">
               <a:ext uri="{FF2B5EF4-FFF2-40B4-BE49-F238E27FC236}">
-                <a16:creationId xmlns:a16="http://schemas.microsoft.com/office/drawing/2014/main" id="{DC0677CF-EEA6-402B-8CE1-B63556D7BA5B}"/>
+                <a16:creationId xmlns:a16="http://schemas.microsoft.com/office/drawing/2014/main" id="{90F798E1-1114-44EB-A8E6-58AE0D6C6F6D}"/>
               </a:ext>
             </a:extLst>
           </p:cNvPr>
@@ -2927,7 +2927,7 @@
           <p:cNvPr id="38" name="Enforce current scope and permissions across task steps">
             <a:extLst xmlns:a="http://schemas.openxmlformats.org/drawingml/2006/main">
               <a:ext uri="{FF2B5EF4-FFF2-40B4-BE49-F238E27FC236}">
-                <a16:creationId xmlns:a16="http://schemas.microsoft.com/office/drawing/2014/main" id="{1F404A05-069C-4F15-A18B-D9D51AEC5D3A}"/>
+                <a16:creationId xmlns:a16="http://schemas.microsoft.com/office/drawing/2014/main" id="{7A4E23A0-BBD9-4428-9502-0DE2358F9FD2}"/>
               </a:ext>
             </a:extLst>
           </p:cNvPr>
@@ -2984,7 +2984,7 @@
           <p:cNvPr id="39" name="Editable boundary">
             <a:extLst xmlns:a="http://schemas.openxmlformats.org/drawingml/2006/main">
               <a:ext uri="{FF2B5EF4-FFF2-40B4-BE49-F238E27FC236}">
-                <a16:creationId xmlns:a16="http://schemas.microsoft.com/office/drawing/2014/main" id="{B4EF50C6-1F5E-413F-8DFD-86633972C5A5}"/>
+                <a16:creationId xmlns:a16="http://schemas.microsoft.com/office/drawing/2014/main" id="{AAA77107-E219-475D-B539-714B38E45466}"/>
               </a:ext>
             </a:extLst>
           </p:cNvPr>
@@ -3017,7 +3017,7 @@
           <p:cNvPr id="40" name="Editable boundary">
             <a:extLst xmlns:a="http://schemas.openxmlformats.org/drawingml/2006/main">
               <a:ext uri="{FF2B5EF4-FFF2-40B4-BE49-F238E27FC236}">
-                <a16:creationId xmlns:a16="http://schemas.microsoft.com/office/drawing/2014/main" id="{1A5AA7F2-4BE1-4093-8207-87168185E98E}"/>
+                <a16:creationId xmlns:a16="http://schemas.microsoft.com/office/drawing/2014/main" id="{F4B8438E-20CE-4EDD-B1B6-EF8FEE280DE1}"/>
               </a:ext>
             </a:extLst>
           </p:cNvPr>
@@ -3050,7 +3050,7 @@
           <p:cNvPr id="41" name="I">
             <a:extLst xmlns:a="http://schemas.openxmlformats.org/drawingml/2006/main">
               <a:ext uri="{FF2B5EF4-FFF2-40B4-BE49-F238E27FC236}">
-                <a16:creationId xmlns:a16="http://schemas.microsoft.com/office/drawing/2014/main" id="{390393A3-B392-4951-BE84-125B4494B53F}"/>
+                <a16:creationId xmlns:a16="http://schemas.microsoft.com/office/drawing/2014/main" id="{00925EB3-3FF0-4B62-BCC1-84F7E195130B}"/>
               </a:ext>
             </a:extLst>
           </p:cNvPr>
@@ -3107,7 +3107,7 @@
           <p:cNvPr id="42" name="Check proposed actions using independent evidence">
             <a:extLst xmlns:a="http://schemas.openxmlformats.org/drawingml/2006/main">
               <a:ext uri="{FF2B5EF4-FFF2-40B4-BE49-F238E27FC236}">
-                <a16:creationId xmlns:a16="http://schemas.microsoft.com/office/drawing/2014/main" id="{1D1FBD57-27CD-4556-B448-26BCFE1E0C69}"/>
+                <a16:creationId xmlns:a16="http://schemas.microsoft.com/office/drawing/2014/main" id="{351A301C-6C69-4369-B89A-7CF981B8B3E3}"/>
               </a:ext>
             </a:extLst>
           </p:cNvPr>
@@ -3164,7 +3164,7 @@
           <p:cNvPr id="43" name="Editable boundary">
             <a:extLst xmlns:a="http://schemas.openxmlformats.org/drawingml/2006/main">
               <a:ext uri="{FF2B5EF4-FFF2-40B4-BE49-F238E27FC236}">
-                <a16:creationId xmlns:a16="http://schemas.microsoft.com/office/drawing/2014/main" id="{DCE37E91-8EE3-4F72-B53F-4527EF0D10CF}"/>
+                <a16:creationId xmlns:a16="http://schemas.microsoft.com/office/drawing/2014/main" id="{6EF7A6B3-0287-4ABB-882D-8F78008EB90F}"/>
               </a:ext>
             </a:extLst>
           </p:cNvPr>
@@ -3197,7 +3197,7 @@
           <p:cNvPr id="44" name="Editable boundary">
             <a:extLst xmlns:a="http://schemas.openxmlformats.org/drawingml/2006/main">
               <a:ext uri="{FF2B5EF4-FFF2-40B4-BE49-F238E27FC236}">
-                <a16:creationId xmlns:a16="http://schemas.microsoft.com/office/drawing/2014/main" id="{7C32FF9F-8498-4FA1-BDA7-C183BA1EFF0A}"/>
+                <a16:creationId xmlns:a16="http://schemas.microsoft.com/office/drawing/2014/main" id="{9E8E6863-0C67-4DEB-A07A-D122DD7FD5FD}"/>
               </a:ext>
             </a:extLst>
           </p:cNvPr>
@@ -3230,7 +3230,7 @@
           <p:cNvPr id="45" name="II">
             <a:extLst xmlns:a="http://schemas.openxmlformats.org/drawingml/2006/main">
               <a:ext uri="{FF2B5EF4-FFF2-40B4-BE49-F238E27FC236}">
-                <a16:creationId xmlns:a16="http://schemas.microsoft.com/office/drawing/2014/main" id="{647C9E02-5311-43D1-A8F8-DEC310E5CCEA}"/>
+                <a16:creationId xmlns:a16="http://schemas.microsoft.com/office/drawing/2014/main" id="{99FA2E15-9232-4ECE-9F4D-8BF9F49B03CE}"/>
               </a:ext>
             </a:extLst>
           </p:cNvPr>
@@ -3287,7 +3287,7 @@
           <p:cNvPr id="46" name="Assess retention after either agent or harness updates">
             <a:extLst xmlns:a="http://schemas.openxmlformats.org/drawingml/2006/main">
               <a:ext uri="{FF2B5EF4-FFF2-40B4-BE49-F238E27FC236}">
-                <a16:creationId xmlns:a16="http://schemas.microsoft.com/office/drawing/2014/main" id="{2A9494CF-2980-4504-99D2-86533E132A27}"/>
+                <a16:creationId xmlns:a16="http://schemas.microsoft.com/office/drawing/2014/main" id="{20B31E2C-2D7C-4239-B2A3-DADF56428AAA}"/>
               </a:ext>
             </a:extLst>
           </p:cNvPr>
@@ -3344,7 +3344,7 @@
           <p:cNvPr id="47" name="Editable boundary">
             <a:extLst xmlns:a="http://schemas.openxmlformats.org/drawingml/2006/main">
               <a:ext uri="{FF2B5EF4-FFF2-40B4-BE49-F238E27FC236}">
-                <a16:creationId xmlns:a16="http://schemas.microsoft.com/office/drawing/2014/main" id="{BD7A5B08-D47A-4C76-B066-AAAD3165836E}"/>
+                <a16:creationId xmlns:a16="http://schemas.microsoft.com/office/drawing/2014/main" id="{6269FAEC-4F1D-43C6-9FEE-D9BBFBF50F27}"/>
               </a:ext>
             </a:extLst>
           </p:cNvPr>
@@ -3377,7 +3377,7 @@
           <p:cNvPr id="48" name="Editable boundary">
             <a:extLst xmlns:a="http://schemas.openxmlformats.org/drawingml/2006/main">
               <a:ext uri="{FF2B5EF4-FFF2-40B4-BE49-F238E27FC236}">
-                <a16:creationId xmlns:a16="http://schemas.microsoft.com/office/drawing/2014/main" id="{2A58E07A-CECE-4CFC-9A8A-3767D603F6EF}"/>
+                <a16:creationId xmlns:a16="http://schemas.microsoft.com/office/drawing/2014/main" id="{E5592A3C-C049-4A54-99A0-F7754ECDE5D1}"/>
               </a:ext>
             </a:extLst>
           </p:cNvPr>
@@ -3410,7 +3410,7 @@
           <p:cNvPr id="49" name="III">
             <a:extLst xmlns:a="http://schemas.openxmlformats.org/drawingml/2006/main">
               <a:ext uri="{FF2B5EF4-FFF2-40B4-BE49-F238E27FC236}">
-                <a16:creationId xmlns:a16="http://schemas.microsoft.com/office/drawing/2014/main" id="{477E184F-FE95-4F98-B4E3-3D30EA54304F}"/>
+                <a16:creationId xmlns:a16="http://schemas.microsoft.com/office/drawing/2014/main" id="{B66247DD-F37F-4819-94D4-AC549992DB90}"/>
               </a:ext>
             </a:extLst>
           </p:cNvPr>
@@ -3467,7 +3467,7 @@
           <p:cNvPr id="50" name="Enforce inherited data limits and valid delegation scope">
             <a:extLst xmlns:a="http://schemas.openxmlformats.org/drawingml/2006/main">
               <a:ext uri="{FF2B5EF4-FFF2-40B4-BE49-F238E27FC236}">
-                <a16:creationId xmlns:a16="http://schemas.microsoft.com/office/drawing/2014/main" id="{74DC4679-F1CC-4366-89BE-2C5D1F9341A6}"/>
+                <a16:creationId xmlns:a16="http://schemas.microsoft.com/office/drawing/2014/main" id="{A448EF07-F73E-4546-AF0F-1BC9F011C271}"/>
               </a:ext>
             </a:extLst>
           </p:cNvPr>
@@ -3524,7 +3524,7 @@
           <p:cNvPr id="51" name="Editable boundary">
             <a:extLst xmlns:a="http://schemas.openxmlformats.org/drawingml/2006/main">
               <a:ext uri="{FF2B5EF4-FFF2-40B4-BE49-F238E27FC236}">
-                <a16:creationId xmlns:a16="http://schemas.microsoft.com/office/drawing/2014/main" id="{9A769459-8854-4FA2-BB5D-02088101F529}"/>
+                <a16:creationId xmlns:a16="http://schemas.microsoft.com/office/drawing/2014/main" id="{49E07091-CDAC-4B6F-A416-6DEA6C1ED35C}"/>
               </a:ext>
             </a:extLst>
           </p:cNvPr>
@@ -3557,7 +3557,7 @@
           <p:cNvPr id="52" name="Shared human-approved requirements Φ">
             <a:extLst xmlns:a="http://schemas.openxmlformats.org/drawingml/2006/main">
               <a:ext uri="{FF2B5EF4-FFF2-40B4-BE49-F238E27FC236}">
-                <a16:creationId xmlns:a16="http://schemas.microsoft.com/office/drawing/2014/main" id="{B54B1420-DABD-4FF6-8AB5-FB1F8A187644}"/>
+                <a16:creationId xmlns:a16="http://schemas.microsoft.com/office/drawing/2014/main" id="{0B40E186-5DD8-443A-84B8-3C643651D15A}"/>
               </a:ext>
             </a:extLst>
           </p:cNvPr>
@@ -3614,7 +3614,7 @@
           <p:cNvPr id="53" name="Task criteria · security properties · authorization scope">
             <a:extLst xmlns:a="http://schemas.openxmlformats.org/drawingml/2006/main">
               <a:ext uri="{FF2B5EF4-FFF2-40B4-BE49-F238E27FC236}">
-                <a16:creationId xmlns:a16="http://schemas.microsoft.com/office/drawing/2014/main" id="{6E8D94F4-026B-4B3D-A19A-32D60FC3F04B}"/>
+                <a16:creationId xmlns:a16="http://schemas.microsoft.com/office/drawing/2014/main" id="{10D8347E-4D6B-4AAA-91B5-215831DCB665}"/>
               </a:ext>
             </a:extLst>
           </p:cNvPr>
@@ -3671,7 +3671,7 @@
           <p:cNvPr id="54" name="Editable flow path">
             <a:extLst xmlns:a="http://schemas.openxmlformats.org/drawingml/2006/main">
               <a:ext uri="{FF2B5EF4-FFF2-40B4-BE49-F238E27FC236}">
-                <a16:creationId xmlns:a16="http://schemas.microsoft.com/office/drawing/2014/main" id="{04291DAE-6929-41C9-BCA4-D87EB21A199A}"/>
+                <a16:creationId xmlns:a16="http://schemas.microsoft.com/office/drawing/2014/main" id="{995450B6-EFA6-4B78-99A4-4D8790AEDD6E}"/>
               </a:ext>
             </a:extLst>
           </p:cNvPr>
@@ -3717,7 +3717,7 @@
           <p:cNvPr id="55" name="Editable arrowhead">
             <a:extLst xmlns:a="http://schemas.openxmlformats.org/drawingml/2006/main">
               <a:ext uri="{FF2B5EF4-FFF2-40B4-BE49-F238E27FC236}">
-                <a16:creationId xmlns:a16="http://schemas.microsoft.com/office/drawing/2014/main" id="{B01AE5EB-1A89-4268-B5A1-71124F4806C7}"/>
+                <a16:creationId xmlns:a16="http://schemas.microsoft.com/office/drawing/2014/main" id="{0114CB9C-8486-4E7D-93A0-62FD6461048C}"/>
               </a:ext>
             </a:extLst>
           </p:cNvPr>
@@ -3760,7 +3760,7 @@
           <p:cNvPr id="56" name="Editable boundary">
             <a:extLst xmlns:a="http://schemas.openxmlformats.org/drawingml/2006/main">
               <a:ext uri="{FF2B5EF4-FFF2-40B4-BE49-F238E27FC236}">
-                <a16:creationId xmlns:a16="http://schemas.microsoft.com/office/drawing/2014/main" id="{A42FD7BB-120C-405A-BF82-7F4279200AA3}"/>
+                <a16:creationId xmlns:a16="http://schemas.microsoft.com/office/drawing/2014/main" id="{3CA13368-0187-44A7-96EC-35207C7220B9}"/>
               </a:ext>
             </a:extLst>
           </p:cNvPr>
@@ -3793,7 +3793,7 @@
           <p:cNvPr id="57" name="scoped approvals">
             <a:extLst xmlns:a="http://schemas.openxmlformats.org/drawingml/2006/main">
               <a:ext uri="{FF2B5EF4-FFF2-40B4-BE49-F238E27FC236}">
-                <a16:creationId xmlns:a16="http://schemas.microsoft.com/office/drawing/2014/main" id="{36A55331-D431-48D2-A05C-B5986D90B8AD}"/>
+                <a16:creationId xmlns:a16="http://schemas.microsoft.com/office/drawing/2014/main" id="{B7999E41-F97E-4C31-A910-5A427A03398A}"/>
               </a:ext>
             </a:extLst>
           </p:cNvPr>
@@ -3850,7 +3850,7 @@
           <p:cNvPr id="58" name="Editable boundary">
             <a:extLst xmlns:a="http://schemas.openxmlformats.org/drawingml/2006/main">
               <a:ext uri="{FF2B5EF4-FFF2-40B4-BE49-F238E27FC236}">
-                <a16:creationId xmlns:a16="http://schemas.microsoft.com/office/drawing/2014/main" id="{AE29A5E1-F49F-4359-B7B4-D7DA01E5E1B0}"/>
+                <a16:creationId xmlns:a16="http://schemas.microsoft.com/office/drawing/2014/main" id="{FAC9F637-62CC-4B4C-8E9B-237406239ED2}"/>
               </a:ext>
             </a:extLst>
           </p:cNvPr>
@@ -3883,7 +3883,7 @@
           <p:cNvPr id="59" name="Editable boundary">
             <a:extLst xmlns:a="http://schemas.openxmlformats.org/drawingml/2006/main">
               <a:ext uri="{FF2B5EF4-FFF2-40B4-BE49-F238E27FC236}">
-                <a16:creationId xmlns:a16="http://schemas.microsoft.com/office/drawing/2014/main" id="{0FAC24F6-78B8-48AA-846B-95CCA404CDFB}"/>
+                <a16:creationId xmlns:a16="http://schemas.microsoft.com/office/drawing/2014/main" id="{E8C9C24C-0BA1-41D0-A940-F9F77DA068EE}"/>
               </a:ext>
             </a:extLst>
           </p:cNvPr>
@@ -3916,7 +3916,7 @@
           <p:cNvPr id="60" name="I">
             <a:extLst xmlns:a="http://schemas.openxmlformats.org/drawingml/2006/main">
               <a:ext uri="{FF2B5EF4-FFF2-40B4-BE49-F238E27FC236}">
-                <a16:creationId xmlns:a16="http://schemas.microsoft.com/office/drawing/2014/main" id="{A56BAE31-4D7B-46D3-ADB7-E8501CEE08BE}"/>
+                <a16:creationId xmlns:a16="http://schemas.microsoft.com/office/drawing/2014/main" id="{6C2303DE-9663-4945-8785-2A3AC159C8BC}"/>
               </a:ext>
             </a:extLst>
           </p:cNvPr>
@@ -3973,7 +3973,7 @@
           <p:cNvPr id="61" name="Action assurance">
             <a:extLst xmlns:a="http://schemas.openxmlformats.org/drawingml/2006/main">
               <a:ext uri="{FF2B5EF4-FFF2-40B4-BE49-F238E27FC236}">
-                <a16:creationId xmlns:a16="http://schemas.microsoft.com/office/drawing/2014/main" id="{7813E88C-03E4-46F9-BFB2-5F7D1080E3A1}"/>
+                <a16:creationId xmlns:a16="http://schemas.microsoft.com/office/drawing/2014/main" id="{985EAFD0-6158-46AF-BF69-766944FAB193}"/>
               </a:ext>
             </a:extLst>
           </p:cNvPr>
@@ -4030,7 +4030,7 @@
           <p:cNvPr id="62" name="Editable boundary">
             <a:extLst xmlns:a="http://schemas.openxmlformats.org/drawingml/2006/main">
               <a:ext uri="{FF2B5EF4-FFF2-40B4-BE49-F238E27FC236}">
-                <a16:creationId xmlns:a16="http://schemas.microsoft.com/office/drawing/2014/main" id="{8C6FBF31-3393-4AD0-85DB-F78BD2B29CA6}"/>
+                <a16:creationId xmlns:a16="http://schemas.microsoft.com/office/drawing/2014/main" id="{FB54786D-2026-4F7B-B3FD-778F74990B5D}"/>
               </a:ext>
             </a:extLst>
           </p:cNvPr>
@@ -4063,7 +4063,7 @@
           <p:cNvPr id="63" name="Editable boundary">
             <a:extLst xmlns:a="http://schemas.openxmlformats.org/drawingml/2006/main">
               <a:ext uri="{FF2B5EF4-FFF2-40B4-BE49-F238E27FC236}">
-                <a16:creationId xmlns:a16="http://schemas.microsoft.com/office/drawing/2014/main" id="{585FFCC3-0941-4758-BF75-256B40D7ACEA}"/>
+                <a16:creationId xmlns:a16="http://schemas.microsoft.com/office/drawing/2014/main" id="{E0E2FCDB-7E4A-43DD-AF0A-D6AC4BBCD45B}"/>
               </a:ext>
             </a:extLst>
           </p:cNvPr>
@@ -4096,7 +4096,7 @@
           <p:cNvPr id="64" name="II">
             <a:extLst xmlns:a="http://schemas.openxmlformats.org/drawingml/2006/main">
               <a:ext uri="{FF2B5EF4-FFF2-40B4-BE49-F238E27FC236}">
-                <a16:creationId xmlns:a16="http://schemas.microsoft.com/office/drawing/2014/main" id="{F4A5DC7C-D9CC-4541-9A44-1CC277E4917B}"/>
+                <a16:creationId xmlns:a16="http://schemas.microsoft.com/office/drawing/2014/main" id="{213DFF7C-9312-4C26-8275-12BC2F156D8D}"/>
               </a:ext>
             </a:extLst>
           </p:cNvPr>
@@ -4153,7 +4153,7 @@
           <p:cNvPr id="65" name="Safety retention">
             <a:extLst xmlns:a="http://schemas.openxmlformats.org/drawingml/2006/main">
               <a:ext uri="{FF2B5EF4-FFF2-40B4-BE49-F238E27FC236}">
-                <a16:creationId xmlns:a16="http://schemas.microsoft.com/office/drawing/2014/main" id="{D86A74F9-470E-4C50-9D95-6C45534BAF5E}"/>
+                <a16:creationId xmlns:a16="http://schemas.microsoft.com/office/drawing/2014/main" id="{929343A2-655D-4898-B5C5-64E082319AED}"/>
               </a:ext>
             </a:extLst>
           </p:cNvPr>
@@ -4210,7 +4210,7 @@
           <p:cNvPr id="66" name="Editable boundary">
             <a:extLst xmlns:a="http://schemas.openxmlformats.org/drawingml/2006/main">
               <a:ext uri="{FF2B5EF4-FFF2-40B4-BE49-F238E27FC236}">
-                <a16:creationId xmlns:a16="http://schemas.microsoft.com/office/drawing/2014/main" id="{7499E6C6-BD49-48CB-8306-2C86A917DB6D}"/>
+                <a16:creationId xmlns:a16="http://schemas.microsoft.com/office/drawing/2014/main" id="{02CF9F4E-94F7-4620-98AC-58FDBE06A81E}"/>
               </a:ext>
             </a:extLst>
           </p:cNvPr>
@@ -4243,7 +4243,7 @@
           <p:cNvPr id="67" name="Editable boundary">
             <a:extLst xmlns:a="http://schemas.openxmlformats.org/drawingml/2006/main">
               <a:ext uri="{FF2B5EF4-FFF2-40B4-BE49-F238E27FC236}">
-                <a16:creationId xmlns:a16="http://schemas.microsoft.com/office/drawing/2014/main" id="{4C772E00-0E35-48A5-A6B2-F6428EAE13DE}"/>
+                <a16:creationId xmlns:a16="http://schemas.microsoft.com/office/drawing/2014/main" id="{34F5E6C9-A8E4-4052-8909-9784BC395F65}"/>
               </a:ext>
             </a:extLst>
           </p:cNvPr>
@@ -4276,7 +4276,7 @@
           <p:cNvPr id="68" name="III">
             <a:extLst xmlns:a="http://schemas.openxmlformats.org/drawingml/2006/main">
               <a:ext uri="{FF2B5EF4-FFF2-40B4-BE49-F238E27FC236}">
-                <a16:creationId xmlns:a16="http://schemas.microsoft.com/office/drawing/2014/main" id="{ACF7F26C-A8ED-4E1B-A7A0-905474B20C5B}"/>
+                <a16:creationId xmlns:a16="http://schemas.microsoft.com/office/drawing/2014/main" id="{750EA5F0-7D47-474C-90D5-1EBB7EC8EF50}"/>
               </a:ext>
             </a:extLst>
           </p:cNvPr>
@@ -4333,7 +4333,7 @@
           <p:cNvPr id="69" name="Workflow control">
             <a:extLst xmlns:a="http://schemas.openxmlformats.org/drawingml/2006/main">
               <a:ext uri="{FF2B5EF4-FFF2-40B4-BE49-F238E27FC236}">
-                <a16:creationId xmlns:a16="http://schemas.microsoft.com/office/drawing/2014/main" id="{B5D9FC71-C263-496E-936A-C34CF1E75682}"/>
+                <a16:creationId xmlns:a16="http://schemas.microsoft.com/office/drawing/2014/main" id="{B58B743E-50BE-457C-B6F2-5957E00F8B1D}"/>
               </a:ext>
             </a:extLst>
           </p:cNvPr>
@@ -4390,7 +4390,7 @@
           <p:cNvPr id="70" name="Editable flow path">
             <a:extLst xmlns:a="http://schemas.openxmlformats.org/drawingml/2006/main">
               <a:ext uri="{FF2B5EF4-FFF2-40B4-BE49-F238E27FC236}">
-                <a16:creationId xmlns:a16="http://schemas.microsoft.com/office/drawing/2014/main" id="{6EF26952-A4A2-4C35-8220-90CC332341A8}"/>
+                <a16:creationId xmlns:a16="http://schemas.microsoft.com/office/drawing/2014/main" id="{044313BF-BF54-4DB6-BB6C-F053522EA2E1}"/>
               </a:ext>
             </a:extLst>
           </p:cNvPr>
@@ -4430,7 +4430,7 @@
           <p:cNvPr id="71" name="Editable arrowhead">
             <a:extLst xmlns:a="http://schemas.openxmlformats.org/drawingml/2006/main">
               <a:ext uri="{FF2B5EF4-FFF2-40B4-BE49-F238E27FC236}">
-                <a16:creationId xmlns:a16="http://schemas.microsoft.com/office/drawing/2014/main" id="{DF95B084-2103-4206-A04E-1AE416E2C3CB}"/>
+                <a16:creationId xmlns:a16="http://schemas.microsoft.com/office/drawing/2014/main" id="{E23EDEB5-383C-448E-BC3E-CCC5AB599ACA}"/>
               </a:ext>
             </a:extLst>
           </p:cNvPr>
@@ -4473,7 +4473,7 @@
           <p:cNvPr id="72" name="checked">
             <a:extLst xmlns:a="http://schemas.openxmlformats.org/drawingml/2006/main">
               <a:ext uri="{FF2B5EF4-FFF2-40B4-BE49-F238E27FC236}">
-                <a16:creationId xmlns:a16="http://schemas.microsoft.com/office/drawing/2014/main" id="{28861FCD-B757-4B6E-BEC8-031CBEB7B221}"/>
+                <a16:creationId xmlns:a16="http://schemas.microsoft.com/office/drawing/2014/main" id="{A8E428FD-1F77-46BB-BC20-ADCC43121031}"/>
               </a:ext>
             </a:extLst>
           </p:cNvPr>
@@ -4530,7 +4530,7 @@
           <p:cNvPr id="73" name="feedback">
             <a:extLst xmlns:a="http://schemas.openxmlformats.org/drawingml/2006/main">
               <a:ext uri="{FF2B5EF4-FFF2-40B4-BE49-F238E27FC236}">
-                <a16:creationId xmlns:a16="http://schemas.microsoft.com/office/drawing/2014/main" id="{AC9368E0-6AB2-49F2-BD72-00061CBCFB4B}"/>
+                <a16:creationId xmlns:a16="http://schemas.microsoft.com/office/drawing/2014/main" id="{3D0557DB-22EB-49BF-BFB1-82A83DDC41AE}"/>
               </a:ext>
             </a:extLst>
           </p:cNvPr>
@@ -4587,7 +4587,7 @@
           <p:cNvPr id="74" name="Editable flow path">
             <a:extLst xmlns:a="http://schemas.openxmlformats.org/drawingml/2006/main">
               <a:ext uri="{FF2B5EF4-FFF2-40B4-BE49-F238E27FC236}">
-                <a16:creationId xmlns:a16="http://schemas.microsoft.com/office/drawing/2014/main" id="{910E77AE-94F4-4909-B25E-CEA33DC1252E}"/>
+                <a16:creationId xmlns:a16="http://schemas.microsoft.com/office/drawing/2014/main" id="{658631C4-68A7-4371-A1E9-1A7A66F34D0D}"/>
               </a:ext>
             </a:extLst>
           </p:cNvPr>
@@ -4627,7 +4627,7 @@
           <p:cNvPr id="75" name="Editable arrowhead">
             <a:extLst xmlns:a="http://schemas.openxmlformats.org/drawingml/2006/main">
               <a:ext uri="{FF2B5EF4-FFF2-40B4-BE49-F238E27FC236}">
-                <a16:creationId xmlns:a16="http://schemas.microsoft.com/office/drawing/2014/main" id="{7E1B9504-8752-4FBC-91E3-DEFEC49390C4}"/>
+                <a16:creationId xmlns:a16="http://schemas.microsoft.com/office/drawing/2014/main" id="{A76972F6-92CB-4AB0-A653-44EC5929A6A6}"/>
               </a:ext>
             </a:extLst>
           </p:cNvPr>
@@ -4670,7 +4670,7 @@
           <p:cNvPr id="76" name="version +">
             <a:extLst xmlns:a="http://schemas.openxmlformats.org/drawingml/2006/main">
               <a:ext uri="{FF2B5EF4-FFF2-40B4-BE49-F238E27FC236}">
-                <a16:creationId xmlns:a16="http://schemas.microsoft.com/office/drawing/2014/main" id="{8B61C7BB-E430-4424-867D-72DFE515B766}"/>
+                <a16:creationId xmlns:a16="http://schemas.microsoft.com/office/drawing/2014/main" id="{261955A3-F28B-4A53-B16A-ACAF2019E063}"/>
               </a:ext>
             </a:extLst>
           </p:cNvPr>
@@ -4727,7 +4727,7 @@
           <p:cNvPr id="77" name="evidence">
             <a:extLst xmlns:a="http://schemas.openxmlformats.org/drawingml/2006/main">
               <a:ext uri="{FF2B5EF4-FFF2-40B4-BE49-F238E27FC236}">
-                <a16:creationId xmlns:a16="http://schemas.microsoft.com/office/drawing/2014/main" id="{FFE4E750-4C08-42C5-B2AD-9F46FC833FAE}"/>
+                <a16:creationId xmlns:a16="http://schemas.microsoft.com/office/drawing/2014/main" id="{22580E84-4ED7-42F6-A93B-B9408CD8927E}"/>
               </a:ext>
             </a:extLst>
           </p:cNvPr>
@@ -4784,7 +4784,7 @@
           <p:cNvPr id="78" name="Editable flow path">
             <a:extLst xmlns:a="http://schemas.openxmlformats.org/drawingml/2006/main">
               <a:ext uri="{FF2B5EF4-FFF2-40B4-BE49-F238E27FC236}">
-                <a16:creationId xmlns:a16="http://schemas.microsoft.com/office/drawing/2014/main" id="{A58BED02-7F94-4749-A6F0-EECAB4E96951}"/>
+                <a16:creationId xmlns:a16="http://schemas.microsoft.com/office/drawing/2014/main" id="{A298BFE4-F687-489E-B04A-88EF1BC54021}"/>
               </a:ext>
             </a:extLst>
           </p:cNvPr>
@@ -4830,7 +4830,7 @@
           <p:cNvPr id="79" name="Editable arrowhead">
             <a:extLst xmlns:a="http://schemas.openxmlformats.org/drawingml/2006/main">
               <a:ext uri="{FF2B5EF4-FFF2-40B4-BE49-F238E27FC236}">
-                <a16:creationId xmlns:a16="http://schemas.microsoft.com/office/drawing/2014/main" id="{872F86EB-AA13-4875-85CC-3883AF75BC96}"/>
+                <a16:creationId xmlns:a16="http://schemas.microsoft.com/office/drawing/2014/main" id="{5A83D03E-EB15-4D62-958E-D58FA0A3C4EA}"/>
               </a:ext>
             </a:extLst>
           </p:cNvPr>
@@ -4873,7 +4873,7 @@
           <p:cNvPr id="80" name="Editable flow path">
             <a:extLst xmlns:a="http://schemas.openxmlformats.org/drawingml/2006/main">
               <a:ext uri="{FF2B5EF4-FFF2-40B4-BE49-F238E27FC236}">
-                <a16:creationId xmlns:a16="http://schemas.microsoft.com/office/drawing/2014/main" id="{216082E7-1AC6-4161-88E9-A21A8D93CE79}"/>
+                <a16:creationId xmlns:a16="http://schemas.microsoft.com/office/drawing/2014/main" id="{50086617-1176-45FC-BFDA-6B99A8BCBCF8}"/>
               </a:ext>
             </a:extLst>
           </p:cNvPr>
@@ -4913,7 +4913,7 @@
           <p:cNvPr id="81" name="Editable arrowhead">
             <a:extLst xmlns:a="http://schemas.openxmlformats.org/drawingml/2006/main">
               <a:ext uri="{FF2B5EF4-FFF2-40B4-BE49-F238E27FC236}">
-                <a16:creationId xmlns:a16="http://schemas.microsoft.com/office/drawing/2014/main" id="{532FFFB2-D4EE-4DEA-A331-B10214E1BDB8}"/>
+                <a16:creationId xmlns:a16="http://schemas.microsoft.com/office/drawing/2014/main" id="{968C108C-1258-4480-9A17-C18B6107DD6F}"/>
               </a:ext>
             </a:extLst>
           </p:cNvPr>
@@ -4956,7 +4956,7 @@
           <p:cNvPr id="82" name="workflow feedback">
             <a:extLst xmlns:a="http://schemas.openxmlformats.org/drawingml/2006/main">
               <a:ext uri="{FF2B5EF4-FFF2-40B4-BE49-F238E27FC236}">
-                <a16:creationId xmlns:a16="http://schemas.microsoft.com/office/drawing/2014/main" id="{BD9DC60B-6FCC-458A-89F5-9AE49612ACC8}"/>
+                <a16:creationId xmlns:a16="http://schemas.microsoft.com/office/drawing/2014/main" id="{1026FA58-CB08-400D-BEAF-DACD6678E8B6}"/>
               </a:ext>
             </a:extLst>
           </p:cNvPr>
@@ -5013,7 +5013,7 @@
           <p:cNvPr id="83" name="Formal claims require faithful models, sound checking, and trust">
             <a:extLst xmlns:a="http://schemas.openxmlformats.org/drawingml/2006/main">
               <a:ext uri="{FF2B5EF4-FFF2-40B4-BE49-F238E27FC236}">
-                <a16:creationId xmlns:a16="http://schemas.microsoft.com/office/drawing/2014/main" id="{0CEC5EE3-FAF1-425A-B4AD-C6EB49CBFC33}"/>
+                <a16:creationId xmlns:a16="http://schemas.microsoft.com/office/drawing/2014/main" id="{190A2B6B-4622-486B-BD07-0555093766E7}"/>
               </a:ext>
             </a:extLst>
           </p:cNvPr>
@@ -5070,7 +5070,7 @@
           <p:cNvPr id="84" name="tests provide evidence for evaluated conditions.">
             <a:extLst xmlns:a="http://schemas.openxmlformats.org/drawingml/2006/main">
               <a:ext uri="{FF2B5EF4-FFF2-40B4-BE49-F238E27FC236}">
-                <a16:creationId xmlns:a16="http://schemas.microsoft.com/office/drawing/2014/main" id="{2C583A15-1981-4267-9E04-D50EE5F28A70}"/>
+                <a16:creationId xmlns:a16="http://schemas.microsoft.com/office/drawing/2014/main" id="{B55591AC-2957-4BDB-8B35-626B736E14BE}"/>
               </a:ext>
             </a:extLst>
           </p:cNvPr>
@@ -5125,7 +5125,7 @@
     </p:spTree>
     <p:extLst>
       <p:ext uri="{BB962C8B-B14F-4D97-AF65-F5344CB8AC3E}">
-        <p14:creationId xmlns:p14="http://schemas.microsoft.com/office/powerpoint/2010/main" val="2144155760"/>
+        <p14:creationId xmlns:p14="http://schemas.microsoft.com/office/powerpoint/2010/main" val="659688927"/>
       </p:ext>
     </p:extLst>
   </p:cSld>
@@ -5156,7 +5156,7 @@
           <p:cNvPr id="66" name="Formal Oversight Before Action">
             <a:extLst xmlns:a="http://schemas.openxmlformats.org/drawingml/2006/main">
               <a:ext uri="{FF2B5EF4-FFF2-40B4-BE49-F238E27FC236}">
-                <a16:creationId xmlns:a16="http://schemas.microsoft.com/office/drawing/2014/main" id="{A4D3BE39-4E56-4AD8-9865-783F4DA4BED3}"/>
+                <a16:creationId xmlns:a16="http://schemas.microsoft.com/office/drawing/2014/main" id="{3BD02DE2-6FCD-4C95-99AB-8A4E2F886828}"/>
               </a:ext>
             </a:extLst>
           </p:cNvPr>
@@ -5213,7 +5213,7 @@
           <p:cNvPr id="2" name="Proposed framework: specify properties, prove obligations, enfor">
             <a:extLst xmlns:a="http://schemas.openxmlformats.org/drawingml/2006/main">
               <a:ext uri="{FF2B5EF4-FFF2-40B4-BE49-F238E27FC236}">
-                <a16:creationId xmlns:a16="http://schemas.microsoft.com/office/drawing/2014/main" id="{BACDA96E-5A74-47B6-AFF8-8BA0D09FC8E0}"/>
+                <a16:creationId xmlns:a16="http://schemas.microsoft.com/office/drawing/2014/main" id="{A62F9A8D-CB86-4B87-9BD5-4F68E3FFEC5D}"/>
               </a:ext>
             </a:extLst>
           </p:cNvPr>
@@ -5270,7 +5270,7 @@
           <p:cNvPr id="3" name="Editable boundary">
             <a:extLst xmlns:a="http://schemas.openxmlformats.org/drawingml/2006/main">
               <a:ext uri="{FF2B5EF4-FFF2-40B4-BE49-F238E27FC236}">
-                <a16:creationId xmlns:a16="http://schemas.microsoft.com/office/drawing/2014/main" id="{4F031845-B9B2-489E-95CE-1F24F10D8E89}"/>
+                <a16:creationId xmlns:a16="http://schemas.microsoft.com/office/drawing/2014/main" id="{491712D7-BDE2-48E3-B0E4-74A5D08B12D0}"/>
               </a:ext>
             </a:extLst>
           </p:cNvPr>
@@ -5303,7 +5303,7 @@
           <p:cNvPr id="4" name="Editable boundary">
             <a:extLst xmlns:a="http://schemas.openxmlformats.org/drawingml/2006/main">
               <a:ext uri="{FF2B5EF4-FFF2-40B4-BE49-F238E27FC236}">
-                <a16:creationId xmlns:a16="http://schemas.microsoft.com/office/drawing/2014/main" id="{27767313-DD0C-47F0-8725-570DAA40571C}"/>
+                <a16:creationId xmlns:a16="http://schemas.microsoft.com/office/drawing/2014/main" id="{FB8622E3-D32E-4D39-B8E9-6541C4A66569}"/>
               </a:ext>
             </a:extLst>
           </p:cNvPr>
@@ -5336,7 +5336,7 @@
           <p:cNvPr id="5" name="Editable boundary">
             <a:extLst xmlns:a="http://schemas.openxmlformats.org/drawingml/2006/main">
               <a:ext uri="{FF2B5EF4-FFF2-40B4-BE49-F238E27FC236}">
-                <a16:creationId xmlns:a16="http://schemas.microsoft.com/office/drawing/2014/main" id="{D4C26C9C-B4F4-4747-9A98-F8D38D8B16F4}"/>
+                <a16:creationId xmlns:a16="http://schemas.microsoft.com/office/drawing/2014/main" id="{947BAA02-3628-46E9-819E-D3523A702B8C}"/>
               </a:ext>
             </a:extLst>
           </p:cNvPr>
@@ -5369,7 +5369,7 @@
           <p:cNvPr id="6" name="1   Formal specification">
             <a:extLst xmlns:a="http://schemas.openxmlformats.org/drawingml/2006/main">
               <a:ext uri="{FF2B5EF4-FFF2-40B4-BE49-F238E27FC236}">
-                <a16:creationId xmlns:a16="http://schemas.microsoft.com/office/drawing/2014/main" id="{4CA467B1-7E8C-4676-A1FF-44A743913F4E}"/>
+                <a16:creationId xmlns:a16="http://schemas.microsoft.com/office/drawing/2014/main" id="{C6E7EBD1-3A17-47A7-8800-0278058A0245}"/>
               </a:ext>
             </a:extLst>
           </p:cNvPr>
@@ -5426,7 +5426,7 @@
           <p:cNvPr id="7" name="2   Formal proof checking">
             <a:extLst xmlns:a="http://schemas.openxmlformats.org/drawingml/2006/main">
               <a:ext uri="{FF2B5EF4-FFF2-40B4-BE49-F238E27FC236}">
-                <a16:creationId xmlns:a16="http://schemas.microsoft.com/office/drawing/2014/main" id="{89A30DE5-E611-47B1-AB91-0E3AABD2D032}"/>
+                <a16:creationId xmlns:a16="http://schemas.microsoft.com/office/drawing/2014/main" id="{6CA76653-E561-4903-9D88-BC2175F9820D}"/>
               </a:ext>
             </a:extLst>
           </p:cNvPr>
@@ -5483,7 +5483,7 @@
           <p:cNvPr id="8" name="3   Execution gate">
             <a:extLst xmlns:a="http://schemas.openxmlformats.org/drawingml/2006/main">
               <a:ext uri="{FF2B5EF4-FFF2-40B4-BE49-F238E27FC236}">
-                <a16:creationId xmlns:a16="http://schemas.microsoft.com/office/drawing/2014/main" id="{CDA20FFD-8A30-42A3-8EB2-23F3AFF58273}"/>
+                <a16:creationId xmlns:a16="http://schemas.microsoft.com/office/drawing/2014/main" id="{7D8634C4-73D6-43D0-91F3-CD91123813DC}"/>
               </a:ext>
             </a:extLst>
           </p:cNvPr>
@@ -5540,7 +5540,7 @@
           <p:cNvPr id="9" name="Editable boundary">
             <a:extLst xmlns:a="http://schemas.openxmlformats.org/drawingml/2006/main">
               <a:ext uri="{FF2B5EF4-FFF2-40B4-BE49-F238E27FC236}">
-                <a16:creationId xmlns:a16="http://schemas.microsoft.com/office/drawing/2014/main" id="{593ED238-FBA0-4BDF-9E4D-85DAF4CF6D5B}"/>
+                <a16:creationId xmlns:a16="http://schemas.microsoft.com/office/drawing/2014/main" id="{0592C041-8408-49F1-8065-53C8E2579822}"/>
               </a:ext>
             </a:extLst>
           </p:cNvPr>
@@ -5558,7 +5558,7 @@
             <a:avLst/>
           </a:prstGeom>
           <a:solidFill xmlns:a="http://schemas.openxmlformats.org/drawingml/2006/main">
-            <a:srgbClr val="F0F3F6"/>
+            <a:srgbClr val="F8F8F8"/>
           </a:solidFill>
           <a:ln xmlns:a="http://schemas.openxmlformats.org/drawingml/2006/main" w="19050">
             <a:solidFill>
@@ -5573,7 +5573,7 @@
           <p:cNvPr id="10" name="Approved specification Φ">
             <a:extLst xmlns:a="http://schemas.openxmlformats.org/drawingml/2006/main">
               <a:ext uri="{FF2B5EF4-FFF2-40B4-BE49-F238E27FC236}">
-                <a16:creationId xmlns:a16="http://schemas.microsoft.com/office/drawing/2014/main" id="{03366E80-6D49-4730-9CD1-5A9481566000}"/>
+                <a16:creationId xmlns:a16="http://schemas.microsoft.com/office/drawing/2014/main" id="{F3C51BC2-3EC2-40D1-9F97-D382A14F857C}"/>
               </a:ext>
             </a:extLst>
           </p:cNvPr>
@@ -5630,7 +5630,7 @@
           <p:cNvPr id="11" name="Task correctness + security">
             <a:extLst xmlns:a="http://schemas.openxmlformats.org/drawingml/2006/main">
               <a:ext uri="{FF2B5EF4-FFF2-40B4-BE49-F238E27FC236}">
-                <a16:creationId xmlns:a16="http://schemas.microsoft.com/office/drawing/2014/main" id="{2A6FD7DE-E862-487C-81CB-7C96C6B9CC16}"/>
+                <a16:creationId xmlns:a16="http://schemas.microsoft.com/office/drawing/2014/main" id="{4629E563-003B-4D67-8CF1-0187099B3A1C}"/>
               </a:ext>
             </a:extLst>
           </p:cNvPr>
@@ -5687,7 +5687,7 @@
           <p:cNvPr id="12" name="Editable boundary">
             <a:extLst xmlns:a="http://schemas.openxmlformats.org/drawingml/2006/main">
               <a:ext uri="{FF2B5EF4-FFF2-40B4-BE49-F238E27FC236}">
-                <a16:creationId xmlns:a16="http://schemas.microsoft.com/office/drawing/2014/main" id="{983421C8-04B4-44E1-985A-81F2F108012F}"/>
+                <a16:creationId xmlns:a16="http://schemas.microsoft.com/office/drawing/2014/main" id="{8B306311-DCF9-4BBF-BFED-1DB3DAF90EFB}"/>
               </a:ext>
             </a:extLst>
           </p:cNvPr>
@@ -5705,11 +5705,11 @@
             <a:avLst/>
           </a:prstGeom>
           <a:solidFill xmlns:a="http://schemas.openxmlformats.org/drawingml/2006/main">
-            <a:srgbClr val="F0F3F6"/>
+            <a:srgbClr val="F8F8F8"/>
           </a:solidFill>
           <a:ln xmlns:a="http://schemas.openxmlformats.org/drawingml/2006/main" w="12383">
             <a:solidFill>
-              <a:srgbClr val="CFD9E2"/>
+              <a:srgbClr val="D0D0D0"/>
             </a:solidFill>
             <a:prstDash val="solid"/>
           </a:ln>
@@ -5720,7 +5720,7 @@
           <p:cNvPr id="13" name="Example security property">
             <a:extLst xmlns:a="http://schemas.openxmlformats.org/drawingml/2006/main">
               <a:ext uri="{FF2B5EF4-FFF2-40B4-BE49-F238E27FC236}">
-                <a16:creationId xmlns:a16="http://schemas.microsoft.com/office/drawing/2014/main" id="{BFFC746F-8A67-4D90-AA43-21486EFC438E}"/>
+                <a16:creationId xmlns:a16="http://schemas.microsoft.com/office/drawing/2014/main" id="{35FA153A-565B-4DD0-A4B1-4245C2E8CDFE}"/>
               </a:ext>
             </a:extLst>
           </p:cNvPr>
@@ -5777,7 +5777,7 @@
           <p:cNvPr id="14" name="always:  Send(d, r) ⇒ Authorized(d, r)">
             <a:extLst xmlns:a="http://schemas.openxmlformats.org/drawingml/2006/main">
               <a:ext uri="{FF2B5EF4-FFF2-40B4-BE49-F238E27FC236}">
-                <a16:creationId xmlns:a16="http://schemas.microsoft.com/office/drawing/2014/main" id="{4457EFB5-AE9B-48BD-9DC3-B3F81C8A29C7}"/>
+                <a16:creationId xmlns:a16="http://schemas.microsoft.com/office/drawing/2014/main" id="{E250A09C-EDBC-45AE-AD29-070570E3231A}"/>
               </a:ext>
             </a:extLst>
           </p:cNvPr>
@@ -5834,7 +5834,7 @@
           <p:cNvPr id="15" name="Every send must be authorized.">
             <a:extLst xmlns:a="http://schemas.openxmlformats.org/drawingml/2006/main">
               <a:ext uri="{FF2B5EF4-FFF2-40B4-BE49-F238E27FC236}">
-                <a16:creationId xmlns:a16="http://schemas.microsoft.com/office/drawing/2014/main" id="{2AF5F230-AD7F-4623-BCC1-DEEA079CA393}"/>
+                <a16:creationId xmlns:a16="http://schemas.microsoft.com/office/drawing/2014/main" id="{990A98BF-6A6F-4818-9FA8-6F9EC8F7AA7D}"/>
               </a:ext>
             </a:extLst>
           </p:cNvPr>
@@ -5891,7 +5891,7 @@
           <p:cNvPr id="16" name="Review intent. Protect the specification.">
             <a:extLst xmlns:a="http://schemas.openxmlformats.org/drawingml/2006/main">
               <a:ext uri="{FF2B5EF4-FFF2-40B4-BE49-F238E27FC236}">
-                <a16:creationId xmlns:a16="http://schemas.microsoft.com/office/drawing/2014/main" id="{34A9A926-0F49-48FC-8F61-BA8E1865A2F6}"/>
+                <a16:creationId xmlns:a16="http://schemas.microsoft.com/office/drawing/2014/main" id="{699B25A2-B1DD-4FBC-8D1E-1CAE58452B8B}"/>
               </a:ext>
             </a:extLst>
           </p:cNvPr>
@@ -5948,7 +5948,7 @@
           <p:cNvPr id="17" name="Φ">
             <a:extLst xmlns:a="http://schemas.openxmlformats.org/drawingml/2006/main">
               <a:ext uri="{FF2B5EF4-FFF2-40B4-BE49-F238E27FC236}">
-                <a16:creationId xmlns:a16="http://schemas.microsoft.com/office/drawing/2014/main" id="{479CE99C-9D5B-48E8-A675-40F8B1BBFF1C}"/>
+                <a16:creationId xmlns:a16="http://schemas.microsoft.com/office/drawing/2014/main" id="{52049CC9-81FD-4423-A522-391568D6CA06}"/>
               </a:ext>
             </a:extLst>
           </p:cNvPr>
@@ -6005,7 +6005,7 @@
           <p:cNvPr id="18" name="Editable flow path">
             <a:extLst xmlns:a="http://schemas.openxmlformats.org/drawingml/2006/main">
               <a:ext uri="{FF2B5EF4-FFF2-40B4-BE49-F238E27FC236}">
-                <a16:creationId xmlns:a16="http://schemas.microsoft.com/office/drawing/2014/main" id="{870AF08D-B6F6-49D2-AB85-221CE18C6743}"/>
+                <a16:creationId xmlns:a16="http://schemas.microsoft.com/office/drawing/2014/main" id="{1B828B16-8A3E-4F37-BBCF-D7EB00A9DDC6}"/>
               </a:ext>
             </a:extLst>
           </p:cNvPr>
@@ -6045,7 +6045,7 @@
           <p:cNvPr id="19" name="Editable arrowhead">
             <a:extLst xmlns:a="http://schemas.openxmlformats.org/drawingml/2006/main">
               <a:ext uri="{FF2B5EF4-FFF2-40B4-BE49-F238E27FC236}">
-                <a16:creationId xmlns:a16="http://schemas.microsoft.com/office/drawing/2014/main" id="{8BF0C7BC-088D-4EA0-ABD6-CA8C11BD85A8}"/>
+                <a16:creationId xmlns:a16="http://schemas.microsoft.com/office/drawing/2014/main" id="{77EF79D3-5AC0-40B3-9341-2675EF3A4E04}"/>
               </a:ext>
             </a:extLst>
           </p:cNvPr>
@@ -6088,7 +6088,7 @@
           <p:cNvPr id="20" name="Editable boundary">
             <a:extLst xmlns:a="http://schemas.openxmlformats.org/drawingml/2006/main">
               <a:ext uri="{FF2B5EF4-FFF2-40B4-BE49-F238E27FC236}">
-                <a16:creationId xmlns:a16="http://schemas.microsoft.com/office/drawing/2014/main" id="{BC7A5D84-4EED-454C-BE58-75754B36AAC8}"/>
+                <a16:creationId xmlns:a16="http://schemas.microsoft.com/office/drawing/2014/main" id="{86AE0BCD-96AB-412E-B5A5-F53949D862E2}"/>
               </a:ext>
             </a:extLst>
           </p:cNvPr>
@@ -6106,7 +6106,7 @@
             <a:avLst/>
           </a:prstGeom>
           <a:solidFill xmlns:a="http://schemas.openxmlformats.org/drawingml/2006/main">
-            <a:srgbClr val="F0F3F6"/>
+            <a:srgbClr val="F8F8F8"/>
           </a:solidFill>
           <a:ln xmlns:a="http://schemas.openxmlformats.org/drawingml/2006/main" w="19050">
             <a:solidFill>
@@ -6121,7 +6121,7 @@
           <p:cNvPr id="21" name="Generate logical obligations">
             <a:extLst xmlns:a="http://schemas.openxmlformats.org/drawingml/2006/main">
               <a:ext uri="{FF2B5EF4-FFF2-40B4-BE49-F238E27FC236}">
-                <a16:creationId xmlns:a16="http://schemas.microsoft.com/office/drawing/2014/main" id="{274152F9-C00F-475C-AC22-A3DDC8DFF218}"/>
+                <a16:creationId xmlns:a16="http://schemas.microsoft.com/office/drawing/2014/main" id="{28A5CEB3-163A-41FC-B6FA-D548D9BABD2F}"/>
               </a:ext>
             </a:extLst>
           </p:cNvPr>
@@ -6178,7 +6178,7 @@
           <p:cNvPr id="22" name="Editable boundary">
             <a:extLst xmlns:a="http://schemas.openxmlformats.org/drawingml/2006/main">
               <a:ext uri="{FF2B5EF4-FFF2-40B4-BE49-F238E27FC236}">
-                <a16:creationId xmlns:a16="http://schemas.microsoft.com/office/drawing/2014/main" id="{D225319C-2A71-4254-BDDE-8CE02F8071DE}"/>
+                <a16:creationId xmlns:a16="http://schemas.microsoft.com/office/drawing/2014/main" id="{049441E3-74C6-411B-B1CD-1F984351850E}"/>
               </a:ext>
             </a:extLst>
           </p:cNvPr>
@@ -6196,11 +6196,11 @@
             <a:avLst/>
           </a:prstGeom>
           <a:solidFill xmlns:a="http://schemas.openxmlformats.org/drawingml/2006/main">
-            <a:srgbClr val="FAFBFD"/>
+            <a:srgbClr val="FAFAFA"/>
           </a:solidFill>
           <a:ln xmlns:a="http://schemas.openxmlformats.org/drawingml/2006/main" w="11430">
             <a:solidFill>
-              <a:srgbClr val="D4DDE6"/>
+              <a:srgbClr val="D0D0D0"/>
             </a:solidFill>
             <a:prstDash val="solid"/>
           </a:ln>
@@ -6211,7 +6211,7 @@
           <p:cNvPr id="23" name="O := Obligations(M(x), Φ)">
             <a:extLst xmlns:a="http://schemas.openxmlformats.org/drawingml/2006/main">
               <a:ext uri="{FF2B5EF4-FFF2-40B4-BE49-F238E27FC236}">
-                <a16:creationId xmlns:a16="http://schemas.microsoft.com/office/drawing/2014/main" id="{8464168E-EC46-449D-9C0C-0CDD63AE283B}"/>
+                <a16:creationId xmlns:a16="http://schemas.microsoft.com/office/drawing/2014/main" id="{B9B9DFE5-0722-4B2D-AC42-B34F4758E7EE}"/>
               </a:ext>
             </a:extLst>
           </p:cNvPr>
@@ -6268,7 +6268,7 @@
           <p:cNvPr id="24" name="Model the candidate and tool effects.">
             <a:extLst xmlns:a="http://schemas.openxmlformats.org/drawingml/2006/main">
               <a:ext uri="{FF2B5EF4-FFF2-40B4-BE49-F238E27FC236}">
-                <a16:creationId xmlns:a16="http://schemas.microsoft.com/office/drawing/2014/main" id="{B913F4DA-CB78-467D-A0E2-C3934140CD7F}"/>
+                <a16:creationId xmlns:a16="http://schemas.microsoft.com/office/drawing/2014/main" id="{1918F6A7-C98D-4F47-BBA1-22580E50839C}"/>
               </a:ext>
             </a:extLst>
           </p:cNvPr>
@@ -6325,7 +6325,7 @@
           <p:cNvPr id="25" name="Editable flow path">
             <a:extLst xmlns:a="http://schemas.openxmlformats.org/drawingml/2006/main">
               <a:ext uri="{FF2B5EF4-FFF2-40B4-BE49-F238E27FC236}">
-                <a16:creationId xmlns:a16="http://schemas.microsoft.com/office/drawing/2014/main" id="{E4EC689F-45D1-4E9C-B319-BB69198D19E3}"/>
+                <a16:creationId xmlns:a16="http://schemas.microsoft.com/office/drawing/2014/main" id="{73BC7B60-91CF-4E34-9771-08034B62F869}"/>
               </a:ext>
             </a:extLst>
           </p:cNvPr>
@@ -6365,7 +6365,7 @@
           <p:cNvPr id="26" name="Editable arrowhead">
             <a:extLst xmlns:a="http://schemas.openxmlformats.org/drawingml/2006/main">
               <a:ext uri="{FF2B5EF4-FFF2-40B4-BE49-F238E27FC236}">
-                <a16:creationId xmlns:a16="http://schemas.microsoft.com/office/drawing/2014/main" id="{7D0EBB79-C16A-44C3-8C2A-63E17AC1BB15}"/>
+                <a16:creationId xmlns:a16="http://schemas.microsoft.com/office/drawing/2014/main" id="{FA01105A-E72C-48C3-816E-DB832BA004FE}"/>
               </a:ext>
             </a:extLst>
           </p:cNvPr>
@@ -6408,7 +6408,7 @@
           <p:cNvPr id="27" name="Editable boundary">
             <a:extLst xmlns:a="http://schemas.openxmlformats.org/drawingml/2006/main">
               <a:ext uri="{FF2B5EF4-FFF2-40B4-BE49-F238E27FC236}">
-                <a16:creationId xmlns:a16="http://schemas.microsoft.com/office/drawing/2014/main" id="{CB57D97E-F972-465F-AB8D-D41AC9B94E3B}"/>
+                <a16:creationId xmlns:a16="http://schemas.microsoft.com/office/drawing/2014/main" id="{FDAEAE90-E45F-4BFE-946A-1E072F141587}"/>
               </a:ext>
             </a:extLst>
           </p:cNvPr>
@@ -6426,7 +6426,7 @@
             <a:avLst/>
           </a:prstGeom>
           <a:solidFill xmlns:a="http://schemas.openxmlformats.org/drawingml/2006/main">
-            <a:srgbClr val="F0F3F6"/>
+            <a:srgbClr val="F8F8F8"/>
           </a:solidFill>
           <a:ln xmlns:a="http://schemas.openxmlformats.org/drawingml/2006/main" w="19050">
             <a:solidFill>
@@ -6441,7 +6441,7 @@
           <p:cNvPr id="28" name="Prove and check every obligation">
             <a:extLst xmlns:a="http://schemas.openxmlformats.org/drawingml/2006/main">
               <a:ext uri="{FF2B5EF4-FFF2-40B4-BE49-F238E27FC236}">
-                <a16:creationId xmlns:a16="http://schemas.microsoft.com/office/drawing/2014/main" id="{579E815D-F8EE-491D-BB15-2554AF2E52E1}"/>
+                <a16:creationId xmlns:a16="http://schemas.microsoft.com/office/drawing/2014/main" id="{5B25B5BA-215C-436B-8158-4B89040500A4}"/>
               </a:ext>
             </a:extLst>
           </p:cNvPr>
@@ -6498,7 +6498,7 @@
           <p:cNvPr id="29" name="Editable boundary">
             <a:extLst xmlns:a="http://schemas.openxmlformats.org/drawingml/2006/main">
               <a:ext uri="{FF2B5EF4-FFF2-40B4-BE49-F238E27FC236}">
-                <a16:creationId xmlns:a16="http://schemas.microsoft.com/office/drawing/2014/main" id="{68DE0E02-92FB-43D6-A641-1413C9A37CFE}"/>
+                <a16:creationId xmlns:a16="http://schemas.microsoft.com/office/drawing/2014/main" id="{5FF628BB-A7B1-40F4-9ED4-28B63D41F149}"/>
               </a:ext>
             </a:extLst>
           </p:cNvPr>
@@ -6516,11 +6516,11 @@
             <a:avLst/>
           </a:prstGeom>
           <a:solidFill xmlns:a="http://schemas.openxmlformats.org/drawingml/2006/main">
-            <a:srgbClr val="FAFBFD"/>
+            <a:srgbClr val="FAFAFA"/>
           </a:solidFill>
           <a:ln xmlns:a="http://schemas.openxmlformats.org/drawingml/2006/main" w="11430">
             <a:solidFill>
-              <a:srgbClr val="D4DDE6"/>
+              <a:srgbClr val="D0D0D0"/>
             </a:solidFill>
             <a:prstDash val="solid"/>
           </a:ln>
@@ -6531,7 +6531,7 @@
           <p:cNvPr id="30" name="SMT solver / proof assistant">
             <a:extLst xmlns:a="http://schemas.openxmlformats.org/drawingml/2006/main">
               <a:ext uri="{FF2B5EF4-FFF2-40B4-BE49-F238E27FC236}">
-                <a16:creationId xmlns:a16="http://schemas.microsoft.com/office/drawing/2014/main" id="{1E73AF37-C0D0-4AB4-BB12-CBE6A1CBAA0E}"/>
+                <a16:creationId xmlns:a16="http://schemas.microsoft.com/office/drawing/2014/main" id="{45AC98BF-A79E-48DB-94BD-C5BF9F4A7390}"/>
               </a:ext>
             </a:extLst>
           </p:cNvPr>
@@ -6588,7 +6588,7 @@
           <p:cNvPr id="31" name="Editable boundary">
             <a:extLst xmlns:a="http://schemas.openxmlformats.org/drawingml/2006/main">
               <a:ext uri="{FF2B5EF4-FFF2-40B4-BE49-F238E27FC236}">
-                <a16:creationId xmlns:a16="http://schemas.microsoft.com/office/drawing/2014/main" id="{EABD05B6-BD7B-454A-B2AA-932221EE4293}"/>
+                <a16:creationId xmlns:a16="http://schemas.microsoft.com/office/drawing/2014/main" id="{4D0ACE5C-BCC5-4C49-AAA7-CDBFD433CBE8}"/>
               </a:ext>
             </a:extLst>
           </p:cNvPr>
@@ -6606,11 +6606,11 @@
             <a:avLst/>
           </a:prstGeom>
           <a:solidFill xmlns:a="http://schemas.openxmlformats.org/drawingml/2006/main">
-            <a:srgbClr val="FAFBFD"/>
+            <a:srgbClr val="FAFAFA"/>
           </a:solidFill>
           <a:ln xmlns:a="http://schemas.openxmlformats.org/drawingml/2006/main" w="11430">
             <a:solidFill>
-              <a:srgbClr val="D4DDE6"/>
+              <a:srgbClr val="D0D0D0"/>
             </a:solidFill>
             <a:prstDash val="solid"/>
           </a:ln>
@@ -6621,7 +6621,7 @@
           <p:cNvPr id="32" name="Check(proof, O) = valid">
             <a:extLst xmlns:a="http://schemas.openxmlformats.org/drawingml/2006/main">
               <a:ext uri="{FF2B5EF4-FFF2-40B4-BE49-F238E27FC236}">
-                <a16:creationId xmlns:a16="http://schemas.microsoft.com/office/drawing/2014/main" id="{C8B5BF93-6D67-4B7E-914B-141F7AFA2BE2}"/>
+                <a16:creationId xmlns:a16="http://schemas.microsoft.com/office/drawing/2014/main" id="{E9AF4F98-75F7-40C8-B8E1-71F4688B1B08}"/>
               </a:ext>
             </a:extLst>
           </p:cNvPr>
@@ -6678,7 +6678,7 @@
           <p:cNvPr id="33" name="Editable flow path">
             <a:extLst xmlns:a="http://schemas.openxmlformats.org/drawingml/2006/main">
               <a:ext uri="{FF2B5EF4-FFF2-40B4-BE49-F238E27FC236}">
-                <a16:creationId xmlns:a16="http://schemas.microsoft.com/office/drawing/2014/main" id="{F2AF1E6A-07A0-479F-9A9B-D99A1880AA6C}"/>
+                <a16:creationId xmlns:a16="http://schemas.microsoft.com/office/drawing/2014/main" id="{BF4D91B7-9E30-4116-9D29-51EBEDC7EDC1}"/>
               </a:ext>
             </a:extLst>
           </p:cNvPr>
@@ -6724,7 +6724,7 @@
           <p:cNvPr id="34" name="Editable arrowhead">
             <a:extLst xmlns:a="http://schemas.openxmlformats.org/drawingml/2006/main">
               <a:ext uri="{FF2B5EF4-FFF2-40B4-BE49-F238E27FC236}">
-                <a16:creationId xmlns:a16="http://schemas.microsoft.com/office/drawing/2014/main" id="{CE98F0EB-1F1E-491D-A8CB-97283BC3372B}"/>
+                <a16:creationId xmlns:a16="http://schemas.microsoft.com/office/drawing/2014/main" id="{B6F1E8D9-A313-452B-922F-C786446996B9}"/>
               </a:ext>
             </a:extLst>
           </p:cNvPr>
@@ -6767,7 +6767,7 @@
           <p:cNvPr id="35" name="Editable boundary">
             <a:extLst xmlns:a="http://schemas.openxmlformats.org/drawingml/2006/main">
               <a:ext uri="{FF2B5EF4-FFF2-40B4-BE49-F238E27FC236}">
-                <a16:creationId xmlns:a16="http://schemas.microsoft.com/office/drawing/2014/main" id="{29C325D8-3BA2-4CA8-9885-EE01823716BD}"/>
+                <a16:creationId xmlns:a16="http://schemas.microsoft.com/office/drawing/2014/main" id="{FF6E746D-AB4D-42B2-9B4D-6E17BB5BE801}"/>
               </a:ext>
             </a:extLst>
           </p:cNvPr>
@@ -6800,7 +6800,7 @@
           <p:cNvPr id="36" name="Repair">
             <a:extLst xmlns:a="http://schemas.openxmlformats.org/drawingml/2006/main">
               <a:ext uri="{FF2B5EF4-FFF2-40B4-BE49-F238E27FC236}">
-                <a16:creationId xmlns:a16="http://schemas.microsoft.com/office/drawing/2014/main" id="{C6671A6E-D97E-4D7A-AEC3-7BB5FAD98809}"/>
+                <a16:creationId xmlns:a16="http://schemas.microsoft.com/office/drawing/2014/main" id="{CE0C7426-C356-4198-B3BC-E40D4CDBAD42}"/>
               </a:ext>
             </a:extLst>
           </p:cNvPr>
@@ -6857,7 +6857,7 @@
           <p:cNvPr id="37" name="candidate">
             <a:extLst xmlns:a="http://schemas.openxmlformats.org/drawingml/2006/main">
               <a:ext uri="{FF2B5EF4-FFF2-40B4-BE49-F238E27FC236}">
-                <a16:creationId xmlns:a16="http://schemas.microsoft.com/office/drawing/2014/main" id="{3765EE0B-695E-4FC8-B203-B5F4B011120F}"/>
+                <a16:creationId xmlns:a16="http://schemas.microsoft.com/office/drawing/2014/main" id="{576C4DF2-B241-48C4-B138-C60FD2EC4BDA}"/>
               </a:ext>
             </a:extLst>
           </p:cNvPr>
@@ -6914,7 +6914,7 @@
           <p:cNvPr id="38" name="or proof">
             <a:extLst xmlns:a="http://schemas.openxmlformats.org/drawingml/2006/main">
               <a:ext uri="{FF2B5EF4-FFF2-40B4-BE49-F238E27FC236}">
-                <a16:creationId xmlns:a16="http://schemas.microsoft.com/office/drawing/2014/main" id="{2377F9FB-FBCC-4572-BE32-6EC340BBCBCA}"/>
+                <a16:creationId xmlns:a16="http://schemas.microsoft.com/office/drawing/2014/main" id="{45A1AEFD-9933-4824-9C6A-A9A30C2688A2}"/>
               </a:ext>
             </a:extLst>
           </p:cNvPr>
@@ -6971,7 +6971,7 @@
           <p:cNvPr id="39" name="Verification target:">
             <a:extLst xmlns:a="http://schemas.openxmlformats.org/drawingml/2006/main">
               <a:ext uri="{FF2B5EF4-FFF2-40B4-BE49-F238E27FC236}">
-                <a16:creationId xmlns:a16="http://schemas.microsoft.com/office/drawing/2014/main" id="{F9CC4193-3DBF-4C72-9FA1-7F46DA4DC2C6}"/>
+                <a16:creationId xmlns:a16="http://schemas.microsoft.com/office/drawing/2014/main" id="{7C9C9EA8-59EE-48AA-95FC-A79A7B317E24}"/>
               </a:ext>
             </a:extLst>
           </p:cNvPr>
@@ -7028,7 +7028,7 @@
           <p:cNvPr id="40" name="M(x) ⊨ Φ">
             <a:extLst xmlns:a="http://schemas.openxmlformats.org/drawingml/2006/main">
               <a:ext uri="{FF2B5EF4-FFF2-40B4-BE49-F238E27FC236}">
-                <a16:creationId xmlns:a16="http://schemas.microsoft.com/office/drawing/2014/main" id="{51C5DF7D-660E-4181-B99E-1C670368E290}"/>
+                <a16:creationId xmlns:a16="http://schemas.microsoft.com/office/drawing/2014/main" id="{29424F60-4903-4A16-A960-564C6A8EEB81}"/>
               </a:ext>
             </a:extLst>
           </p:cNvPr>
@@ -7085,7 +7085,7 @@
           <p:cNvPr id="41" name="Editable flow path">
             <a:extLst xmlns:a="http://schemas.openxmlformats.org/drawingml/2006/main">
               <a:ext uri="{FF2B5EF4-FFF2-40B4-BE49-F238E27FC236}">
-                <a16:creationId xmlns:a16="http://schemas.microsoft.com/office/drawing/2014/main" id="{954F90DB-F208-4B67-AFE8-A0008A539B9B}"/>
+                <a16:creationId xmlns:a16="http://schemas.microsoft.com/office/drawing/2014/main" id="{0B84E62F-F88D-4866-9B69-7689D3A44908}"/>
               </a:ext>
             </a:extLst>
           </p:cNvPr>
@@ -7125,7 +7125,7 @@
           <p:cNvPr id="42" name="Editable arrowhead">
             <a:extLst xmlns:a="http://schemas.openxmlformats.org/drawingml/2006/main">
               <a:ext uri="{FF2B5EF4-FFF2-40B4-BE49-F238E27FC236}">
-                <a16:creationId xmlns:a16="http://schemas.microsoft.com/office/drawing/2014/main" id="{21E90BE9-636A-4885-922E-95EC6A0509D9}"/>
+                <a16:creationId xmlns:a16="http://schemas.microsoft.com/office/drawing/2014/main" id="{4AA6C07B-BC45-4051-B00E-D80D2D906262}"/>
               </a:ext>
             </a:extLst>
           </p:cNvPr>
@@ -7168,7 +7168,7 @@
           <p:cNvPr id="43" name="Editable boundary">
             <a:extLst xmlns:a="http://schemas.openxmlformats.org/drawingml/2006/main">
               <a:ext uri="{FF2B5EF4-FFF2-40B4-BE49-F238E27FC236}">
-                <a16:creationId xmlns:a16="http://schemas.microsoft.com/office/drawing/2014/main" id="{F529F72B-C45A-41E2-832E-FB65632BD542}"/>
+                <a16:creationId xmlns:a16="http://schemas.microsoft.com/office/drawing/2014/main" id="{BBDB6562-4020-4F12-AF09-807CF8567FCF}"/>
               </a:ext>
             </a:extLst>
           </p:cNvPr>
@@ -7186,7 +7186,7 @@
             <a:avLst/>
           </a:prstGeom>
           <a:solidFill xmlns:a="http://schemas.openxmlformats.org/drawingml/2006/main">
-            <a:srgbClr val="F0F3F6"/>
+            <a:srgbClr val="F8F8F8"/>
           </a:solidFill>
           <a:ln xmlns:a="http://schemas.openxmlformats.org/drawingml/2006/main" w="19050">
             <a:solidFill>
@@ -7201,7 +7201,7 @@
           <p:cNvPr id="44" name="Allow only when ALL hold">
             <a:extLst xmlns:a="http://schemas.openxmlformats.org/drawingml/2006/main">
               <a:ext uri="{FF2B5EF4-FFF2-40B4-BE49-F238E27FC236}">
-                <a16:creationId xmlns:a16="http://schemas.microsoft.com/office/drawing/2014/main" id="{75A8410A-7EEE-4872-B929-962F4999AC10}"/>
+                <a16:creationId xmlns:a16="http://schemas.microsoft.com/office/drawing/2014/main" id="{B421940F-FB8B-41AC-9D05-3C2554021A28}"/>
               </a:ext>
             </a:extLst>
           </p:cNvPr>
@@ -7258,7 +7258,7 @@
           <p:cNvPr id="45" name="Editable boundary">
             <a:extLst xmlns:a="http://schemas.openxmlformats.org/drawingml/2006/main">
               <a:ext uri="{FF2B5EF4-FFF2-40B4-BE49-F238E27FC236}">
-                <a16:creationId xmlns:a16="http://schemas.microsoft.com/office/drawing/2014/main" id="{BEFE47ED-799A-472B-8975-1E2595B9D44A}"/>
+                <a16:creationId xmlns:a16="http://schemas.microsoft.com/office/drawing/2014/main" id="{9A4D46A1-1103-4446-9470-9423FDAB24A3}"/>
               </a:ext>
             </a:extLst>
           </p:cNvPr>
@@ -7276,11 +7276,11 @@
             <a:avLst/>
           </a:prstGeom>
           <a:solidFill xmlns:a="http://schemas.openxmlformats.org/drawingml/2006/main">
-            <a:srgbClr val="FAFBFD"/>
+            <a:srgbClr val="FAFAFA"/>
           </a:solidFill>
           <a:ln xmlns:a="http://schemas.openxmlformats.org/drawingml/2006/main" w="11430">
             <a:solidFill>
-              <a:srgbClr val="D4DDE6"/>
+              <a:srgbClr val="D0D0D0"/>
             </a:solidFill>
             <a:prstDash val="solid"/>
           </a:ln>
@@ -7291,7 +7291,7 @@
           <p:cNvPr id="46" name="Proof accepted">
             <a:extLst xmlns:a="http://schemas.openxmlformats.org/drawingml/2006/main">
               <a:ext uri="{FF2B5EF4-FFF2-40B4-BE49-F238E27FC236}">
-                <a16:creationId xmlns:a16="http://schemas.microsoft.com/office/drawing/2014/main" id="{C5078EED-8868-4232-8787-49EE71E1D9D3}"/>
+                <a16:creationId xmlns:a16="http://schemas.microsoft.com/office/drawing/2014/main" id="{46C828C2-709A-40EA-A1B6-40238FC2ACE7}"/>
               </a:ext>
             </a:extLst>
           </p:cNvPr>
@@ -7348,7 +7348,7 @@
           <p:cNvPr id="47" name="Editable boundary">
             <a:extLst xmlns:a="http://schemas.openxmlformats.org/drawingml/2006/main">
               <a:ext uri="{FF2B5EF4-FFF2-40B4-BE49-F238E27FC236}">
-                <a16:creationId xmlns:a16="http://schemas.microsoft.com/office/drawing/2014/main" id="{187A9547-2C39-4293-8ED2-40EC03D6D728}"/>
+                <a16:creationId xmlns:a16="http://schemas.microsoft.com/office/drawing/2014/main" id="{F5443715-1B42-40FA-86E1-C0B031F0C13F}"/>
               </a:ext>
             </a:extLst>
           </p:cNvPr>
@@ -7366,11 +7366,11 @@
             <a:avLst/>
           </a:prstGeom>
           <a:solidFill xmlns:a="http://schemas.openxmlformats.org/drawingml/2006/main">
-            <a:srgbClr val="FAFBFD"/>
+            <a:srgbClr val="FAFAFA"/>
           </a:solidFill>
           <a:ln xmlns:a="http://schemas.openxmlformats.org/drawingml/2006/main" w="11430">
             <a:solidFill>
-              <a:srgbClr val="D4DDE6"/>
+              <a:srgbClr val="D0D0D0"/>
             </a:solidFill>
             <a:prstDash val="solid"/>
           </a:ln>
@@ -7381,7 +7381,7 @@
           <p:cNvPr id="48" name="Artifact, model, spec match proof">
             <a:extLst xmlns:a="http://schemas.openxmlformats.org/drawingml/2006/main">
               <a:ext uri="{FF2B5EF4-FFF2-40B4-BE49-F238E27FC236}">
-                <a16:creationId xmlns:a16="http://schemas.microsoft.com/office/drawing/2014/main" id="{EE865201-5942-4027-9CD4-90639369FFAD}"/>
+                <a16:creationId xmlns:a16="http://schemas.microsoft.com/office/drawing/2014/main" id="{B172B2EF-44AD-492F-AE18-9E2F6E05C7CD}"/>
               </a:ext>
             </a:extLst>
           </p:cNvPr>
@@ -7438,7 +7438,7 @@
           <p:cNvPr id="49" name="Editable boundary">
             <a:extLst xmlns:a="http://schemas.openxmlformats.org/drawingml/2006/main">
               <a:ext uri="{FF2B5EF4-FFF2-40B4-BE49-F238E27FC236}">
-                <a16:creationId xmlns:a16="http://schemas.microsoft.com/office/drawing/2014/main" id="{EA4ADF8A-8142-4638-B9C0-C68703FB111A}"/>
+                <a16:creationId xmlns:a16="http://schemas.microsoft.com/office/drawing/2014/main" id="{067B96D6-B97F-41B7-B247-A323E6EE25F9}"/>
               </a:ext>
             </a:extLst>
           </p:cNvPr>
@@ -7456,11 +7456,11 @@
             <a:avLst/>
           </a:prstGeom>
           <a:solidFill xmlns:a="http://schemas.openxmlformats.org/drawingml/2006/main">
-            <a:srgbClr val="FAFBFD"/>
+            <a:srgbClr val="FAFAFA"/>
           </a:solidFill>
           <a:ln xmlns:a="http://schemas.openxmlformats.org/drawingml/2006/main" w="11430">
             <a:solidFill>
-              <a:srgbClr val="D4DDE6"/>
+              <a:srgbClr val="D0D0D0"/>
             </a:solidFill>
             <a:prstDash val="solid"/>
           </a:ln>
@@ -7471,7 +7471,7 @@
           <p:cNvPr id="50" name="Permission valid at execution">
             <a:extLst xmlns:a="http://schemas.openxmlformats.org/drawingml/2006/main">
               <a:ext uri="{FF2B5EF4-FFF2-40B4-BE49-F238E27FC236}">
-                <a16:creationId xmlns:a16="http://schemas.microsoft.com/office/drawing/2014/main" id="{D30F372D-ECDC-4F6F-8D1D-8C7327D591CA}"/>
+                <a16:creationId xmlns:a16="http://schemas.microsoft.com/office/drawing/2014/main" id="{FB03712E-25D2-4F94-A526-8AB69B90D7F4}"/>
               </a:ext>
             </a:extLst>
           </p:cNvPr>
@@ -7528,7 +7528,7 @@
           <p:cNvPr id="51" name="Editable boundary">
             <a:extLst xmlns:a="http://schemas.openxmlformats.org/drawingml/2006/main">
               <a:ext uri="{FF2B5EF4-FFF2-40B4-BE49-F238E27FC236}">
-                <a16:creationId xmlns:a16="http://schemas.microsoft.com/office/drawing/2014/main" id="{D4B439D2-8FB8-489F-94C9-DF9A59861628}"/>
+                <a16:creationId xmlns:a16="http://schemas.microsoft.com/office/drawing/2014/main" id="{8D13E184-A75C-4B71-9E22-2AFF0B7A8CFB}"/>
               </a:ext>
             </a:extLst>
           </p:cNvPr>
@@ -7546,11 +7546,11 @@
             <a:avLst/>
           </a:prstGeom>
           <a:solidFill xmlns:a="http://schemas.openxmlformats.org/drawingml/2006/main">
-            <a:srgbClr val="FAFBFD"/>
+            <a:srgbClr val="FAFAFA"/>
           </a:solidFill>
           <a:ln xmlns:a="http://schemas.openxmlformats.org/drawingml/2006/main" w="11430">
             <a:solidFill>
-              <a:srgbClr val="D4DDE6"/>
+              <a:srgbClr val="D0D0D0"/>
             </a:solidFill>
             <a:prstDash val="solid"/>
           </a:ln>
@@ -7561,7 +7561,7 @@
           <p:cNvPr id="52" name="Model assumptions still hold">
             <a:extLst xmlns:a="http://schemas.openxmlformats.org/drawingml/2006/main">
               <a:ext uri="{FF2B5EF4-FFF2-40B4-BE49-F238E27FC236}">
-                <a16:creationId xmlns:a16="http://schemas.microsoft.com/office/drawing/2014/main" id="{3DCB7ABD-0589-4D61-B884-39517DD5CB39}"/>
+                <a16:creationId xmlns:a16="http://schemas.microsoft.com/office/drawing/2014/main" id="{8BA86189-4ED4-4EC7-B282-E8CC0337B62A}"/>
               </a:ext>
             </a:extLst>
           </p:cNvPr>
@@ -7618,7 +7618,7 @@
           <p:cNvPr id="53" name="Editable flow path">
             <a:extLst xmlns:a="http://schemas.openxmlformats.org/drawingml/2006/main">
               <a:ext uri="{FF2B5EF4-FFF2-40B4-BE49-F238E27FC236}">
-                <a16:creationId xmlns:a16="http://schemas.microsoft.com/office/drawing/2014/main" id="{6A5CBEDA-BD1A-49B5-96A0-6B009461EC66}"/>
+                <a16:creationId xmlns:a16="http://schemas.microsoft.com/office/drawing/2014/main" id="{963DBFA5-865F-472F-BE8E-6E1F830E69C8}"/>
               </a:ext>
             </a:extLst>
           </p:cNvPr>
@@ -7658,7 +7658,7 @@
           <p:cNvPr id="54" name="Editable flow path">
             <a:extLst xmlns:a="http://schemas.openxmlformats.org/drawingml/2006/main">
               <a:ext uri="{FF2B5EF4-FFF2-40B4-BE49-F238E27FC236}">
-                <a16:creationId xmlns:a16="http://schemas.microsoft.com/office/drawing/2014/main" id="{84EF29DF-5931-4EFD-A84E-70CAE4977974}"/>
+                <a16:creationId xmlns:a16="http://schemas.microsoft.com/office/drawing/2014/main" id="{7453FA4B-552A-4176-97F0-5A3C5A5C1CD5}"/>
               </a:ext>
             </a:extLst>
           </p:cNvPr>
@@ -7701,7 +7701,7 @@
           <p:cNvPr id="55" name="Editable arrowhead">
             <a:extLst xmlns:a="http://schemas.openxmlformats.org/drawingml/2006/main">
               <a:ext uri="{FF2B5EF4-FFF2-40B4-BE49-F238E27FC236}">
-                <a16:creationId xmlns:a16="http://schemas.microsoft.com/office/drawing/2014/main" id="{8252C54B-C83A-45D8-923F-9E2276435A6F}"/>
+                <a16:creationId xmlns:a16="http://schemas.microsoft.com/office/drawing/2014/main" id="{8811E227-69C7-4C2F-9C3B-893CC258D22D}"/>
               </a:ext>
             </a:extLst>
           </p:cNvPr>
@@ -7744,7 +7744,7 @@
           <p:cNvPr id="56" name="Editable flow path">
             <a:extLst xmlns:a="http://schemas.openxmlformats.org/drawingml/2006/main">
               <a:ext uri="{FF2B5EF4-FFF2-40B4-BE49-F238E27FC236}">
-                <a16:creationId xmlns:a16="http://schemas.microsoft.com/office/drawing/2014/main" id="{7B593EAA-D26A-4C4E-9143-583A94C4D652}"/>
+                <a16:creationId xmlns:a16="http://schemas.microsoft.com/office/drawing/2014/main" id="{BC7D919A-8825-42E2-9D09-73BB5EC10AD8}"/>
               </a:ext>
             </a:extLst>
           </p:cNvPr>
@@ -7787,7 +7787,7 @@
           <p:cNvPr id="57" name="Editable arrowhead">
             <a:extLst xmlns:a="http://schemas.openxmlformats.org/drawingml/2006/main">
               <a:ext uri="{FF2B5EF4-FFF2-40B4-BE49-F238E27FC236}">
-                <a16:creationId xmlns:a16="http://schemas.microsoft.com/office/drawing/2014/main" id="{35C3F34D-BFE7-4E05-A6DE-4CF5A28BB946}"/>
+                <a16:creationId xmlns:a16="http://schemas.microsoft.com/office/drawing/2014/main" id="{A1FE9789-949D-43E1-B5F6-DA1D772F8436}"/>
               </a:ext>
             </a:extLst>
           </p:cNvPr>
@@ -7830,7 +7830,7 @@
           <p:cNvPr id="58" name="all true">
             <a:extLst xmlns:a="http://schemas.openxmlformats.org/drawingml/2006/main">
               <a:ext uri="{FF2B5EF4-FFF2-40B4-BE49-F238E27FC236}">
-                <a16:creationId xmlns:a16="http://schemas.microsoft.com/office/drawing/2014/main" id="{BC3C399C-DA80-4DDF-91A8-6BAE5839186B}"/>
+                <a16:creationId xmlns:a16="http://schemas.microsoft.com/office/drawing/2014/main" id="{9BDD81C0-38A7-4501-BDB5-DCA8404D9CC3}"/>
               </a:ext>
             </a:extLst>
           </p:cNvPr>
@@ -7887,7 +7887,7 @@
           <p:cNvPr id="59" name="false or unknown">
             <a:extLst xmlns:a="http://schemas.openxmlformats.org/drawingml/2006/main">
               <a:ext uri="{FF2B5EF4-FFF2-40B4-BE49-F238E27FC236}">
-                <a16:creationId xmlns:a16="http://schemas.microsoft.com/office/drawing/2014/main" id="{0F7DC4DC-508E-4BC1-8441-E5F7866C5725}"/>
+                <a16:creationId xmlns:a16="http://schemas.microsoft.com/office/drawing/2014/main" id="{09AEDB00-973A-4B5D-A762-5C90F21CCFCA}"/>
               </a:ext>
             </a:extLst>
           </p:cNvPr>
@@ -7944,7 +7944,7 @@
           <p:cNvPr id="60" name="Editable boundary">
             <a:extLst xmlns:a="http://schemas.openxmlformats.org/drawingml/2006/main">
               <a:ext uri="{FF2B5EF4-FFF2-40B4-BE49-F238E27FC236}">
-                <a16:creationId xmlns:a16="http://schemas.microsoft.com/office/drawing/2014/main" id="{937C5C9B-1843-4B01-AF11-974257784D34}"/>
+                <a16:creationId xmlns:a16="http://schemas.microsoft.com/office/drawing/2014/main" id="{3350543A-39DC-4656-AAF5-C354CD41C8C2}"/>
               </a:ext>
             </a:extLst>
           </p:cNvPr>
@@ -7962,7 +7962,7 @@
             <a:avLst/>
           </a:prstGeom>
           <a:solidFill xmlns:a="http://schemas.openxmlformats.org/drawingml/2006/main">
-            <a:srgbClr val="F0F3F6"/>
+            <a:srgbClr val="F8F8F8"/>
           </a:solidFill>
           <a:ln xmlns:a="http://schemas.openxmlformats.org/drawingml/2006/main" w="19050">
             <a:solidFill>
@@ -7977,7 +7977,7 @@
           <p:cNvPr id="61" name="Editable boundary">
             <a:extLst xmlns:a="http://schemas.openxmlformats.org/drawingml/2006/main">
               <a:ext uri="{FF2B5EF4-FFF2-40B4-BE49-F238E27FC236}">
-                <a16:creationId xmlns:a16="http://schemas.microsoft.com/office/drawing/2014/main" id="{7044D630-02F4-4FFA-9C41-E79BA99CDCE1}"/>
+                <a16:creationId xmlns:a16="http://schemas.microsoft.com/office/drawing/2014/main" id="{95A7DD81-FA4D-41E4-99D6-BCCB0442C22A}"/>
               </a:ext>
             </a:extLst>
           </p:cNvPr>
@@ -7995,7 +7995,7 @@
             <a:avLst/>
           </a:prstGeom>
           <a:solidFill xmlns:a="http://schemas.openxmlformats.org/drawingml/2006/main">
-            <a:srgbClr val="F0F3F6"/>
+            <a:srgbClr val="F8F8F8"/>
           </a:solidFill>
           <a:ln xmlns:a="http://schemas.openxmlformats.org/drawingml/2006/main" w="19050">
             <a:solidFill>
@@ -8010,7 +8010,7 @@
           <p:cNvPr id="62" name="Execute">
             <a:extLst xmlns:a="http://schemas.openxmlformats.org/drawingml/2006/main">
               <a:ext uri="{FF2B5EF4-FFF2-40B4-BE49-F238E27FC236}">
-                <a16:creationId xmlns:a16="http://schemas.microsoft.com/office/drawing/2014/main" id="{6ACE10DD-A875-4E9D-A3F0-DBBC89B5D096}"/>
+                <a16:creationId xmlns:a16="http://schemas.microsoft.com/office/drawing/2014/main" id="{9F14E297-BDCD-4B89-82A3-F9336AB72776}"/>
               </a:ext>
             </a:extLst>
           </p:cNvPr>
@@ -8067,7 +8067,7 @@
           <p:cNvPr id="63" name="Defer / review">
             <a:extLst xmlns:a="http://schemas.openxmlformats.org/drawingml/2006/main">
               <a:ext uri="{FF2B5EF4-FFF2-40B4-BE49-F238E27FC236}">
-                <a16:creationId xmlns:a16="http://schemas.microsoft.com/office/drawing/2014/main" id="{8EB9C09F-F5FC-4292-A9F0-E21F3358A776}"/>
+                <a16:creationId xmlns:a16="http://schemas.microsoft.com/office/drawing/2014/main" id="{88078208-AFAE-4363-84DD-4ACC91755FEC}"/>
               </a:ext>
             </a:extLst>
           </p:cNvPr>
@@ -8124,7 +8124,7 @@
           <p:cNvPr id="64" name="Enforce through trusted controls.">
             <a:extLst xmlns:a="http://schemas.openxmlformats.org/drawingml/2006/main">
               <a:ext uri="{FF2B5EF4-FFF2-40B4-BE49-F238E27FC236}">
-                <a16:creationId xmlns:a16="http://schemas.microsoft.com/office/drawing/2014/main" id="{C1CE297F-5207-4721-8517-365A4724067B}"/>
+                <a16:creationId xmlns:a16="http://schemas.microsoft.com/office/drawing/2014/main" id="{0F741154-7828-4B02-80D6-A0945AA7575F}"/>
               </a:ext>
             </a:extLst>
           </p:cNvPr>
@@ -8181,7 +8181,7 @@
           <p:cNvPr id="65" name="Assurance requires faithful models, sound proof checking, and tr">
             <a:extLst xmlns:a="http://schemas.openxmlformats.org/drawingml/2006/main">
               <a:ext uri="{FF2B5EF4-FFF2-40B4-BE49-F238E27FC236}">
-                <a16:creationId xmlns:a16="http://schemas.microsoft.com/office/drawing/2014/main" id="{B5BD9118-BD2A-497E-B3B2-E99D6869420F}"/>
+                <a16:creationId xmlns:a16="http://schemas.microsoft.com/office/drawing/2014/main" id="{D762998B-191C-4B1D-AAE4-2E034656F1CD}"/>
               </a:ext>
             </a:extLst>
           </p:cNvPr>
@@ -8236,7 +8236,7 @@
     </p:spTree>
     <p:extLst>
       <p:ext uri="{BB962C8B-B14F-4D97-AF65-F5344CB8AC3E}">
-        <p14:creationId xmlns:p14="http://schemas.microsoft.com/office/powerpoint/2010/main" val="1248138567"/>
+        <p14:creationId xmlns:p14="http://schemas.microsoft.com/office/powerpoint/2010/main" val="251440990"/>
       </p:ext>
     </p:extLst>
   </p:cSld>
@@ -8267,7 +8267,7 @@
           <p:cNvPr id="79" name="Preserving Safety Through Continual Updates">
             <a:extLst xmlns:a="http://schemas.openxmlformats.org/drawingml/2006/main">
               <a:ext uri="{FF2B5EF4-FFF2-40B4-BE49-F238E27FC236}">
-                <a16:creationId xmlns:a16="http://schemas.microsoft.com/office/drawing/2014/main" id="{325AA68D-92A9-4F15-B767-3BCA2C5D5952}"/>
+                <a16:creationId xmlns:a16="http://schemas.microsoft.com/office/drawing/2014/main" id="{8D3994EC-5EC8-42C2-92A1-41B4AB13D2D5}"/>
               </a:ext>
             </a:extLst>
           </p:cNvPr>
@@ -8324,7 +8324,7 @@
           <p:cNvPr id="2" name="LLM or harness changes can invalidate existing guardrails">
             <a:extLst xmlns:a="http://schemas.openxmlformats.org/drawingml/2006/main">
               <a:ext uri="{FF2B5EF4-FFF2-40B4-BE49-F238E27FC236}">
-                <a16:creationId xmlns:a16="http://schemas.microsoft.com/office/drawing/2014/main" id="{03A587A0-DE3E-413D-A166-CAA3E9012A03}"/>
+                <a16:creationId xmlns:a16="http://schemas.microsoft.com/office/drawing/2014/main" id="{2B11B677-4738-4E02-BEF9-8A41A534F081}"/>
               </a:ext>
             </a:extLst>
           </p:cNvPr>
@@ -8381,7 +8381,7 @@
           <p:cNvPr id="3" name="Editable boundary">
             <a:extLst xmlns:a="http://schemas.openxmlformats.org/drawingml/2006/main">
               <a:ext uri="{FF2B5EF4-FFF2-40B4-BE49-F238E27FC236}">
-                <a16:creationId xmlns:a16="http://schemas.microsoft.com/office/drawing/2014/main" id="{D9EA934F-DF64-4F7B-95A4-0A6BE7A2E4C0}"/>
+                <a16:creationId xmlns:a16="http://schemas.microsoft.com/office/drawing/2014/main" id="{B9193F22-30A2-4E4D-B317-8A6D3ABFE8D3}"/>
               </a:ext>
             </a:extLst>
           </p:cNvPr>
@@ -8414,7 +8414,7 @@
           <p:cNvPr id="4" name="Editable boundary">
             <a:extLst xmlns:a="http://schemas.openxmlformats.org/drawingml/2006/main">
               <a:ext uri="{FF2B5EF4-FFF2-40B4-BE49-F238E27FC236}">
-                <a16:creationId xmlns:a16="http://schemas.microsoft.com/office/drawing/2014/main" id="{AC361568-7DC5-4C4F-8411-6BA29E9689C9}"/>
+                <a16:creationId xmlns:a16="http://schemas.microsoft.com/office/drawing/2014/main" id="{22841B00-AA3F-488C-89F9-87743E6AA312}"/>
               </a:ext>
             </a:extLst>
           </p:cNvPr>
@@ -8447,7 +8447,7 @@
           <p:cNvPr id="5" name="Editable boundary">
             <a:extLst xmlns:a="http://schemas.openxmlformats.org/drawingml/2006/main">
               <a:ext uri="{FF2B5EF4-FFF2-40B4-BE49-F238E27FC236}">
-                <a16:creationId xmlns:a16="http://schemas.microsoft.com/office/drawing/2014/main" id="{3C435080-D30C-4E7A-A26D-929976A18E8B}"/>
+                <a16:creationId xmlns:a16="http://schemas.microsoft.com/office/drawing/2014/main" id="{02337090-85BE-460C-A76A-CECC325F7CFE}"/>
               </a:ext>
             </a:extLst>
           </p:cNvPr>
@@ -8480,7 +8480,7 @@
           <p:cNvPr id="6" name="Editable boundary">
             <a:extLst xmlns:a="http://schemas.openxmlformats.org/drawingml/2006/main">
               <a:ext uri="{FF2B5EF4-FFF2-40B4-BE49-F238E27FC236}">
-                <a16:creationId xmlns:a16="http://schemas.microsoft.com/office/drawing/2014/main" id="{CF4EF305-4FFF-484F-8D15-5EDB0DC1393D}"/>
+                <a16:creationId xmlns:a16="http://schemas.microsoft.com/office/drawing/2014/main" id="{D6B1F57C-8443-4588-83DE-68E224A6555E}"/>
               </a:ext>
             </a:extLst>
           </p:cNvPr>
@@ -8513,7 +8513,7 @@
           <p:cNvPr id="7" name="1">
             <a:extLst xmlns:a="http://schemas.openxmlformats.org/drawingml/2006/main">
               <a:ext uri="{FF2B5EF4-FFF2-40B4-BE49-F238E27FC236}">
-                <a16:creationId xmlns:a16="http://schemas.microsoft.com/office/drawing/2014/main" id="{721511CD-0744-4D1C-8D91-4E64BDB7CD69}"/>
+                <a16:creationId xmlns:a16="http://schemas.microsoft.com/office/drawing/2014/main" id="{F96D3AB9-8404-4AA1-94F3-88046CE5ACB8}"/>
               </a:ext>
             </a:extLst>
           </p:cNvPr>
@@ -8570,7 +8570,7 @@
           <p:cNvPr id="8" name="Propose Δ">
             <a:extLst xmlns:a="http://schemas.openxmlformats.org/drawingml/2006/main">
               <a:ext uri="{FF2B5EF4-FFF2-40B4-BE49-F238E27FC236}">
-                <a16:creationId xmlns:a16="http://schemas.microsoft.com/office/drawing/2014/main" id="{E2B0B7F3-A23E-4698-8B89-1311FF3DCE9F}"/>
+                <a16:creationId xmlns:a16="http://schemas.microsoft.com/office/drawing/2014/main" id="{D42BD1EC-57BC-4826-BFC9-B3C6CE3DF571}"/>
               </a:ext>
             </a:extLst>
           </p:cNvPr>
@@ -8627,7 +8627,7 @@
           <p:cNvPr id="9" name="Editable boundary">
             <a:extLst xmlns:a="http://schemas.openxmlformats.org/drawingml/2006/main">
               <a:ext uri="{FF2B5EF4-FFF2-40B4-BE49-F238E27FC236}">
-                <a16:creationId xmlns:a16="http://schemas.microsoft.com/office/drawing/2014/main" id="{61B32309-A9E1-4E19-89A6-5E3264310F34}"/>
+                <a16:creationId xmlns:a16="http://schemas.microsoft.com/office/drawing/2014/main" id="{49C2FA90-E5DE-4EC7-8312-8451789EBA8A}"/>
               </a:ext>
             </a:extLst>
           </p:cNvPr>
@@ -8660,7 +8660,7 @@
           <p:cNvPr id="10" name="2">
             <a:extLst xmlns:a="http://schemas.openxmlformats.org/drawingml/2006/main">
               <a:ext uri="{FF2B5EF4-FFF2-40B4-BE49-F238E27FC236}">
-                <a16:creationId xmlns:a16="http://schemas.microsoft.com/office/drawing/2014/main" id="{5A7F782C-F7FD-4A83-807C-65796D77A99D}"/>
+                <a16:creationId xmlns:a16="http://schemas.microsoft.com/office/drawing/2014/main" id="{34AD8980-9A6A-4827-B195-6584672981B3}"/>
               </a:ext>
             </a:extLst>
           </p:cNvPr>
@@ -8717,7 +8717,7 @@
           <p:cNvPr id="11" name="Revalidate protection">
             <a:extLst xmlns:a="http://schemas.openxmlformats.org/drawingml/2006/main">
               <a:ext uri="{FF2B5EF4-FFF2-40B4-BE49-F238E27FC236}">
-                <a16:creationId xmlns:a16="http://schemas.microsoft.com/office/drawing/2014/main" id="{83DBA3C9-73D3-4905-A8ED-1FC7049C9469}"/>
+                <a16:creationId xmlns:a16="http://schemas.microsoft.com/office/drawing/2014/main" id="{58D7C1B5-0A05-4AEF-AEB0-7942A9FCC03C}"/>
               </a:ext>
             </a:extLst>
           </p:cNvPr>
@@ -8774,7 +8774,7 @@
           <p:cNvPr id="12" name="Editable boundary">
             <a:extLst xmlns:a="http://schemas.openxmlformats.org/drawingml/2006/main">
               <a:ext uri="{FF2B5EF4-FFF2-40B4-BE49-F238E27FC236}">
-                <a16:creationId xmlns:a16="http://schemas.microsoft.com/office/drawing/2014/main" id="{ED068292-826C-48CF-8B63-53159B737583}"/>
+                <a16:creationId xmlns:a16="http://schemas.microsoft.com/office/drawing/2014/main" id="{EE49E6D9-06AB-45EF-9D69-BD7D918D6AF4}"/>
               </a:ext>
             </a:extLst>
           </p:cNvPr>
@@ -8807,7 +8807,7 @@
           <p:cNvPr id="13" name="3">
             <a:extLst xmlns:a="http://schemas.openxmlformats.org/drawingml/2006/main">
               <a:ext uri="{FF2B5EF4-FFF2-40B4-BE49-F238E27FC236}">
-                <a16:creationId xmlns:a16="http://schemas.microsoft.com/office/drawing/2014/main" id="{17ED77CB-FD35-4CC4-ADD3-633D0371A2DB}"/>
+                <a16:creationId xmlns:a16="http://schemas.microsoft.com/office/drawing/2014/main" id="{EF738ADD-410E-42D7-AD2D-44C2D1569181}"/>
               </a:ext>
             </a:extLst>
           </p:cNvPr>
@@ -8864,7 +8864,7 @@
           <p:cNvPr id="14" name="Apply validated Δ">
             <a:extLst xmlns:a="http://schemas.openxmlformats.org/drawingml/2006/main">
               <a:ext uri="{FF2B5EF4-FFF2-40B4-BE49-F238E27FC236}">
-                <a16:creationId xmlns:a16="http://schemas.microsoft.com/office/drawing/2014/main" id="{0183D046-B847-4E4B-973B-28F163362A36}"/>
+                <a16:creationId xmlns:a16="http://schemas.microsoft.com/office/drawing/2014/main" id="{74EB9348-D7F7-4FAF-AE18-01CE6DF5FD04}"/>
               </a:ext>
             </a:extLst>
           </p:cNvPr>
@@ -8921,7 +8921,7 @@
           <p:cNvPr id="15" name="Editable boundary">
             <a:extLst xmlns:a="http://schemas.openxmlformats.org/drawingml/2006/main">
               <a:ext uri="{FF2B5EF4-FFF2-40B4-BE49-F238E27FC236}">
-                <a16:creationId xmlns:a16="http://schemas.microsoft.com/office/drawing/2014/main" id="{D0A13B81-AF86-4878-804A-D62DA05F5A3E}"/>
+                <a16:creationId xmlns:a16="http://schemas.microsoft.com/office/drawing/2014/main" id="{92A456FF-DB90-47B6-8714-FDB127B9EF3B}"/>
               </a:ext>
             </a:extLst>
           </p:cNvPr>
@@ -8939,7 +8939,7 @@
             <a:avLst/>
           </a:prstGeom>
           <a:solidFill xmlns:a="http://schemas.openxmlformats.org/drawingml/2006/main">
-            <a:srgbClr val="F7F7F7"/>
+            <a:srgbClr val="F8F8F8"/>
           </a:solidFill>
           <a:ln xmlns:a="http://schemas.openxmlformats.org/drawingml/2006/main" w="19050">
             <a:solidFill>
@@ -8954,7 +8954,7 @@
           <p:cNvPr id="16" name="Current system">
             <a:extLst xmlns:a="http://schemas.openxmlformats.org/drawingml/2006/main">
               <a:ext uri="{FF2B5EF4-FFF2-40B4-BE49-F238E27FC236}">
-                <a16:creationId xmlns:a16="http://schemas.microsoft.com/office/drawing/2014/main" id="{40959F5F-7BAD-4715-915D-FBF149B29197}"/>
+                <a16:creationId xmlns:a16="http://schemas.microsoft.com/office/drawing/2014/main" id="{44A60951-BDC7-498A-9233-8C47532E5A75}"/>
               </a:ext>
             </a:extLst>
           </p:cNvPr>
@@ -9011,7 +9011,7 @@
           <p:cNvPr id="17" name="Sₜ = (Lₜ, Hₜ)">
             <a:extLst xmlns:a="http://schemas.openxmlformats.org/drawingml/2006/main">
               <a:ext uri="{FF2B5EF4-FFF2-40B4-BE49-F238E27FC236}">
-                <a16:creationId xmlns:a16="http://schemas.microsoft.com/office/drawing/2014/main" id="{F06D3537-3B7A-417C-9E82-9E50F2280548}"/>
+                <a16:creationId xmlns:a16="http://schemas.microsoft.com/office/drawing/2014/main" id="{84812984-E448-4047-AC42-4DE595626F71}"/>
               </a:ext>
             </a:extLst>
           </p:cNvPr>
@@ -9068,7 +9068,7 @@
           <p:cNvPr id="18" name="LLM + harness, including guardrails">
             <a:extLst xmlns:a="http://schemas.openxmlformats.org/drawingml/2006/main">
               <a:ext uri="{FF2B5EF4-FFF2-40B4-BE49-F238E27FC236}">
-                <a16:creationId xmlns:a16="http://schemas.microsoft.com/office/drawing/2014/main" id="{68BC2EE0-39A2-489A-921F-9300EE76F282}"/>
+                <a16:creationId xmlns:a16="http://schemas.microsoft.com/office/drawing/2014/main" id="{44444844-1155-4D06-9A2B-D3F8AE0AB1EC}"/>
               </a:ext>
             </a:extLst>
           </p:cNvPr>
@@ -9125,7 +9125,7 @@
           <p:cNvPr id="19" name="Editable boundary">
             <a:extLst xmlns:a="http://schemas.openxmlformats.org/drawingml/2006/main">
               <a:ext uri="{FF2B5EF4-FFF2-40B4-BE49-F238E27FC236}">
-                <a16:creationId xmlns:a16="http://schemas.microsoft.com/office/drawing/2014/main" id="{DE86F532-4469-45BF-AF0A-EC59998762E4}"/>
+                <a16:creationId xmlns:a16="http://schemas.microsoft.com/office/drawing/2014/main" id="{54DE0AA2-F3CA-48B8-8657-78A098B18AB8}"/>
               </a:ext>
             </a:extLst>
           </p:cNvPr>
@@ -9143,7 +9143,7 @@
             <a:avLst/>
           </a:prstGeom>
           <a:solidFill xmlns:a="http://schemas.openxmlformats.org/drawingml/2006/main">
-            <a:srgbClr val="F7F7F7"/>
+            <a:srgbClr val="F8F8F8"/>
           </a:solidFill>
           <a:ln xmlns:a="http://schemas.openxmlformats.org/drawingml/2006/main" w="19050">
             <a:solidFill>
@@ -9158,7 +9158,7 @@
           <p:cNvPr id="20" name="LLM learning">
             <a:extLst xmlns:a="http://schemas.openxmlformats.org/drawingml/2006/main">
               <a:ext uri="{FF2B5EF4-FFF2-40B4-BE49-F238E27FC236}">
-                <a16:creationId xmlns:a16="http://schemas.microsoft.com/office/drawing/2014/main" id="{B30F6176-5DC3-4CD6-A2B6-82AA53363674}"/>
+                <a16:creationId xmlns:a16="http://schemas.microsoft.com/office/drawing/2014/main" id="{7FADEC1C-BF38-48A8-8700-8672E2469278}"/>
               </a:ext>
             </a:extLst>
           </p:cNvPr>
@@ -9215,7 +9215,7 @@
           <p:cNvPr id="21" name="Paired authorized tasks">
             <a:extLst xmlns:a="http://schemas.openxmlformats.org/drawingml/2006/main">
               <a:ext uri="{FF2B5EF4-FFF2-40B4-BE49-F238E27FC236}">
-                <a16:creationId xmlns:a16="http://schemas.microsoft.com/office/drawing/2014/main" id="{7BF953FE-0409-4E65-9C02-2774EF4921BF}"/>
+                <a16:creationId xmlns:a16="http://schemas.microsoft.com/office/drawing/2014/main" id="{3EDB53E7-EF49-4C03-9A38-6BAB04B00741}"/>
               </a:ext>
             </a:extLst>
           </p:cNvPr>
@@ -9272,7 +9272,7 @@
           <p:cNvPr id="22" name="Editable boundary">
             <a:extLst xmlns:a="http://schemas.openxmlformats.org/drawingml/2006/main">
               <a:ext uri="{FF2B5EF4-FFF2-40B4-BE49-F238E27FC236}">
-                <a16:creationId xmlns:a16="http://schemas.microsoft.com/office/drawing/2014/main" id="{43C6864F-A53B-40A1-8BCD-8ADF5FFC1463}"/>
+                <a16:creationId xmlns:a16="http://schemas.microsoft.com/office/drawing/2014/main" id="{6BE4961B-04F1-4F70-ABEF-488FA540701F}"/>
               </a:ext>
             </a:extLst>
           </p:cNvPr>
@@ -9290,7 +9290,7 @@
             <a:avLst/>
           </a:prstGeom>
           <a:solidFill xmlns:a="http://schemas.openxmlformats.org/drawingml/2006/main">
-            <a:srgbClr val="F7F7F7"/>
+            <a:srgbClr val="F8F8F8"/>
           </a:solidFill>
           <a:ln xmlns:a="http://schemas.openxmlformats.org/drawingml/2006/main" w="19050">
             <a:solidFill>
@@ -9305,7 +9305,7 @@
           <p:cNvPr id="23" name="Harness upgrades">
             <a:extLst xmlns:a="http://schemas.openxmlformats.org/drawingml/2006/main">
               <a:ext uri="{FF2B5EF4-FFF2-40B4-BE49-F238E27FC236}">
-                <a16:creationId xmlns:a16="http://schemas.microsoft.com/office/drawing/2014/main" id="{EC2755A9-D291-4AF8-8144-F3331A6D2B35}"/>
+                <a16:creationId xmlns:a16="http://schemas.microsoft.com/office/drawing/2014/main" id="{9131DD75-1482-45DA-A1CD-B4571912C73E}"/>
               </a:ext>
             </a:extLst>
           </p:cNvPr>
@@ -9362,7 +9362,7 @@
           <p:cNvPr id="24" name="Tools · monitors · training feedback">
             <a:extLst xmlns:a="http://schemas.openxmlformats.org/drawingml/2006/main">
               <a:ext uri="{FF2B5EF4-FFF2-40B4-BE49-F238E27FC236}">
-                <a16:creationId xmlns:a16="http://schemas.microsoft.com/office/drawing/2014/main" id="{BAC00E8E-ECFB-40F4-8468-E4355E0B7669}"/>
+                <a16:creationId xmlns:a16="http://schemas.microsoft.com/office/drawing/2014/main" id="{CC472C59-CF16-449E-A9EB-6CA6C18120AD}"/>
               </a:ext>
             </a:extLst>
           </p:cNvPr>
@@ -9419,7 +9419,7 @@
           <p:cNvPr id="25" name="Test a candidate before release.">
             <a:extLst xmlns:a="http://schemas.openxmlformats.org/drawingml/2006/main">
               <a:ext uri="{FF2B5EF4-FFF2-40B4-BE49-F238E27FC236}">
-                <a16:creationId xmlns:a16="http://schemas.microsoft.com/office/drawing/2014/main" id="{DF80171A-26F2-4698-978D-E4CA6DD6A5BC}"/>
+                <a16:creationId xmlns:a16="http://schemas.microsoft.com/office/drawing/2014/main" id="{C43CE20B-5F8C-49D4-A495-EBA26440763F}"/>
               </a:ext>
             </a:extLst>
           </p:cNvPr>
@@ -9476,7 +9476,7 @@
           <p:cNvPr id="26" name="updated">
             <a:extLst xmlns:a="http://schemas.openxmlformats.org/drawingml/2006/main">
               <a:ext uri="{FF2B5EF4-FFF2-40B4-BE49-F238E27FC236}">
-                <a16:creationId xmlns:a16="http://schemas.microsoft.com/office/drawing/2014/main" id="{B8DBD068-64AA-4A09-A1FC-DBD43E6A5406}"/>
+                <a16:creationId xmlns:a16="http://schemas.microsoft.com/office/drawing/2014/main" id="{E66A81C1-4EF1-4EBD-86E5-98B1F299019C}"/>
               </a:ext>
             </a:extLst>
           </p:cNvPr>
@@ -9533,7 +9533,7 @@
           <p:cNvPr id="27" name="candidate">
             <a:extLst xmlns:a="http://schemas.openxmlformats.org/drawingml/2006/main">
               <a:ext uri="{FF2B5EF4-FFF2-40B4-BE49-F238E27FC236}">
-                <a16:creationId xmlns:a16="http://schemas.microsoft.com/office/drawing/2014/main" id="{BB58DA46-ABEA-4970-B880-B420EEC9650D}"/>
+                <a16:creationId xmlns:a16="http://schemas.microsoft.com/office/drawing/2014/main" id="{0CBCE4D2-FD6B-44DB-9C89-027511968A7E}"/>
               </a:ext>
             </a:extLst>
           </p:cNvPr>
@@ -9590,7 +9590,7 @@
           <p:cNvPr id="28" name="Editable flow path">
             <a:extLst xmlns:a="http://schemas.openxmlformats.org/drawingml/2006/main">
               <a:ext uri="{FF2B5EF4-FFF2-40B4-BE49-F238E27FC236}">
-                <a16:creationId xmlns:a16="http://schemas.microsoft.com/office/drawing/2014/main" id="{3F90A71A-E41D-4B3C-A013-D4E4B9DCCF64}"/>
+                <a16:creationId xmlns:a16="http://schemas.microsoft.com/office/drawing/2014/main" id="{ED48FAA1-9530-4B5D-8B5C-6C73451789C3}"/>
               </a:ext>
             </a:extLst>
           </p:cNvPr>
@@ -9630,7 +9630,7 @@
           <p:cNvPr id="29" name="Editable arrowhead">
             <a:extLst xmlns:a="http://schemas.openxmlformats.org/drawingml/2006/main">
               <a:ext uri="{FF2B5EF4-FFF2-40B4-BE49-F238E27FC236}">
-                <a16:creationId xmlns:a16="http://schemas.microsoft.com/office/drawing/2014/main" id="{A70915DC-87F6-43F8-8E89-66CCED5FCC5F}"/>
+                <a16:creationId xmlns:a16="http://schemas.microsoft.com/office/drawing/2014/main" id="{DC70AB0E-D943-40C7-B8A9-4C7AAE17869B}"/>
               </a:ext>
             </a:extLst>
           </p:cNvPr>
@@ -9673,7 +9673,7 @@
           <p:cNvPr id="30" name="Editable boundary">
             <a:extLst xmlns:a="http://schemas.openxmlformats.org/drawingml/2006/main">
               <a:ext uri="{FF2B5EF4-FFF2-40B4-BE49-F238E27FC236}">
-                <a16:creationId xmlns:a16="http://schemas.microsoft.com/office/drawing/2014/main" id="{94E12760-10BE-494E-AF2C-1A627A64E384}"/>
+                <a16:creationId xmlns:a16="http://schemas.microsoft.com/office/drawing/2014/main" id="{7CC9ACFA-64A3-4B3F-8D99-858BEAAC10E7}"/>
               </a:ext>
             </a:extLst>
           </p:cNvPr>
@@ -9691,7 +9691,7 @@
             <a:avLst/>
           </a:prstGeom>
           <a:solidFill xmlns:a="http://schemas.openxmlformats.org/drawingml/2006/main">
-            <a:srgbClr val="F7F7F7"/>
+            <a:srgbClr val="F8F8F8"/>
           </a:solidFill>
           <a:ln xmlns:a="http://schemas.openxmlformats.org/drawingml/2006/main" w="19050">
             <a:solidFill>
@@ -9706,7 +9706,7 @@
           <p:cNvPr id="31" name="Protected requirements">
             <a:extLst xmlns:a="http://schemas.openxmlformats.org/drawingml/2006/main">
               <a:ext uri="{FF2B5EF4-FFF2-40B4-BE49-F238E27FC236}">
-                <a16:creationId xmlns:a16="http://schemas.microsoft.com/office/drawing/2014/main" id="{E8926162-121C-48F4-BDA2-E74BE42ACB43}"/>
+                <a16:creationId xmlns:a16="http://schemas.microsoft.com/office/drawing/2014/main" id="{C5ACBE4D-7EAF-4E94-B39C-FDC7F275DCCF}"/>
               </a:ext>
             </a:extLst>
           </p:cNvPr>
@@ -9763,7 +9763,7 @@
           <p:cNvPr id="32" name="Security · reliability · task completion">
             <a:extLst xmlns:a="http://schemas.openxmlformats.org/drawingml/2006/main">
               <a:ext uri="{FF2B5EF4-FFF2-40B4-BE49-F238E27FC236}">
-                <a16:creationId xmlns:a16="http://schemas.microsoft.com/office/drawing/2014/main" id="{67C7F65C-D82E-4C50-8681-DC54F223C447}"/>
+                <a16:creationId xmlns:a16="http://schemas.microsoft.com/office/drawing/2014/main" id="{DEC657AD-C0D5-4860-B1A4-ED0496C71331}"/>
               </a:ext>
             </a:extLst>
           </p:cNvPr>
@@ -9820,7 +9820,7 @@
           <p:cNvPr id="33" name="Editable boundary">
             <a:extLst xmlns:a="http://schemas.openxmlformats.org/drawingml/2006/main">
               <a:ext uri="{FF2B5EF4-FFF2-40B4-BE49-F238E27FC236}">
-                <a16:creationId xmlns:a16="http://schemas.microsoft.com/office/drawing/2014/main" id="{A6DAA3AB-85E7-4773-94CB-2447A1FE4EA8}"/>
+                <a16:creationId xmlns:a16="http://schemas.microsoft.com/office/drawing/2014/main" id="{0ECB4171-468E-4E7C-9D46-EDD1C5F44180}"/>
               </a:ext>
             </a:extLst>
           </p:cNvPr>
@@ -9838,7 +9838,7 @@
             <a:avLst/>
           </a:prstGeom>
           <a:solidFill xmlns:a="http://schemas.openxmlformats.org/drawingml/2006/main">
-            <a:srgbClr val="F7F7F7"/>
+            <a:srgbClr val="F8F8F8"/>
           </a:solidFill>
           <a:ln xmlns:a="http://schemas.openxmlformats.org/drawingml/2006/main" w="19050">
             <a:solidFill>
@@ -9853,7 +9853,7 @@
           <p:cNvPr id="34" name="Recheck existing guardrails">
             <a:extLst xmlns:a="http://schemas.openxmlformats.org/drawingml/2006/main">
               <a:ext uri="{FF2B5EF4-FFF2-40B4-BE49-F238E27FC236}">
-                <a16:creationId xmlns:a16="http://schemas.microsoft.com/office/drawing/2014/main" id="{708DA1D1-9490-4E7E-B100-B4232B74FF40}"/>
+                <a16:creationId xmlns:a16="http://schemas.microsoft.com/office/drawing/2014/main" id="{1423D3C1-BFEE-4ADE-88A9-3300A4427AA4}"/>
               </a:ext>
             </a:extLst>
           </p:cNvPr>
@@ -9910,7 +9910,7 @@
           <p:cNvPr id="35" name="Editable boundary">
             <a:extLst xmlns:a="http://schemas.openxmlformats.org/drawingml/2006/main">
               <a:ext uri="{FF2B5EF4-FFF2-40B4-BE49-F238E27FC236}">
-                <a16:creationId xmlns:a16="http://schemas.microsoft.com/office/drawing/2014/main" id="{CDF3DDE6-0AC8-4EB4-87FD-EB66FDFFE49A}"/>
+                <a16:creationId xmlns:a16="http://schemas.microsoft.com/office/drawing/2014/main" id="{84235DBF-D200-4576-B34B-E71F4695A182}"/>
               </a:ext>
             </a:extLst>
           </p:cNvPr>
@@ -9943,7 +9943,7 @@
           <p:cNvPr id="36" name="PolicyOK">
             <a:extLst xmlns:a="http://schemas.openxmlformats.org/drawingml/2006/main">
               <a:ext uri="{FF2B5EF4-FFF2-40B4-BE49-F238E27FC236}">
-                <a16:creationId xmlns:a16="http://schemas.microsoft.com/office/drawing/2014/main" id="{AD35889B-8F87-4E7E-B92E-0294B7321AA9}"/>
+                <a16:creationId xmlns:a16="http://schemas.microsoft.com/office/drawing/2014/main" id="{C4397355-94DC-4FE4-BB99-7C11163DBF65}"/>
               </a:ext>
             </a:extLst>
           </p:cNvPr>
@@ -10000,7 +10000,7 @@
           <p:cNvPr id="37" name="Permissions · data boundaries">
             <a:extLst xmlns:a="http://schemas.openxmlformats.org/drawingml/2006/main">
               <a:ext uri="{FF2B5EF4-FFF2-40B4-BE49-F238E27FC236}">
-                <a16:creationId xmlns:a16="http://schemas.microsoft.com/office/drawing/2014/main" id="{8E39DE99-9880-4F7D-B7CB-5DCAFCD2571B}"/>
+                <a16:creationId xmlns:a16="http://schemas.microsoft.com/office/drawing/2014/main" id="{2EB960C3-E4C8-412A-8528-AE1C24F11AB9}"/>
               </a:ext>
             </a:extLst>
           </p:cNvPr>
@@ -10057,7 +10057,7 @@
           <p:cNvPr id="38" name="Editable boundary">
             <a:extLst xmlns:a="http://schemas.openxmlformats.org/drawingml/2006/main">
               <a:ext uri="{FF2B5EF4-FFF2-40B4-BE49-F238E27FC236}">
-                <a16:creationId xmlns:a16="http://schemas.microsoft.com/office/drawing/2014/main" id="{69079702-073A-43CA-B47F-E73C3D1DC56B}"/>
+                <a16:creationId xmlns:a16="http://schemas.microsoft.com/office/drawing/2014/main" id="{4895A30A-456F-4A68-B10B-9F95538F65EA}"/>
               </a:ext>
             </a:extLst>
           </p:cNvPr>
@@ -10090,7 +10090,7 @@
           <p:cNvPr id="39" name="RetentionOK">
             <a:extLst xmlns:a="http://schemas.openxmlformats.org/drawingml/2006/main">
               <a:ext uri="{FF2B5EF4-FFF2-40B4-BE49-F238E27FC236}">
-                <a16:creationId xmlns:a16="http://schemas.microsoft.com/office/drawing/2014/main" id="{4C5C5BC0-2684-40E2-BC65-17201DDBB1B0}"/>
+                <a16:creationId xmlns:a16="http://schemas.microsoft.com/office/drawing/2014/main" id="{BB5FC411-B2D9-4826-99A8-3673A813FFD0}"/>
               </a:ext>
             </a:extLst>
           </p:cNvPr>
@@ -10147,7 +10147,7 @@
           <p:cNvPr id="40" name="Independent regression and adversarial tests">
             <a:extLst xmlns:a="http://schemas.openxmlformats.org/drawingml/2006/main">
               <a:ext uri="{FF2B5EF4-FFF2-40B4-BE49-F238E27FC236}">
-                <a16:creationId xmlns:a16="http://schemas.microsoft.com/office/drawing/2014/main" id="{30B9F9DF-DDFB-45BE-9B1F-DCB67FA9FAE2}"/>
+                <a16:creationId xmlns:a16="http://schemas.microsoft.com/office/drawing/2014/main" id="{CDF05929-8471-4BE7-B01F-7AA1288EB103}"/>
               </a:ext>
             </a:extLst>
           </p:cNvPr>
@@ -10204,7 +10204,7 @@
           <p:cNvPr id="41" name="Editable flow path">
             <a:extLst xmlns:a="http://schemas.openxmlformats.org/drawingml/2006/main">
               <a:ext uri="{FF2B5EF4-FFF2-40B4-BE49-F238E27FC236}">
-                <a16:creationId xmlns:a16="http://schemas.microsoft.com/office/drawing/2014/main" id="{E4C8C147-01A3-4CD9-A509-A8B3C56AA012}"/>
+                <a16:creationId xmlns:a16="http://schemas.microsoft.com/office/drawing/2014/main" id="{B9E8CB5A-9C46-415F-BC22-E3CEDECA5B65}"/>
               </a:ext>
             </a:extLst>
           </p:cNvPr>
@@ -10244,7 +10244,7 @@
           <p:cNvPr id="42" name="Editable arrowhead">
             <a:extLst xmlns:a="http://schemas.openxmlformats.org/drawingml/2006/main">
               <a:ext uri="{FF2B5EF4-FFF2-40B4-BE49-F238E27FC236}">
-                <a16:creationId xmlns:a16="http://schemas.microsoft.com/office/drawing/2014/main" id="{AEA5FF0B-81DA-47CF-AA1C-7D396FF56231}"/>
+                <a16:creationId xmlns:a16="http://schemas.microsoft.com/office/drawing/2014/main" id="{6AD17306-DD71-4CAD-9DA4-CFB1034D866D}"/>
               </a:ext>
             </a:extLst>
           </p:cNvPr>
@@ -10287,7 +10287,7 @@
           <p:cNvPr id="43" name="fail / unknown">
             <a:extLst xmlns:a="http://schemas.openxmlformats.org/drawingml/2006/main">
               <a:ext uri="{FF2B5EF4-FFF2-40B4-BE49-F238E27FC236}">
-                <a16:creationId xmlns:a16="http://schemas.microsoft.com/office/drawing/2014/main" id="{CA3FAB48-E37A-4CA7-A97A-899EF83A0925}"/>
+                <a16:creationId xmlns:a16="http://schemas.microsoft.com/office/drawing/2014/main" id="{C0D82FE0-28BB-4691-8A06-3306DA43F8BF}"/>
               </a:ext>
             </a:extLst>
           </p:cNvPr>
@@ -10344,7 +10344,7 @@
           <p:cNvPr id="44" name="Editable flow path">
             <a:extLst xmlns:a="http://schemas.openxmlformats.org/drawingml/2006/main">
               <a:ext uri="{FF2B5EF4-FFF2-40B4-BE49-F238E27FC236}">
-                <a16:creationId xmlns:a16="http://schemas.microsoft.com/office/drawing/2014/main" id="{6EAC2030-D91F-4051-AA3C-9FC8121DA0D1}"/>
+                <a16:creationId xmlns:a16="http://schemas.microsoft.com/office/drawing/2014/main" id="{925CF941-5351-4E4E-80D3-A0137B1E2854}"/>
               </a:ext>
             </a:extLst>
           </p:cNvPr>
@@ -10384,7 +10384,7 @@
           <p:cNvPr id="45" name="Editable arrowhead">
             <a:extLst xmlns:a="http://schemas.openxmlformats.org/drawingml/2006/main">
               <a:ext uri="{FF2B5EF4-FFF2-40B4-BE49-F238E27FC236}">
-                <a16:creationId xmlns:a16="http://schemas.microsoft.com/office/drawing/2014/main" id="{8FC9CA01-A74C-4DC8-B7E5-9746A0FEA046}"/>
+                <a16:creationId xmlns:a16="http://schemas.microsoft.com/office/drawing/2014/main" id="{B14997BC-7C66-4EB0-95C1-1273958FF527}"/>
               </a:ext>
             </a:extLst>
           </p:cNvPr>
@@ -10427,7 +10427,7 @@
           <p:cNvPr id="46" name="retest">
             <a:extLst xmlns:a="http://schemas.openxmlformats.org/drawingml/2006/main">
               <a:ext uri="{FF2B5EF4-FFF2-40B4-BE49-F238E27FC236}">
-                <a16:creationId xmlns:a16="http://schemas.microsoft.com/office/drawing/2014/main" id="{474936C5-A333-4C5D-BB8E-E9BBB94A7E58}"/>
+                <a16:creationId xmlns:a16="http://schemas.microsoft.com/office/drawing/2014/main" id="{FFBDF5E9-913D-4FEF-955D-90C5051D8671}"/>
               </a:ext>
             </a:extLst>
           </p:cNvPr>
@@ -10484,7 +10484,7 @@
           <p:cNvPr id="47" name="Editable boundary">
             <a:extLst xmlns:a="http://schemas.openxmlformats.org/drawingml/2006/main">
               <a:ext uri="{FF2B5EF4-FFF2-40B4-BE49-F238E27FC236}">
-                <a16:creationId xmlns:a16="http://schemas.microsoft.com/office/drawing/2014/main" id="{34B5E1F9-1ED7-479F-84DA-4BF6574DD747}"/>
+                <a16:creationId xmlns:a16="http://schemas.microsoft.com/office/drawing/2014/main" id="{0B41DAEB-1AB0-4C56-A2AE-9330857EA6E2}"/>
               </a:ext>
             </a:extLst>
           </p:cNvPr>
@@ -10502,7 +10502,7 @@
             <a:avLst/>
           </a:prstGeom>
           <a:solidFill xmlns:a="http://schemas.openxmlformats.org/drawingml/2006/main">
-            <a:srgbClr val="F7F7F7"/>
+            <a:srgbClr val="F8F8F8"/>
           </a:solidFill>
           <a:ln xmlns:a="http://schemas.openxmlformats.org/drawingml/2006/main" w="19050">
             <a:solidFill>
@@ -10517,7 +10517,7 @@
           <p:cNvPr id="48" name="Repair update or guardrails">
             <a:extLst xmlns:a="http://schemas.openxmlformats.org/drawingml/2006/main">
               <a:ext uri="{FF2B5EF4-FFF2-40B4-BE49-F238E27FC236}">
-                <a16:creationId xmlns:a16="http://schemas.microsoft.com/office/drawing/2014/main" id="{95548F1D-6107-4481-89A9-DD3B4DB54E58}"/>
+                <a16:creationId xmlns:a16="http://schemas.microsoft.com/office/drawing/2014/main" id="{1C851D41-F68E-41C2-B661-E47575758F6E}"/>
               </a:ext>
             </a:extLst>
           </p:cNvPr>
@@ -10574,7 +10574,7 @@
           <p:cNvPr id="49" name="Keep requirements unchanged">
             <a:extLst xmlns:a="http://schemas.openxmlformats.org/drawingml/2006/main">
               <a:ext uri="{FF2B5EF4-FFF2-40B4-BE49-F238E27FC236}">
-                <a16:creationId xmlns:a16="http://schemas.microsoft.com/office/drawing/2014/main" id="{979EF774-E1ED-4BBB-A40A-68D9D0AC0E33}"/>
+                <a16:creationId xmlns:a16="http://schemas.microsoft.com/office/drawing/2014/main" id="{03B411A3-A4C4-4492-AD19-0BD6D8AED0EC}"/>
               </a:ext>
             </a:extLst>
           </p:cNvPr>
@@ -10631,7 +10631,7 @@
           <p:cNvPr id="50" name="checked">
             <a:extLst xmlns:a="http://schemas.openxmlformats.org/drawingml/2006/main">
               <a:ext uri="{FF2B5EF4-FFF2-40B4-BE49-F238E27FC236}">
-                <a16:creationId xmlns:a16="http://schemas.microsoft.com/office/drawing/2014/main" id="{43AE3F2B-86BD-4314-BF0D-41375CA8857B}"/>
+                <a16:creationId xmlns:a16="http://schemas.microsoft.com/office/drawing/2014/main" id="{3B14544F-5376-415F-8EDF-6FD599F3618F}"/>
               </a:ext>
             </a:extLst>
           </p:cNvPr>
@@ -10688,7 +10688,7 @@
           <p:cNvPr id="51" name="evidence">
             <a:extLst xmlns:a="http://schemas.openxmlformats.org/drawingml/2006/main">
               <a:ext uri="{FF2B5EF4-FFF2-40B4-BE49-F238E27FC236}">
-                <a16:creationId xmlns:a16="http://schemas.microsoft.com/office/drawing/2014/main" id="{7D044282-8183-45F7-9F3D-E77ACAA550DD}"/>
+                <a16:creationId xmlns:a16="http://schemas.microsoft.com/office/drawing/2014/main" id="{147E1FA6-831D-4FEB-BCF4-288E20F2BCF4}"/>
               </a:ext>
             </a:extLst>
           </p:cNvPr>
@@ -10745,7 +10745,7 @@
           <p:cNvPr id="52" name="Editable flow path">
             <a:extLst xmlns:a="http://schemas.openxmlformats.org/drawingml/2006/main">
               <a:ext uri="{FF2B5EF4-FFF2-40B4-BE49-F238E27FC236}">
-                <a16:creationId xmlns:a16="http://schemas.microsoft.com/office/drawing/2014/main" id="{CC2EE4AB-F8DF-426E-955D-F557463F7E1E}"/>
+                <a16:creationId xmlns:a16="http://schemas.microsoft.com/office/drawing/2014/main" id="{74694343-84F8-4B46-938A-8AEF92A15DB2}"/>
               </a:ext>
             </a:extLst>
           </p:cNvPr>
@@ -10785,7 +10785,7 @@
           <p:cNvPr id="53" name="Editable arrowhead">
             <a:extLst xmlns:a="http://schemas.openxmlformats.org/drawingml/2006/main">
               <a:ext uri="{FF2B5EF4-FFF2-40B4-BE49-F238E27FC236}">
-                <a16:creationId xmlns:a16="http://schemas.microsoft.com/office/drawing/2014/main" id="{32D5DEA4-1C23-4EB0-9320-D31AD0305A56}"/>
+                <a16:creationId xmlns:a16="http://schemas.microsoft.com/office/drawing/2014/main" id="{ADE87577-D86E-4025-BEB2-DC46EDC7E20D}"/>
               </a:ext>
             </a:extLst>
           </p:cNvPr>
@@ -10828,7 +10828,7 @@
           <p:cNvPr id="54" name="Editable boundary">
             <a:extLst xmlns:a="http://schemas.openxmlformats.org/drawingml/2006/main">
               <a:ext uri="{FF2B5EF4-FFF2-40B4-BE49-F238E27FC236}">
-                <a16:creationId xmlns:a16="http://schemas.microsoft.com/office/drawing/2014/main" id="{210F9C41-B37A-4B9B-9B98-C2AA6AF36E39}"/>
+                <a16:creationId xmlns:a16="http://schemas.microsoft.com/office/drawing/2014/main" id="{187744EE-CDCE-4A46-965C-5F211291AF79}"/>
               </a:ext>
             </a:extLst>
           </p:cNvPr>
@@ -10846,7 +10846,7 @@
             <a:avLst/>
           </a:prstGeom>
           <a:solidFill xmlns:a="http://schemas.openxmlformats.org/drawingml/2006/main">
-            <a:srgbClr val="F7F7F7"/>
+            <a:srgbClr val="F8F8F8"/>
           </a:solidFill>
           <a:ln xmlns:a="http://schemas.openxmlformats.org/drawingml/2006/main" w="19050">
             <a:solidFill>
@@ -10861,7 +10861,7 @@
           <p:cNvPr id="55" name="Update gate">
             <a:extLst xmlns:a="http://schemas.openxmlformats.org/drawingml/2006/main">
               <a:ext uri="{FF2B5EF4-FFF2-40B4-BE49-F238E27FC236}">
-                <a16:creationId xmlns:a16="http://schemas.microsoft.com/office/drawing/2014/main" id="{BD0CBB12-1BC6-4EC1-981C-7F4B140EFEDC}"/>
+                <a16:creationId xmlns:a16="http://schemas.microsoft.com/office/drawing/2014/main" id="{2B501CD4-047F-457A-B11A-3032454A459C}"/>
               </a:ext>
             </a:extLst>
           </p:cNvPr>
@@ -10918,7 +10918,7 @@
           <p:cNvPr id="56" name="Accept(Δ*) :=">
             <a:extLst xmlns:a="http://schemas.openxmlformats.org/drawingml/2006/main">
               <a:ext uri="{FF2B5EF4-FFF2-40B4-BE49-F238E27FC236}">
-                <a16:creationId xmlns:a16="http://schemas.microsoft.com/office/drawing/2014/main" id="{89EF14EF-131C-45EE-8874-2E98C0D89F68}"/>
+                <a16:creationId xmlns:a16="http://schemas.microsoft.com/office/drawing/2014/main" id="{8A3F9E71-1308-4473-AC37-85224CE60489}"/>
               </a:ext>
             </a:extLst>
           </p:cNvPr>
@@ -10975,7 +10975,7 @@
           <p:cNvPr id="57" name="PolicyOK ∧ RetentionOK">
             <a:extLst xmlns:a="http://schemas.openxmlformats.org/drawingml/2006/main">
               <a:ext uri="{FF2B5EF4-FFF2-40B4-BE49-F238E27FC236}">
-                <a16:creationId xmlns:a16="http://schemas.microsoft.com/office/drawing/2014/main" id="{2387D19A-9B83-4ABF-A649-6CB0E14E4932}"/>
+                <a16:creationId xmlns:a16="http://schemas.microsoft.com/office/drawing/2014/main" id="{9FB3DB50-E5C3-4479-BB8A-A263FF6C402D}"/>
               </a:ext>
             </a:extLst>
           </p:cNvPr>
@@ -11032,7 +11032,7 @@
           <p:cNvPr id="58" name="Release the checked version only">
             <a:extLst xmlns:a="http://schemas.openxmlformats.org/drawingml/2006/main">
               <a:ext uri="{FF2B5EF4-FFF2-40B4-BE49-F238E27FC236}">
-                <a16:creationId xmlns:a16="http://schemas.microsoft.com/office/drawing/2014/main" id="{46B3E663-E6FE-457C-BC29-DB5319A47D0E}"/>
+                <a16:creationId xmlns:a16="http://schemas.microsoft.com/office/drawing/2014/main" id="{E39CA9E9-D74C-4F29-8B46-42DEBA5C0080}"/>
               </a:ext>
             </a:extLst>
           </p:cNvPr>
@@ -11089,7 +11089,7 @@
           <p:cNvPr id="59" name="Editable flow path">
             <a:extLst xmlns:a="http://schemas.openxmlformats.org/drawingml/2006/main">
               <a:ext uri="{FF2B5EF4-FFF2-40B4-BE49-F238E27FC236}">
-                <a16:creationId xmlns:a16="http://schemas.microsoft.com/office/drawing/2014/main" id="{3451B0BD-C597-44E2-A422-13326F7D9232}"/>
+                <a16:creationId xmlns:a16="http://schemas.microsoft.com/office/drawing/2014/main" id="{7EB1AFD8-5337-4C81-9117-B65D4D8C6AF3}"/>
               </a:ext>
             </a:extLst>
           </p:cNvPr>
@@ -11129,7 +11129,7 @@
           <p:cNvPr id="60" name="Editable flow path">
             <a:extLst xmlns:a="http://schemas.openxmlformats.org/drawingml/2006/main">
               <a:ext uri="{FF2B5EF4-FFF2-40B4-BE49-F238E27FC236}">
-                <a16:creationId xmlns:a16="http://schemas.microsoft.com/office/drawing/2014/main" id="{0CBC1869-645A-48FC-8ECC-E7301ACAED1C}"/>
+                <a16:creationId xmlns:a16="http://schemas.microsoft.com/office/drawing/2014/main" id="{40C77FD8-3FA3-4A59-94C0-48FA36B90F49}"/>
               </a:ext>
             </a:extLst>
           </p:cNvPr>
@@ -11172,7 +11172,7 @@
           <p:cNvPr id="61" name="Editable arrowhead">
             <a:extLst xmlns:a="http://schemas.openxmlformats.org/drawingml/2006/main">
               <a:ext uri="{FF2B5EF4-FFF2-40B4-BE49-F238E27FC236}">
-                <a16:creationId xmlns:a16="http://schemas.microsoft.com/office/drawing/2014/main" id="{45F0A5A1-4326-4E83-B5FB-B223666C89B6}"/>
+                <a16:creationId xmlns:a16="http://schemas.microsoft.com/office/drawing/2014/main" id="{94FD7D26-1AB8-4D50-9939-5540F046B1D4}"/>
               </a:ext>
             </a:extLst>
           </p:cNvPr>
@@ -11215,7 +11215,7 @@
           <p:cNvPr id="62" name="Editable flow path">
             <a:extLst xmlns:a="http://schemas.openxmlformats.org/drawingml/2006/main">
               <a:ext uri="{FF2B5EF4-FFF2-40B4-BE49-F238E27FC236}">
-                <a16:creationId xmlns:a16="http://schemas.microsoft.com/office/drawing/2014/main" id="{112B0DD4-F768-4F1D-8062-8CE34F31B825}"/>
+                <a16:creationId xmlns:a16="http://schemas.microsoft.com/office/drawing/2014/main" id="{9AD237A0-326F-45F8-99FB-D3C1A81A1C61}"/>
               </a:ext>
             </a:extLst>
           </p:cNvPr>
@@ -11258,7 +11258,7 @@
           <p:cNvPr id="63" name="Editable arrowhead">
             <a:extLst xmlns:a="http://schemas.openxmlformats.org/drawingml/2006/main">
               <a:ext uri="{FF2B5EF4-FFF2-40B4-BE49-F238E27FC236}">
-                <a16:creationId xmlns:a16="http://schemas.microsoft.com/office/drawing/2014/main" id="{5A681F1D-1225-49C1-9B1E-50ACD323A634}"/>
+                <a16:creationId xmlns:a16="http://schemas.microsoft.com/office/drawing/2014/main" id="{6E20CA9E-ACC8-44ED-BC8B-1017FB05EDAD}"/>
               </a:ext>
             </a:extLst>
           </p:cNvPr>
@@ -11301,7 +11301,7 @@
           <p:cNvPr id="64" name="pass">
             <a:extLst xmlns:a="http://schemas.openxmlformats.org/drawingml/2006/main">
               <a:ext uri="{FF2B5EF4-FFF2-40B4-BE49-F238E27FC236}">
-                <a16:creationId xmlns:a16="http://schemas.microsoft.com/office/drawing/2014/main" id="{56F0EDBB-A267-4475-9334-7C6A04F43317}"/>
+                <a16:creationId xmlns:a16="http://schemas.microsoft.com/office/drawing/2014/main" id="{CE3BE94F-8A5C-4101-81B1-8DA6EA0D8BD4}"/>
               </a:ext>
             </a:extLst>
           </p:cNvPr>
@@ -11358,7 +11358,7 @@
           <p:cNvPr id="65" name="fail / unknown">
             <a:extLst xmlns:a="http://schemas.openxmlformats.org/drawingml/2006/main">
               <a:ext uri="{FF2B5EF4-FFF2-40B4-BE49-F238E27FC236}">
-                <a16:creationId xmlns:a16="http://schemas.microsoft.com/office/drawing/2014/main" id="{D56A0151-87EA-41AF-AE83-E3B980C3468A}"/>
+                <a16:creationId xmlns:a16="http://schemas.microsoft.com/office/drawing/2014/main" id="{B4AE5254-C67A-4C16-BA65-3324575064C5}"/>
               </a:ext>
             </a:extLst>
           </p:cNvPr>
@@ -11415,7 +11415,7 @@
           <p:cNvPr id="66" name="Editable boundary">
             <a:extLst xmlns:a="http://schemas.openxmlformats.org/drawingml/2006/main">
               <a:ext uri="{FF2B5EF4-FFF2-40B4-BE49-F238E27FC236}">
-                <a16:creationId xmlns:a16="http://schemas.microsoft.com/office/drawing/2014/main" id="{E87D9F24-C3DD-4E97-B693-EB3482D68ADB}"/>
+                <a16:creationId xmlns:a16="http://schemas.microsoft.com/office/drawing/2014/main" id="{EA2F7F10-FC30-4695-857E-492EF2D2889C}"/>
               </a:ext>
             </a:extLst>
           </p:cNvPr>
@@ -11433,7 +11433,7 @@
             <a:avLst/>
           </a:prstGeom>
           <a:solidFill xmlns:a="http://schemas.openxmlformats.org/drawingml/2006/main">
-            <a:srgbClr val="F7F7F7"/>
+            <a:srgbClr val="F8F8F8"/>
           </a:solidFill>
           <a:ln xmlns:a="http://schemas.openxmlformats.org/drawingml/2006/main" w="19050">
             <a:solidFill>
@@ -11448,7 +11448,7 @@
           <p:cNvPr id="67" name="Editable boundary">
             <a:extLst xmlns:a="http://schemas.openxmlformats.org/drawingml/2006/main">
               <a:ext uri="{FF2B5EF4-FFF2-40B4-BE49-F238E27FC236}">
-                <a16:creationId xmlns:a16="http://schemas.microsoft.com/office/drawing/2014/main" id="{B302A6C3-616C-41EC-A9D5-72DB9E63D13C}"/>
+                <a16:creationId xmlns:a16="http://schemas.microsoft.com/office/drawing/2014/main" id="{4CABDB87-D198-4D41-B980-0FD30E6E7DA4}"/>
               </a:ext>
             </a:extLst>
           </p:cNvPr>
@@ -11466,7 +11466,7 @@
             <a:avLst/>
           </a:prstGeom>
           <a:solidFill xmlns:a="http://schemas.openxmlformats.org/drawingml/2006/main">
-            <a:srgbClr val="F7F7F7"/>
+            <a:srgbClr val="F8F8F8"/>
           </a:solidFill>
           <a:ln xmlns:a="http://schemas.openxmlformats.org/drawingml/2006/main" w="19050">
             <a:solidFill>
@@ -11481,7 +11481,7 @@
           <p:cNvPr id="68" name="Apply Δ*">
             <a:extLst xmlns:a="http://schemas.openxmlformats.org/drawingml/2006/main">
               <a:ext uri="{FF2B5EF4-FFF2-40B4-BE49-F238E27FC236}">
-                <a16:creationId xmlns:a16="http://schemas.microsoft.com/office/drawing/2014/main" id="{ECC47E22-8479-48A5-B6BA-E77AB13667AF}"/>
+                <a16:creationId xmlns:a16="http://schemas.microsoft.com/office/drawing/2014/main" id="{B0EBAABE-FB9D-4C61-9E2C-CBDA58E91904}"/>
               </a:ext>
             </a:extLst>
           </p:cNvPr>
@@ -11538,7 +11538,7 @@
           <p:cNvPr id="69" name="Retain Sₜ">
             <a:extLst xmlns:a="http://schemas.openxmlformats.org/drawingml/2006/main">
               <a:ext uri="{FF2B5EF4-FFF2-40B4-BE49-F238E27FC236}">
-                <a16:creationId xmlns:a16="http://schemas.microsoft.com/office/drawing/2014/main" id="{8929A462-EE45-4E4E-8F1C-5384D7E64223}"/>
+                <a16:creationId xmlns:a16="http://schemas.microsoft.com/office/drawing/2014/main" id="{C0347FE4-77A1-4DEF-9737-9D516CC244BE}"/>
               </a:ext>
             </a:extLst>
           </p:cNvPr>
@@ -11595,7 +11595,7 @@
           <p:cNvPr id="70" name="Editable boundary">
             <a:extLst xmlns:a="http://schemas.openxmlformats.org/drawingml/2006/main">
               <a:ext uri="{FF2B5EF4-FFF2-40B4-BE49-F238E27FC236}">
-                <a16:creationId xmlns:a16="http://schemas.microsoft.com/office/drawing/2014/main" id="{F5B51800-C2DF-4309-B895-B0685FF546CA}"/>
+                <a16:creationId xmlns:a16="http://schemas.microsoft.com/office/drawing/2014/main" id="{532CF414-B7A6-4088-BC2A-8579DD2E375E}"/>
               </a:ext>
             </a:extLst>
           </p:cNvPr>
@@ -11613,7 +11613,7 @@
             <a:avLst/>
           </a:prstGeom>
           <a:solidFill xmlns:a="http://schemas.openxmlformats.org/drawingml/2006/main">
-            <a:srgbClr val="F7F7F7"/>
+            <a:srgbClr val="F8F8F8"/>
           </a:solidFill>
           <a:ln xmlns:a="http://schemas.openxmlformats.org/drawingml/2006/main" w="19050">
             <a:solidFill>
@@ -11628,7 +11628,7 @@
           <p:cNvPr id="71" name="On acceptance:">
             <a:extLst xmlns:a="http://schemas.openxmlformats.org/drawingml/2006/main">
               <a:ext uri="{FF2B5EF4-FFF2-40B4-BE49-F238E27FC236}">
-                <a16:creationId xmlns:a16="http://schemas.microsoft.com/office/drawing/2014/main" id="{070720BA-7024-4041-9761-22A26BD1B39B}"/>
+                <a16:creationId xmlns:a16="http://schemas.microsoft.com/office/drawing/2014/main" id="{E631219E-4F85-451E-BF88-0C03F32FB24A}"/>
               </a:ext>
             </a:extLst>
           </p:cNvPr>
@@ -11685,7 +11685,7 @@
           <p:cNvPr id="72" name="Sₜ₊₁ = Update(Sₜ, Δ*)">
             <a:extLst xmlns:a="http://schemas.openxmlformats.org/drawingml/2006/main">
               <a:ext uri="{FF2B5EF4-FFF2-40B4-BE49-F238E27FC236}">
-                <a16:creationId xmlns:a16="http://schemas.microsoft.com/office/drawing/2014/main" id="{76065F6F-61BF-4ACD-8685-D85EC1092FFE}"/>
+                <a16:creationId xmlns:a16="http://schemas.microsoft.com/office/drawing/2014/main" id="{DD08EE9C-AB43-4DBB-8C8C-171081CD6D46}"/>
               </a:ext>
             </a:extLst>
           </p:cNvPr>
@@ -11742,7 +11742,7 @@
           <p:cNvPr id="73" name="Δ*: checked change, including needed guardrail repairs">
             <a:extLst xmlns:a="http://schemas.openxmlformats.org/drawingml/2006/main">
               <a:ext uri="{FF2B5EF4-FFF2-40B4-BE49-F238E27FC236}">
-                <a16:creationId xmlns:a16="http://schemas.microsoft.com/office/drawing/2014/main" id="{DAB5C180-915D-4502-853E-64866B3B922D}"/>
+                <a16:creationId xmlns:a16="http://schemas.microsoft.com/office/drawing/2014/main" id="{90AB649C-3D27-428D-B776-5C7069248C77}"/>
               </a:ext>
             </a:extLst>
           </p:cNvPr>
@@ -11799,7 +11799,7 @@
           <p:cNvPr id="74" name="Editable flow path">
             <a:extLst xmlns:a="http://schemas.openxmlformats.org/drawingml/2006/main">
               <a:ext uri="{FF2B5EF4-FFF2-40B4-BE49-F238E27FC236}">
-                <a16:creationId xmlns:a16="http://schemas.microsoft.com/office/drawing/2014/main" id="{6A15C399-B537-4BDB-9F26-0A99101906D3}"/>
+                <a16:creationId xmlns:a16="http://schemas.microsoft.com/office/drawing/2014/main" id="{726C121F-C4B3-4EDE-BCC7-344AFB45600A}"/>
               </a:ext>
             </a:extLst>
           </p:cNvPr>
@@ -11848,7 +11848,7 @@
           <p:cNvPr id="75" name="Editable arrowhead">
             <a:extLst xmlns:a="http://schemas.openxmlformats.org/drawingml/2006/main">
               <a:ext uri="{FF2B5EF4-FFF2-40B4-BE49-F238E27FC236}">
-                <a16:creationId xmlns:a16="http://schemas.microsoft.com/office/drawing/2014/main" id="{1774A751-928E-4A84-B620-C746AFE61932}"/>
+                <a16:creationId xmlns:a16="http://schemas.microsoft.com/office/drawing/2014/main" id="{7308698E-5301-4C16-B06D-839229A16FA5}"/>
               </a:ext>
             </a:extLst>
           </p:cNvPr>
@@ -11891,7 +11891,7 @@
           <p:cNvPr id="76" name="Editable boundary">
             <a:extLst xmlns:a="http://schemas.openxmlformats.org/drawingml/2006/main">
               <a:ext uri="{FF2B5EF4-FFF2-40B4-BE49-F238E27FC236}">
-                <a16:creationId xmlns:a16="http://schemas.microsoft.com/office/drawing/2014/main" id="{D9C3E981-2DF1-4636-AB5E-ECC002552416}"/>
+                <a16:creationId xmlns:a16="http://schemas.microsoft.com/office/drawing/2014/main" id="{85E62C60-6449-4EFD-9DDF-E789584D67BC}"/>
               </a:ext>
             </a:extLst>
           </p:cNvPr>
@@ -11924,7 +11924,7 @@
           <p:cNvPr id="77" name="Revalidate at every update">
             <a:extLst xmlns:a="http://schemas.openxmlformats.org/drawingml/2006/main">
               <a:ext uri="{FF2B5EF4-FFF2-40B4-BE49-F238E27FC236}">
-                <a16:creationId xmlns:a16="http://schemas.microsoft.com/office/drawing/2014/main" id="{E87FE3E2-45BE-4D70-B27D-B00A7482CD7F}"/>
+                <a16:creationId xmlns:a16="http://schemas.microsoft.com/office/drawing/2014/main" id="{A89E1E4A-933E-4931-B996-6E02B0CC78D1}"/>
               </a:ext>
             </a:extLst>
           </p:cNvPr>
@@ -11981,7 +11981,7 @@
           <p:cNvPr id="78" name="Protection requirements stay fixed; guardrail implementations ma">
             <a:extLst xmlns:a="http://schemas.openxmlformats.org/drawingml/2006/main">
               <a:ext uri="{FF2B5EF4-FFF2-40B4-BE49-F238E27FC236}">
-                <a16:creationId xmlns:a16="http://schemas.microsoft.com/office/drawing/2014/main" id="{0FCC610E-5AAD-4CE0-978A-9236234D389A}"/>
+                <a16:creationId xmlns:a16="http://schemas.microsoft.com/office/drawing/2014/main" id="{3BB9C4EA-EA61-4108-AFD4-1308DD5AFB4A}"/>
               </a:ext>
             </a:extLst>
           </p:cNvPr>
@@ -12036,7 +12036,7 @@
     </p:spTree>
     <p:extLst>
       <p:ext uri="{BB962C8B-B14F-4D97-AF65-F5344CB8AC3E}">
-        <p14:creationId xmlns:p14="http://schemas.microsoft.com/office/powerpoint/2010/main" val="91042657"/>
+        <p14:creationId xmlns:p14="http://schemas.microsoft.com/office/powerpoint/2010/main" val="303363959"/>
       </p:ext>
     </p:extLst>
   </p:cSld>
@@ -12067,7 +12067,7 @@
           <p:cNvPr id="79" name="III. Authorization Across Delegated Workflows">
             <a:extLst xmlns:a="http://schemas.openxmlformats.org/drawingml/2006/main">
               <a:ext uri="{FF2B5EF4-FFF2-40B4-BE49-F238E27FC236}">
-                <a16:creationId xmlns:a16="http://schemas.microsoft.com/office/drawing/2014/main" id="{0C4735B5-C95B-4782-A687-A7D0D7EA01DD}"/>
+                <a16:creationId xmlns:a16="http://schemas.microsoft.com/office/drawing/2014/main" id="{6F262E94-1ECF-4906-841A-37EE352E6419}"/>
               </a:ext>
             </a:extLst>
           </p:cNvPr>
@@ -12124,7 +12124,7 @@
           <p:cNvPr id="2" name="A private report can leak through a delegated email draft.">
             <a:extLst xmlns:a="http://schemas.openxmlformats.org/drawingml/2006/main">
               <a:ext uri="{FF2B5EF4-FFF2-40B4-BE49-F238E27FC236}">
-                <a16:creationId xmlns:a16="http://schemas.microsoft.com/office/drawing/2014/main" id="{FB58DF01-A2E2-4BE0-9C41-952D8CE8319E}"/>
+                <a16:creationId xmlns:a16="http://schemas.microsoft.com/office/drawing/2014/main" id="{315DE7C8-DB53-4710-AB88-FB0797D4E250}"/>
               </a:ext>
             </a:extLst>
           </p:cNvPr>
@@ -12181,7 +12181,7 @@
           <p:cNvPr id="3" name="Editable boundary">
             <a:extLst xmlns:a="http://schemas.openxmlformats.org/drawingml/2006/main">
               <a:ext uri="{FF2B5EF4-FFF2-40B4-BE49-F238E27FC236}">
-                <a16:creationId xmlns:a16="http://schemas.microsoft.com/office/drawing/2014/main" id="{4B47C68C-7312-42FD-97CE-D3344330FE82}"/>
+                <a16:creationId xmlns:a16="http://schemas.microsoft.com/office/drawing/2014/main" id="{FDF80871-5E4D-4E42-91CB-9044121E4787}"/>
               </a:ext>
             </a:extLst>
           </p:cNvPr>
@@ -12214,7 +12214,7 @@
           <p:cNvPr id="4" name="Editable boundary">
             <a:extLst xmlns:a="http://schemas.openxmlformats.org/drawingml/2006/main">
               <a:ext uri="{FF2B5EF4-FFF2-40B4-BE49-F238E27FC236}">
-                <a16:creationId xmlns:a16="http://schemas.microsoft.com/office/drawing/2014/main" id="{82936CDD-FA30-462A-9927-AA4E290621A1}"/>
+                <a16:creationId xmlns:a16="http://schemas.microsoft.com/office/drawing/2014/main" id="{68BB0D91-5D79-445A-98C9-9D261E2C91C5}"/>
               </a:ext>
             </a:extLst>
           </p:cNvPr>
@@ -12247,7 +12247,7 @@
           <p:cNvPr id="5" name="Editable boundary">
             <a:extLst xmlns:a="http://schemas.openxmlformats.org/drawingml/2006/main">
               <a:ext uri="{FF2B5EF4-FFF2-40B4-BE49-F238E27FC236}">
-                <a16:creationId xmlns:a16="http://schemas.microsoft.com/office/drawing/2014/main" id="{B589B509-A5CB-44F6-908A-A0F6D8F817E7}"/>
+                <a16:creationId xmlns:a16="http://schemas.microsoft.com/office/drawing/2014/main" id="{44D7D46A-63C6-4C9F-923F-394B4A67B3F5}"/>
               </a:ext>
             </a:extLst>
           </p:cNvPr>
@@ -12280,7 +12280,7 @@
           <p:cNvPr id="6" name="Editable boundary">
             <a:extLst xmlns:a="http://schemas.openxmlformats.org/drawingml/2006/main">
               <a:ext uri="{FF2B5EF4-FFF2-40B4-BE49-F238E27FC236}">
-                <a16:creationId xmlns:a16="http://schemas.microsoft.com/office/drawing/2014/main" id="{FE3DB305-28FC-426F-ACEE-F97488E9B747}"/>
+                <a16:creationId xmlns:a16="http://schemas.microsoft.com/office/drawing/2014/main" id="{819B8ED8-9642-4E1E-9AA3-66C4550D7624}"/>
               </a:ext>
             </a:extLst>
           </p:cNvPr>
@@ -12313,7 +12313,7 @@
           <p:cNvPr id="7" name="1">
             <a:extLst xmlns:a="http://schemas.openxmlformats.org/drawingml/2006/main">
               <a:ext uri="{FF2B5EF4-FFF2-40B4-BE49-F238E27FC236}">
-                <a16:creationId xmlns:a16="http://schemas.microsoft.com/office/drawing/2014/main" id="{6B967FDD-AAB8-49C2-A956-15C00C5230CF}"/>
+                <a16:creationId xmlns:a16="http://schemas.microsoft.com/office/drawing/2014/main" id="{A3A24E3A-1AB6-4F6C-A580-BCAE0CD24F6C}"/>
               </a:ext>
             </a:extLst>
           </p:cNvPr>
@@ -12370,7 +12370,7 @@
           <p:cNvPr id="8" name="A concrete handoff">
             <a:extLst xmlns:a="http://schemas.openxmlformats.org/drawingml/2006/main">
               <a:ext uri="{FF2B5EF4-FFF2-40B4-BE49-F238E27FC236}">
-                <a16:creationId xmlns:a16="http://schemas.microsoft.com/office/drawing/2014/main" id="{0F477F9A-F090-4B21-B9DC-500533040FA8}"/>
+                <a16:creationId xmlns:a16="http://schemas.microsoft.com/office/drawing/2014/main" id="{1367AF21-7414-4134-A519-CA5B9D4127AF}"/>
               </a:ext>
             </a:extLst>
           </p:cNvPr>
@@ -12427,7 +12427,7 @@
           <p:cNvPr id="9" name="Editable boundary">
             <a:extLst xmlns:a="http://schemas.openxmlformats.org/drawingml/2006/main">
               <a:ext uri="{FF2B5EF4-FFF2-40B4-BE49-F238E27FC236}">
-                <a16:creationId xmlns:a16="http://schemas.microsoft.com/office/drawing/2014/main" id="{F669CA2C-2214-4945-B8ED-D48AFE67494D}"/>
+                <a16:creationId xmlns:a16="http://schemas.microsoft.com/office/drawing/2014/main" id="{4C2FC083-A8FD-42E9-9698-42CD4780E3D5}"/>
               </a:ext>
             </a:extLst>
           </p:cNvPr>
@@ -12460,7 +12460,7 @@
           <p:cNvPr id="10" name="2">
             <a:extLst xmlns:a="http://schemas.openxmlformats.org/drawingml/2006/main">
               <a:ext uri="{FF2B5EF4-FFF2-40B4-BE49-F238E27FC236}">
-                <a16:creationId xmlns:a16="http://schemas.microsoft.com/office/drawing/2014/main" id="{6CA00C42-6B77-4BCF-A936-6D3E6F073E22}"/>
+                <a16:creationId xmlns:a16="http://schemas.microsoft.com/office/drawing/2014/main" id="{22CA6685-DA0C-4A94-B358-BDD9F649AD2A}"/>
               </a:ext>
             </a:extLst>
           </p:cNvPr>
@@ -12517,7 +12517,7 @@
           <p:cNvPr id="11" name="Track workflow context">
             <a:extLst xmlns:a="http://schemas.openxmlformats.org/drawingml/2006/main">
               <a:ext uri="{FF2B5EF4-FFF2-40B4-BE49-F238E27FC236}">
-                <a16:creationId xmlns:a16="http://schemas.microsoft.com/office/drawing/2014/main" id="{7C7CE151-6B61-46EE-A13C-064F996EA582}"/>
+                <a16:creationId xmlns:a16="http://schemas.microsoft.com/office/drawing/2014/main" id="{2AC06DD3-933E-487A-8EBF-AFBB544BA356}"/>
               </a:ext>
             </a:extLst>
           </p:cNvPr>
@@ -12574,7 +12574,7 @@
           <p:cNvPr id="12" name="Editable boundary">
             <a:extLst xmlns:a="http://schemas.openxmlformats.org/drawingml/2006/main">
               <a:ext uri="{FF2B5EF4-FFF2-40B4-BE49-F238E27FC236}">
-                <a16:creationId xmlns:a16="http://schemas.microsoft.com/office/drawing/2014/main" id="{4265D084-8B53-4A7E-B00D-205AE9D0B1BF}"/>
+                <a16:creationId xmlns:a16="http://schemas.microsoft.com/office/drawing/2014/main" id="{630A0500-36F4-4557-A43D-1C4CFE94CB55}"/>
               </a:ext>
             </a:extLst>
           </p:cNvPr>
@@ -12607,7 +12607,7 @@
           <p:cNvPr id="13" name="3">
             <a:extLst xmlns:a="http://schemas.openxmlformats.org/drawingml/2006/main">
               <a:ext uri="{FF2B5EF4-FFF2-40B4-BE49-F238E27FC236}">
-                <a16:creationId xmlns:a16="http://schemas.microsoft.com/office/drawing/2014/main" id="{557447D2-F483-4176-B710-AD038AA65D29}"/>
+                <a16:creationId xmlns:a16="http://schemas.microsoft.com/office/drawing/2014/main" id="{F354A345-83E1-403E-859B-CFF3AD180382}"/>
               </a:ext>
             </a:extLst>
           </p:cNvPr>
@@ -12664,7 +12664,7 @@
           <p:cNvPr id="14" name="Enforce and recover">
             <a:extLst xmlns:a="http://schemas.openxmlformats.org/drawingml/2006/main">
               <a:ext uri="{FF2B5EF4-FFF2-40B4-BE49-F238E27FC236}">
-                <a16:creationId xmlns:a16="http://schemas.microsoft.com/office/drawing/2014/main" id="{AC847650-C135-4D0B-9122-229845264DC7}"/>
+                <a16:creationId xmlns:a16="http://schemas.microsoft.com/office/drawing/2014/main" id="{9431E51D-9A92-453D-BD13-D23ADD1C744A}"/>
               </a:ext>
             </a:extLst>
           </p:cNvPr>
@@ -12721,7 +12721,7 @@
           <p:cNvPr id="15" name="Editable boundary">
             <a:extLst xmlns:a="http://schemas.openxmlformats.org/drawingml/2006/main">
               <a:ext uri="{FF2B5EF4-FFF2-40B4-BE49-F238E27FC236}">
-                <a16:creationId xmlns:a16="http://schemas.microsoft.com/office/drawing/2014/main" id="{EF66E149-0887-4D45-8C13-0EA20DF57DAE}"/>
+                <a16:creationId xmlns:a16="http://schemas.microsoft.com/office/drawing/2014/main" id="{85264E2C-F86F-47A7-BB80-5F93F7CC4ECC}"/>
               </a:ext>
             </a:extLst>
           </p:cNvPr>
@@ -12754,7 +12754,7 @@
           <p:cNvPr id="16" name="Approved task">
             <a:extLst xmlns:a="http://schemas.openxmlformats.org/drawingml/2006/main">
               <a:ext uri="{FF2B5EF4-FFF2-40B4-BE49-F238E27FC236}">
-                <a16:creationId xmlns:a16="http://schemas.microsoft.com/office/drawing/2014/main" id="{9AF7A242-547D-47E3-916D-A92DD5C339BD}"/>
+                <a16:creationId xmlns:a16="http://schemas.microsoft.com/office/drawing/2014/main" id="{9042AD81-466D-4417-92C1-C803E3876716}"/>
               </a:ext>
             </a:extLst>
           </p:cNvPr>
@@ -12811,7 +12811,7 @@
           <p:cNvPr id="17" name="Send a sanitized vendor update">
             <a:extLst xmlns:a="http://schemas.openxmlformats.org/drawingml/2006/main">
               <a:ext uri="{FF2B5EF4-FFF2-40B4-BE49-F238E27FC236}">
-                <a16:creationId xmlns:a16="http://schemas.microsoft.com/office/drawing/2014/main" id="{4B3380A1-C8F0-4F3D-AA84-F0E2348F29D5}"/>
+                <a16:creationId xmlns:a16="http://schemas.microsoft.com/office/drawing/2014/main" id="{87EC80B6-1D08-4C29-8206-8396A204761F}"/>
               </a:ext>
             </a:extLst>
           </p:cNvPr>
@@ -12868,7 +12868,7 @@
           <p:cNvPr id="18" name="Keep customer IDs internal">
             <a:extLst xmlns:a="http://schemas.openxmlformats.org/drawingml/2006/main">
               <a:ext uri="{FF2B5EF4-FFF2-40B4-BE49-F238E27FC236}">
-                <a16:creationId xmlns:a16="http://schemas.microsoft.com/office/drawing/2014/main" id="{854FBC62-8B6E-4CAD-BE83-09F464F2E82F}"/>
+                <a16:creationId xmlns:a16="http://schemas.microsoft.com/office/drawing/2014/main" id="{FE8D0DFE-4FD2-4AE1-B9B1-EDDA2E0CEC7E}"/>
               </a:ext>
             </a:extLst>
           </p:cNvPr>
@@ -12925,7 +12925,7 @@
           <p:cNvPr id="19" name="Editable flow path">
             <a:extLst xmlns:a="http://schemas.openxmlformats.org/drawingml/2006/main">
               <a:ext uri="{FF2B5EF4-FFF2-40B4-BE49-F238E27FC236}">
-                <a16:creationId xmlns:a16="http://schemas.microsoft.com/office/drawing/2014/main" id="{967B18AC-7357-4170-B84A-F72EEE46A5E2}"/>
+                <a16:creationId xmlns:a16="http://schemas.microsoft.com/office/drawing/2014/main" id="{9A005351-8011-4436-92CF-2CA70E942E90}"/>
               </a:ext>
             </a:extLst>
           </p:cNvPr>
@@ -12965,7 +12965,7 @@
           <p:cNvPr id="20" name="Editable arrowhead">
             <a:extLst xmlns:a="http://schemas.openxmlformats.org/drawingml/2006/main">
               <a:ext uri="{FF2B5EF4-FFF2-40B4-BE49-F238E27FC236}">
-                <a16:creationId xmlns:a16="http://schemas.microsoft.com/office/drawing/2014/main" id="{941460B7-18E6-430D-A6B5-60EE06AD3725}"/>
+                <a16:creationId xmlns:a16="http://schemas.microsoft.com/office/drawing/2014/main" id="{398AF6A0-6852-4118-9A9F-11509DA62108}"/>
               </a:ext>
             </a:extLst>
           </p:cNvPr>
@@ -13008,7 +13008,7 @@
           <p:cNvPr id="21" name="delegated scope">
             <a:extLst xmlns:a="http://schemas.openxmlformats.org/drawingml/2006/main">
               <a:ext uri="{FF2B5EF4-FFF2-40B4-BE49-F238E27FC236}">
-                <a16:creationId xmlns:a16="http://schemas.microsoft.com/office/drawing/2014/main" id="{3F651E23-7B7E-4B75-819E-227F28120FA8}"/>
+                <a16:creationId xmlns:a16="http://schemas.microsoft.com/office/drawing/2014/main" id="{C2B3C9D6-3E3F-4EB0-A070-03DA96BADF23}"/>
               </a:ext>
             </a:extLst>
           </p:cNvPr>
@@ -13065,7 +13065,7 @@
           <p:cNvPr id="22" name="Editable boundary">
             <a:extLst xmlns:a="http://schemas.openxmlformats.org/drawingml/2006/main">
               <a:ext uri="{FF2B5EF4-FFF2-40B4-BE49-F238E27FC236}">
-                <a16:creationId xmlns:a16="http://schemas.microsoft.com/office/drawing/2014/main" id="{3E48EC6F-0E8E-4B22-B4DF-080B1721BCDE}"/>
+                <a16:creationId xmlns:a16="http://schemas.microsoft.com/office/drawing/2014/main" id="{00ADCF38-B2A6-49E3-9732-CB545E660FCA}"/>
               </a:ext>
             </a:extLst>
           </p:cNvPr>
@@ -13098,7 +13098,7 @@
           <p:cNvPr id="23" name="Agent A: incident analyst">
             <a:extLst xmlns:a="http://schemas.openxmlformats.org/drawingml/2006/main">
               <a:ext uri="{FF2B5EF4-FFF2-40B4-BE49-F238E27FC236}">
-                <a16:creationId xmlns:a16="http://schemas.microsoft.com/office/drawing/2014/main" id="{08911C7E-2C84-4DB5-86FC-BE5F05299513}"/>
+                <a16:creationId xmlns:a16="http://schemas.microsoft.com/office/drawing/2014/main" id="{589F311F-C5A8-4EE3-B023-2927ADB38B78}"/>
               </a:ext>
             </a:extLst>
           </p:cNvPr>
@@ -13155,7 +13155,7 @@
           <p:cNvPr id="24" name="Reads private incident report">
             <a:extLst xmlns:a="http://schemas.openxmlformats.org/drawingml/2006/main">
               <a:ext uri="{FF2B5EF4-FFF2-40B4-BE49-F238E27FC236}">
-                <a16:creationId xmlns:a16="http://schemas.microsoft.com/office/drawing/2014/main" id="{854975D1-DAC0-42BD-A216-79A4BBECEAB2}"/>
+                <a16:creationId xmlns:a16="http://schemas.microsoft.com/office/drawing/2014/main" id="{FD605563-A886-431B-9612-D6B1BC8D7B8B}"/>
               </a:ext>
             </a:extLst>
           </p:cNvPr>
@@ -13212,7 +13212,7 @@
           <p:cNvPr id="25" name="Drafts the vendor update">
             <a:extLst xmlns:a="http://schemas.openxmlformats.org/drawingml/2006/main">
               <a:ext uri="{FF2B5EF4-FFF2-40B4-BE49-F238E27FC236}">
-                <a16:creationId xmlns:a16="http://schemas.microsoft.com/office/drawing/2014/main" id="{1BC76936-634C-46C6-8640-126BCC2E9C22}"/>
+                <a16:creationId xmlns:a16="http://schemas.microsoft.com/office/drawing/2014/main" id="{6AD6F9C7-0257-4BA9-9744-001F2660A040}"/>
               </a:ext>
             </a:extLst>
           </p:cNvPr>
@@ -13269,7 +13269,7 @@
           <p:cNvPr id="26" name="Editable flow path">
             <a:extLst xmlns:a="http://schemas.openxmlformats.org/drawingml/2006/main">
               <a:ext uri="{FF2B5EF4-FFF2-40B4-BE49-F238E27FC236}">
-                <a16:creationId xmlns:a16="http://schemas.microsoft.com/office/drawing/2014/main" id="{FDEB3D6F-AE51-4003-AB0D-D1F3F1C4212F}"/>
+                <a16:creationId xmlns:a16="http://schemas.microsoft.com/office/drawing/2014/main" id="{BAF9A3F4-2917-45D6-B575-E86063DA1CBB}"/>
               </a:ext>
             </a:extLst>
           </p:cNvPr>
@@ -13309,7 +13309,7 @@
           <p:cNvPr id="27" name="Editable arrowhead">
             <a:extLst xmlns:a="http://schemas.openxmlformats.org/drawingml/2006/main">
               <a:ext uri="{FF2B5EF4-FFF2-40B4-BE49-F238E27FC236}">
-                <a16:creationId xmlns:a16="http://schemas.microsoft.com/office/drawing/2014/main" id="{456EBC73-C674-4F33-91C9-E5FBB6B30C2E}"/>
+                <a16:creationId xmlns:a16="http://schemas.microsoft.com/office/drawing/2014/main" id="{D92A3DC3-6EE4-4B31-93B4-18C03C8DC17C}"/>
               </a:ext>
             </a:extLst>
           </p:cNvPr>
@@ -13352,7 +13352,7 @@
           <p:cNvPr id="28" name="Editable boundary">
             <a:extLst xmlns:a="http://schemas.openxmlformats.org/drawingml/2006/main">
               <a:ext uri="{FF2B5EF4-FFF2-40B4-BE49-F238E27FC236}">
-                <a16:creationId xmlns:a16="http://schemas.microsoft.com/office/drawing/2014/main" id="{550130CC-2CB7-4C4E-A375-44F6D5C0C6C5}"/>
+                <a16:creationId xmlns:a16="http://schemas.microsoft.com/office/drawing/2014/main" id="{860C986B-0F0E-40E8-AFCF-4473FBD17FC4}"/>
               </a:ext>
             </a:extLst>
           </p:cNvPr>
@@ -13385,7 +13385,7 @@
           <p:cNvPr id="29" name="Handoff package">
             <a:extLst xmlns:a="http://schemas.openxmlformats.org/drawingml/2006/main">
               <a:ext uri="{FF2B5EF4-FFF2-40B4-BE49-F238E27FC236}">
-                <a16:creationId xmlns:a16="http://schemas.microsoft.com/office/drawing/2014/main" id="{641BC473-7ABF-4458-98E9-4FE0B69F7DF1}"/>
+                <a16:creationId xmlns:a16="http://schemas.microsoft.com/office/drawing/2014/main" id="{7182E373-8802-46B2-AAFF-2126FDDB1B48}"/>
               </a:ext>
             </a:extLst>
           </p:cNvPr>
@@ -13442,7 +13442,7 @@
           <p:cNvPr id="30" name="Task: send the vendor update">
             <a:extLst xmlns:a="http://schemas.openxmlformats.org/drawingml/2006/main">
               <a:ext uri="{FF2B5EF4-FFF2-40B4-BE49-F238E27FC236}">
-                <a16:creationId xmlns:a16="http://schemas.microsoft.com/office/drawing/2014/main" id="{E2A4E0D5-41A2-4BA2-8391-AEFA22C75C34}"/>
+                <a16:creationId xmlns:a16="http://schemas.microsoft.com/office/drawing/2014/main" id="{ABA315E5-693C-4B5C-9219-3E9D494590E3}"/>
               </a:ext>
             </a:extLst>
           </p:cNvPr>
@@ -13499,7 +13499,7 @@
           <p:cNvPr id="31" name="Payload: draft containing customer IDs">
             <a:extLst xmlns:a="http://schemas.openxmlformats.org/drawingml/2006/main">
               <a:ext uri="{FF2B5EF4-FFF2-40B4-BE49-F238E27FC236}">
-                <a16:creationId xmlns:a16="http://schemas.microsoft.com/office/drawing/2014/main" id="{6933BDD8-EAA4-488C-A735-4864C58130CF}"/>
+                <a16:creationId xmlns:a16="http://schemas.microsoft.com/office/drawing/2014/main" id="{210BCD04-FB70-4606-811F-906F10BCAFC9}"/>
               </a:ext>
             </a:extLst>
           </p:cNvPr>
@@ -13556,7 +13556,7 @@
           <p:cNvPr id="32" name="Editable flow path">
             <a:extLst xmlns:a="http://schemas.openxmlformats.org/drawingml/2006/main">
               <a:ext uri="{FF2B5EF4-FFF2-40B4-BE49-F238E27FC236}">
-                <a16:creationId xmlns:a16="http://schemas.microsoft.com/office/drawing/2014/main" id="{A1E449A9-7412-40E4-965A-9A1EE275B9B1}"/>
+                <a16:creationId xmlns:a16="http://schemas.microsoft.com/office/drawing/2014/main" id="{5A48C9B0-7A6C-4423-BA99-9614BF7213DC}"/>
               </a:ext>
             </a:extLst>
           </p:cNvPr>
@@ -13596,7 +13596,7 @@
           <p:cNvPr id="33" name="Editable arrowhead">
             <a:extLst xmlns:a="http://schemas.openxmlformats.org/drawingml/2006/main">
               <a:ext uri="{FF2B5EF4-FFF2-40B4-BE49-F238E27FC236}">
-                <a16:creationId xmlns:a16="http://schemas.microsoft.com/office/drawing/2014/main" id="{3727C483-A7C9-4536-954E-594301E94AED}"/>
+                <a16:creationId xmlns:a16="http://schemas.microsoft.com/office/drawing/2014/main" id="{6A57C6BB-5477-4C09-AAC3-E4D319C7B9E3}"/>
               </a:ext>
             </a:extLst>
           </p:cNvPr>
@@ -13639,7 +13639,7 @@
           <p:cNvPr id="34" name="task + data">
             <a:extLst xmlns:a="http://schemas.openxmlformats.org/drawingml/2006/main">
               <a:ext uri="{FF2B5EF4-FFF2-40B4-BE49-F238E27FC236}">
-                <a16:creationId xmlns:a16="http://schemas.microsoft.com/office/drawing/2014/main" id="{CECE1D9F-F76D-40A3-9264-77D5A93A1616}"/>
+                <a16:creationId xmlns:a16="http://schemas.microsoft.com/office/drawing/2014/main" id="{DFB16F98-5854-401E-88C8-1A761A0331F0}"/>
               </a:ext>
             </a:extLst>
           </p:cNvPr>
@@ -13696,7 +13696,7 @@
           <p:cNvPr id="35" name="Editable boundary">
             <a:extLst xmlns:a="http://schemas.openxmlformats.org/drawingml/2006/main">
               <a:ext uri="{FF2B5EF4-FFF2-40B4-BE49-F238E27FC236}">
-                <a16:creationId xmlns:a16="http://schemas.microsoft.com/office/drawing/2014/main" id="{3D60A484-FE6E-4D00-AC4D-8BA919DBDE12}"/>
+                <a16:creationId xmlns:a16="http://schemas.microsoft.com/office/drawing/2014/main" id="{5958507B-0399-42B6-BB10-8F52A85CA578}"/>
               </a:ext>
             </a:extLst>
           </p:cNvPr>
@@ -13729,7 +13729,7 @@
           <p:cNvPr id="36" name="Agent B: vendor liaison">
             <a:extLst xmlns:a="http://schemas.openxmlformats.org/drawingml/2006/main">
               <a:ext uri="{FF2B5EF4-FFF2-40B4-BE49-F238E27FC236}">
-                <a16:creationId xmlns:a16="http://schemas.microsoft.com/office/drawing/2014/main" id="{502A2E58-9984-4756-9356-21229906733E}"/>
+                <a16:creationId xmlns:a16="http://schemas.microsoft.com/office/drawing/2014/main" id="{6D206B08-AD4E-458C-A067-C04BB8B10AA3}"/>
               </a:ext>
             </a:extLst>
           </p:cNvPr>
@@ -13786,7 +13786,7 @@
           <p:cNvPr id="37" name="Can email the external vendor">
             <a:extLst xmlns:a="http://schemas.openxmlformats.org/drawingml/2006/main">
               <a:ext uri="{FF2B5EF4-FFF2-40B4-BE49-F238E27FC236}">
-                <a16:creationId xmlns:a16="http://schemas.microsoft.com/office/drawing/2014/main" id="{0FC9A0C9-7418-45C8-95BA-CB07C7728EFF}"/>
+                <a16:creationId xmlns:a16="http://schemas.microsoft.com/office/drawing/2014/main" id="{D738894F-0090-4560-8907-E95159FCA51B}"/>
               </a:ext>
             </a:extLst>
           </p:cNvPr>
@@ -13843,7 +13843,7 @@
           <p:cNvPr id="38" name="Uses A’s draft as message content">
             <a:extLst xmlns:a="http://schemas.openxmlformats.org/drawingml/2006/main">
               <a:ext uri="{FF2B5EF4-FFF2-40B4-BE49-F238E27FC236}">
-                <a16:creationId xmlns:a16="http://schemas.microsoft.com/office/drawing/2014/main" id="{C3184E34-15BA-4D2F-8402-43CA461502EC}"/>
+                <a16:creationId xmlns:a16="http://schemas.microsoft.com/office/drawing/2014/main" id="{F2ABEAEE-2A3A-4147-8353-F5AC9E9A2AC2}"/>
               </a:ext>
             </a:extLst>
           </p:cNvPr>
@@ -13900,7 +13900,7 @@
           <p:cNvPr id="39" name="Read access + email access">
             <a:extLst xmlns:a="http://schemas.openxmlformats.org/drawingml/2006/main">
               <a:ext uri="{FF2B5EF4-FFF2-40B4-BE49-F238E27FC236}">
-                <a16:creationId xmlns:a16="http://schemas.microsoft.com/office/drawing/2014/main" id="{5E780CBB-83A9-4166-9380-2360E99B133F}"/>
+                <a16:creationId xmlns:a16="http://schemas.microsoft.com/office/drawing/2014/main" id="{1BDBAA37-AFD8-4D82-BA0E-B5348191BA2B}"/>
               </a:ext>
             </a:extLst>
           </p:cNvPr>
@@ -13957,7 +13957,7 @@
           <p:cNvPr id="40" name="do not authorize disclosure.">
             <a:extLst xmlns:a="http://schemas.openxmlformats.org/drawingml/2006/main">
               <a:ext uri="{FF2B5EF4-FFF2-40B4-BE49-F238E27FC236}">
-                <a16:creationId xmlns:a16="http://schemas.microsoft.com/office/drawing/2014/main" id="{C26E1719-D539-471D-8E28-428DC91A2B0D}"/>
+                <a16:creationId xmlns:a16="http://schemas.microsoft.com/office/drawing/2014/main" id="{1D8A143B-7F83-4E3E-9286-0E3347C23473}"/>
               </a:ext>
             </a:extLst>
           </p:cNvPr>
@@ -14014,7 +14014,7 @@
           <p:cNvPr id="41" name="authority +">
             <a:extLst xmlns:a="http://schemas.openxmlformats.org/drawingml/2006/main">
               <a:ext uri="{FF2B5EF4-FFF2-40B4-BE49-F238E27FC236}">
-                <a16:creationId xmlns:a16="http://schemas.microsoft.com/office/drawing/2014/main" id="{3F7D3473-EC49-461D-988E-5052ADAA360A}"/>
+                <a16:creationId xmlns:a16="http://schemas.microsoft.com/office/drawing/2014/main" id="{42FCADCB-E210-4B33-9AC5-748D3F14616F}"/>
               </a:ext>
             </a:extLst>
           </p:cNvPr>
@@ -14071,7 +14071,7 @@
           <p:cNvPr id="42" name="data lineage">
             <a:extLst xmlns:a="http://schemas.openxmlformats.org/drawingml/2006/main">
               <a:ext uri="{FF2B5EF4-FFF2-40B4-BE49-F238E27FC236}">
-                <a16:creationId xmlns:a16="http://schemas.microsoft.com/office/drawing/2014/main" id="{2B3184E1-9F49-4EAE-B0E3-8056B7190F8A}"/>
+                <a16:creationId xmlns:a16="http://schemas.microsoft.com/office/drawing/2014/main" id="{9C354763-A716-4005-A5E3-9801CDBDD302}"/>
               </a:ext>
             </a:extLst>
           </p:cNvPr>
@@ -14128,7 +14128,7 @@
           <p:cNvPr id="43" name="Editable flow path">
             <a:extLst xmlns:a="http://schemas.openxmlformats.org/drawingml/2006/main">
               <a:ext uri="{FF2B5EF4-FFF2-40B4-BE49-F238E27FC236}">
-                <a16:creationId xmlns:a16="http://schemas.microsoft.com/office/drawing/2014/main" id="{8B29A52C-6DC8-47CC-A5ED-7E38D8841491}"/>
+                <a16:creationId xmlns:a16="http://schemas.microsoft.com/office/drawing/2014/main" id="{26857139-6EE6-4A58-8660-51BE2858241F}"/>
               </a:ext>
             </a:extLst>
           </p:cNvPr>
@@ -14168,7 +14168,7 @@
           <p:cNvPr id="44" name="Editable arrowhead">
             <a:extLst xmlns:a="http://schemas.openxmlformats.org/drawingml/2006/main">
               <a:ext uri="{FF2B5EF4-FFF2-40B4-BE49-F238E27FC236}">
-                <a16:creationId xmlns:a16="http://schemas.microsoft.com/office/drawing/2014/main" id="{EE81C290-D12F-45A1-A15A-51DE298B5AF7}"/>
+                <a16:creationId xmlns:a16="http://schemas.microsoft.com/office/drawing/2014/main" id="{4CE7314E-3DC8-48D1-8E46-1EA8834B0692}"/>
               </a:ext>
             </a:extLst>
           </p:cNvPr>
@@ -14211,7 +14211,7 @@
           <p:cNvPr id="45" name="Editable boundary">
             <a:extLst xmlns:a="http://schemas.openxmlformats.org/drawingml/2006/main">
               <a:ext uri="{FF2B5EF4-FFF2-40B4-BE49-F238E27FC236}">
-                <a16:creationId xmlns:a16="http://schemas.microsoft.com/office/drawing/2014/main" id="{15A9897A-67B0-4062-A61A-5E632B330F29}"/>
+                <a16:creationId xmlns:a16="http://schemas.microsoft.com/office/drawing/2014/main" id="{73A787DC-DFAE-4D48-9E7E-CCB33690398C}"/>
               </a:ext>
             </a:extLst>
           </p:cNvPr>
@@ -14244,7 +14244,7 @@
           <p:cNvPr id="46" name="ScopeOK">
             <a:extLst xmlns:a="http://schemas.openxmlformats.org/drawingml/2006/main">
               <a:ext uri="{FF2B5EF4-FFF2-40B4-BE49-F238E27FC236}">
-                <a16:creationId xmlns:a16="http://schemas.microsoft.com/office/drawing/2014/main" id="{BDBCF0E6-AD41-4C3C-BE96-8248D8614C1F}"/>
+                <a16:creationId xmlns:a16="http://schemas.microsoft.com/office/drawing/2014/main" id="{3E4828E9-8F6A-4C3E-845A-B276F8AD094D}"/>
               </a:ext>
             </a:extLst>
           </p:cNvPr>
@@ -14301,7 +14301,7 @@
           <p:cNvPr id="47" name="Within delegated authority">
             <a:extLst xmlns:a="http://schemas.openxmlformats.org/drawingml/2006/main">
               <a:ext uri="{FF2B5EF4-FFF2-40B4-BE49-F238E27FC236}">
-                <a16:creationId xmlns:a16="http://schemas.microsoft.com/office/drawing/2014/main" id="{715AFD2A-1CDC-493E-B6F6-F187CDC0718C}"/>
+                <a16:creationId xmlns:a16="http://schemas.microsoft.com/office/drawing/2014/main" id="{5FEE6231-D459-4C9B-8D01-1EA8021284E4}"/>
               </a:ext>
             </a:extLst>
           </p:cNvPr>
@@ -14358,7 +14358,7 @@
           <p:cNvPr id="48" name="Editable boundary">
             <a:extLst xmlns:a="http://schemas.openxmlformats.org/drawingml/2006/main">
               <a:ext uri="{FF2B5EF4-FFF2-40B4-BE49-F238E27FC236}">
-                <a16:creationId xmlns:a16="http://schemas.microsoft.com/office/drawing/2014/main" id="{284C4C5E-DB33-43A6-9A90-86358E8AE494}"/>
+                <a16:creationId xmlns:a16="http://schemas.microsoft.com/office/drawing/2014/main" id="{57089C0B-B961-4F32-94AD-DB60B3A67363}"/>
               </a:ext>
             </a:extLst>
           </p:cNvPr>
@@ -14391,7 +14391,7 @@
           <p:cNvPr id="49" name="FlowOK">
             <a:extLst xmlns:a="http://schemas.openxmlformats.org/drawingml/2006/main">
               <a:ext uri="{FF2B5EF4-FFF2-40B4-BE49-F238E27FC236}">
-                <a16:creationId xmlns:a16="http://schemas.microsoft.com/office/drawing/2014/main" id="{41538C13-20DD-4066-92A7-A233BCC6C228}"/>
+                <a16:creationId xmlns:a16="http://schemas.microsoft.com/office/drawing/2014/main" id="{76CCF0FC-153B-459C-9415-1E2D1F85729E}"/>
               </a:ext>
             </a:extLst>
           </p:cNvPr>
@@ -14448,7 +14448,7 @@
           <p:cNvPr id="50" name="Preserves inherited data restrictions">
             <a:extLst xmlns:a="http://schemas.openxmlformats.org/drawingml/2006/main">
               <a:ext uri="{FF2B5EF4-FFF2-40B4-BE49-F238E27FC236}">
-                <a16:creationId xmlns:a16="http://schemas.microsoft.com/office/drawing/2014/main" id="{550EFB6B-C2AE-41A5-8F53-B21A32C77233}"/>
+                <a16:creationId xmlns:a16="http://schemas.microsoft.com/office/drawing/2014/main" id="{A83B359A-EB13-4086-92ED-03FFD25B006F}"/>
               </a:ext>
             </a:extLst>
           </p:cNvPr>
@@ -14505,7 +14505,7 @@
           <p:cNvPr id="51" name="Editable boundary">
             <a:extLst xmlns:a="http://schemas.openxmlformats.org/drawingml/2006/main">
               <a:ext uri="{FF2B5EF4-FFF2-40B4-BE49-F238E27FC236}">
-                <a16:creationId xmlns:a16="http://schemas.microsoft.com/office/drawing/2014/main" id="{E8C9D84E-54DE-4031-8B25-FD47D4D223E9}"/>
+                <a16:creationId xmlns:a16="http://schemas.microsoft.com/office/drawing/2014/main" id="{D2AF6FEB-882D-444B-9FF6-9D11C8203AD3}"/>
               </a:ext>
             </a:extLst>
           </p:cNvPr>
@@ -14538,7 +14538,7 @@
           <p:cNvPr id="52" name="FreshOK">
             <a:extLst xmlns:a="http://schemas.openxmlformats.org/drawingml/2006/main">
               <a:ext uri="{FF2B5EF4-FFF2-40B4-BE49-F238E27FC236}">
-                <a16:creationId xmlns:a16="http://schemas.microsoft.com/office/drawing/2014/main" id="{95BA7AD7-3116-4774-A399-2859E850F9FB}"/>
+                <a16:creationId xmlns:a16="http://schemas.microsoft.com/office/drawing/2014/main" id="{50D5F24F-569D-4701-9060-5330320C8AFC}"/>
               </a:ext>
             </a:extLst>
           </p:cNvPr>
@@ -14595,7 +14595,7 @@
           <p:cNvPr id="53" name="Approval dependencies remain valid">
             <a:extLst xmlns:a="http://schemas.openxmlformats.org/drawingml/2006/main">
               <a:ext uri="{FF2B5EF4-FFF2-40B4-BE49-F238E27FC236}">
-                <a16:creationId xmlns:a16="http://schemas.microsoft.com/office/drawing/2014/main" id="{AE7E4D8F-565B-4046-999D-F26B2BA4DC54}"/>
+                <a16:creationId xmlns:a16="http://schemas.microsoft.com/office/drawing/2014/main" id="{FA670D17-3C5E-456C-A9D8-288CC41CC9DB}"/>
               </a:ext>
             </a:extLst>
           </p:cNvPr>
@@ -14652,7 +14652,7 @@
           <p:cNvPr id="54" name="Revocation or changed context">
             <a:extLst xmlns:a="http://schemas.openxmlformats.org/drawingml/2006/main">
               <a:ext uri="{FF2B5EF4-FFF2-40B4-BE49-F238E27FC236}">
-                <a16:creationId xmlns:a16="http://schemas.microsoft.com/office/drawing/2014/main" id="{6E4406FF-4C4A-4BDF-B1AF-C4BC711C7575}"/>
+                <a16:creationId xmlns:a16="http://schemas.microsoft.com/office/drawing/2014/main" id="{1C179D43-8560-4564-9F93-DDF588CEC54C}"/>
               </a:ext>
             </a:extLst>
           </p:cNvPr>
@@ -14709,7 +14709,7 @@
           <p:cNvPr id="55" name="triggers revalidation.">
             <a:extLst xmlns:a="http://schemas.openxmlformats.org/drawingml/2006/main">
               <a:ext uri="{FF2B5EF4-FFF2-40B4-BE49-F238E27FC236}">
-                <a16:creationId xmlns:a16="http://schemas.microsoft.com/office/drawing/2014/main" id="{20A1341D-887F-4A44-8CD2-9F79832594D8}"/>
+                <a16:creationId xmlns:a16="http://schemas.microsoft.com/office/drawing/2014/main" id="{8637980F-F20E-4053-9F60-55B8E6487029}"/>
               </a:ext>
             </a:extLst>
           </p:cNvPr>
@@ -14766,7 +14766,7 @@
           <p:cNvPr id="56" name="current">
             <a:extLst xmlns:a="http://schemas.openxmlformats.org/drawingml/2006/main">
               <a:ext uri="{FF2B5EF4-FFF2-40B4-BE49-F238E27FC236}">
-                <a16:creationId xmlns:a16="http://schemas.microsoft.com/office/drawing/2014/main" id="{B0C137ED-A810-4093-9549-7304E978FB12}"/>
+                <a16:creationId xmlns:a16="http://schemas.microsoft.com/office/drawing/2014/main" id="{B8766E72-5A54-4E95-AB95-25DCDC28CAFB}"/>
               </a:ext>
             </a:extLst>
           </p:cNvPr>
@@ -14823,7 +14823,7 @@
           <p:cNvPr id="57" name="context c">
             <a:extLst xmlns:a="http://schemas.openxmlformats.org/drawingml/2006/main">
               <a:ext uri="{FF2B5EF4-FFF2-40B4-BE49-F238E27FC236}">
-                <a16:creationId xmlns:a16="http://schemas.microsoft.com/office/drawing/2014/main" id="{830E0D75-AB4A-43CA-993A-6A26E49F3982}"/>
+                <a16:creationId xmlns:a16="http://schemas.microsoft.com/office/drawing/2014/main" id="{51E3077C-0EAA-44B7-A01F-1CA17AA89B3A}"/>
               </a:ext>
             </a:extLst>
           </p:cNvPr>
@@ -14880,7 +14880,7 @@
           <p:cNvPr id="58" name="Editable flow path">
             <a:extLst xmlns:a="http://schemas.openxmlformats.org/drawingml/2006/main">
               <a:ext uri="{FF2B5EF4-FFF2-40B4-BE49-F238E27FC236}">
-                <a16:creationId xmlns:a16="http://schemas.microsoft.com/office/drawing/2014/main" id="{C09361EF-97C8-4B0A-B360-94534B612392}"/>
+                <a16:creationId xmlns:a16="http://schemas.microsoft.com/office/drawing/2014/main" id="{9FA0C2F5-77E4-4846-BEA6-5C7A0B332302}"/>
               </a:ext>
             </a:extLst>
           </p:cNvPr>
@@ -14920,7 +14920,7 @@
           <p:cNvPr id="59" name="Editable arrowhead">
             <a:extLst xmlns:a="http://schemas.openxmlformats.org/drawingml/2006/main">
               <a:ext uri="{FF2B5EF4-FFF2-40B4-BE49-F238E27FC236}">
-                <a16:creationId xmlns:a16="http://schemas.microsoft.com/office/drawing/2014/main" id="{CD034A46-46E7-438F-AE4B-03355145F7F2}"/>
+                <a16:creationId xmlns:a16="http://schemas.microsoft.com/office/drawing/2014/main" id="{7DC1332A-7A89-42D6-8697-8A0450104D21}"/>
               </a:ext>
             </a:extLst>
           </p:cNvPr>
@@ -14963,7 +14963,7 @@
           <p:cNvPr id="60" name="Editable boundary">
             <a:extLst xmlns:a="http://schemas.openxmlformats.org/drawingml/2006/main">
               <a:ext uri="{FF2B5EF4-FFF2-40B4-BE49-F238E27FC236}">
-                <a16:creationId xmlns:a16="http://schemas.microsoft.com/office/drawing/2014/main" id="{DE5ECD0A-8C7F-4B53-B2FF-74DC290A487C}"/>
+                <a16:creationId xmlns:a16="http://schemas.microsoft.com/office/drawing/2014/main" id="{D2CBD10D-F08D-41FA-876C-44CB64B3BBA9}"/>
               </a:ext>
             </a:extLst>
           </p:cNvPr>
@@ -14996,7 +14996,7 @@
           <p:cNvPr id="61" name="Workflow authorization rule">
             <a:extLst xmlns:a="http://schemas.openxmlformats.org/drawingml/2006/main">
               <a:ext uri="{FF2B5EF4-FFF2-40B4-BE49-F238E27FC236}">
-                <a16:creationId xmlns:a16="http://schemas.microsoft.com/office/drawing/2014/main" id="{48F97CB7-996A-4410-8449-E4F9A26C32CD}"/>
+                <a16:creationId xmlns:a16="http://schemas.microsoft.com/office/drawing/2014/main" id="{D5096615-51C7-4DB4-A0A5-C8D998F72476}"/>
               </a:ext>
             </a:extLst>
           </p:cNvPr>
@@ -15053,7 +15053,7 @@
           <p:cNvPr id="62" name="Allow(a, c) :=">
             <a:extLst xmlns:a="http://schemas.openxmlformats.org/drawingml/2006/main">
               <a:ext uri="{FF2B5EF4-FFF2-40B4-BE49-F238E27FC236}">
-                <a16:creationId xmlns:a16="http://schemas.microsoft.com/office/drawing/2014/main" id="{E42C10FC-0277-4496-BAC3-B28F5F872F83}"/>
+                <a16:creationId xmlns:a16="http://schemas.microsoft.com/office/drawing/2014/main" id="{6DC4EE89-FB08-485C-BC3D-51C3F1C4741F}"/>
               </a:ext>
             </a:extLst>
           </p:cNvPr>
@@ -15110,7 +15110,7 @@
           <p:cNvPr id="63" name="ScopeOK ∧ FlowOK ∧ FreshOK">
             <a:extLst xmlns:a="http://schemas.openxmlformats.org/drawingml/2006/main">
               <a:ext uri="{FF2B5EF4-FFF2-40B4-BE49-F238E27FC236}">
-                <a16:creationId xmlns:a16="http://schemas.microsoft.com/office/drawing/2014/main" id="{26EEB8F3-09A8-4482-8EEB-47D8206C0B45}"/>
+                <a16:creationId xmlns:a16="http://schemas.microsoft.com/office/drawing/2014/main" id="{36DFD45B-E3F0-4C85-832E-F131194673DB}"/>
               </a:ext>
             </a:extLst>
           </p:cNvPr>
@@ -15167,7 +15167,7 @@
           <p:cNvPr id="64" name="a: next delegated action">
             <a:extLst xmlns:a="http://schemas.openxmlformats.org/drawingml/2006/main">
               <a:ext uri="{FF2B5EF4-FFF2-40B4-BE49-F238E27FC236}">
-                <a16:creationId xmlns:a16="http://schemas.microsoft.com/office/drawing/2014/main" id="{2722C27B-94A6-4804-BAFC-988470DCE8F7}"/>
+                <a16:creationId xmlns:a16="http://schemas.microsoft.com/office/drawing/2014/main" id="{E87F8AB7-3535-4FC8-8BE9-CC237635494D}"/>
               </a:ext>
             </a:extLst>
           </p:cNvPr>
@@ -15224,7 +15224,7 @@
           <p:cNvPr id="65" name="c: current workflow context">
             <a:extLst xmlns:a="http://schemas.openxmlformats.org/drawingml/2006/main">
               <a:ext uri="{FF2B5EF4-FFF2-40B4-BE49-F238E27FC236}">
-                <a16:creationId xmlns:a16="http://schemas.microsoft.com/office/drawing/2014/main" id="{9B0B9AAB-DD3B-4E50-96DB-00D22B1FD1DE}"/>
+                <a16:creationId xmlns:a16="http://schemas.microsoft.com/office/drawing/2014/main" id="{BE542BE7-7101-4CBE-B5FF-4B25740B5A2E}"/>
               </a:ext>
             </a:extLst>
           </p:cNvPr>
@@ -15281,7 +15281,7 @@
           <p:cNvPr id="66" name="Editable flow path">
             <a:extLst xmlns:a="http://schemas.openxmlformats.org/drawingml/2006/main">
               <a:ext uri="{FF2B5EF4-FFF2-40B4-BE49-F238E27FC236}">
-                <a16:creationId xmlns:a16="http://schemas.microsoft.com/office/drawing/2014/main" id="{69C724D2-4A8A-4DFC-8920-84F7EABD1660}"/>
+                <a16:creationId xmlns:a16="http://schemas.microsoft.com/office/drawing/2014/main" id="{6932D516-2136-44BC-BC86-CB5D6E1060C4}"/>
               </a:ext>
             </a:extLst>
           </p:cNvPr>
@@ -15321,7 +15321,7 @@
           <p:cNvPr id="67" name="Editable flow path">
             <a:extLst xmlns:a="http://schemas.openxmlformats.org/drawingml/2006/main">
               <a:ext uri="{FF2B5EF4-FFF2-40B4-BE49-F238E27FC236}">
-                <a16:creationId xmlns:a16="http://schemas.microsoft.com/office/drawing/2014/main" id="{3590FB98-DBB4-448A-87F3-21E014D5CF66}"/>
+                <a16:creationId xmlns:a16="http://schemas.microsoft.com/office/drawing/2014/main" id="{45C5AE37-B0BC-4CF7-A31B-D5A67ECBF412}"/>
               </a:ext>
             </a:extLst>
           </p:cNvPr>
@@ -15364,7 +15364,7 @@
           <p:cNvPr id="68" name="Editable arrowhead">
             <a:extLst xmlns:a="http://schemas.openxmlformats.org/drawingml/2006/main">
               <a:ext uri="{FF2B5EF4-FFF2-40B4-BE49-F238E27FC236}">
-                <a16:creationId xmlns:a16="http://schemas.microsoft.com/office/drawing/2014/main" id="{F055FF8E-6AEC-4883-B3C5-A1B8427B59B8}"/>
+                <a16:creationId xmlns:a16="http://schemas.microsoft.com/office/drawing/2014/main" id="{3CE72E18-1680-47C4-90F0-D64B634F78A3}"/>
               </a:ext>
             </a:extLst>
           </p:cNvPr>
@@ -15407,7 +15407,7 @@
           <p:cNvPr id="69" name="Editable flow path">
             <a:extLst xmlns:a="http://schemas.openxmlformats.org/drawingml/2006/main">
               <a:ext uri="{FF2B5EF4-FFF2-40B4-BE49-F238E27FC236}">
-                <a16:creationId xmlns:a16="http://schemas.microsoft.com/office/drawing/2014/main" id="{E325B8FC-9B98-4ABC-B586-392C446058F5}"/>
+                <a16:creationId xmlns:a16="http://schemas.microsoft.com/office/drawing/2014/main" id="{43A210D6-2DCF-405E-A1A0-F2C784C6D346}"/>
               </a:ext>
             </a:extLst>
           </p:cNvPr>
@@ -15450,7 +15450,7 @@
           <p:cNvPr id="70" name="Editable arrowhead">
             <a:extLst xmlns:a="http://schemas.openxmlformats.org/drawingml/2006/main">
               <a:ext uri="{FF2B5EF4-FFF2-40B4-BE49-F238E27FC236}">
-                <a16:creationId xmlns:a16="http://schemas.microsoft.com/office/drawing/2014/main" id="{1E213D40-AA00-4198-B460-CBB1C9B2B012}"/>
+                <a16:creationId xmlns:a16="http://schemas.microsoft.com/office/drawing/2014/main" id="{DE46DC41-5B39-4410-9BEF-6AFEF943D5A4}"/>
               </a:ext>
             </a:extLst>
           </p:cNvPr>
@@ -15493,7 +15493,7 @@
           <p:cNvPr id="71" name="all pass">
             <a:extLst xmlns:a="http://schemas.openxmlformats.org/drawingml/2006/main">
               <a:ext uri="{FF2B5EF4-FFF2-40B4-BE49-F238E27FC236}">
-                <a16:creationId xmlns:a16="http://schemas.microsoft.com/office/drawing/2014/main" id="{88401182-D586-4054-A682-A5EE75634819}"/>
+                <a16:creationId xmlns:a16="http://schemas.microsoft.com/office/drawing/2014/main" id="{A49C5350-7778-45BA-98F7-464D4854A30A}"/>
               </a:ext>
             </a:extLst>
           </p:cNvPr>
@@ -15550,7 +15550,7 @@
           <p:cNvPr id="72" name="false / unknown">
             <a:extLst xmlns:a="http://schemas.openxmlformats.org/drawingml/2006/main">
               <a:ext uri="{FF2B5EF4-FFF2-40B4-BE49-F238E27FC236}">
-                <a16:creationId xmlns:a16="http://schemas.microsoft.com/office/drawing/2014/main" id="{5C547C09-50B1-4FB2-B003-AFD95C12A8A4}"/>
+                <a16:creationId xmlns:a16="http://schemas.microsoft.com/office/drawing/2014/main" id="{7DA7971E-1376-439C-935D-7D213AEE4A4D}"/>
               </a:ext>
             </a:extLst>
           </p:cNvPr>
@@ -15607,7 +15607,7 @@
           <p:cNvPr id="73" name="Editable boundary">
             <a:extLst xmlns:a="http://schemas.openxmlformats.org/drawingml/2006/main">
               <a:ext uri="{FF2B5EF4-FFF2-40B4-BE49-F238E27FC236}">
-                <a16:creationId xmlns:a16="http://schemas.microsoft.com/office/drawing/2014/main" id="{1FEB19D9-DF29-470D-9E25-AB4707FD6E4B}"/>
+                <a16:creationId xmlns:a16="http://schemas.microsoft.com/office/drawing/2014/main" id="{D7EDDBA0-1B09-4672-A856-86CCD08B5E61}"/>
               </a:ext>
             </a:extLst>
           </p:cNvPr>
@@ -15640,7 +15640,7 @@
           <p:cNvPr id="74" name="Editable boundary">
             <a:extLst xmlns:a="http://schemas.openxmlformats.org/drawingml/2006/main">
               <a:ext uri="{FF2B5EF4-FFF2-40B4-BE49-F238E27FC236}">
-                <a16:creationId xmlns:a16="http://schemas.microsoft.com/office/drawing/2014/main" id="{687244A6-2EEE-4859-8FA0-DB7BD734BE57}"/>
+                <a16:creationId xmlns:a16="http://schemas.microsoft.com/office/drawing/2014/main" id="{345F3CF3-A942-4AC1-B398-43D1C690000C}"/>
               </a:ext>
             </a:extLst>
           </p:cNvPr>
@@ -15673,7 +15673,7 @@
           <p:cNvPr id="75" name="Execute">
             <a:extLst xmlns:a="http://schemas.openxmlformats.org/drawingml/2006/main">
               <a:ext uri="{FF2B5EF4-FFF2-40B4-BE49-F238E27FC236}">
-                <a16:creationId xmlns:a16="http://schemas.microsoft.com/office/drawing/2014/main" id="{117CBBCF-0961-43EF-9DFC-78FBF7CFB540}"/>
+                <a16:creationId xmlns:a16="http://schemas.microsoft.com/office/drawing/2014/main" id="{0233C998-D4B5-47AD-A15C-4FB1CE7FB43F}"/>
               </a:ext>
             </a:extLst>
           </p:cNvPr>
@@ -15730,7 +15730,7 @@
           <p:cNvPr id="76" name="Suspend / replan">
             <a:extLst xmlns:a="http://schemas.openxmlformats.org/drawingml/2006/main">
               <a:ext uri="{FF2B5EF4-FFF2-40B4-BE49-F238E27FC236}">
-                <a16:creationId xmlns:a16="http://schemas.microsoft.com/office/drawing/2014/main" id="{239BCCC4-2963-44A3-82BE-A5A5EA7D6C83}"/>
+                <a16:creationId xmlns:a16="http://schemas.microsoft.com/office/drawing/2014/main" id="{3528DC1C-F1B6-4284-A3B3-AD1057C068E3}"/>
               </a:ext>
             </a:extLst>
           </p:cNvPr>
@@ -15787,7 +15787,7 @@
           <p:cNvPr id="77" name="Revalidate affected work; preserve valid progress.">
             <a:extLst xmlns:a="http://schemas.openxmlformats.org/drawingml/2006/main">
               <a:ext uri="{FF2B5EF4-FFF2-40B4-BE49-F238E27FC236}">
-                <a16:creationId xmlns:a16="http://schemas.microsoft.com/office/drawing/2014/main" id="{CF32905C-5CF7-4550-8BEE-8009AF3EF3A8}"/>
+                <a16:creationId xmlns:a16="http://schemas.microsoft.com/office/drawing/2014/main" id="{E4D5742C-0022-4FBC-B127-9E925CCD09A2}"/>
               </a:ext>
             </a:extLst>
           </p:cNvPr>
@@ -15844,7 +15844,7 @@
           <p:cNvPr id="78" name="Guarantees depend on captured effects and trusted enforcement.">
             <a:extLst xmlns:a="http://schemas.openxmlformats.org/drawingml/2006/main">
               <a:ext uri="{FF2B5EF4-FFF2-40B4-BE49-F238E27FC236}">
-                <a16:creationId xmlns:a16="http://schemas.microsoft.com/office/drawing/2014/main" id="{FC0E3EFD-88E5-4641-8EC6-532B162E6290}"/>
+                <a16:creationId xmlns:a16="http://schemas.microsoft.com/office/drawing/2014/main" id="{360FF40E-29A1-4386-9843-9F8E00CDF344}"/>
               </a:ext>
             </a:extLst>
           </p:cNvPr>
@@ -15899,7 +15899,7 @@
     </p:spTree>
     <p:extLst>
       <p:ext uri="{BB962C8B-B14F-4D97-AF65-F5344CB8AC3E}">
-        <p14:creationId xmlns:p14="http://schemas.microsoft.com/office/powerpoint/2010/main" val="1277759237"/>
+        <p14:creationId xmlns:p14="http://schemas.microsoft.com/office/powerpoint/2010/main" val="1267069358"/>
       </p:ext>
     </p:extLst>
   </p:cSld>

</xml_diff>

<commit_message>
Unify section diagram backgrounds and enable full-size image links (#140)
Co-authored-by: Claude <noreply@anthropic.com>
</commit_message>
<xml_diff>
--- a/public/data/statement-diagrams/statement-diagrams.pptx
+++ b/public/data/statement-diagrams/statement-diagrams.pptx
@@ -2,16 +2,16 @@
 <file path=ppt/presentation.xml><?xml version="1.0" encoding="utf-8"?>
 <p:presentation xmlns:p="http://schemas.openxmlformats.org/presentationml/2006/main">
   <p:sldMasterIdLst>
-    <p:sldMasterId xmlns:r="http://schemas.openxmlformats.org/officeDocument/2006/relationships" id="2147483648" r:id="Rd4b2b9beadf84b27"/>
+    <p:sldMasterId xmlns:r="http://schemas.openxmlformats.org/officeDocument/2006/relationships" id="2147483648" r:id="Rbca3071d395b4c4d"/>
   </p:sldMasterIdLst>
   <p:notesMasterIdLst>
-    <p:notesMasterId xmlns:r="http://schemas.openxmlformats.org/officeDocument/2006/relationships" r:id="R100055c3c7454f04"/>
+    <p:notesMasterId xmlns:r="http://schemas.openxmlformats.org/officeDocument/2006/relationships" r:id="R73a5df89d3794562"/>
   </p:notesMasterIdLst>
   <p:sldIdLst>
-    <p:sldId xmlns:r="http://schemas.openxmlformats.org/officeDocument/2006/relationships" id="256" r:id="R1d4817399874443b"/>
-    <p:sldId xmlns:r="http://schemas.openxmlformats.org/officeDocument/2006/relationships" id="257" r:id="R72fc32d638444e21"/>
-    <p:sldId xmlns:r="http://schemas.openxmlformats.org/officeDocument/2006/relationships" id="258" r:id="R02eb172ac2d64fdc"/>
-    <p:sldId xmlns:r="http://schemas.openxmlformats.org/officeDocument/2006/relationships" id="259" r:id="R11d16865722c486d"/>
+    <p:sldId xmlns:r="http://schemas.openxmlformats.org/officeDocument/2006/relationships" id="256" r:id="R2f8304cd73054eff"/>
+    <p:sldId xmlns:r="http://schemas.openxmlformats.org/officeDocument/2006/relationships" id="257" r:id="Rc23c832bf7fd47fe"/>
+    <p:sldId xmlns:r="http://schemas.openxmlformats.org/officeDocument/2006/relationships" id="258" r:id="R889ee02f71a34c14"/>
+    <p:sldId xmlns:r="http://schemas.openxmlformats.org/officeDocument/2006/relationships" id="259" r:id="Ra2ee8e9ea0e34e78"/>
   </p:sldIdLst>
   <p:sldSz cx="17916525" cy="10344150"/>
   <p:notesSz cx="6858000" cy="9144000"/>
@@ -723,7 +723,7 @@
   </p:cSld>
   <p:clrMap bg1="lt1" tx1="dk1" bg2="lt2" tx2="dk2" accent1="accent1" accent2="accent2" accent3="accent3" accent4="accent4" accent5="accent5" accent6="accent6" hlink="hlink" folHlink="folHlink"/>
   <p:sldLayoutIdLst>
-    <p:sldLayoutId xmlns:r="http://schemas.openxmlformats.org/officeDocument/2006/relationships" id="2147483649" r:id="R933be37ade7843cc"/>
+    <p:sldLayoutId xmlns:r="http://schemas.openxmlformats.org/officeDocument/2006/relationships" id="2147483649" r:id="R92d4c3da0bf347eb"/>
   </p:sldLayoutIdLst>
   <p:txStyles>
     <p:titleStyle>
@@ -1274,7 +1274,7 @@
           <p:cNvPr id="85" name="Reliable AI Agents Under Human Control">
             <a:extLst xmlns:a="http://schemas.openxmlformats.org/drawingml/2006/main">
               <a:ext uri="{FF2B5EF4-FFF2-40B4-BE49-F238E27FC236}">
-                <a16:creationId xmlns:a16="http://schemas.microsoft.com/office/drawing/2014/main" id="{7C010C66-0389-4552-86F8-6E8EB31F5A01}"/>
+                <a16:creationId xmlns:a16="http://schemas.microsoft.com/office/drawing/2014/main" id="{F541E00E-93CE-4914-8F13-3D0317740F86}"/>
               </a:ext>
             </a:extLst>
           </p:cNvPr>
@@ -1331,7 +1331,7 @@
           <p:cNvPr id="2" name="A proposed research agenda for actions, system updates, and dele">
             <a:extLst xmlns:a="http://schemas.openxmlformats.org/drawingml/2006/main">
               <a:ext uri="{FF2B5EF4-FFF2-40B4-BE49-F238E27FC236}">
-                <a16:creationId xmlns:a16="http://schemas.microsoft.com/office/drawing/2014/main" id="{88977193-E159-452B-9C18-47F20C7E995E}"/>
+                <a16:creationId xmlns:a16="http://schemas.microsoft.com/office/drawing/2014/main" id="{A1BAC1C2-DEE4-4202-81E1-34424DF46F27}"/>
               </a:ext>
             </a:extLst>
           </p:cNvPr>
@@ -1388,7 +1388,7 @@
           <p:cNvPr id="3" name="Editable boundary">
             <a:extLst xmlns:a="http://schemas.openxmlformats.org/drawingml/2006/main">
               <a:ext uri="{FF2B5EF4-FFF2-40B4-BE49-F238E27FC236}">
-                <a16:creationId xmlns:a16="http://schemas.microsoft.com/office/drawing/2014/main" id="{BECBB875-4A6B-476C-B305-21AE4845B7DE}"/>
+                <a16:creationId xmlns:a16="http://schemas.microsoft.com/office/drawing/2014/main" id="{2D6344F7-59C1-4A70-8A54-77B0866BC768}"/>
               </a:ext>
             </a:extLst>
           </p:cNvPr>
@@ -1421,7 +1421,7 @@
           <p:cNvPr id="4" name="Editable boundary">
             <a:extLst xmlns:a="http://schemas.openxmlformats.org/drawingml/2006/main">
               <a:ext uri="{FF2B5EF4-FFF2-40B4-BE49-F238E27FC236}">
-                <a16:creationId xmlns:a16="http://schemas.microsoft.com/office/drawing/2014/main" id="{D4E40C57-0068-45BC-B889-0584A1AD6E7D}"/>
+                <a16:creationId xmlns:a16="http://schemas.microsoft.com/office/drawing/2014/main" id="{6129F0E2-132A-45F4-B4A1-7D56C5B0521B}"/>
               </a:ext>
             </a:extLst>
           </p:cNvPr>
@@ -1454,7 +1454,7 @@
           <p:cNvPr id="5" name="Human–Agent Interaction">
             <a:extLst xmlns:a="http://schemas.openxmlformats.org/drawingml/2006/main">
               <a:ext uri="{FF2B5EF4-FFF2-40B4-BE49-F238E27FC236}">
-                <a16:creationId xmlns:a16="http://schemas.microsoft.com/office/drawing/2014/main" id="{18A7153E-49F3-4CB2-BB8C-1DB7864EA7ED}"/>
+                <a16:creationId xmlns:a16="http://schemas.microsoft.com/office/drawing/2014/main" id="{9930446E-F202-4203-93AA-7C6583CC278B}"/>
               </a:ext>
             </a:extLst>
           </p:cNvPr>
@@ -1511,7 +1511,7 @@
           <p:cNvPr id="6" name="Agent–Agent Collaboration">
             <a:extLst xmlns:a="http://schemas.openxmlformats.org/drawingml/2006/main">
               <a:ext uri="{FF2B5EF4-FFF2-40B4-BE49-F238E27FC236}">
-                <a16:creationId xmlns:a16="http://schemas.microsoft.com/office/drawing/2014/main" id="{90BE166A-F805-4066-8651-6F51122A5C74}"/>
+                <a16:creationId xmlns:a16="http://schemas.microsoft.com/office/drawing/2014/main" id="{C1826997-3102-459E-B4FC-AFDDAA9E4FF9}"/>
               </a:ext>
             </a:extLst>
           </p:cNvPr>
@@ -1572,7 +1572,7 @@
           <p:nvPr/>
         </p:nvPicPr>
         <p:blipFill>
-          <a:blip xmlns:r="http://schemas.openxmlformats.org/officeDocument/2006/relationships" xmlns:a="http://schemas.openxmlformats.org/drawingml/2006/main" r:embed="Rb8ea008a9b6149ab"/>
+          <a:blip xmlns:r="http://schemas.openxmlformats.org/officeDocument/2006/relationships" xmlns:a="http://schemas.openxmlformats.org/drawingml/2006/main" r:embed="Rd37ac12176e94266"/>
           <a:stretch xmlns:a="http://schemas.openxmlformats.org/drawingml/2006/main"/>
         </p:blipFill>
         <p:spPr>
@@ -1594,7 +1594,7 @@
           <p:nvPr/>
         </p:nvPicPr>
         <p:blipFill>
-          <a:blip xmlns:r="http://schemas.openxmlformats.org/officeDocument/2006/relationships" xmlns:a="http://schemas.openxmlformats.org/drawingml/2006/main" r:embed="Rb745a1813fdf4151"/>
+          <a:blip xmlns:r="http://schemas.openxmlformats.org/officeDocument/2006/relationships" xmlns:a="http://schemas.openxmlformats.org/drawingml/2006/main" r:embed="R20f5c4631ac24f88"/>
           <a:stretch xmlns:a="http://schemas.openxmlformats.org/drawingml/2006/main"/>
         </p:blipFill>
         <p:spPr>
@@ -1616,7 +1616,7 @@
           <p:nvPr/>
         </p:nvPicPr>
         <p:blipFill>
-          <a:blip xmlns:r="http://schemas.openxmlformats.org/officeDocument/2006/relationships" xmlns:a="http://schemas.openxmlformats.org/drawingml/2006/main" r:embed="R0b3bd1e933e1432a"/>
+          <a:blip xmlns:r="http://schemas.openxmlformats.org/officeDocument/2006/relationships" xmlns:a="http://schemas.openxmlformats.org/drawingml/2006/main" r:embed="R753c113c9fbe4335"/>
           <a:stretch xmlns:a="http://schemas.openxmlformats.org/drawingml/2006/main"/>
         </p:blipFill>
         <p:spPr>
@@ -1638,7 +1638,7 @@
           <p:nvPr/>
         </p:nvPicPr>
         <p:blipFill>
-          <a:blip xmlns:r="http://schemas.openxmlformats.org/officeDocument/2006/relationships" xmlns:a="http://schemas.openxmlformats.org/drawingml/2006/main" r:embed="R7470f3fbb51342ed"/>
+          <a:blip xmlns:r="http://schemas.openxmlformats.org/officeDocument/2006/relationships" xmlns:a="http://schemas.openxmlformats.org/drawingml/2006/main" r:embed="R6cdd35ac4b41436b"/>
           <a:stretch xmlns:a="http://schemas.openxmlformats.org/drawingml/2006/main"/>
         </p:blipFill>
         <p:spPr>
@@ -1656,7 +1656,7 @@
           <p:cNvPr id="11" name="Human">
             <a:extLst xmlns:a="http://schemas.openxmlformats.org/drawingml/2006/main">
               <a:ext uri="{FF2B5EF4-FFF2-40B4-BE49-F238E27FC236}">
-                <a16:creationId xmlns:a16="http://schemas.microsoft.com/office/drawing/2014/main" id="{DE6A4282-E9AA-4AA2-9BE6-DF26A4C9A54B}"/>
+                <a16:creationId xmlns:a16="http://schemas.microsoft.com/office/drawing/2014/main" id="{02415D4D-44F3-41D4-84F2-D03A5C8CC463}"/>
               </a:ext>
             </a:extLst>
           </p:cNvPr>
@@ -1713,7 +1713,7 @@
           <p:cNvPr id="12" name="AI agent">
             <a:extLst xmlns:a="http://schemas.openxmlformats.org/drawingml/2006/main">
               <a:ext uri="{FF2B5EF4-FFF2-40B4-BE49-F238E27FC236}">
-                <a16:creationId xmlns:a16="http://schemas.microsoft.com/office/drawing/2014/main" id="{973CC4AD-B973-4ACE-B7FD-97275B2F4CF9}"/>
+                <a16:creationId xmlns:a16="http://schemas.microsoft.com/office/drawing/2014/main" id="{898ED6D7-B892-4713-85FF-C08CEF2FDEAF}"/>
               </a:ext>
             </a:extLst>
           </p:cNvPr>
@@ -1770,7 +1770,7 @@
           <p:cNvPr id="13" name="Agent A">
             <a:extLst xmlns:a="http://schemas.openxmlformats.org/drawingml/2006/main">
               <a:ext uri="{FF2B5EF4-FFF2-40B4-BE49-F238E27FC236}">
-                <a16:creationId xmlns:a16="http://schemas.microsoft.com/office/drawing/2014/main" id="{3A90201A-E50C-40DA-821D-BA3D61DE738B}"/>
+                <a16:creationId xmlns:a16="http://schemas.microsoft.com/office/drawing/2014/main" id="{65725406-44A8-496F-9BC6-7183CE12AE79}"/>
               </a:ext>
             </a:extLst>
           </p:cNvPr>
@@ -1827,7 +1827,7 @@
           <p:cNvPr id="14" name="Agent B">
             <a:extLst xmlns:a="http://schemas.openxmlformats.org/drawingml/2006/main">
               <a:ext uri="{FF2B5EF4-FFF2-40B4-BE49-F238E27FC236}">
-                <a16:creationId xmlns:a16="http://schemas.microsoft.com/office/drawing/2014/main" id="{2ED8D931-C5AE-487D-AF51-5C8F9C289FEF}"/>
+                <a16:creationId xmlns:a16="http://schemas.microsoft.com/office/drawing/2014/main" id="{685B5718-358B-4E00-A343-0DB1860F4E4E}"/>
               </a:ext>
             </a:extLst>
           </p:cNvPr>
@@ -1884,7 +1884,7 @@
           <p:cNvPr id="15" name="Task + authorized scope">
             <a:extLst xmlns:a="http://schemas.openxmlformats.org/drawingml/2006/main">
               <a:ext uri="{FF2B5EF4-FFF2-40B4-BE49-F238E27FC236}">
-                <a16:creationId xmlns:a16="http://schemas.microsoft.com/office/drawing/2014/main" id="{87A77615-578D-4145-BBCA-BF06490FBE46}"/>
+                <a16:creationId xmlns:a16="http://schemas.microsoft.com/office/drawing/2014/main" id="{EA448735-003B-48D0-B036-C4F2BFE3D25F}"/>
               </a:ext>
             </a:extLst>
           </p:cNvPr>
@@ -1941,7 +1941,7 @@
           <p:cNvPr id="16" name="Editable flow path">
             <a:extLst xmlns:a="http://schemas.openxmlformats.org/drawingml/2006/main">
               <a:ext uri="{FF2B5EF4-FFF2-40B4-BE49-F238E27FC236}">
-                <a16:creationId xmlns:a16="http://schemas.microsoft.com/office/drawing/2014/main" id="{6B5725E4-F2F0-407B-A2DB-4322846E72FE}"/>
+                <a16:creationId xmlns:a16="http://schemas.microsoft.com/office/drawing/2014/main" id="{8544126D-417E-4D37-81EF-37CBBE629317}"/>
               </a:ext>
             </a:extLst>
           </p:cNvPr>
@@ -1981,7 +1981,7 @@
           <p:cNvPr id="17" name="Editable arrowhead">
             <a:extLst xmlns:a="http://schemas.openxmlformats.org/drawingml/2006/main">
               <a:ext uri="{FF2B5EF4-FFF2-40B4-BE49-F238E27FC236}">
-                <a16:creationId xmlns:a16="http://schemas.microsoft.com/office/drawing/2014/main" id="{BB510973-5DC8-4E12-A24B-CBB627BED026}"/>
+                <a16:creationId xmlns:a16="http://schemas.microsoft.com/office/drawing/2014/main" id="{F38B4851-2B91-47BB-99C1-B7D96556539B}"/>
               </a:ext>
             </a:extLst>
           </p:cNvPr>
@@ -2024,7 +2024,7 @@
           <p:cNvPr id="18" name="Editable flow path">
             <a:extLst xmlns:a="http://schemas.openxmlformats.org/drawingml/2006/main">
               <a:ext uri="{FF2B5EF4-FFF2-40B4-BE49-F238E27FC236}">
-                <a16:creationId xmlns:a16="http://schemas.microsoft.com/office/drawing/2014/main" id="{A8F464A7-8532-4F04-9B10-215939E4A747}"/>
+                <a16:creationId xmlns:a16="http://schemas.microsoft.com/office/drawing/2014/main" id="{30EF0F97-AAE4-408A-B17D-642EC36007A7}"/>
               </a:ext>
             </a:extLst>
           </p:cNvPr>
@@ -2064,7 +2064,7 @@
           <p:cNvPr id="19" name="Editable arrowhead">
             <a:extLst xmlns:a="http://schemas.openxmlformats.org/drawingml/2006/main">
               <a:ext uri="{FF2B5EF4-FFF2-40B4-BE49-F238E27FC236}">
-                <a16:creationId xmlns:a16="http://schemas.microsoft.com/office/drawing/2014/main" id="{B9A78B6C-8126-4257-B71B-2502D6798ADF}"/>
+                <a16:creationId xmlns:a16="http://schemas.microsoft.com/office/drawing/2014/main" id="{93C6DD90-B069-4C05-8D0B-99AD736F1D12}"/>
               </a:ext>
             </a:extLst>
           </p:cNvPr>
@@ -2107,7 +2107,7 @@
           <p:cNvPr id="20" name="Action proposal + evidence">
             <a:extLst xmlns:a="http://schemas.openxmlformats.org/drawingml/2006/main">
               <a:ext uri="{FF2B5EF4-FFF2-40B4-BE49-F238E27FC236}">
-                <a16:creationId xmlns:a16="http://schemas.microsoft.com/office/drawing/2014/main" id="{EAF05EEF-0B97-4592-94F5-4866F02F3216}"/>
+                <a16:creationId xmlns:a16="http://schemas.microsoft.com/office/drawing/2014/main" id="{226AA0A1-729D-4415-943E-A9C6FA583A88}"/>
               </a:ext>
             </a:extLst>
           </p:cNvPr>
@@ -2164,7 +2164,7 @@
           <p:cNvPr id="21" name="Subtask + data + constraints">
             <a:extLst xmlns:a="http://schemas.openxmlformats.org/drawingml/2006/main">
               <a:ext uri="{FF2B5EF4-FFF2-40B4-BE49-F238E27FC236}">
-                <a16:creationId xmlns:a16="http://schemas.microsoft.com/office/drawing/2014/main" id="{B9CDBF56-D582-44E0-ADC6-8ED92D010944}"/>
+                <a16:creationId xmlns:a16="http://schemas.microsoft.com/office/drawing/2014/main" id="{0137091F-7FE4-4732-A20E-8EB90D7D3F4F}"/>
               </a:ext>
             </a:extLst>
           </p:cNvPr>
@@ -2221,7 +2221,7 @@
           <p:cNvPr id="22" name="Editable flow path">
             <a:extLst xmlns:a="http://schemas.openxmlformats.org/drawingml/2006/main">
               <a:ext uri="{FF2B5EF4-FFF2-40B4-BE49-F238E27FC236}">
-                <a16:creationId xmlns:a16="http://schemas.microsoft.com/office/drawing/2014/main" id="{CCD55726-6EC5-43E2-B06E-0076A8A989F3}"/>
+                <a16:creationId xmlns:a16="http://schemas.microsoft.com/office/drawing/2014/main" id="{57AFC192-DE1A-4000-BF05-B0C0918B761C}"/>
               </a:ext>
             </a:extLst>
           </p:cNvPr>
@@ -2261,7 +2261,7 @@
           <p:cNvPr id="23" name="Editable arrowhead">
             <a:extLst xmlns:a="http://schemas.openxmlformats.org/drawingml/2006/main">
               <a:ext uri="{FF2B5EF4-FFF2-40B4-BE49-F238E27FC236}">
-                <a16:creationId xmlns:a16="http://schemas.microsoft.com/office/drawing/2014/main" id="{03700B64-3315-4DB3-9556-E8DE126A6F27}"/>
+                <a16:creationId xmlns:a16="http://schemas.microsoft.com/office/drawing/2014/main" id="{1C495C38-7C7B-4B6B-BE05-BF2A0E00FF5B}"/>
               </a:ext>
             </a:extLst>
           </p:cNvPr>
@@ -2304,7 +2304,7 @@
           <p:cNvPr id="24" name="Editable flow path">
             <a:extLst xmlns:a="http://schemas.openxmlformats.org/drawingml/2006/main">
               <a:ext uri="{FF2B5EF4-FFF2-40B4-BE49-F238E27FC236}">
-                <a16:creationId xmlns:a16="http://schemas.microsoft.com/office/drawing/2014/main" id="{64F93547-D2A6-4242-B6DC-B42B4FD8A177}"/>
+                <a16:creationId xmlns:a16="http://schemas.microsoft.com/office/drawing/2014/main" id="{52C54361-7765-4CA0-BBEB-6B3E0A4AC5BE}"/>
               </a:ext>
             </a:extLst>
           </p:cNvPr>
@@ -2344,7 +2344,7 @@
           <p:cNvPr id="25" name="Editable arrowhead">
             <a:extLst xmlns:a="http://schemas.openxmlformats.org/drawingml/2006/main">
               <a:ext uri="{FF2B5EF4-FFF2-40B4-BE49-F238E27FC236}">
-                <a16:creationId xmlns:a16="http://schemas.microsoft.com/office/drawing/2014/main" id="{3BFCD736-E4BF-439A-B6F0-6D5F3E275E93}"/>
+                <a16:creationId xmlns:a16="http://schemas.microsoft.com/office/drawing/2014/main" id="{F75577C5-59E0-49F0-9CDF-E9D2B5AE0888}"/>
               </a:ext>
             </a:extLst>
           </p:cNvPr>
@@ -2387,7 +2387,7 @@
           <p:cNvPr id="26" name="Proposal + evidence + status">
             <a:extLst xmlns:a="http://schemas.openxmlformats.org/drawingml/2006/main">
               <a:ext uri="{FF2B5EF4-FFF2-40B4-BE49-F238E27FC236}">
-                <a16:creationId xmlns:a16="http://schemas.microsoft.com/office/drawing/2014/main" id="{6A75542F-A56B-4FCD-BFE6-A18A944F922F}"/>
+                <a16:creationId xmlns:a16="http://schemas.microsoft.com/office/drawing/2014/main" id="{6E38C956-F935-4274-9B89-99F07C4B12A2}"/>
               </a:ext>
             </a:extLst>
           </p:cNvPr>
@@ -2444,7 +2444,7 @@
           <p:cNvPr id="27" name="Editable boundary">
             <a:extLst xmlns:a="http://schemas.openxmlformats.org/drawingml/2006/main">
               <a:ext uri="{FF2B5EF4-FFF2-40B4-BE49-F238E27FC236}">
-                <a16:creationId xmlns:a16="http://schemas.microsoft.com/office/drawing/2014/main" id="{A0DCF679-723E-4D91-BB16-AB51DDE60CBE}"/>
+                <a16:creationId xmlns:a16="http://schemas.microsoft.com/office/drawing/2014/main" id="{CE65DF32-913D-48D6-A246-D62EBA60F7A0}"/>
               </a:ext>
             </a:extLst>
           </p:cNvPr>
@@ -2477,7 +2477,7 @@
           <p:cNvPr id="28" name="Editable boundary">
             <a:extLst xmlns:a="http://schemas.openxmlformats.org/drawingml/2006/main">
               <a:ext uri="{FF2B5EF4-FFF2-40B4-BE49-F238E27FC236}">
-                <a16:creationId xmlns:a16="http://schemas.microsoft.com/office/drawing/2014/main" id="{18B46462-3920-4707-BABD-29DFF619F201}"/>
+                <a16:creationId xmlns:a16="http://schemas.microsoft.com/office/drawing/2014/main" id="{7DB26436-F0DD-4141-B6BC-F16FA3FEA8F7}"/>
               </a:ext>
             </a:extLst>
           </p:cNvPr>
@@ -2510,7 +2510,7 @@
           <p:cNvPr id="29" name="I">
             <a:extLst xmlns:a="http://schemas.openxmlformats.org/drawingml/2006/main">
               <a:ext uri="{FF2B5EF4-FFF2-40B4-BE49-F238E27FC236}">
-                <a16:creationId xmlns:a16="http://schemas.microsoft.com/office/drawing/2014/main" id="{027FECE3-72E4-4F71-B3B8-F9BDD0B5E541}"/>
+                <a16:creationId xmlns:a16="http://schemas.microsoft.com/office/drawing/2014/main" id="{3BFBB24B-43C0-47DB-A0E6-6885A0BFEA8B}"/>
               </a:ext>
             </a:extLst>
           </p:cNvPr>
@@ -2567,7 +2567,7 @@
           <p:cNvPr id="30" name="Check proposed actions against approved requirements">
             <a:extLst xmlns:a="http://schemas.openxmlformats.org/drawingml/2006/main">
               <a:ext uri="{FF2B5EF4-FFF2-40B4-BE49-F238E27FC236}">
-                <a16:creationId xmlns:a16="http://schemas.microsoft.com/office/drawing/2014/main" id="{D0D54E28-F5A4-4E51-8ADF-7B0D8F89E7A2}"/>
+                <a16:creationId xmlns:a16="http://schemas.microsoft.com/office/drawing/2014/main" id="{A7E05D7E-6144-4E9E-B30D-85FC9D7AB326}"/>
               </a:ext>
             </a:extLst>
           </p:cNvPr>
@@ -2624,7 +2624,7 @@
           <p:cNvPr id="31" name="Editable boundary">
             <a:extLst xmlns:a="http://schemas.openxmlformats.org/drawingml/2006/main">
               <a:ext uri="{FF2B5EF4-FFF2-40B4-BE49-F238E27FC236}">
-                <a16:creationId xmlns:a16="http://schemas.microsoft.com/office/drawing/2014/main" id="{CCA70040-507B-44AB-B9CE-1E33DF005E51}"/>
+                <a16:creationId xmlns:a16="http://schemas.microsoft.com/office/drawing/2014/main" id="{E73FD651-E6D9-47B1-859D-104D2ADB98EB}"/>
               </a:ext>
             </a:extLst>
           </p:cNvPr>
@@ -2657,7 +2657,7 @@
           <p:cNvPr id="32" name="Editable boundary">
             <a:extLst xmlns:a="http://schemas.openxmlformats.org/drawingml/2006/main">
               <a:ext uri="{FF2B5EF4-FFF2-40B4-BE49-F238E27FC236}">
-                <a16:creationId xmlns:a16="http://schemas.microsoft.com/office/drawing/2014/main" id="{90C5A85F-38F5-467A-BB4E-0368A7FB16B5}"/>
+                <a16:creationId xmlns:a16="http://schemas.microsoft.com/office/drawing/2014/main" id="{B1043525-115F-4031-A7BA-CDFBCA87D80C}"/>
               </a:ext>
             </a:extLst>
           </p:cNvPr>
@@ -2690,7 +2690,7 @@
           <p:cNvPr id="33" name="II">
             <a:extLst xmlns:a="http://schemas.openxmlformats.org/drawingml/2006/main">
               <a:ext uri="{FF2B5EF4-FFF2-40B4-BE49-F238E27FC236}">
-                <a16:creationId xmlns:a16="http://schemas.microsoft.com/office/drawing/2014/main" id="{BA1EAFF8-2D34-4C13-A288-6AADF529BAEC}"/>
+                <a16:creationId xmlns:a16="http://schemas.microsoft.com/office/drawing/2014/main" id="{BF7A318D-DD8E-4637-96CC-106F956818AA}"/>
               </a:ext>
             </a:extLst>
           </p:cNvPr>
@@ -2747,7 +2747,7 @@
           <p:cNvPr id="34" name="Evaluate security and reliability after system updates">
             <a:extLst xmlns:a="http://schemas.openxmlformats.org/drawingml/2006/main">
               <a:ext uri="{FF2B5EF4-FFF2-40B4-BE49-F238E27FC236}">
-                <a16:creationId xmlns:a16="http://schemas.microsoft.com/office/drawing/2014/main" id="{E1E9FF91-C9BF-4CE2-89FC-9043D32C4003}"/>
+                <a16:creationId xmlns:a16="http://schemas.microsoft.com/office/drawing/2014/main" id="{BC6FAEA7-5E05-418A-8171-84F651EE1839}"/>
               </a:ext>
             </a:extLst>
           </p:cNvPr>
@@ -2804,7 +2804,7 @@
           <p:cNvPr id="35" name="Editable boundary">
             <a:extLst xmlns:a="http://schemas.openxmlformats.org/drawingml/2006/main">
               <a:ext uri="{FF2B5EF4-FFF2-40B4-BE49-F238E27FC236}">
-                <a16:creationId xmlns:a16="http://schemas.microsoft.com/office/drawing/2014/main" id="{2633C748-023B-4643-934F-FF5F96F61C79}"/>
+                <a16:creationId xmlns:a16="http://schemas.microsoft.com/office/drawing/2014/main" id="{2B2BED98-B3B5-4832-98B6-DCEDFB6B11D9}"/>
               </a:ext>
             </a:extLst>
           </p:cNvPr>
@@ -2837,7 +2837,7 @@
           <p:cNvPr id="36" name="Editable boundary">
             <a:extLst xmlns:a="http://schemas.openxmlformats.org/drawingml/2006/main">
               <a:ext uri="{FF2B5EF4-FFF2-40B4-BE49-F238E27FC236}">
-                <a16:creationId xmlns:a16="http://schemas.microsoft.com/office/drawing/2014/main" id="{113B4FB1-05AA-4BA6-B18D-231155619217}"/>
+                <a16:creationId xmlns:a16="http://schemas.microsoft.com/office/drawing/2014/main" id="{3F1376D3-7BCC-47CA-AA24-3D67A4288462}"/>
               </a:ext>
             </a:extLst>
           </p:cNvPr>
@@ -2870,7 +2870,7 @@
           <p:cNvPr id="37" name="III">
             <a:extLst xmlns:a="http://schemas.openxmlformats.org/drawingml/2006/main">
               <a:ext uri="{FF2B5EF4-FFF2-40B4-BE49-F238E27FC236}">
-                <a16:creationId xmlns:a16="http://schemas.microsoft.com/office/drawing/2014/main" id="{DC0677CF-EEA6-402B-8CE1-B63556D7BA5B}"/>
+                <a16:creationId xmlns:a16="http://schemas.microsoft.com/office/drawing/2014/main" id="{90F798E1-1114-44EB-A8E6-58AE0D6C6F6D}"/>
               </a:ext>
             </a:extLst>
           </p:cNvPr>
@@ -2927,7 +2927,7 @@
           <p:cNvPr id="38" name="Enforce current scope and permissions across task steps">
             <a:extLst xmlns:a="http://schemas.openxmlformats.org/drawingml/2006/main">
               <a:ext uri="{FF2B5EF4-FFF2-40B4-BE49-F238E27FC236}">
-                <a16:creationId xmlns:a16="http://schemas.microsoft.com/office/drawing/2014/main" id="{1F404A05-069C-4F15-A18B-D9D51AEC5D3A}"/>
+                <a16:creationId xmlns:a16="http://schemas.microsoft.com/office/drawing/2014/main" id="{7A4E23A0-BBD9-4428-9502-0DE2358F9FD2}"/>
               </a:ext>
             </a:extLst>
           </p:cNvPr>
@@ -2984,7 +2984,7 @@
           <p:cNvPr id="39" name="Editable boundary">
             <a:extLst xmlns:a="http://schemas.openxmlformats.org/drawingml/2006/main">
               <a:ext uri="{FF2B5EF4-FFF2-40B4-BE49-F238E27FC236}">
-                <a16:creationId xmlns:a16="http://schemas.microsoft.com/office/drawing/2014/main" id="{B4EF50C6-1F5E-413F-8DFD-86633972C5A5}"/>
+                <a16:creationId xmlns:a16="http://schemas.microsoft.com/office/drawing/2014/main" id="{AAA77107-E219-475D-B539-714B38E45466}"/>
               </a:ext>
             </a:extLst>
           </p:cNvPr>
@@ -3017,7 +3017,7 @@
           <p:cNvPr id="40" name="Editable boundary">
             <a:extLst xmlns:a="http://schemas.openxmlformats.org/drawingml/2006/main">
               <a:ext uri="{FF2B5EF4-FFF2-40B4-BE49-F238E27FC236}">
-                <a16:creationId xmlns:a16="http://schemas.microsoft.com/office/drawing/2014/main" id="{1A5AA7F2-4BE1-4093-8207-87168185E98E}"/>
+                <a16:creationId xmlns:a16="http://schemas.microsoft.com/office/drawing/2014/main" id="{F4B8438E-20CE-4EDD-B1B6-EF8FEE280DE1}"/>
               </a:ext>
             </a:extLst>
           </p:cNvPr>
@@ -3050,7 +3050,7 @@
           <p:cNvPr id="41" name="I">
             <a:extLst xmlns:a="http://schemas.openxmlformats.org/drawingml/2006/main">
               <a:ext uri="{FF2B5EF4-FFF2-40B4-BE49-F238E27FC236}">
-                <a16:creationId xmlns:a16="http://schemas.microsoft.com/office/drawing/2014/main" id="{390393A3-B392-4951-BE84-125B4494B53F}"/>
+                <a16:creationId xmlns:a16="http://schemas.microsoft.com/office/drawing/2014/main" id="{00925EB3-3FF0-4B62-BCC1-84F7E195130B}"/>
               </a:ext>
             </a:extLst>
           </p:cNvPr>
@@ -3107,7 +3107,7 @@
           <p:cNvPr id="42" name="Check proposed actions using independent evidence">
             <a:extLst xmlns:a="http://schemas.openxmlformats.org/drawingml/2006/main">
               <a:ext uri="{FF2B5EF4-FFF2-40B4-BE49-F238E27FC236}">
-                <a16:creationId xmlns:a16="http://schemas.microsoft.com/office/drawing/2014/main" id="{1D1FBD57-27CD-4556-B448-26BCFE1E0C69}"/>
+                <a16:creationId xmlns:a16="http://schemas.microsoft.com/office/drawing/2014/main" id="{351A301C-6C69-4369-B89A-7CF981B8B3E3}"/>
               </a:ext>
             </a:extLst>
           </p:cNvPr>
@@ -3164,7 +3164,7 @@
           <p:cNvPr id="43" name="Editable boundary">
             <a:extLst xmlns:a="http://schemas.openxmlformats.org/drawingml/2006/main">
               <a:ext uri="{FF2B5EF4-FFF2-40B4-BE49-F238E27FC236}">
-                <a16:creationId xmlns:a16="http://schemas.microsoft.com/office/drawing/2014/main" id="{DCE37E91-8EE3-4F72-B53F-4527EF0D10CF}"/>
+                <a16:creationId xmlns:a16="http://schemas.microsoft.com/office/drawing/2014/main" id="{6EF7A6B3-0287-4ABB-882D-8F78008EB90F}"/>
               </a:ext>
             </a:extLst>
           </p:cNvPr>
@@ -3197,7 +3197,7 @@
           <p:cNvPr id="44" name="Editable boundary">
             <a:extLst xmlns:a="http://schemas.openxmlformats.org/drawingml/2006/main">
               <a:ext uri="{FF2B5EF4-FFF2-40B4-BE49-F238E27FC236}">
-                <a16:creationId xmlns:a16="http://schemas.microsoft.com/office/drawing/2014/main" id="{7C32FF9F-8498-4FA1-BDA7-C183BA1EFF0A}"/>
+                <a16:creationId xmlns:a16="http://schemas.microsoft.com/office/drawing/2014/main" id="{9E8E6863-0C67-4DEB-A07A-D122DD7FD5FD}"/>
               </a:ext>
             </a:extLst>
           </p:cNvPr>
@@ -3230,7 +3230,7 @@
           <p:cNvPr id="45" name="II">
             <a:extLst xmlns:a="http://schemas.openxmlformats.org/drawingml/2006/main">
               <a:ext uri="{FF2B5EF4-FFF2-40B4-BE49-F238E27FC236}">
-                <a16:creationId xmlns:a16="http://schemas.microsoft.com/office/drawing/2014/main" id="{647C9E02-5311-43D1-A8F8-DEC310E5CCEA}"/>
+                <a16:creationId xmlns:a16="http://schemas.microsoft.com/office/drawing/2014/main" id="{99FA2E15-9232-4ECE-9F4D-8BF9F49B03CE}"/>
               </a:ext>
             </a:extLst>
           </p:cNvPr>
@@ -3287,7 +3287,7 @@
           <p:cNvPr id="46" name="Assess retention after either agent or harness updates">
             <a:extLst xmlns:a="http://schemas.openxmlformats.org/drawingml/2006/main">
               <a:ext uri="{FF2B5EF4-FFF2-40B4-BE49-F238E27FC236}">
-                <a16:creationId xmlns:a16="http://schemas.microsoft.com/office/drawing/2014/main" id="{2A9494CF-2980-4504-99D2-86533E132A27}"/>
+                <a16:creationId xmlns:a16="http://schemas.microsoft.com/office/drawing/2014/main" id="{20B31E2C-2D7C-4239-B2A3-DADF56428AAA}"/>
               </a:ext>
             </a:extLst>
           </p:cNvPr>
@@ -3344,7 +3344,7 @@
           <p:cNvPr id="47" name="Editable boundary">
             <a:extLst xmlns:a="http://schemas.openxmlformats.org/drawingml/2006/main">
               <a:ext uri="{FF2B5EF4-FFF2-40B4-BE49-F238E27FC236}">
-                <a16:creationId xmlns:a16="http://schemas.microsoft.com/office/drawing/2014/main" id="{BD7A5B08-D47A-4C76-B066-AAAD3165836E}"/>
+                <a16:creationId xmlns:a16="http://schemas.microsoft.com/office/drawing/2014/main" id="{6269FAEC-4F1D-43C6-9FEE-D9BBFBF50F27}"/>
               </a:ext>
             </a:extLst>
           </p:cNvPr>
@@ -3377,7 +3377,7 @@
           <p:cNvPr id="48" name="Editable boundary">
             <a:extLst xmlns:a="http://schemas.openxmlformats.org/drawingml/2006/main">
               <a:ext uri="{FF2B5EF4-FFF2-40B4-BE49-F238E27FC236}">
-                <a16:creationId xmlns:a16="http://schemas.microsoft.com/office/drawing/2014/main" id="{2A58E07A-CECE-4CFC-9A8A-3767D603F6EF}"/>
+                <a16:creationId xmlns:a16="http://schemas.microsoft.com/office/drawing/2014/main" id="{E5592A3C-C049-4A54-99A0-F7754ECDE5D1}"/>
               </a:ext>
             </a:extLst>
           </p:cNvPr>
@@ -3410,7 +3410,7 @@
           <p:cNvPr id="49" name="III">
             <a:extLst xmlns:a="http://schemas.openxmlformats.org/drawingml/2006/main">
               <a:ext uri="{FF2B5EF4-FFF2-40B4-BE49-F238E27FC236}">
-                <a16:creationId xmlns:a16="http://schemas.microsoft.com/office/drawing/2014/main" id="{477E184F-FE95-4F98-B4E3-3D30EA54304F}"/>
+                <a16:creationId xmlns:a16="http://schemas.microsoft.com/office/drawing/2014/main" id="{B66247DD-F37F-4819-94D4-AC549992DB90}"/>
               </a:ext>
             </a:extLst>
           </p:cNvPr>
@@ -3467,7 +3467,7 @@
           <p:cNvPr id="50" name="Enforce inherited data limits and valid delegation scope">
             <a:extLst xmlns:a="http://schemas.openxmlformats.org/drawingml/2006/main">
               <a:ext uri="{FF2B5EF4-FFF2-40B4-BE49-F238E27FC236}">
-                <a16:creationId xmlns:a16="http://schemas.microsoft.com/office/drawing/2014/main" id="{74DC4679-F1CC-4366-89BE-2C5D1F9341A6}"/>
+                <a16:creationId xmlns:a16="http://schemas.microsoft.com/office/drawing/2014/main" id="{A448EF07-F73E-4546-AF0F-1BC9F011C271}"/>
               </a:ext>
             </a:extLst>
           </p:cNvPr>
@@ -3524,7 +3524,7 @@
           <p:cNvPr id="51" name="Editable boundary">
             <a:extLst xmlns:a="http://schemas.openxmlformats.org/drawingml/2006/main">
               <a:ext uri="{FF2B5EF4-FFF2-40B4-BE49-F238E27FC236}">
-                <a16:creationId xmlns:a16="http://schemas.microsoft.com/office/drawing/2014/main" id="{9A769459-8854-4FA2-BB5D-02088101F529}"/>
+                <a16:creationId xmlns:a16="http://schemas.microsoft.com/office/drawing/2014/main" id="{49E07091-CDAC-4B6F-A416-6DEA6C1ED35C}"/>
               </a:ext>
             </a:extLst>
           </p:cNvPr>
@@ -3557,7 +3557,7 @@
           <p:cNvPr id="52" name="Shared human-approved requirements Φ">
             <a:extLst xmlns:a="http://schemas.openxmlformats.org/drawingml/2006/main">
               <a:ext uri="{FF2B5EF4-FFF2-40B4-BE49-F238E27FC236}">
-                <a16:creationId xmlns:a16="http://schemas.microsoft.com/office/drawing/2014/main" id="{B54B1420-DABD-4FF6-8AB5-FB1F8A187644}"/>
+                <a16:creationId xmlns:a16="http://schemas.microsoft.com/office/drawing/2014/main" id="{0B40E186-5DD8-443A-84B8-3C643651D15A}"/>
               </a:ext>
             </a:extLst>
           </p:cNvPr>
@@ -3614,7 +3614,7 @@
           <p:cNvPr id="53" name="Task criteria · security properties · authorization scope">
             <a:extLst xmlns:a="http://schemas.openxmlformats.org/drawingml/2006/main">
               <a:ext uri="{FF2B5EF4-FFF2-40B4-BE49-F238E27FC236}">
-                <a16:creationId xmlns:a16="http://schemas.microsoft.com/office/drawing/2014/main" id="{6E8D94F4-026B-4B3D-A19A-32D60FC3F04B}"/>
+                <a16:creationId xmlns:a16="http://schemas.microsoft.com/office/drawing/2014/main" id="{10D8347E-4D6B-4AAA-91B5-215831DCB665}"/>
               </a:ext>
             </a:extLst>
           </p:cNvPr>
@@ -3671,7 +3671,7 @@
           <p:cNvPr id="54" name="Editable flow path">
             <a:extLst xmlns:a="http://schemas.openxmlformats.org/drawingml/2006/main">
               <a:ext uri="{FF2B5EF4-FFF2-40B4-BE49-F238E27FC236}">
-                <a16:creationId xmlns:a16="http://schemas.microsoft.com/office/drawing/2014/main" id="{04291DAE-6929-41C9-BCA4-D87EB21A199A}"/>
+                <a16:creationId xmlns:a16="http://schemas.microsoft.com/office/drawing/2014/main" id="{995450B6-EFA6-4B78-99A4-4D8790AEDD6E}"/>
               </a:ext>
             </a:extLst>
           </p:cNvPr>
@@ -3717,7 +3717,7 @@
           <p:cNvPr id="55" name="Editable arrowhead">
             <a:extLst xmlns:a="http://schemas.openxmlformats.org/drawingml/2006/main">
               <a:ext uri="{FF2B5EF4-FFF2-40B4-BE49-F238E27FC236}">
-                <a16:creationId xmlns:a16="http://schemas.microsoft.com/office/drawing/2014/main" id="{B01AE5EB-1A89-4268-B5A1-71124F4806C7}"/>
+                <a16:creationId xmlns:a16="http://schemas.microsoft.com/office/drawing/2014/main" id="{0114CB9C-8486-4E7D-93A0-62FD6461048C}"/>
               </a:ext>
             </a:extLst>
           </p:cNvPr>
@@ -3760,7 +3760,7 @@
           <p:cNvPr id="56" name="Editable boundary">
             <a:extLst xmlns:a="http://schemas.openxmlformats.org/drawingml/2006/main">
               <a:ext uri="{FF2B5EF4-FFF2-40B4-BE49-F238E27FC236}">
-                <a16:creationId xmlns:a16="http://schemas.microsoft.com/office/drawing/2014/main" id="{A42FD7BB-120C-405A-BF82-7F4279200AA3}"/>
+                <a16:creationId xmlns:a16="http://schemas.microsoft.com/office/drawing/2014/main" id="{3CA13368-0187-44A7-96EC-35207C7220B9}"/>
               </a:ext>
             </a:extLst>
           </p:cNvPr>
@@ -3793,7 +3793,7 @@
           <p:cNvPr id="57" name="scoped approvals">
             <a:extLst xmlns:a="http://schemas.openxmlformats.org/drawingml/2006/main">
               <a:ext uri="{FF2B5EF4-FFF2-40B4-BE49-F238E27FC236}">
-                <a16:creationId xmlns:a16="http://schemas.microsoft.com/office/drawing/2014/main" id="{36A55331-D431-48D2-A05C-B5986D90B8AD}"/>
+                <a16:creationId xmlns:a16="http://schemas.microsoft.com/office/drawing/2014/main" id="{B7999E41-F97E-4C31-A910-5A427A03398A}"/>
               </a:ext>
             </a:extLst>
           </p:cNvPr>
@@ -3850,7 +3850,7 @@
           <p:cNvPr id="58" name="Editable boundary">
             <a:extLst xmlns:a="http://schemas.openxmlformats.org/drawingml/2006/main">
               <a:ext uri="{FF2B5EF4-FFF2-40B4-BE49-F238E27FC236}">
-                <a16:creationId xmlns:a16="http://schemas.microsoft.com/office/drawing/2014/main" id="{AE29A5E1-F49F-4359-B7B4-D7DA01E5E1B0}"/>
+                <a16:creationId xmlns:a16="http://schemas.microsoft.com/office/drawing/2014/main" id="{FAC9F637-62CC-4B4C-8E9B-237406239ED2}"/>
               </a:ext>
             </a:extLst>
           </p:cNvPr>
@@ -3883,7 +3883,7 @@
           <p:cNvPr id="59" name="Editable boundary">
             <a:extLst xmlns:a="http://schemas.openxmlformats.org/drawingml/2006/main">
               <a:ext uri="{FF2B5EF4-FFF2-40B4-BE49-F238E27FC236}">
-                <a16:creationId xmlns:a16="http://schemas.microsoft.com/office/drawing/2014/main" id="{0FAC24F6-78B8-48AA-846B-95CCA404CDFB}"/>
+                <a16:creationId xmlns:a16="http://schemas.microsoft.com/office/drawing/2014/main" id="{E8C9C24C-0BA1-41D0-A940-F9F77DA068EE}"/>
               </a:ext>
             </a:extLst>
           </p:cNvPr>
@@ -3916,7 +3916,7 @@
           <p:cNvPr id="60" name="I">
             <a:extLst xmlns:a="http://schemas.openxmlformats.org/drawingml/2006/main">
               <a:ext uri="{FF2B5EF4-FFF2-40B4-BE49-F238E27FC236}">
-                <a16:creationId xmlns:a16="http://schemas.microsoft.com/office/drawing/2014/main" id="{A56BAE31-4D7B-46D3-ADB7-E8501CEE08BE}"/>
+                <a16:creationId xmlns:a16="http://schemas.microsoft.com/office/drawing/2014/main" id="{6C2303DE-9663-4945-8785-2A3AC159C8BC}"/>
               </a:ext>
             </a:extLst>
           </p:cNvPr>
@@ -3973,7 +3973,7 @@
           <p:cNvPr id="61" name="Action assurance">
             <a:extLst xmlns:a="http://schemas.openxmlformats.org/drawingml/2006/main">
               <a:ext uri="{FF2B5EF4-FFF2-40B4-BE49-F238E27FC236}">
-                <a16:creationId xmlns:a16="http://schemas.microsoft.com/office/drawing/2014/main" id="{7813E88C-03E4-46F9-BFB2-5F7D1080E3A1}"/>
+                <a16:creationId xmlns:a16="http://schemas.microsoft.com/office/drawing/2014/main" id="{985EAFD0-6158-46AF-BF69-766944FAB193}"/>
               </a:ext>
             </a:extLst>
           </p:cNvPr>
@@ -4030,7 +4030,7 @@
           <p:cNvPr id="62" name="Editable boundary">
             <a:extLst xmlns:a="http://schemas.openxmlformats.org/drawingml/2006/main">
               <a:ext uri="{FF2B5EF4-FFF2-40B4-BE49-F238E27FC236}">
-                <a16:creationId xmlns:a16="http://schemas.microsoft.com/office/drawing/2014/main" id="{8C6FBF31-3393-4AD0-85DB-F78BD2B29CA6}"/>
+                <a16:creationId xmlns:a16="http://schemas.microsoft.com/office/drawing/2014/main" id="{FB54786D-2026-4F7B-B3FD-778F74990B5D}"/>
               </a:ext>
             </a:extLst>
           </p:cNvPr>
@@ -4063,7 +4063,7 @@
           <p:cNvPr id="63" name="Editable boundary">
             <a:extLst xmlns:a="http://schemas.openxmlformats.org/drawingml/2006/main">
               <a:ext uri="{FF2B5EF4-FFF2-40B4-BE49-F238E27FC236}">
-                <a16:creationId xmlns:a16="http://schemas.microsoft.com/office/drawing/2014/main" id="{585FFCC3-0941-4758-BF75-256B40D7ACEA}"/>
+                <a16:creationId xmlns:a16="http://schemas.microsoft.com/office/drawing/2014/main" id="{E0E2FCDB-7E4A-43DD-AF0A-D6AC4BBCD45B}"/>
               </a:ext>
             </a:extLst>
           </p:cNvPr>
@@ -4096,7 +4096,7 @@
           <p:cNvPr id="64" name="II">
             <a:extLst xmlns:a="http://schemas.openxmlformats.org/drawingml/2006/main">
               <a:ext uri="{FF2B5EF4-FFF2-40B4-BE49-F238E27FC236}">
-                <a16:creationId xmlns:a16="http://schemas.microsoft.com/office/drawing/2014/main" id="{F4A5DC7C-D9CC-4541-9A44-1CC277E4917B}"/>
+                <a16:creationId xmlns:a16="http://schemas.microsoft.com/office/drawing/2014/main" id="{213DFF7C-9312-4C26-8275-12BC2F156D8D}"/>
               </a:ext>
             </a:extLst>
           </p:cNvPr>
@@ -4153,7 +4153,7 @@
           <p:cNvPr id="65" name="Safety retention">
             <a:extLst xmlns:a="http://schemas.openxmlformats.org/drawingml/2006/main">
               <a:ext uri="{FF2B5EF4-FFF2-40B4-BE49-F238E27FC236}">
-                <a16:creationId xmlns:a16="http://schemas.microsoft.com/office/drawing/2014/main" id="{D86A74F9-470E-4C50-9D95-6C45534BAF5E}"/>
+                <a16:creationId xmlns:a16="http://schemas.microsoft.com/office/drawing/2014/main" id="{929343A2-655D-4898-B5C5-64E082319AED}"/>
               </a:ext>
             </a:extLst>
           </p:cNvPr>
@@ -4210,7 +4210,7 @@
           <p:cNvPr id="66" name="Editable boundary">
             <a:extLst xmlns:a="http://schemas.openxmlformats.org/drawingml/2006/main">
               <a:ext uri="{FF2B5EF4-FFF2-40B4-BE49-F238E27FC236}">
-                <a16:creationId xmlns:a16="http://schemas.microsoft.com/office/drawing/2014/main" id="{7499E6C6-BD49-48CB-8306-2C86A917DB6D}"/>
+                <a16:creationId xmlns:a16="http://schemas.microsoft.com/office/drawing/2014/main" id="{02CF9F4E-94F7-4620-98AC-58FDBE06A81E}"/>
               </a:ext>
             </a:extLst>
           </p:cNvPr>
@@ -4243,7 +4243,7 @@
           <p:cNvPr id="67" name="Editable boundary">
             <a:extLst xmlns:a="http://schemas.openxmlformats.org/drawingml/2006/main">
               <a:ext uri="{FF2B5EF4-FFF2-40B4-BE49-F238E27FC236}">
-                <a16:creationId xmlns:a16="http://schemas.microsoft.com/office/drawing/2014/main" id="{4C772E00-0E35-48A5-A6B2-F6428EAE13DE}"/>
+                <a16:creationId xmlns:a16="http://schemas.microsoft.com/office/drawing/2014/main" id="{34F5E6C9-A8E4-4052-8909-9784BC395F65}"/>
               </a:ext>
             </a:extLst>
           </p:cNvPr>
@@ -4276,7 +4276,7 @@
           <p:cNvPr id="68" name="III">
             <a:extLst xmlns:a="http://schemas.openxmlformats.org/drawingml/2006/main">
               <a:ext uri="{FF2B5EF4-FFF2-40B4-BE49-F238E27FC236}">
-                <a16:creationId xmlns:a16="http://schemas.microsoft.com/office/drawing/2014/main" id="{ACF7F26C-A8ED-4E1B-A7A0-905474B20C5B}"/>
+                <a16:creationId xmlns:a16="http://schemas.microsoft.com/office/drawing/2014/main" id="{750EA5F0-7D47-474C-90D5-1EBB7EC8EF50}"/>
               </a:ext>
             </a:extLst>
           </p:cNvPr>
@@ -4333,7 +4333,7 @@
           <p:cNvPr id="69" name="Workflow control">
             <a:extLst xmlns:a="http://schemas.openxmlformats.org/drawingml/2006/main">
               <a:ext uri="{FF2B5EF4-FFF2-40B4-BE49-F238E27FC236}">
-                <a16:creationId xmlns:a16="http://schemas.microsoft.com/office/drawing/2014/main" id="{B5D9FC71-C263-496E-936A-C34CF1E75682}"/>
+                <a16:creationId xmlns:a16="http://schemas.microsoft.com/office/drawing/2014/main" id="{B58B743E-50BE-457C-B6F2-5957E00F8B1D}"/>
               </a:ext>
             </a:extLst>
           </p:cNvPr>
@@ -4390,7 +4390,7 @@
           <p:cNvPr id="70" name="Editable flow path">
             <a:extLst xmlns:a="http://schemas.openxmlformats.org/drawingml/2006/main">
               <a:ext uri="{FF2B5EF4-FFF2-40B4-BE49-F238E27FC236}">
-                <a16:creationId xmlns:a16="http://schemas.microsoft.com/office/drawing/2014/main" id="{6EF26952-A4A2-4C35-8220-90CC332341A8}"/>
+                <a16:creationId xmlns:a16="http://schemas.microsoft.com/office/drawing/2014/main" id="{044313BF-BF54-4DB6-BB6C-F053522EA2E1}"/>
               </a:ext>
             </a:extLst>
           </p:cNvPr>
@@ -4430,7 +4430,7 @@
           <p:cNvPr id="71" name="Editable arrowhead">
             <a:extLst xmlns:a="http://schemas.openxmlformats.org/drawingml/2006/main">
               <a:ext uri="{FF2B5EF4-FFF2-40B4-BE49-F238E27FC236}">
-                <a16:creationId xmlns:a16="http://schemas.microsoft.com/office/drawing/2014/main" id="{DF95B084-2103-4206-A04E-1AE416E2C3CB}"/>
+                <a16:creationId xmlns:a16="http://schemas.microsoft.com/office/drawing/2014/main" id="{E23EDEB5-383C-448E-BC3E-CCC5AB599ACA}"/>
               </a:ext>
             </a:extLst>
           </p:cNvPr>
@@ -4473,7 +4473,7 @@
           <p:cNvPr id="72" name="checked">
             <a:extLst xmlns:a="http://schemas.openxmlformats.org/drawingml/2006/main">
               <a:ext uri="{FF2B5EF4-FFF2-40B4-BE49-F238E27FC236}">
-                <a16:creationId xmlns:a16="http://schemas.microsoft.com/office/drawing/2014/main" id="{28861FCD-B757-4B6E-BEC8-031CBEB7B221}"/>
+                <a16:creationId xmlns:a16="http://schemas.microsoft.com/office/drawing/2014/main" id="{A8E428FD-1F77-46BB-BC20-ADCC43121031}"/>
               </a:ext>
             </a:extLst>
           </p:cNvPr>
@@ -4530,7 +4530,7 @@
           <p:cNvPr id="73" name="feedback">
             <a:extLst xmlns:a="http://schemas.openxmlformats.org/drawingml/2006/main">
               <a:ext uri="{FF2B5EF4-FFF2-40B4-BE49-F238E27FC236}">
-                <a16:creationId xmlns:a16="http://schemas.microsoft.com/office/drawing/2014/main" id="{AC9368E0-6AB2-49F2-BD72-00061CBCFB4B}"/>
+                <a16:creationId xmlns:a16="http://schemas.microsoft.com/office/drawing/2014/main" id="{3D0557DB-22EB-49BF-BFB1-82A83DDC41AE}"/>
               </a:ext>
             </a:extLst>
           </p:cNvPr>
@@ -4587,7 +4587,7 @@
           <p:cNvPr id="74" name="Editable flow path">
             <a:extLst xmlns:a="http://schemas.openxmlformats.org/drawingml/2006/main">
               <a:ext uri="{FF2B5EF4-FFF2-40B4-BE49-F238E27FC236}">
-                <a16:creationId xmlns:a16="http://schemas.microsoft.com/office/drawing/2014/main" id="{910E77AE-94F4-4909-B25E-CEA33DC1252E}"/>
+                <a16:creationId xmlns:a16="http://schemas.microsoft.com/office/drawing/2014/main" id="{658631C4-68A7-4371-A1E9-1A7A66F34D0D}"/>
               </a:ext>
             </a:extLst>
           </p:cNvPr>
@@ -4627,7 +4627,7 @@
           <p:cNvPr id="75" name="Editable arrowhead">
             <a:extLst xmlns:a="http://schemas.openxmlformats.org/drawingml/2006/main">
               <a:ext uri="{FF2B5EF4-FFF2-40B4-BE49-F238E27FC236}">
-                <a16:creationId xmlns:a16="http://schemas.microsoft.com/office/drawing/2014/main" id="{7E1B9504-8752-4FBC-91E3-DEFEC49390C4}"/>
+                <a16:creationId xmlns:a16="http://schemas.microsoft.com/office/drawing/2014/main" id="{A76972F6-92CB-4AB0-A653-44EC5929A6A6}"/>
               </a:ext>
             </a:extLst>
           </p:cNvPr>
@@ -4670,7 +4670,7 @@
           <p:cNvPr id="76" name="version +">
             <a:extLst xmlns:a="http://schemas.openxmlformats.org/drawingml/2006/main">
               <a:ext uri="{FF2B5EF4-FFF2-40B4-BE49-F238E27FC236}">
-                <a16:creationId xmlns:a16="http://schemas.microsoft.com/office/drawing/2014/main" id="{8B61C7BB-E430-4424-867D-72DFE515B766}"/>
+                <a16:creationId xmlns:a16="http://schemas.microsoft.com/office/drawing/2014/main" id="{261955A3-F28B-4A53-B16A-ACAF2019E063}"/>
               </a:ext>
             </a:extLst>
           </p:cNvPr>
@@ -4727,7 +4727,7 @@
           <p:cNvPr id="77" name="evidence">
             <a:extLst xmlns:a="http://schemas.openxmlformats.org/drawingml/2006/main">
               <a:ext uri="{FF2B5EF4-FFF2-40B4-BE49-F238E27FC236}">
-                <a16:creationId xmlns:a16="http://schemas.microsoft.com/office/drawing/2014/main" id="{FFE4E750-4C08-42C5-B2AD-9F46FC833FAE}"/>
+                <a16:creationId xmlns:a16="http://schemas.microsoft.com/office/drawing/2014/main" id="{22580E84-4ED7-42F6-A93B-B9408CD8927E}"/>
               </a:ext>
             </a:extLst>
           </p:cNvPr>
@@ -4784,7 +4784,7 @@
           <p:cNvPr id="78" name="Editable flow path">
             <a:extLst xmlns:a="http://schemas.openxmlformats.org/drawingml/2006/main">
               <a:ext uri="{FF2B5EF4-FFF2-40B4-BE49-F238E27FC236}">
-                <a16:creationId xmlns:a16="http://schemas.microsoft.com/office/drawing/2014/main" id="{A58BED02-7F94-4749-A6F0-EECAB4E96951}"/>
+                <a16:creationId xmlns:a16="http://schemas.microsoft.com/office/drawing/2014/main" id="{A298BFE4-F687-489E-B04A-88EF1BC54021}"/>
               </a:ext>
             </a:extLst>
           </p:cNvPr>
@@ -4830,7 +4830,7 @@
           <p:cNvPr id="79" name="Editable arrowhead">
             <a:extLst xmlns:a="http://schemas.openxmlformats.org/drawingml/2006/main">
               <a:ext uri="{FF2B5EF4-FFF2-40B4-BE49-F238E27FC236}">
-                <a16:creationId xmlns:a16="http://schemas.microsoft.com/office/drawing/2014/main" id="{872F86EB-AA13-4875-85CC-3883AF75BC96}"/>
+                <a16:creationId xmlns:a16="http://schemas.microsoft.com/office/drawing/2014/main" id="{5A83D03E-EB15-4D62-958E-D58FA0A3C4EA}"/>
               </a:ext>
             </a:extLst>
           </p:cNvPr>
@@ -4873,7 +4873,7 @@
           <p:cNvPr id="80" name="Editable flow path">
             <a:extLst xmlns:a="http://schemas.openxmlformats.org/drawingml/2006/main">
               <a:ext uri="{FF2B5EF4-FFF2-40B4-BE49-F238E27FC236}">
-                <a16:creationId xmlns:a16="http://schemas.microsoft.com/office/drawing/2014/main" id="{216082E7-1AC6-4161-88E9-A21A8D93CE79}"/>
+                <a16:creationId xmlns:a16="http://schemas.microsoft.com/office/drawing/2014/main" id="{50086617-1176-45FC-BFDA-6B99A8BCBCF8}"/>
               </a:ext>
             </a:extLst>
           </p:cNvPr>
@@ -4913,7 +4913,7 @@
           <p:cNvPr id="81" name="Editable arrowhead">
             <a:extLst xmlns:a="http://schemas.openxmlformats.org/drawingml/2006/main">
               <a:ext uri="{FF2B5EF4-FFF2-40B4-BE49-F238E27FC236}">
-                <a16:creationId xmlns:a16="http://schemas.microsoft.com/office/drawing/2014/main" id="{532FFFB2-D4EE-4DEA-A331-B10214E1BDB8}"/>
+                <a16:creationId xmlns:a16="http://schemas.microsoft.com/office/drawing/2014/main" id="{968C108C-1258-4480-9A17-C18B6107DD6F}"/>
               </a:ext>
             </a:extLst>
           </p:cNvPr>
@@ -4956,7 +4956,7 @@
           <p:cNvPr id="82" name="workflow feedback">
             <a:extLst xmlns:a="http://schemas.openxmlformats.org/drawingml/2006/main">
               <a:ext uri="{FF2B5EF4-FFF2-40B4-BE49-F238E27FC236}">
-                <a16:creationId xmlns:a16="http://schemas.microsoft.com/office/drawing/2014/main" id="{BD9DC60B-6FCC-458A-89F5-9AE49612ACC8}"/>
+                <a16:creationId xmlns:a16="http://schemas.microsoft.com/office/drawing/2014/main" id="{1026FA58-CB08-400D-BEAF-DACD6678E8B6}"/>
               </a:ext>
             </a:extLst>
           </p:cNvPr>
@@ -5013,7 +5013,7 @@
           <p:cNvPr id="83" name="Formal claims require faithful models, sound checking, and trust">
             <a:extLst xmlns:a="http://schemas.openxmlformats.org/drawingml/2006/main">
               <a:ext uri="{FF2B5EF4-FFF2-40B4-BE49-F238E27FC236}">
-                <a16:creationId xmlns:a16="http://schemas.microsoft.com/office/drawing/2014/main" id="{0CEC5EE3-FAF1-425A-B4AD-C6EB49CBFC33}"/>
+                <a16:creationId xmlns:a16="http://schemas.microsoft.com/office/drawing/2014/main" id="{190A2B6B-4622-486B-BD07-0555093766E7}"/>
               </a:ext>
             </a:extLst>
           </p:cNvPr>
@@ -5070,7 +5070,7 @@
           <p:cNvPr id="84" name="tests provide evidence for evaluated conditions.">
             <a:extLst xmlns:a="http://schemas.openxmlformats.org/drawingml/2006/main">
               <a:ext uri="{FF2B5EF4-FFF2-40B4-BE49-F238E27FC236}">
-                <a16:creationId xmlns:a16="http://schemas.microsoft.com/office/drawing/2014/main" id="{2C583A15-1981-4267-9E04-D50EE5F28A70}"/>
+                <a16:creationId xmlns:a16="http://schemas.microsoft.com/office/drawing/2014/main" id="{B55591AC-2957-4BDB-8B35-626B736E14BE}"/>
               </a:ext>
             </a:extLst>
           </p:cNvPr>
@@ -5125,7 +5125,7 @@
     </p:spTree>
     <p:extLst>
       <p:ext uri="{BB962C8B-B14F-4D97-AF65-F5344CB8AC3E}">
-        <p14:creationId xmlns:p14="http://schemas.microsoft.com/office/powerpoint/2010/main" val="2144155760"/>
+        <p14:creationId xmlns:p14="http://schemas.microsoft.com/office/powerpoint/2010/main" val="659688927"/>
       </p:ext>
     </p:extLst>
   </p:cSld>
@@ -5156,7 +5156,7 @@
           <p:cNvPr id="66" name="Formal Oversight Before Action">
             <a:extLst xmlns:a="http://schemas.openxmlformats.org/drawingml/2006/main">
               <a:ext uri="{FF2B5EF4-FFF2-40B4-BE49-F238E27FC236}">
-                <a16:creationId xmlns:a16="http://schemas.microsoft.com/office/drawing/2014/main" id="{A4D3BE39-4E56-4AD8-9865-783F4DA4BED3}"/>
+                <a16:creationId xmlns:a16="http://schemas.microsoft.com/office/drawing/2014/main" id="{3BD02DE2-6FCD-4C95-99AB-8A4E2F886828}"/>
               </a:ext>
             </a:extLst>
           </p:cNvPr>
@@ -5213,7 +5213,7 @@
           <p:cNvPr id="2" name="Proposed framework: specify properties, prove obligations, enfor">
             <a:extLst xmlns:a="http://schemas.openxmlformats.org/drawingml/2006/main">
               <a:ext uri="{FF2B5EF4-FFF2-40B4-BE49-F238E27FC236}">
-                <a16:creationId xmlns:a16="http://schemas.microsoft.com/office/drawing/2014/main" id="{BACDA96E-5A74-47B6-AFF8-8BA0D09FC8E0}"/>
+                <a16:creationId xmlns:a16="http://schemas.microsoft.com/office/drawing/2014/main" id="{A62F9A8D-CB86-4B87-9BD5-4F68E3FFEC5D}"/>
               </a:ext>
             </a:extLst>
           </p:cNvPr>
@@ -5270,7 +5270,7 @@
           <p:cNvPr id="3" name="Editable boundary">
             <a:extLst xmlns:a="http://schemas.openxmlformats.org/drawingml/2006/main">
               <a:ext uri="{FF2B5EF4-FFF2-40B4-BE49-F238E27FC236}">
-                <a16:creationId xmlns:a16="http://schemas.microsoft.com/office/drawing/2014/main" id="{4F031845-B9B2-489E-95CE-1F24F10D8E89}"/>
+                <a16:creationId xmlns:a16="http://schemas.microsoft.com/office/drawing/2014/main" id="{491712D7-BDE2-48E3-B0E4-74A5D08B12D0}"/>
               </a:ext>
             </a:extLst>
           </p:cNvPr>
@@ -5303,7 +5303,7 @@
           <p:cNvPr id="4" name="Editable boundary">
             <a:extLst xmlns:a="http://schemas.openxmlformats.org/drawingml/2006/main">
               <a:ext uri="{FF2B5EF4-FFF2-40B4-BE49-F238E27FC236}">
-                <a16:creationId xmlns:a16="http://schemas.microsoft.com/office/drawing/2014/main" id="{27767313-DD0C-47F0-8725-570DAA40571C}"/>
+                <a16:creationId xmlns:a16="http://schemas.microsoft.com/office/drawing/2014/main" id="{FB8622E3-D32E-4D39-B8E9-6541C4A66569}"/>
               </a:ext>
             </a:extLst>
           </p:cNvPr>
@@ -5336,7 +5336,7 @@
           <p:cNvPr id="5" name="Editable boundary">
             <a:extLst xmlns:a="http://schemas.openxmlformats.org/drawingml/2006/main">
               <a:ext uri="{FF2B5EF4-FFF2-40B4-BE49-F238E27FC236}">
-                <a16:creationId xmlns:a16="http://schemas.microsoft.com/office/drawing/2014/main" id="{D4C26C9C-B4F4-4747-9A98-F8D38D8B16F4}"/>
+                <a16:creationId xmlns:a16="http://schemas.microsoft.com/office/drawing/2014/main" id="{947BAA02-3628-46E9-819E-D3523A702B8C}"/>
               </a:ext>
             </a:extLst>
           </p:cNvPr>
@@ -5369,7 +5369,7 @@
           <p:cNvPr id="6" name="1   Formal specification">
             <a:extLst xmlns:a="http://schemas.openxmlformats.org/drawingml/2006/main">
               <a:ext uri="{FF2B5EF4-FFF2-40B4-BE49-F238E27FC236}">
-                <a16:creationId xmlns:a16="http://schemas.microsoft.com/office/drawing/2014/main" id="{4CA467B1-7E8C-4676-A1FF-44A743913F4E}"/>
+                <a16:creationId xmlns:a16="http://schemas.microsoft.com/office/drawing/2014/main" id="{C6E7EBD1-3A17-47A7-8800-0278058A0245}"/>
               </a:ext>
             </a:extLst>
           </p:cNvPr>
@@ -5426,7 +5426,7 @@
           <p:cNvPr id="7" name="2   Formal proof checking">
             <a:extLst xmlns:a="http://schemas.openxmlformats.org/drawingml/2006/main">
               <a:ext uri="{FF2B5EF4-FFF2-40B4-BE49-F238E27FC236}">
-                <a16:creationId xmlns:a16="http://schemas.microsoft.com/office/drawing/2014/main" id="{89A30DE5-E611-47B1-AB91-0E3AABD2D032}"/>
+                <a16:creationId xmlns:a16="http://schemas.microsoft.com/office/drawing/2014/main" id="{6CA76653-E561-4903-9D88-BC2175F9820D}"/>
               </a:ext>
             </a:extLst>
           </p:cNvPr>
@@ -5483,7 +5483,7 @@
           <p:cNvPr id="8" name="3   Execution gate">
             <a:extLst xmlns:a="http://schemas.openxmlformats.org/drawingml/2006/main">
               <a:ext uri="{FF2B5EF4-FFF2-40B4-BE49-F238E27FC236}">
-                <a16:creationId xmlns:a16="http://schemas.microsoft.com/office/drawing/2014/main" id="{CDA20FFD-8A30-42A3-8EB2-23F3AFF58273}"/>
+                <a16:creationId xmlns:a16="http://schemas.microsoft.com/office/drawing/2014/main" id="{7D8634C4-73D6-43D0-91F3-CD91123813DC}"/>
               </a:ext>
             </a:extLst>
           </p:cNvPr>
@@ -5540,7 +5540,7 @@
           <p:cNvPr id="9" name="Editable boundary">
             <a:extLst xmlns:a="http://schemas.openxmlformats.org/drawingml/2006/main">
               <a:ext uri="{FF2B5EF4-FFF2-40B4-BE49-F238E27FC236}">
-                <a16:creationId xmlns:a16="http://schemas.microsoft.com/office/drawing/2014/main" id="{593ED238-FBA0-4BDF-9E4D-85DAF4CF6D5B}"/>
+                <a16:creationId xmlns:a16="http://schemas.microsoft.com/office/drawing/2014/main" id="{0592C041-8408-49F1-8065-53C8E2579822}"/>
               </a:ext>
             </a:extLst>
           </p:cNvPr>
@@ -5558,7 +5558,7 @@
             <a:avLst/>
           </a:prstGeom>
           <a:solidFill xmlns:a="http://schemas.openxmlformats.org/drawingml/2006/main">
-            <a:srgbClr val="F0F3F6"/>
+            <a:srgbClr val="F8F8F8"/>
           </a:solidFill>
           <a:ln xmlns:a="http://schemas.openxmlformats.org/drawingml/2006/main" w="19050">
             <a:solidFill>
@@ -5573,7 +5573,7 @@
           <p:cNvPr id="10" name="Approved specification Φ">
             <a:extLst xmlns:a="http://schemas.openxmlformats.org/drawingml/2006/main">
               <a:ext uri="{FF2B5EF4-FFF2-40B4-BE49-F238E27FC236}">
-                <a16:creationId xmlns:a16="http://schemas.microsoft.com/office/drawing/2014/main" id="{03366E80-6D49-4730-9CD1-5A9481566000}"/>
+                <a16:creationId xmlns:a16="http://schemas.microsoft.com/office/drawing/2014/main" id="{F3C51BC2-3EC2-40D1-9F97-D382A14F857C}"/>
               </a:ext>
             </a:extLst>
           </p:cNvPr>
@@ -5630,7 +5630,7 @@
           <p:cNvPr id="11" name="Task correctness + security">
             <a:extLst xmlns:a="http://schemas.openxmlformats.org/drawingml/2006/main">
               <a:ext uri="{FF2B5EF4-FFF2-40B4-BE49-F238E27FC236}">
-                <a16:creationId xmlns:a16="http://schemas.microsoft.com/office/drawing/2014/main" id="{2A6FD7DE-E862-487C-81CB-7C96C6B9CC16}"/>
+                <a16:creationId xmlns:a16="http://schemas.microsoft.com/office/drawing/2014/main" id="{4629E563-003B-4D67-8CF1-0187099B3A1C}"/>
               </a:ext>
             </a:extLst>
           </p:cNvPr>
@@ -5687,7 +5687,7 @@
           <p:cNvPr id="12" name="Editable boundary">
             <a:extLst xmlns:a="http://schemas.openxmlformats.org/drawingml/2006/main">
               <a:ext uri="{FF2B5EF4-FFF2-40B4-BE49-F238E27FC236}">
-                <a16:creationId xmlns:a16="http://schemas.microsoft.com/office/drawing/2014/main" id="{983421C8-04B4-44E1-985A-81F2F108012F}"/>
+                <a16:creationId xmlns:a16="http://schemas.microsoft.com/office/drawing/2014/main" id="{8B306311-DCF9-4BBF-BFED-1DB3DAF90EFB}"/>
               </a:ext>
             </a:extLst>
           </p:cNvPr>
@@ -5705,11 +5705,11 @@
             <a:avLst/>
           </a:prstGeom>
           <a:solidFill xmlns:a="http://schemas.openxmlformats.org/drawingml/2006/main">
-            <a:srgbClr val="F0F3F6"/>
+            <a:srgbClr val="F8F8F8"/>
           </a:solidFill>
           <a:ln xmlns:a="http://schemas.openxmlformats.org/drawingml/2006/main" w="12383">
             <a:solidFill>
-              <a:srgbClr val="CFD9E2"/>
+              <a:srgbClr val="D0D0D0"/>
             </a:solidFill>
             <a:prstDash val="solid"/>
           </a:ln>
@@ -5720,7 +5720,7 @@
           <p:cNvPr id="13" name="Example security property">
             <a:extLst xmlns:a="http://schemas.openxmlformats.org/drawingml/2006/main">
               <a:ext uri="{FF2B5EF4-FFF2-40B4-BE49-F238E27FC236}">
-                <a16:creationId xmlns:a16="http://schemas.microsoft.com/office/drawing/2014/main" id="{BFFC746F-8A67-4D90-AA43-21486EFC438E}"/>
+                <a16:creationId xmlns:a16="http://schemas.microsoft.com/office/drawing/2014/main" id="{35FA153A-565B-4DD0-A4B1-4245C2E8CDFE}"/>
               </a:ext>
             </a:extLst>
           </p:cNvPr>
@@ -5777,7 +5777,7 @@
           <p:cNvPr id="14" name="always:  Send(d, r) ⇒ Authorized(d, r)">
             <a:extLst xmlns:a="http://schemas.openxmlformats.org/drawingml/2006/main">
               <a:ext uri="{FF2B5EF4-FFF2-40B4-BE49-F238E27FC236}">
-                <a16:creationId xmlns:a16="http://schemas.microsoft.com/office/drawing/2014/main" id="{4457EFB5-AE9B-48BD-9DC3-B3F81C8A29C7}"/>
+                <a16:creationId xmlns:a16="http://schemas.microsoft.com/office/drawing/2014/main" id="{E250A09C-EDBC-45AE-AD29-070570E3231A}"/>
               </a:ext>
             </a:extLst>
           </p:cNvPr>
@@ -5834,7 +5834,7 @@
           <p:cNvPr id="15" name="Every send must be authorized.">
             <a:extLst xmlns:a="http://schemas.openxmlformats.org/drawingml/2006/main">
               <a:ext uri="{FF2B5EF4-FFF2-40B4-BE49-F238E27FC236}">
-                <a16:creationId xmlns:a16="http://schemas.microsoft.com/office/drawing/2014/main" id="{2AF5F230-AD7F-4623-BCC1-DEEA079CA393}"/>
+                <a16:creationId xmlns:a16="http://schemas.microsoft.com/office/drawing/2014/main" id="{990A98BF-6A6F-4818-9FA8-6F9EC8F7AA7D}"/>
               </a:ext>
             </a:extLst>
           </p:cNvPr>
@@ -5891,7 +5891,7 @@
           <p:cNvPr id="16" name="Review intent. Protect the specification.">
             <a:extLst xmlns:a="http://schemas.openxmlformats.org/drawingml/2006/main">
               <a:ext uri="{FF2B5EF4-FFF2-40B4-BE49-F238E27FC236}">
-                <a16:creationId xmlns:a16="http://schemas.microsoft.com/office/drawing/2014/main" id="{34A9A926-0F49-48FC-8F61-BA8E1865A2F6}"/>
+                <a16:creationId xmlns:a16="http://schemas.microsoft.com/office/drawing/2014/main" id="{699B25A2-B1DD-4FBC-8D1E-1CAE58452B8B}"/>
               </a:ext>
             </a:extLst>
           </p:cNvPr>
@@ -5948,7 +5948,7 @@
           <p:cNvPr id="17" name="Φ">
             <a:extLst xmlns:a="http://schemas.openxmlformats.org/drawingml/2006/main">
               <a:ext uri="{FF2B5EF4-FFF2-40B4-BE49-F238E27FC236}">
-                <a16:creationId xmlns:a16="http://schemas.microsoft.com/office/drawing/2014/main" id="{479CE99C-9D5B-48E8-A675-40F8B1BBFF1C}"/>
+                <a16:creationId xmlns:a16="http://schemas.microsoft.com/office/drawing/2014/main" id="{52049CC9-81FD-4423-A522-391568D6CA06}"/>
               </a:ext>
             </a:extLst>
           </p:cNvPr>
@@ -6005,7 +6005,7 @@
           <p:cNvPr id="18" name="Editable flow path">
             <a:extLst xmlns:a="http://schemas.openxmlformats.org/drawingml/2006/main">
               <a:ext uri="{FF2B5EF4-FFF2-40B4-BE49-F238E27FC236}">
-                <a16:creationId xmlns:a16="http://schemas.microsoft.com/office/drawing/2014/main" id="{870AF08D-B6F6-49D2-AB85-221CE18C6743}"/>
+                <a16:creationId xmlns:a16="http://schemas.microsoft.com/office/drawing/2014/main" id="{1B828B16-8A3E-4F37-BBCF-D7EB00A9DDC6}"/>
               </a:ext>
             </a:extLst>
           </p:cNvPr>
@@ -6045,7 +6045,7 @@
           <p:cNvPr id="19" name="Editable arrowhead">
             <a:extLst xmlns:a="http://schemas.openxmlformats.org/drawingml/2006/main">
               <a:ext uri="{FF2B5EF4-FFF2-40B4-BE49-F238E27FC236}">
-                <a16:creationId xmlns:a16="http://schemas.microsoft.com/office/drawing/2014/main" id="{8BF0C7BC-088D-4EA0-ABD6-CA8C11BD85A8}"/>
+                <a16:creationId xmlns:a16="http://schemas.microsoft.com/office/drawing/2014/main" id="{77EF79D3-5AC0-40B3-9341-2675EF3A4E04}"/>
               </a:ext>
             </a:extLst>
           </p:cNvPr>
@@ -6088,7 +6088,7 @@
           <p:cNvPr id="20" name="Editable boundary">
             <a:extLst xmlns:a="http://schemas.openxmlformats.org/drawingml/2006/main">
               <a:ext uri="{FF2B5EF4-FFF2-40B4-BE49-F238E27FC236}">
-                <a16:creationId xmlns:a16="http://schemas.microsoft.com/office/drawing/2014/main" id="{BC7A5D84-4EED-454C-BE58-75754B36AAC8}"/>
+                <a16:creationId xmlns:a16="http://schemas.microsoft.com/office/drawing/2014/main" id="{86AE0BCD-96AB-412E-B5A5-F53949D862E2}"/>
               </a:ext>
             </a:extLst>
           </p:cNvPr>
@@ -6106,7 +6106,7 @@
             <a:avLst/>
           </a:prstGeom>
           <a:solidFill xmlns:a="http://schemas.openxmlformats.org/drawingml/2006/main">
-            <a:srgbClr val="F0F3F6"/>
+            <a:srgbClr val="F8F8F8"/>
           </a:solidFill>
           <a:ln xmlns:a="http://schemas.openxmlformats.org/drawingml/2006/main" w="19050">
             <a:solidFill>
@@ -6121,7 +6121,7 @@
           <p:cNvPr id="21" name="Generate logical obligations">
             <a:extLst xmlns:a="http://schemas.openxmlformats.org/drawingml/2006/main">
               <a:ext uri="{FF2B5EF4-FFF2-40B4-BE49-F238E27FC236}">
-                <a16:creationId xmlns:a16="http://schemas.microsoft.com/office/drawing/2014/main" id="{274152F9-C00F-475C-AC22-A3DDC8DFF218}"/>
+                <a16:creationId xmlns:a16="http://schemas.microsoft.com/office/drawing/2014/main" id="{28A5CEB3-163A-41FC-B6FA-D548D9BABD2F}"/>
               </a:ext>
             </a:extLst>
           </p:cNvPr>
@@ -6178,7 +6178,7 @@
           <p:cNvPr id="22" name="Editable boundary">
             <a:extLst xmlns:a="http://schemas.openxmlformats.org/drawingml/2006/main">
               <a:ext uri="{FF2B5EF4-FFF2-40B4-BE49-F238E27FC236}">
-                <a16:creationId xmlns:a16="http://schemas.microsoft.com/office/drawing/2014/main" id="{D225319C-2A71-4254-BDDE-8CE02F8071DE}"/>
+                <a16:creationId xmlns:a16="http://schemas.microsoft.com/office/drawing/2014/main" id="{049441E3-74C6-411B-B1CD-1F984351850E}"/>
               </a:ext>
             </a:extLst>
           </p:cNvPr>
@@ -6196,11 +6196,11 @@
             <a:avLst/>
           </a:prstGeom>
           <a:solidFill xmlns:a="http://schemas.openxmlformats.org/drawingml/2006/main">
-            <a:srgbClr val="FAFBFD"/>
+            <a:srgbClr val="FAFAFA"/>
           </a:solidFill>
           <a:ln xmlns:a="http://schemas.openxmlformats.org/drawingml/2006/main" w="11430">
             <a:solidFill>
-              <a:srgbClr val="D4DDE6"/>
+              <a:srgbClr val="D0D0D0"/>
             </a:solidFill>
             <a:prstDash val="solid"/>
           </a:ln>
@@ -6211,7 +6211,7 @@
           <p:cNvPr id="23" name="O := Obligations(M(x), Φ)">
             <a:extLst xmlns:a="http://schemas.openxmlformats.org/drawingml/2006/main">
               <a:ext uri="{FF2B5EF4-FFF2-40B4-BE49-F238E27FC236}">
-                <a16:creationId xmlns:a16="http://schemas.microsoft.com/office/drawing/2014/main" id="{8464168E-EC46-449D-9C0C-0CDD63AE283B}"/>
+                <a16:creationId xmlns:a16="http://schemas.microsoft.com/office/drawing/2014/main" id="{B9B9DFE5-0722-4B2D-AC42-B34F4758E7EE}"/>
               </a:ext>
             </a:extLst>
           </p:cNvPr>
@@ -6268,7 +6268,7 @@
           <p:cNvPr id="24" name="Model the candidate and tool effects.">
             <a:extLst xmlns:a="http://schemas.openxmlformats.org/drawingml/2006/main">
               <a:ext uri="{FF2B5EF4-FFF2-40B4-BE49-F238E27FC236}">
-                <a16:creationId xmlns:a16="http://schemas.microsoft.com/office/drawing/2014/main" id="{B913F4DA-CB78-467D-A0E2-C3934140CD7F}"/>
+                <a16:creationId xmlns:a16="http://schemas.microsoft.com/office/drawing/2014/main" id="{1918F6A7-C98D-4F47-BBA1-22580E50839C}"/>
               </a:ext>
             </a:extLst>
           </p:cNvPr>
@@ -6325,7 +6325,7 @@
           <p:cNvPr id="25" name="Editable flow path">
             <a:extLst xmlns:a="http://schemas.openxmlformats.org/drawingml/2006/main">
               <a:ext uri="{FF2B5EF4-FFF2-40B4-BE49-F238E27FC236}">
-                <a16:creationId xmlns:a16="http://schemas.microsoft.com/office/drawing/2014/main" id="{E4EC689F-45D1-4E9C-B319-BB69198D19E3}"/>
+                <a16:creationId xmlns:a16="http://schemas.microsoft.com/office/drawing/2014/main" id="{73BC7B60-91CF-4E34-9771-08034B62F869}"/>
               </a:ext>
             </a:extLst>
           </p:cNvPr>
@@ -6365,7 +6365,7 @@
           <p:cNvPr id="26" name="Editable arrowhead">
             <a:extLst xmlns:a="http://schemas.openxmlformats.org/drawingml/2006/main">
               <a:ext uri="{FF2B5EF4-FFF2-40B4-BE49-F238E27FC236}">
-                <a16:creationId xmlns:a16="http://schemas.microsoft.com/office/drawing/2014/main" id="{7D0EBB79-C16A-44C3-8C2A-63E17AC1BB15}"/>
+                <a16:creationId xmlns:a16="http://schemas.microsoft.com/office/drawing/2014/main" id="{FA01105A-E72C-48C3-816E-DB832BA004FE}"/>
               </a:ext>
             </a:extLst>
           </p:cNvPr>
@@ -6408,7 +6408,7 @@
           <p:cNvPr id="27" name="Editable boundary">
             <a:extLst xmlns:a="http://schemas.openxmlformats.org/drawingml/2006/main">
               <a:ext uri="{FF2B5EF4-FFF2-40B4-BE49-F238E27FC236}">
-                <a16:creationId xmlns:a16="http://schemas.microsoft.com/office/drawing/2014/main" id="{CB57D97E-F972-465F-AB8D-D41AC9B94E3B}"/>
+                <a16:creationId xmlns:a16="http://schemas.microsoft.com/office/drawing/2014/main" id="{FDAEAE90-E45F-4BFE-946A-1E072F141587}"/>
               </a:ext>
             </a:extLst>
           </p:cNvPr>
@@ -6426,7 +6426,7 @@
             <a:avLst/>
           </a:prstGeom>
           <a:solidFill xmlns:a="http://schemas.openxmlformats.org/drawingml/2006/main">
-            <a:srgbClr val="F0F3F6"/>
+            <a:srgbClr val="F8F8F8"/>
           </a:solidFill>
           <a:ln xmlns:a="http://schemas.openxmlformats.org/drawingml/2006/main" w="19050">
             <a:solidFill>
@@ -6441,7 +6441,7 @@
           <p:cNvPr id="28" name="Prove and check every obligation">
             <a:extLst xmlns:a="http://schemas.openxmlformats.org/drawingml/2006/main">
               <a:ext uri="{FF2B5EF4-FFF2-40B4-BE49-F238E27FC236}">
-                <a16:creationId xmlns:a16="http://schemas.microsoft.com/office/drawing/2014/main" id="{579E815D-F8EE-491D-BB15-2554AF2E52E1}"/>
+                <a16:creationId xmlns:a16="http://schemas.microsoft.com/office/drawing/2014/main" id="{5B25B5BA-215C-436B-8158-4B89040500A4}"/>
               </a:ext>
             </a:extLst>
           </p:cNvPr>
@@ -6498,7 +6498,7 @@
           <p:cNvPr id="29" name="Editable boundary">
             <a:extLst xmlns:a="http://schemas.openxmlformats.org/drawingml/2006/main">
               <a:ext uri="{FF2B5EF4-FFF2-40B4-BE49-F238E27FC236}">
-                <a16:creationId xmlns:a16="http://schemas.microsoft.com/office/drawing/2014/main" id="{68DE0E02-92FB-43D6-A641-1413C9A37CFE}"/>
+                <a16:creationId xmlns:a16="http://schemas.microsoft.com/office/drawing/2014/main" id="{5FF628BB-A7B1-40F4-9ED4-28B63D41F149}"/>
               </a:ext>
             </a:extLst>
           </p:cNvPr>
@@ -6516,11 +6516,11 @@
             <a:avLst/>
           </a:prstGeom>
           <a:solidFill xmlns:a="http://schemas.openxmlformats.org/drawingml/2006/main">
-            <a:srgbClr val="FAFBFD"/>
+            <a:srgbClr val="FAFAFA"/>
           </a:solidFill>
           <a:ln xmlns:a="http://schemas.openxmlformats.org/drawingml/2006/main" w="11430">
             <a:solidFill>
-              <a:srgbClr val="D4DDE6"/>
+              <a:srgbClr val="D0D0D0"/>
             </a:solidFill>
             <a:prstDash val="solid"/>
           </a:ln>
@@ -6531,7 +6531,7 @@
           <p:cNvPr id="30" name="SMT solver / proof assistant">
             <a:extLst xmlns:a="http://schemas.openxmlformats.org/drawingml/2006/main">
               <a:ext uri="{FF2B5EF4-FFF2-40B4-BE49-F238E27FC236}">
-                <a16:creationId xmlns:a16="http://schemas.microsoft.com/office/drawing/2014/main" id="{1E73AF37-C0D0-4AB4-BB12-CBE6A1CBAA0E}"/>
+                <a16:creationId xmlns:a16="http://schemas.microsoft.com/office/drawing/2014/main" id="{45AC98BF-A79E-48DB-94BD-C5BF9F4A7390}"/>
               </a:ext>
             </a:extLst>
           </p:cNvPr>
@@ -6588,7 +6588,7 @@
           <p:cNvPr id="31" name="Editable boundary">
             <a:extLst xmlns:a="http://schemas.openxmlformats.org/drawingml/2006/main">
               <a:ext uri="{FF2B5EF4-FFF2-40B4-BE49-F238E27FC236}">
-                <a16:creationId xmlns:a16="http://schemas.microsoft.com/office/drawing/2014/main" id="{EABD05B6-BD7B-454A-B2AA-932221EE4293}"/>
+                <a16:creationId xmlns:a16="http://schemas.microsoft.com/office/drawing/2014/main" id="{4D0ACE5C-BCC5-4C49-AAA7-CDBFD433CBE8}"/>
               </a:ext>
             </a:extLst>
           </p:cNvPr>
@@ -6606,11 +6606,11 @@
             <a:avLst/>
           </a:prstGeom>
           <a:solidFill xmlns:a="http://schemas.openxmlformats.org/drawingml/2006/main">
-            <a:srgbClr val="FAFBFD"/>
+            <a:srgbClr val="FAFAFA"/>
           </a:solidFill>
           <a:ln xmlns:a="http://schemas.openxmlformats.org/drawingml/2006/main" w="11430">
             <a:solidFill>
-              <a:srgbClr val="D4DDE6"/>
+              <a:srgbClr val="D0D0D0"/>
             </a:solidFill>
             <a:prstDash val="solid"/>
           </a:ln>
@@ -6621,7 +6621,7 @@
           <p:cNvPr id="32" name="Check(proof, O) = valid">
             <a:extLst xmlns:a="http://schemas.openxmlformats.org/drawingml/2006/main">
               <a:ext uri="{FF2B5EF4-FFF2-40B4-BE49-F238E27FC236}">
-                <a16:creationId xmlns:a16="http://schemas.microsoft.com/office/drawing/2014/main" id="{C8B5BF93-6D67-4B7E-914B-141F7AFA2BE2}"/>
+                <a16:creationId xmlns:a16="http://schemas.microsoft.com/office/drawing/2014/main" id="{E9AF4F98-75F7-40C8-B8E1-71F4688B1B08}"/>
               </a:ext>
             </a:extLst>
           </p:cNvPr>
@@ -6678,7 +6678,7 @@
           <p:cNvPr id="33" name="Editable flow path">
             <a:extLst xmlns:a="http://schemas.openxmlformats.org/drawingml/2006/main">
               <a:ext uri="{FF2B5EF4-FFF2-40B4-BE49-F238E27FC236}">
-                <a16:creationId xmlns:a16="http://schemas.microsoft.com/office/drawing/2014/main" id="{F2AF1E6A-07A0-479F-9A9B-D99A1880AA6C}"/>
+                <a16:creationId xmlns:a16="http://schemas.microsoft.com/office/drawing/2014/main" id="{BF4D91B7-9E30-4116-9D29-51EBEDC7EDC1}"/>
               </a:ext>
             </a:extLst>
           </p:cNvPr>
@@ -6724,7 +6724,7 @@
           <p:cNvPr id="34" name="Editable arrowhead">
             <a:extLst xmlns:a="http://schemas.openxmlformats.org/drawingml/2006/main">
               <a:ext uri="{FF2B5EF4-FFF2-40B4-BE49-F238E27FC236}">
-                <a16:creationId xmlns:a16="http://schemas.microsoft.com/office/drawing/2014/main" id="{CE98F0EB-1F1E-491D-A8CB-97283BC3372B}"/>
+                <a16:creationId xmlns:a16="http://schemas.microsoft.com/office/drawing/2014/main" id="{B6F1E8D9-A313-452B-922F-C786446996B9}"/>
               </a:ext>
             </a:extLst>
           </p:cNvPr>
@@ -6767,7 +6767,7 @@
           <p:cNvPr id="35" name="Editable boundary">
             <a:extLst xmlns:a="http://schemas.openxmlformats.org/drawingml/2006/main">
               <a:ext uri="{FF2B5EF4-FFF2-40B4-BE49-F238E27FC236}">
-                <a16:creationId xmlns:a16="http://schemas.microsoft.com/office/drawing/2014/main" id="{29C325D8-3BA2-4CA8-9885-EE01823716BD}"/>
+                <a16:creationId xmlns:a16="http://schemas.microsoft.com/office/drawing/2014/main" id="{FF6E746D-AB4D-42B2-9B4D-6E17BB5BE801}"/>
               </a:ext>
             </a:extLst>
           </p:cNvPr>
@@ -6800,7 +6800,7 @@
           <p:cNvPr id="36" name="Repair">
             <a:extLst xmlns:a="http://schemas.openxmlformats.org/drawingml/2006/main">
               <a:ext uri="{FF2B5EF4-FFF2-40B4-BE49-F238E27FC236}">
-                <a16:creationId xmlns:a16="http://schemas.microsoft.com/office/drawing/2014/main" id="{C6671A6E-D97E-4D7A-AEC3-7BB5FAD98809}"/>
+                <a16:creationId xmlns:a16="http://schemas.microsoft.com/office/drawing/2014/main" id="{CE0C7426-C356-4198-B3BC-E40D4CDBAD42}"/>
               </a:ext>
             </a:extLst>
           </p:cNvPr>
@@ -6857,7 +6857,7 @@
           <p:cNvPr id="37" name="candidate">
             <a:extLst xmlns:a="http://schemas.openxmlformats.org/drawingml/2006/main">
               <a:ext uri="{FF2B5EF4-FFF2-40B4-BE49-F238E27FC236}">
-                <a16:creationId xmlns:a16="http://schemas.microsoft.com/office/drawing/2014/main" id="{3765EE0B-695E-4FC8-B203-B5F4B011120F}"/>
+                <a16:creationId xmlns:a16="http://schemas.microsoft.com/office/drawing/2014/main" id="{576C4DF2-B241-48C4-B138-C60FD2EC4BDA}"/>
               </a:ext>
             </a:extLst>
           </p:cNvPr>
@@ -6914,7 +6914,7 @@
           <p:cNvPr id="38" name="or proof">
             <a:extLst xmlns:a="http://schemas.openxmlformats.org/drawingml/2006/main">
               <a:ext uri="{FF2B5EF4-FFF2-40B4-BE49-F238E27FC236}">
-                <a16:creationId xmlns:a16="http://schemas.microsoft.com/office/drawing/2014/main" id="{2377F9FB-FBCC-4572-BE32-6EC340BBCBCA}"/>
+                <a16:creationId xmlns:a16="http://schemas.microsoft.com/office/drawing/2014/main" id="{45A1AEFD-9933-4824-9C6A-A9A30C2688A2}"/>
               </a:ext>
             </a:extLst>
           </p:cNvPr>
@@ -6971,7 +6971,7 @@
           <p:cNvPr id="39" name="Verification target:">
             <a:extLst xmlns:a="http://schemas.openxmlformats.org/drawingml/2006/main">
               <a:ext uri="{FF2B5EF4-FFF2-40B4-BE49-F238E27FC236}">
-                <a16:creationId xmlns:a16="http://schemas.microsoft.com/office/drawing/2014/main" id="{F9CC4193-3DBF-4C72-9FA1-7F46DA4DC2C6}"/>
+                <a16:creationId xmlns:a16="http://schemas.microsoft.com/office/drawing/2014/main" id="{7C9C9EA8-59EE-48AA-95FC-A79A7B317E24}"/>
               </a:ext>
             </a:extLst>
           </p:cNvPr>
@@ -7028,7 +7028,7 @@
           <p:cNvPr id="40" name="M(x) ⊨ Φ">
             <a:extLst xmlns:a="http://schemas.openxmlformats.org/drawingml/2006/main">
               <a:ext uri="{FF2B5EF4-FFF2-40B4-BE49-F238E27FC236}">
-                <a16:creationId xmlns:a16="http://schemas.microsoft.com/office/drawing/2014/main" id="{51C5DF7D-660E-4181-B99E-1C670368E290}"/>
+                <a16:creationId xmlns:a16="http://schemas.microsoft.com/office/drawing/2014/main" id="{29424F60-4903-4A16-A960-564C6A8EEB81}"/>
               </a:ext>
             </a:extLst>
           </p:cNvPr>
@@ -7085,7 +7085,7 @@
           <p:cNvPr id="41" name="Editable flow path">
             <a:extLst xmlns:a="http://schemas.openxmlformats.org/drawingml/2006/main">
               <a:ext uri="{FF2B5EF4-FFF2-40B4-BE49-F238E27FC236}">
-                <a16:creationId xmlns:a16="http://schemas.microsoft.com/office/drawing/2014/main" id="{954F90DB-F208-4B67-AFE8-A0008A539B9B}"/>
+                <a16:creationId xmlns:a16="http://schemas.microsoft.com/office/drawing/2014/main" id="{0B84E62F-F88D-4866-9B69-7689D3A44908}"/>
               </a:ext>
             </a:extLst>
           </p:cNvPr>
@@ -7125,7 +7125,7 @@
           <p:cNvPr id="42" name="Editable arrowhead">
             <a:extLst xmlns:a="http://schemas.openxmlformats.org/drawingml/2006/main">
               <a:ext uri="{FF2B5EF4-FFF2-40B4-BE49-F238E27FC236}">
-                <a16:creationId xmlns:a16="http://schemas.microsoft.com/office/drawing/2014/main" id="{21E90BE9-636A-4885-922E-95EC6A0509D9}"/>
+                <a16:creationId xmlns:a16="http://schemas.microsoft.com/office/drawing/2014/main" id="{4AA6C07B-BC45-4051-B00E-D80D2D906262}"/>
               </a:ext>
             </a:extLst>
           </p:cNvPr>
@@ -7168,7 +7168,7 @@
           <p:cNvPr id="43" name="Editable boundary">
             <a:extLst xmlns:a="http://schemas.openxmlformats.org/drawingml/2006/main">
               <a:ext uri="{FF2B5EF4-FFF2-40B4-BE49-F238E27FC236}">
-                <a16:creationId xmlns:a16="http://schemas.microsoft.com/office/drawing/2014/main" id="{F529F72B-C45A-41E2-832E-FB65632BD542}"/>
+                <a16:creationId xmlns:a16="http://schemas.microsoft.com/office/drawing/2014/main" id="{BBDB6562-4020-4F12-AF09-807CF8567FCF}"/>
               </a:ext>
             </a:extLst>
           </p:cNvPr>
@@ -7186,7 +7186,7 @@
             <a:avLst/>
           </a:prstGeom>
           <a:solidFill xmlns:a="http://schemas.openxmlformats.org/drawingml/2006/main">
-            <a:srgbClr val="F0F3F6"/>
+            <a:srgbClr val="F8F8F8"/>
           </a:solidFill>
           <a:ln xmlns:a="http://schemas.openxmlformats.org/drawingml/2006/main" w="19050">
             <a:solidFill>
@@ -7201,7 +7201,7 @@
           <p:cNvPr id="44" name="Allow only when ALL hold">
             <a:extLst xmlns:a="http://schemas.openxmlformats.org/drawingml/2006/main">
               <a:ext uri="{FF2B5EF4-FFF2-40B4-BE49-F238E27FC236}">
-                <a16:creationId xmlns:a16="http://schemas.microsoft.com/office/drawing/2014/main" id="{75A8410A-7EEE-4872-B929-962F4999AC10}"/>
+                <a16:creationId xmlns:a16="http://schemas.microsoft.com/office/drawing/2014/main" id="{B421940F-FB8B-41AC-9D05-3C2554021A28}"/>
               </a:ext>
             </a:extLst>
           </p:cNvPr>
@@ -7258,7 +7258,7 @@
           <p:cNvPr id="45" name="Editable boundary">
             <a:extLst xmlns:a="http://schemas.openxmlformats.org/drawingml/2006/main">
               <a:ext uri="{FF2B5EF4-FFF2-40B4-BE49-F238E27FC236}">
-                <a16:creationId xmlns:a16="http://schemas.microsoft.com/office/drawing/2014/main" id="{BEFE47ED-799A-472B-8975-1E2595B9D44A}"/>
+                <a16:creationId xmlns:a16="http://schemas.microsoft.com/office/drawing/2014/main" id="{9A4D46A1-1103-4446-9470-9423FDAB24A3}"/>
               </a:ext>
             </a:extLst>
           </p:cNvPr>
@@ -7276,11 +7276,11 @@
             <a:avLst/>
           </a:prstGeom>
           <a:solidFill xmlns:a="http://schemas.openxmlformats.org/drawingml/2006/main">
-            <a:srgbClr val="FAFBFD"/>
+            <a:srgbClr val="FAFAFA"/>
           </a:solidFill>
           <a:ln xmlns:a="http://schemas.openxmlformats.org/drawingml/2006/main" w="11430">
             <a:solidFill>
-              <a:srgbClr val="D4DDE6"/>
+              <a:srgbClr val="D0D0D0"/>
             </a:solidFill>
             <a:prstDash val="solid"/>
           </a:ln>
@@ -7291,7 +7291,7 @@
           <p:cNvPr id="46" name="Proof accepted">
             <a:extLst xmlns:a="http://schemas.openxmlformats.org/drawingml/2006/main">
               <a:ext uri="{FF2B5EF4-FFF2-40B4-BE49-F238E27FC236}">
-                <a16:creationId xmlns:a16="http://schemas.microsoft.com/office/drawing/2014/main" id="{C5078EED-8868-4232-8787-49EE71E1D9D3}"/>
+                <a16:creationId xmlns:a16="http://schemas.microsoft.com/office/drawing/2014/main" id="{46C828C2-709A-40EA-A1B6-40238FC2ACE7}"/>
               </a:ext>
             </a:extLst>
           </p:cNvPr>
@@ -7348,7 +7348,7 @@
           <p:cNvPr id="47" name="Editable boundary">
             <a:extLst xmlns:a="http://schemas.openxmlformats.org/drawingml/2006/main">
               <a:ext uri="{FF2B5EF4-FFF2-40B4-BE49-F238E27FC236}">
-                <a16:creationId xmlns:a16="http://schemas.microsoft.com/office/drawing/2014/main" id="{187A9547-2C39-4293-8ED2-40EC03D6D728}"/>
+                <a16:creationId xmlns:a16="http://schemas.microsoft.com/office/drawing/2014/main" id="{F5443715-1B42-40FA-86E1-C0B031F0C13F}"/>
               </a:ext>
             </a:extLst>
           </p:cNvPr>
@@ -7366,11 +7366,11 @@
             <a:avLst/>
           </a:prstGeom>
           <a:solidFill xmlns:a="http://schemas.openxmlformats.org/drawingml/2006/main">
-            <a:srgbClr val="FAFBFD"/>
+            <a:srgbClr val="FAFAFA"/>
           </a:solidFill>
           <a:ln xmlns:a="http://schemas.openxmlformats.org/drawingml/2006/main" w="11430">
             <a:solidFill>
-              <a:srgbClr val="D4DDE6"/>
+              <a:srgbClr val="D0D0D0"/>
             </a:solidFill>
             <a:prstDash val="solid"/>
           </a:ln>
@@ -7381,7 +7381,7 @@
           <p:cNvPr id="48" name="Artifact, model, spec match proof">
             <a:extLst xmlns:a="http://schemas.openxmlformats.org/drawingml/2006/main">
               <a:ext uri="{FF2B5EF4-FFF2-40B4-BE49-F238E27FC236}">
-                <a16:creationId xmlns:a16="http://schemas.microsoft.com/office/drawing/2014/main" id="{EE865201-5942-4027-9CD4-90639369FFAD}"/>
+                <a16:creationId xmlns:a16="http://schemas.microsoft.com/office/drawing/2014/main" id="{B172B2EF-44AD-492F-AE18-9E2F6E05C7CD}"/>
               </a:ext>
             </a:extLst>
           </p:cNvPr>
@@ -7438,7 +7438,7 @@
           <p:cNvPr id="49" name="Editable boundary">
             <a:extLst xmlns:a="http://schemas.openxmlformats.org/drawingml/2006/main">
               <a:ext uri="{FF2B5EF4-FFF2-40B4-BE49-F238E27FC236}">
-                <a16:creationId xmlns:a16="http://schemas.microsoft.com/office/drawing/2014/main" id="{EA4ADF8A-8142-4638-B9C0-C68703FB111A}"/>
+                <a16:creationId xmlns:a16="http://schemas.microsoft.com/office/drawing/2014/main" id="{067B96D6-B97F-41B7-B247-A323E6EE25F9}"/>
               </a:ext>
             </a:extLst>
           </p:cNvPr>
@@ -7456,11 +7456,11 @@
             <a:avLst/>
           </a:prstGeom>
           <a:solidFill xmlns:a="http://schemas.openxmlformats.org/drawingml/2006/main">
-            <a:srgbClr val="FAFBFD"/>
+            <a:srgbClr val="FAFAFA"/>
           </a:solidFill>
           <a:ln xmlns:a="http://schemas.openxmlformats.org/drawingml/2006/main" w="11430">
             <a:solidFill>
-              <a:srgbClr val="D4DDE6"/>
+              <a:srgbClr val="D0D0D0"/>
             </a:solidFill>
             <a:prstDash val="solid"/>
           </a:ln>
@@ -7471,7 +7471,7 @@
           <p:cNvPr id="50" name="Permission valid at execution">
             <a:extLst xmlns:a="http://schemas.openxmlformats.org/drawingml/2006/main">
               <a:ext uri="{FF2B5EF4-FFF2-40B4-BE49-F238E27FC236}">
-                <a16:creationId xmlns:a16="http://schemas.microsoft.com/office/drawing/2014/main" id="{D30F372D-ECDC-4F6F-8D1D-8C7327D591CA}"/>
+                <a16:creationId xmlns:a16="http://schemas.microsoft.com/office/drawing/2014/main" id="{FB03712E-25D2-4F94-A526-8AB69B90D7F4}"/>
               </a:ext>
             </a:extLst>
           </p:cNvPr>
@@ -7528,7 +7528,7 @@
           <p:cNvPr id="51" name="Editable boundary">
             <a:extLst xmlns:a="http://schemas.openxmlformats.org/drawingml/2006/main">
               <a:ext uri="{FF2B5EF4-FFF2-40B4-BE49-F238E27FC236}">
-                <a16:creationId xmlns:a16="http://schemas.microsoft.com/office/drawing/2014/main" id="{D4B439D2-8FB8-489F-94C9-DF9A59861628}"/>
+                <a16:creationId xmlns:a16="http://schemas.microsoft.com/office/drawing/2014/main" id="{8D13E184-A75C-4B71-9E22-2AFF0B7A8CFB}"/>
               </a:ext>
             </a:extLst>
           </p:cNvPr>
@@ -7546,11 +7546,11 @@
             <a:avLst/>
           </a:prstGeom>
           <a:solidFill xmlns:a="http://schemas.openxmlformats.org/drawingml/2006/main">
-            <a:srgbClr val="FAFBFD"/>
+            <a:srgbClr val="FAFAFA"/>
           </a:solidFill>
           <a:ln xmlns:a="http://schemas.openxmlformats.org/drawingml/2006/main" w="11430">
             <a:solidFill>
-              <a:srgbClr val="D4DDE6"/>
+              <a:srgbClr val="D0D0D0"/>
             </a:solidFill>
             <a:prstDash val="solid"/>
           </a:ln>
@@ -7561,7 +7561,7 @@
           <p:cNvPr id="52" name="Model assumptions still hold">
             <a:extLst xmlns:a="http://schemas.openxmlformats.org/drawingml/2006/main">
               <a:ext uri="{FF2B5EF4-FFF2-40B4-BE49-F238E27FC236}">
-                <a16:creationId xmlns:a16="http://schemas.microsoft.com/office/drawing/2014/main" id="{3DCB7ABD-0589-4D61-B884-39517DD5CB39}"/>
+                <a16:creationId xmlns:a16="http://schemas.microsoft.com/office/drawing/2014/main" id="{8BA86189-4ED4-4EC7-B282-E8CC0337B62A}"/>
               </a:ext>
             </a:extLst>
           </p:cNvPr>
@@ -7618,7 +7618,7 @@
           <p:cNvPr id="53" name="Editable flow path">
             <a:extLst xmlns:a="http://schemas.openxmlformats.org/drawingml/2006/main">
               <a:ext uri="{FF2B5EF4-FFF2-40B4-BE49-F238E27FC236}">
-                <a16:creationId xmlns:a16="http://schemas.microsoft.com/office/drawing/2014/main" id="{6A5CBEDA-BD1A-49B5-96A0-6B009461EC66}"/>
+                <a16:creationId xmlns:a16="http://schemas.microsoft.com/office/drawing/2014/main" id="{963DBFA5-865F-472F-BE8E-6E1F830E69C8}"/>
               </a:ext>
             </a:extLst>
           </p:cNvPr>
@@ -7658,7 +7658,7 @@
           <p:cNvPr id="54" name="Editable flow path">
             <a:extLst xmlns:a="http://schemas.openxmlformats.org/drawingml/2006/main">
               <a:ext uri="{FF2B5EF4-FFF2-40B4-BE49-F238E27FC236}">
-                <a16:creationId xmlns:a16="http://schemas.microsoft.com/office/drawing/2014/main" id="{84EF29DF-5931-4EFD-A84E-70CAE4977974}"/>
+                <a16:creationId xmlns:a16="http://schemas.microsoft.com/office/drawing/2014/main" id="{7453FA4B-552A-4176-97F0-5A3C5A5C1CD5}"/>
               </a:ext>
             </a:extLst>
           </p:cNvPr>
@@ -7701,7 +7701,7 @@
           <p:cNvPr id="55" name="Editable arrowhead">
             <a:extLst xmlns:a="http://schemas.openxmlformats.org/drawingml/2006/main">
               <a:ext uri="{FF2B5EF4-FFF2-40B4-BE49-F238E27FC236}">
-                <a16:creationId xmlns:a16="http://schemas.microsoft.com/office/drawing/2014/main" id="{8252C54B-C83A-45D8-923F-9E2276435A6F}"/>
+                <a16:creationId xmlns:a16="http://schemas.microsoft.com/office/drawing/2014/main" id="{8811E227-69C7-4C2F-9C3B-893CC258D22D}"/>
               </a:ext>
             </a:extLst>
           </p:cNvPr>
@@ -7744,7 +7744,7 @@
           <p:cNvPr id="56" name="Editable flow path">
             <a:extLst xmlns:a="http://schemas.openxmlformats.org/drawingml/2006/main">
               <a:ext uri="{FF2B5EF4-FFF2-40B4-BE49-F238E27FC236}">
-                <a16:creationId xmlns:a16="http://schemas.microsoft.com/office/drawing/2014/main" id="{7B593EAA-D26A-4C4E-9143-583A94C4D652}"/>
+                <a16:creationId xmlns:a16="http://schemas.microsoft.com/office/drawing/2014/main" id="{BC7D919A-8825-42E2-9D09-73BB5EC10AD8}"/>
               </a:ext>
             </a:extLst>
           </p:cNvPr>
@@ -7787,7 +7787,7 @@
           <p:cNvPr id="57" name="Editable arrowhead">
             <a:extLst xmlns:a="http://schemas.openxmlformats.org/drawingml/2006/main">
               <a:ext uri="{FF2B5EF4-FFF2-40B4-BE49-F238E27FC236}">
-                <a16:creationId xmlns:a16="http://schemas.microsoft.com/office/drawing/2014/main" id="{35C3F34D-BFE7-4E05-A6DE-4CF5A28BB946}"/>
+                <a16:creationId xmlns:a16="http://schemas.microsoft.com/office/drawing/2014/main" id="{A1FE9789-949D-43E1-B5F6-DA1D772F8436}"/>
               </a:ext>
             </a:extLst>
           </p:cNvPr>
@@ -7830,7 +7830,7 @@
           <p:cNvPr id="58" name="all true">
             <a:extLst xmlns:a="http://schemas.openxmlformats.org/drawingml/2006/main">
               <a:ext uri="{FF2B5EF4-FFF2-40B4-BE49-F238E27FC236}">
-                <a16:creationId xmlns:a16="http://schemas.microsoft.com/office/drawing/2014/main" id="{BC3C399C-DA80-4DDF-91A8-6BAE5839186B}"/>
+                <a16:creationId xmlns:a16="http://schemas.microsoft.com/office/drawing/2014/main" id="{9BDD81C0-38A7-4501-BDB5-DCA8404D9CC3}"/>
               </a:ext>
             </a:extLst>
           </p:cNvPr>
@@ -7887,7 +7887,7 @@
           <p:cNvPr id="59" name="false or unknown">
             <a:extLst xmlns:a="http://schemas.openxmlformats.org/drawingml/2006/main">
               <a:ext uri="{FF2B5EF4-FFF2-40B4-BE49-F238E27FC236}">
-                <a16:creationId xmlns:a16="http://schemas.microsoft.com/office/drawing/2014/main" id="{0F7DC4DC-508E-4BC1-8441-E5F7866C5725}"/>
+                <a16:creationId xmlns:a16="http://schemas.microsoft.com/office/drawing/2014/main" id="{09AEDB00-973A-4B5D-A762-5C90F21CCFCA}"/>
               </a:ext>
             </a:extLst>
           </p:cNvPr>
@@ -7944,7 +7944,7 @@
           <p:cNvPr id="60" name="Editable boundary">
             <a:extLst xmlns:a="http://schemas.openxmlformats.org/drawingml/2006/main">
               <a:ext uri="{FF2B5EF4-FFF2-40B4-BE49-F238E27FC236}">
-                <a16:creationId xmlns:a16="http://schemas.microsoft.com/office/drawing/2014/main" id="{937C5C9B-1843-4B01-AF11-974257784D34}"/>
+                <a16:creationId xmlns:a16="http://schemas.microsoft.com/office/drawing/2014/main" id="{3350543A-39DC-4656-AAF5-C354CD41C8C2}"/>
               </a:ext>
             </a:extLst>
           </p:cNvPr>
@@ -7962,7 +7962,7 @@
             <a:avLst/>
           </a:prstGeom>
           <a:solidFill xmlns:a="http://schemas.openxmlformats.org/drawingml/2006/main">
-            <a:srgbClr val="F0F3F6"/>
+            <a:srgbClr val="F8F8F8"/>
           </a:solidFill>
           <a:ln xmlns:a="http://schemas.openxmlformats.org/drawingml/2006/main" w="19050">
             <a:solidFill>
@@ -7977,7 +7977,7 @@
           <p:cNvPr id="61" name="Editable boundary">
             <a:extLst xmlns:a="http://schemas.openxmlformats.org/drawingml/2006/main">
               <a:ext uri="{FF2B5EF4-FFF2-40B4-BE49-F238E27FC236}">
-                <a16:creationId xmlns:a16="http://schemas.microsoft.com/office/drawing/2014/main" id="{7044D630-02F4-4FFA-9C41-E79BA99CDCE1}"/>
+                <a16:creationId xmlns:a16="http://schemas.microsoft.com/office/drawing/2014/main" id="{95A7DD81-FA4D-41E4-99D6-BCCB0442C22A}"/>
               </a:ext>
             </a:extLst>
           </p:cNvPr>
@@ -7995,7 +7995,7 @@
             <a:avLst/>
           </a:prstGeom>
           <a:solidFill xmlns:a="http://schemas.openxmlformats.org/drawingml/2006/main">
-            <a:srgbClr val="F0F3F6"/>
+            <a:srgbClr val="F8F8F8"/>
           </a:solidFill>
           <a:ln xmlns:a="http://schemas.openxmlformats.org/drawingml/2006/main" w="19050">
             <a:solidFill>
@@ -8010,7 +8010,7 @@
           <p:cNvPr id="62" name="Execute">
             <a:extLst xmlns:a="http://schemas.openxmlformats.org/drawingml/2006/main">
               <a:ext uri="{FF2B5EF4-FFF2-40B4-BE49-F238E27FC236}">
-                <a16:creationId xmlns:a16="http://schemas.microsoft.com/office/drawing/2014/main" id="{6ACE10DD-A875-4E9D-A3F0-DBBC89B5D096}"/>
+                <a16:creationId xmlns:a16="http://schemas.microsoft.com/office/drawing/2014/main" id="{9F14E297-BDCD-4B89-82A3-F9336AB72776}"/>
               </a:ext>
             </a:extLst>
           </p:cNvPr>
@@ -8067,7 +8067,7 @@
           <p:cNvPr id="63" name="Defer / review">
             <a:extLst xmlns:a="http://schemas.openxmlformats.org/drawingml/2006/main">
               <a:ext uri="{FF2B5EF4-FFF2-40B4-BE49-F238E27FC236}">
-                <a16:creationId xmlns:a16="http://schemas.microsoft.com/office/drawing/2014/main" id="{8EB9C09F-F5FC-4292-A9F0-E21F3358A776}"/>
+                <a16:creationId xmlns:a16="http://schemas.microsoft.com/office/drawing/2014/main" id="{88078208-AFAE-4363-84DD-4ACC91755FEC}"/>
               </a:ext>
             </a:extLst>
           </p:cNvPr>
@@ -8124,7 +8124,7 @@
           <p:cNvPr id="64" name="Enforce through trusted controls.">
             <a:extLst xmlns:a="http://schemas.openxmlformats.org/drawingml/2006/main">
               <a:ext uri="{FF2B5EF4-FFF2-40B4-BE49-F238E27FC236}">
-                <a16:creationId xmlns:a16="http://schemas.microsoft.com/office/drawing/2014/main" id="{C1CE297F-5207-4721-8517-365A4724067B}"/>
+                <a16:creationId xmlns:a16="http://schemas.microsoft.com/office/drawing/2014/main" id="{0F741154-7828-4B02-80D6-A0945AA7575F}"/>
               </a:ext>
             </a:extLst>
           </p:cNvPr>
@@ -8181,7 +8181,7 @@
           <p:cNvPr id="65" name="Assurance requires faithful models, sound proof checking, and tr">
             <a:extLst xmlns:a="http://schemas.openxmlformats.org/drawingml/2006/main">
               <a:ext uri="{FF2B5EF4-FFF2-40B4-BE49-F238E27FC236}">
-                <a16:creationId xmlns:a16="http://schemas.microsoft.com/office/drawing/2014/main" id="{B5BD9118-BD2A-497E-B3B2-E99D6869420F}"/>
+                <a16:creationId xmlns:a16="http://schemas.microsoft.com/office/drawing/2014/main" id="{D762998B-191C-4B1D-AAE4-2E034656F1CD}"/>
               </a:ext>
             </a:extLst>
           </p:cNvPr>
@@ -8236,7 +8236,7 @@
     </p:spTree>
     <p:extLst>
       <p:ext uri="{BB962C8B-B14F-4D97-AF65-F5344CB8AC3E}">
-        <p14:creationId xmlns:p14="http://schemas.microsoft.com/office/powerpoint/2010/main" val="1248138567"/>
+        <p14:creationId xmlns:p14="http://schemas.microsoft.com/office/powerpoint/2010/main" val="251440990"/>
       </p:ext>
     </p:extLst>
   </p:cSld>
@@ -8267,7 +8267,7 @@
           <p:cNvPr id="79" name="Preserving Safety Through Continual Updates">
             <a:extLst xmlns:a="http://schemas.openxmlformats.org/drawingml/2006/main">
               <a:ext uri="{FF2B5EF4-FFF2-40B4-BE49-F238E27FC236}">
-                <a16:creationId xmlns:a16="http://schemas.microsoft.com/office/drawing/2014/main" id="{325AA68D-92A9-4F15-B767-3BCA2C5D5952}"/>
+                <a16:creationId xmlns:a16="http://schemas.microsoft.com/office/drawing/2014/main" id="{8D3994EC-5EC8-42C2-92A1-41B4AB13D2D5}"/>
               </a:ext>
             </a:extLst>
           </p:cNvPr>
@@ -8324,7 +8324,7 @@
           <p:cNvPr id="2" name="LLM or harness changes can invalidate existing guardrails">
             <a:extLst xmlns:a="http://schemas.openxmlformats.org/drawingml/2006/main">
               <a:ext uri="{FF2B5EF4-FFF2-40B4-BE49-F238E27FC236}">
-                <a16:creationId xmlns:a16="http://schemas.microsoft.com/office/drawing/2014/main" id="{03A587A0-DE3E-413D-A166-CAA3E9012A03}"/>
+                <a16:creationId xmlns:a16="http://schemas.microsoft.com/office/drawing/2014/main" id="{2B11B677-4738-4E02-BEF9-8A41A534F081}"/>
               </a:ext>
             </a:extLst>
           </p:cNvPr>
@@ -8381,7 +8381,7 @@
           <p:cNvPr id="3" name="Editable boundary">
             <a:extLst xmlns:a="http://schemas.openxmlformats.org/drawingml/2006/main">
               <a:ext uri="{FF2B5EF4-FFF2-40B4-BE49-F238E27FC236}">
-                <a16:creationId xmlns:a16="http://schemas.microsoft.com/office/drawing/2014/main" id="{D9EA934F-DF64-4F7B-95A4-0A6BE7A2E4C0}"/>
+                <a16:creationId xmlns:a16="http://schemas.microsoft.com/office/drawing/2014/main" id="{B9193F22-30A2-4E4D-B317-8A6D3ABFE8D3}"/>
               </a:ext>
             </a:extLst>
           </p:cNvPr>
@@ -8414,7 +8414,7 @@
           <p:cNvPr id="4" name="Editable boundary">
             <a:extLst xmlns:a="http://schemas.openxmlformats.org/drawingml/2006/main">
               <a:ext uri="{FF2B5EF4-FFF2-40B4-BE49-F238E27FC236}">
-                <a16:creationId xmlns:a16="http://schemas.microsoft.com/office/drawing/2014/main" id="{AC361568-7DC5-4C4F-8411-6BA29E9689C9}"/>
+                <a16:creationId xmlns:a16="http://schemas.microsoft.com/office/drawing/2014/main" id="{22841B00-AA3F-488C-89F9-87743E6AA312}"/>
               </a:ext>
             </a:extLst>
           </p:cNvPr>
@@ -8447,7 +8447,7 @@
           <p:cNvPr id="5" name="Editable boundary">
             <a:extLst xmlns:a="http://schemas.openxmlformats.org/drawingml/2006/main">
               <a:ext uri="{FF2B5EF4-FFF2-40B4-BE49-F238E27FC236}">
-                <a16:creationId xmlns:a16="http://schemas.microsoft.com/office/drawing/2014/main" id="{3C435080-D30C-4E7A-A26D-929976A18E8B}"/>
+                <a16:creationId xmlns:a16="http://schemas.microsoft.com/office/drawing/2014/main" id="{02337090-85BE-460C-A76A-CECC325F7CFE}"/>
               </a:ext>
             </a:extLst>
           </p:cNvPr>
@@ -8480,7 +8480,7 @@
           <p:cNvPr id="6" name="Editable boundary">
             <a:extLst xmlns:a="http://schemas.openxmlformats.org/drawingml/2006/main">
               <a:ext uri="{FF2B5EF4-FFF2-40B4-BE49-F238E27FC236}">
-                <a16:creationId xmlns:a16="http://schemas.microsoft.com/office/drawing/2014/main" id="{CF4EF305-4FFF-484F-8D15-5EDB0DC1393D}"/>
+                <a16:creationId xmlns:a16="http://schemas.microsoft.com/office/drawing/2014/main" id="{D6B1F57C-8443-4588-83DE-68E224A6555E}"/>
               </a:ext>
             </a:extLst>
           </p:cNvPr>
@@ -8513,7 +8513,7 @@
           <p:cNvPr id="7" name="1">
             <a:extLst xmlns:a="http://schemas.openxmlformats.org/drawingml/2006/main">
               <a:ext uri="{FF2B5EF4-FFF2-40B4-BE49-F238E27FC236}">
-                <a16:creationId xmlns:a16="http://schemas.microsoft.com/office/drawing/2014/main" id="{721511CD-0744-4D1C-8D91-4E64BDB7CD69}"/>
+                <a16:creationId xmlns:a16="http://schemas.microsoft.com/office/drawing/2014/main" id="{F96D3AB9-8404-4AA1-94F3-88046CE5ACB8}"/>
               </a:ext>
             </a:extLst>
           </p:cNvPr>
@@ -8570,7 +8570,7 @@
           <p:cNvPr id="8" name="Propose Δ">
             <a:extLst xmlns:a="http://schemas.openxmlformats.org/drawingml/2006/main">
               <a:ext uri="{FF2B5EF4-FFF2-40B4-BE49-F238E27FC236}">
-                <a16:creationId xmlns:a16="http://schemas.microsoft.com/office/drawing/2014/main" id="{E2B0B7F3-A23E-4698-8B89-1311FF3DCE9F}"/>
+                <a16:creationId xmlns:a16="http://schemas.microsoft.com/office/drawing/2014/main" id="{D42BD1EC-57BC-4826-BFC9-B3C6CE3DF571}"/>
               </a:ext>
             </a:extLst>
           </p:cNvPr>
@@ -8627,7 +8627,7 @@
           <p:cNvPr id="9" name="Editable boundary">
             <a:extLst xmlns:a="http://schemas.openxmlformats.org/drawingml/2006/main">
               <a:ext uri="{FF2B5EF4-FFF2-40B4-BE49-F238E27FC236}">
-                <a16:creationId xmlns:a16="http://schemas.microsoft.com/office/drawing/2014/main" id="{61B32309-A9E1-4E19-89A6-5E3264310F34}"/>
+                <a16:creationId xmlns:a16="http://schemas.microsoft.com/office/drawing/2014/main" id="{49C2FA90-E5DE-4EC7-8312-8451789EBA8A}"/>
               </a:ext>
             </a:extLst>
           </p:cNvPr>
@@ -8660,7 +8660,7 @@
           <p:cNvPr id="10" name="2">
             <a:extLst xmlns:a="http://schemas.openxmlformats.org/drawingml/2006/main">
               <a:ext uri="{FF2B5EF4-FFF2-40B4-BE49-F238E27FC236}">
-                <a16:creationId xmlns:a16="http://schemas.microsoft.com/office/drawing/2014/main" id="{5A7F782C-F7FD-4A83-807C-65796D77A99D}"/>
+                <a16:creationId xmlns:a16="http://schemas.microsoft.com/office/drawing/2014/main" id="{34AD8980-9A6A-4827-B195-6584672981B3}"/>
               </a:ext>
             </a:extLst>
           </p:cNvPr>
@@ -8717,7 +8717,7 @@
           <p:cNvPr id="11" name="Revalidate protection">
             <a:extLst xmlns:a="http://schemas.openxmlformats.org/drawingml/2006/main">
               <a:ext uri="{FF2B5EF4-FFF2-40B4-BE49-F238E27FC236}">
-                <a16:creationId xmlns:a16="http://schemas.microsoft.com/office/drawing/2014/main" id="{83DBA3C9-73D3-4905-A8ED-1FC7049C9469}"/>
+                <a16:creationId xmlns:a16="http://schemas.microsoft.com/office/drawing/2014/main" id="{58D7C1B5-0A05-4AEF-AEB0-7942A9FCC03C}"/>
               </a:ext>
             </a:extLst>
           </p:cNvPr>
@@ -8774,7 +8774,7 @@
           <p:cNvPr id="12" name="Editable boundary">
             <a:extLst xmlns:a="http://schemas.openxmlformats.org/drawingml/2006/main">
               <a:ext uri="{FF2B5EF4-FFF2-40B4-BE49-F238E27FC236}">
-                <a16:creationId xmlns:a16="http://schemas.microsoft.com/office/drawing/2014/main" id="{ED068292-826C-48CF-8B63-53159B737583}"/>
+                <a16:creationId xmlns:a16="http://schemas.microsoft.com/office/drawing/2014/main" id="{EE49E6D9-06AB-45EF-9D69-BD7D918D6AF4}"/>
               </a:ext>
             </a:extLst>
           </p:cNvPr>
@@ -8807,7 +8807,7 @@
           <p:cNvPr id="13" name="3">
             <a:extLst xmlns:a="http://schemas.openxmlformats.org/drawingml/2006/main">
               <a:ext uri="{FF2B5EF4-FFF2-40B4-BE49-F238E27FC236}">
-                <a16:creationId xmlns:a16="http://schemas.microsoft.com/office/drawing/2014/main" id="{17ED77CB-FD35-4CC4-ADD3-633D0371A2DB}"/>
+                <a16:creationId xmlns:a16="http://schemas.microsoft.com/office/drawing/2014/main" id="{EF738ADD-410E-42D7-AD2D-44C2D1569181}"/>
               </a:ext>
             </a:extLst>
           </p:cNvPr>
@@ -8864,7 +8864,7 @@
           <p:cNvPr id="14" name="Apply validated Δ">
             <a:extLst xmlns:a="http://schemas.openxmlformats.org/drawingml/2006/main">
               <a:ext uri="{FF2B5EF4-FFF2-40B4-BE49-F238E27FC236}">
-                <a16:creationId xmlns:a16="http://schemas.microsoft.com/office/drawing/2014/main" id="{0183D046-B847-4E4B-973B-28F163362A36}"/>
+                <a16:creationId xmlns:a16="http://schemas.microsoft.com/office/drawing/2014/main" id="{74EB9348-D7F7-4FAF-AE18-01CE6DF5FD04}"/>
               </a:ext>
             </a:extLst>
           </p:cNvPr>
@@ -8921,7 +8921,7 @@
           <p:cNvPr id="15" name="Editable boundary">
             <a:extLst xmlns:a="http://schemas.openxmlformats.org/drawingml/2006/main">
               <a:ext uri="{FF2B5EF4-FFF2-40B4-BE49-F238E27FC236}">
-                <a16:creationId xmlns:a16="http://schemas.microsoft.com/office/drawing/2014/main" id="{D0A13B81-AF86-4878-804A-D62DA05F5A3E}"/>
+                <a16:creationId xmlns:a16="http://schemas.microsoft.com/office/drawing/2014/main" id="{92A456FF-DB90-47B6-8714-FDB127B9EF3B}"/>
               </a:ext>
             </a:extLst>
           </p:cNvPr>
@@ -8939,7 +8939,7 @@
             <a:avLst/>
           </a:prstGeom>
           <a:solidFill xmlns:a="http://schemas.openxmlformats.org/drawingml/2006/main">
-            <a:srgbClr val="F7F7F7"/>
+            <a:srgbClr val="F8F8F8"/>
           </a:solidFill>
           <a:ln xmlns:a="http://schemas.openxmlformats.org/drawingml/2006/main" w="19050">
             <a:solidFill>
@@ -8954,7 +8954,7 @@
           <p:cNvPr id="16" name="Current system">
             <a:extLst xmlns:a="http://schemas.openxmlformats.org/drawingml/2006/main">
               <a:ext uri="{FF2B5EF4-FFF2-40B4-BE49-F238E27FC236}">
-                <a16:creationId xmlns:a16="http://schemas.microsoft.com/office/drawing/2014/main" id="{40959F5F-7BAD-4715-915D-FBF149B29197}"/>
+                <a16:creationId xmlns:a16="http://schemas.microsoft.com/office/drawing/2014/main" id="{44A60951-BDC7-498A-9233-8C47532E5A75}"/>
               </a:ext>
             </a:extLst>
           </p:cNvPr>
@@ -9011,7 +9011,7 @@
           <p:cNvPr id="17" name="Sₜ = (Lₜ, Hₜ)">
             <a:extLst xmlns:a="http://schemas.openxmlformats.org/drawingml/2006/main">
               <a:ext uri="{FF2B5EF4-FFF2-40B4-BE49-F238E27FC236}">
-                <a16:creationId xmlns:a16="http://schemas.microsoft.com/office/drawing/2014/main" id="{F06D3537-3B7A-417C-9E82-9E50F2280548}"/>
+                <a16:creationId xmlns:a16="http://schemas.microsoft.com/office/drawing/2014/main" id="{84812984-E448-4047-AC42-4DE595626F71}"/>
               </a:ext>
             </a:extLst>
           </p:cNvPr>
@@ -9068,7 +9068,7 @@
           <p:cNvPr id="18" name="LLM + harness, including guardrails">
             <a:extLst xmlns:a="http://schemas.openxmlformats.org/drawingml/2006/main">
               <a:ext uri="{FF2B5EF4-FFF2-40B4-BE49-F238E27FC236}">
-                <a16:creationId xmlns:a16="http://schemas.microsoft.com/office/drawing/2014/main" id="{68BC2EE0-39A2-489A-921F-9300EE76F282}"/>
+                <a16:creationId xmlns:a16="http://schemas.microsoft.com/office/drawing/2014/main" id="{44444844-1155-4D06-9A2B-D3F8AE0AB1EC}"/>
               </a:ext>
             </a:extLst>
           </p:cNvPr>
@@ -9125,7 +9125,7 @@
           <p:cNvPr id="19" name="Editable boundary">
             <a:extLst xmlns:a="http://schemas.openxmlformats.org/drawingml/2006/main">
               <a:ext uri="{FF2B5EF4-FFF2-40B4-BE49-F238E27FC236}">
-                <a16:creationId xmlns:a16="http://schemas.microsoft.com/office/drawing/2014/main" id="{DE86F532-4469-45BF-AF0A-EC59998762E4}"/>
+                <a16:creationId xmlns:a16="http://schemas.microsoft.com/office/drawing/2014/main" id="{54DE0AA2-F3CA-48B8-8657-78A098B18AB8}"/>
               </a:ext>
             </a:extLst>
           </p:cNvPr>
@@ -9143,7 +9143,7 @@
             <a:avLst/>
           </a:prstGeom>
           <a:solidFill xmlns:a="http://schemas.openxmlformats.org/drawingml/2006/main">
-            <a:srgbClr val="F7F7F7"/>
+            <a:srgbClr val="F8F8F8"/>
           </a:solidFill>
           <a:ln xmlns:a="http://schemas.openxmlformats.org/drawingml/2006/main" w="19050">
             <a:solidFill>
@@ -9158,7 +9158,7 @@
           <p:cNvPr id="20" name="LLM learning">
             <a:extLst xmlns:a="http://schemas.openxmlformats.org/drawingml/2006/main">
               <a:ext uri="{FF2B5EF4-FFF2-40B4-BE49-F238E27FC236}">
-                <a16:creationId xmlns:a16="http://schemas.microsoft.com/office/drawing/2014/main" id="{B30F6176-5DC3-4CD6-A2B6-82AA53363674}"/>
+                <a16:creationId xmlns:a16="http://schemas.microsoft.com/office/drawing/2014/main" id="{7FADEC1C-BF38-48A8-8700-8672E2469278}"/>
               </a:ext>
             </a:extLst>
           </p:cNvPr>
@@ -9215,7 +9215,7 @@
           <p:cNvPr id="21" name="Paired authorized tasks">
             <a:extLst xmlns:a="http://schemas.openxmlformats.org/drawingml/2006/main">
               <a:ext uri="{FF2B5EF4-FFF2-40B4-BE49-F238E27FC236}">
-                <a16:creationId xmlns:a16="http://schemas.microsoft.com/office/drawing/2014/main" id="{7BF953FE-0409-4E65-9C02-2774EF4921BF}"/>
+                <a16:creationId xmlns:a16="http://schemas.microsoft.com/office/drawing/2014/main" id="{3EDB53E7-EF49-4C03-9A38-6BAB04B00741}"/>
               </a:ext>
             </a:extLst>
           </p:cNvPr>
@@ -9272,7 +9272,7 @@
           <p:cNvPr id="22" name="Editable boundary">
             <a:extLst xmlns:a="http://schemas.openxmlformats.org/drawingml/2006/main">
               <a:ext uri="{FF2B5EF4-FFF2-40B4-BE49-F238E27FC236}">
-                <a16:creationId xmlns:a16="http://schemas.microsoft.com/office/drawing/2014/main" id="{43C6864F-A53B-40A1-8BCD-8ADF5FFC1463}"/>
+                <a16:creationId xmlns:a16="http://schemas.microsoft.com/office/drawing/2014/main" id="{6BE4961B-04F1-4F70-ABEF-488FA540701F}"/>
               </a:ext>
             </a:extLst>
           </p:cNvPr>
@@ -9290,7 +9290,7 @@
             <a:avLst/>
           </a:prstGeom>
           <a:solidFill xmlns:a="http://schemas.openxmlformats.org/drawingml/2006/main">
-            <a:srgbClr val="F7F7F7"/>
+            <a:srgbClr val="F8F8F8"/>
           </a:solidFill>
           <a:ln xmlns:a="http://schemas.openxmlformats.org/drawingml/2006/main" w="19050">
             <a:solidFill>
@@ -9305,7 +9305,7 @@
           <p:cNvPr id="23" name="Harness upgrades">
             <a:extLst xmlns:a="http://schemas.openxmlformats.org/drawingml/2006/main">
               <a:ext uri="{FF2B5EF4-FFF2-40B4-BE49-F238E27FC236}">
-                <a16:creationId xmlns:a16="http://schemas.microsoft.com/office/drawing/2014/main" id="{EC2755A9-D291-4AF8-8144-F3331A6D2B35}"/>
+                <a16:creationId xmlns:a16="http://schemas.microsoft.com/office/drawing/2014/main" id="{9131DD75-1482-45DA-A1CD-B4571912C73E}"/>
               </a:ext>
             </a:extLst>
           </p:cNvPr>
@@ -9362,7 +9362,7 @@
           <p:cNvPr id="24" name="Tools · monitors · training feedback">
             <a:extLst xmlns:a="http://schemas.openxmlformats.org/drawingml/2006/main">
               <a:ext uri="{FF2B5EF4-FFF2-40B4-BE49-F238E27FC236}">
-                <a16:creationId xmlns:a16="http://schemas.microsoft.com/office/drawing/2014/main" id="{BAC00E8E-ECFB-40F4-8468-E4355E0B7669}"/>
+                <a16:creationId xmlns:a16="http://schemas.microsoft.com/office/drawing/2014/main" id="{CC472C59-CF16-449E-A9EB-6CA6C18120AD}"/>
               </a:ext>
             </a:extLst>
           </p:cNvPr>
@@ -9419,7 +9419,7 @@
           <p:cNvPr id="25" name="Test a candidate before release.">
             <a:extLst xmlns:a="http://schemas.openxmlformats.org/drawingml/2006/main">
               <a:ext uri="{FF2B5EF4-FFF2-40B4-BE49-F238E27FC236}">
-                <a16:creationId xmlns:a16="http://schemas.microsoft.com/office/drawing/2014/main" id="{DF80171A-26F2-4698-978D-E4CA6DD6A5BC}"/>
+                <a16:creationId xmlns:a16="http://schemas.microsoft.com/office/drawing/2014/main" id="{C43CE20B-5F8C-49D4-A495-EBA26440763F}"/>
               </a:ext>
             </a:extLst>
           </p:cNvPr>
@@ -9476,7 +9476,7 @@
           <p:cNvPr id="26" name="updated">
             <a:extLst xmlns:a="http://schemas.openxmlformats.org/drawingml/2006/main">
               <a:ext uri="{FF2B5EF4-FFF2-40B4-BE49-F238E27FC236}">
-                <a16:creationId xmlns:a16="http://schemas.microsoft.com/office/drawing/2014/main" id="{B8DBD068-64AA-4A09-A1FC-DBD43E6A5406}"/>
+                <a16:creationId xmlns:a16="http://schemas.microsoft.com/office/drawing/2014/main" id="{E66A81C1-4EF1-4EBD-86E5-98B1F299019C}"/>
               </a:ext>
             </a:extLst>
           </p:cNvPr>
@@ -9533,7 +9533,7 @@
           <p:cNvPr id="27" name="candidate">
             <a:extLst xmlns:a="http://schemas.openxmlformats.org/drawingml/2006/main">
               <a:ext uri="{FF2B5EF4-FFF2-40B4-BE49-F238E27FC236}">
-                <a16:creationId xmlns:a16="http://schemas.microsoft.com/office/drawing/2014/main" id="{BB58DA46-ABEA-4970-B880-B420EEC9650D}"/>
+                <a16:creationId xmlns:a16="http://schemas.microsoft.com/office/drawing/2014/main" id="{0CBCE4D2-FD6B-44DB-9C89-027511968A7E}"/>
               </a:ext>
             </a:extLst>
           </p:cNvPr>
@@ -9590,7 +9590,7 @@
           <p:cNvPr id="28" name="Editable flow path">
             <a:extLst xmlns:a="http://schemas.openxmlformats.org/drawingml/2006/main">
               <a:ext uri="{FF2B5EF4-FFF2-40B4-BE49-F238E27FC236}">
-                <a16:creationId xmlns:a16="http://schemas.microsoft.com/office/drawing/2014/main" id="{3F90A71A-E41D-4B3C-A013-D4E4B9DCCF64}"/>
+                <a16:creationId xmlns:a16="http://schemas.microsoft.com/office/drawing/2014/main" id="{ED48FAA1-9530-4B5D-8B5C-6C73451789C3}"/>
               </a:ext>
             </a:extLst>
           </p:cNvPr>
@@ -9630,7 +9630,7 @@
           <p:cNvPr id="29" name="Editable arrowhead">
             <a:extLst xmlns:a="http://schemas.openxmlformats.org/drawingml/2006/main">
               <a:ext uri="{FF2B5EF4-FFF2-40B4-BE49-F238E27FC236}">
-                <a16:creationId xmlns:a16="http://schemas.microsoft.com/office/drawing/2014/main" id="{A70915DC-87F6-43F8-8E89-66CCED5FCC5F}"/>
+                <a16:creationId xmlns:a16="http://schemas.microsoft.com/office/drawing/2014/main" id="{DC70AB0E-D943-40C7-B8A9-4C7AAE17869B}"/>
               </a:ext>
             </a:extLst>
           </p:cNvPr>
@@ -9673,7 +9673,7 @@
           <p:cNvPr id="30" name="Editable boundary">
             <a:extLst xmlns:a="http://schemas.openxmlformats.org/drawingml/2006/main">
               <a:ext uri="{FF2B5EF4-FFF2-40B4-BE49-F238E27FC236}">
-                <a16:creationId xmlns:a16="http://schemas.microsoft.com/office/drawing/2014/main" id="{94E12760-10BE-494E-AF2C-1A627A64E384}"/>
+                <a16:creationId xmlns:a16="http://schemas.microsoft.com/office/drawing/2014/main" id="{7CC9ACFA-64A3-4B3F-8D99-858BEAAC10E7}"/>
               </a:ext>
             </a:extLst>
           </p:cNvPr>
@@ -9691,7 +9691,7 @@
             <a:avLst/>
           </a:prstGeom>
           <a:solidFill xmlns:a="http://schemas.openxmlformats.org/drawingml/2006/main">
-            <a:srgbClr val="F7F7F7"/>
+            <a:srgbClr val="F8F8F8"/>
           </a:solidFill>
           <a:ln xmlns:a="http://schemas.openxmlformats.org/drawingml/2006/main" w="19050">
             <a:solidFill>
@@ -9706,7 +9706,7 @@
           <p:cNvPr id="31" name="Protected requirements">
             <a:extLst xmlns:a="http://schemas.openxmlformats.org/drawingml/2006/main">
               <a:ext uri="{FF2B5EF4-FFF2-40B4-BE49-F238E27FC236}">
-                <a16:creationId xmlns:a16="http://schemas.microsoft.com/office/drawing/2014/main" id="{E8926162-121C-48F4-BDA2-E74BE42ACB43}"/>
+                <a16:creationId xmlns:a16="http://schemas.microsoft.com/office/drawing/2014/main" id="{C5ACBE4D-7EAF-4E94-B39C-FDC7F275DCCF}"/>
               </a:ext>
             </a:extLst>
           </p:cNvPr>
@@ -9763,7 +9763,7 @@
           <p:cNvPr id="32" name="Security · reliability · task completion">
             <a:extLst xmlns:a="http://schemas.openxmlformats.org/drawingml/2006/main">
               <a:ext uri="{FF2B5EF4-FFF2-40B4-BE49-F238E27FC236}">
-                <a16:creationId xmlns:a16="http://schemas.microsoft.com/office/drawing/2014/main" id="{67C7F65C-D82E-4C50-8681-DC54F223C447}"/>
+                <a16:creationId xmlns:a16="http://schemas.microsoft.com/office/drawing/2014/main" id="{DEC657AD-C0D5-4860-B1A4-ED0496C71331}"/>
               </a:ext>
             </a:extLst>
           </p:cNvPr>
@@ -9820,7 +9820,7 @@
           <p:cNvPr id="33" name="Editable boundary">
             <a:extLst xmlns:a="http://schemas.openxmlformats.org/drawingml/2006/main">
               <a:ext uri="{FF2B5EF4-FFF2-40B4-BE49-F238E27FC236}">
-                <a16:creationId xmlns:a16="http://schemas.microsoft.com/office/drawing/2014/main" id="{A6DAA3AB-85E7-4773-94CB-2447A1FE4EA8}"/>
+                <a16:creationId xmlns:a16="http://schemas.microsoft.com/office/drawing/2014/main" id="{0ECB4171-468E-4E7C-9D46-EDD1C5F44180}"/>
               </a:ext>
             </a:extLst>
           </p:cNvPr>
@@ -9838,7 +9838,7 @@
             <a:avLst/>
           </a:prstGeom>
           <a:solidFill xmlns:a="http://schemas.openxmlformats.org/drawingml/2006/main">
-            <a:srgbClr val="F7F7F7"/>
+            <a:srgbClr val="F8F8F8"/>
           </a:solidFill>
           <a:ln xmlns:a="http://schemas.openxmlformats.org/drawingml/2006/main" w="19050">
             <a:solidFill>
@@ -9853,7 +9853,7 @@
           <p:cNvPr id="34" name="Recheck existing guardrails">
             <a:extLst xmlns:a="http://schemas.openxmlformats.org/drawingml/2006/main">
               <a:ext uri="{FF2B5EF4-FFF2-40B4-BE49-F238E27FC236}">
-                <a16:creationId xmlns:a16="http://schemas.microsoft.com/office/drawing/2014/main" id="{708DA1D1-9490-4E7E-B100-B4232B74FF40}"/>
+                <a16:creationId xmlns:a16="http://schemas.microsoft.com/office/drawing/2014/main" id="{1423D3C1-BFEE-4ADE-88A9-3300A4427AA4}"/>
               </a:ext>
             </a:extLst>
           </p:cNvPr>
@@ -9910,7 +9910,7 @@
           <p:cNvPr id="35" name="Editable boundary">
             <a:extLst xmlns:a="http://schemas.openxmlformats.org/drawingml/2006/main">
               <a:ext uri="{FF2B5EF4-FFF2-40B4-BE49-F238E27FC236}">
-                <a16:creationId xmlns:a16="http://schemas.microsoft.com/office/drawing/2014/main" id="{CDF3DDE6-0AC8-4EB4-87FD-EB66FDFFE49A}"/>
+                <a16:creationId xmlns:a16="http://schemas.microsoft.com/office/drawing/2014/main" id="{84235DBF-D200-4576-B34B-E71F4695A182}"/>
               </a:ext>
             </a:extLst>
           </p:cNvPr>
@@ -9943,7 +9943,7 @@
           <p:cNvPr id="36" name="PolicyOK">
             <a:extLst xmlns:a="http://schemas.openxmlformats.org/drawingml/2006/main">
               <a:ext uri="{FF2B5EF4-FFF2-40B4-BE49-F238E27FC236}">
-                <a16:creationId xmlns:a16="http://schemas.microsoft.com/office/drawing/2014/main" id="{AD35889B-8F87-4E7E-B92E-0294B7321AA9}"/>
+                <a16:creationId xmlns:a16="http://schemas.microsoft.com/office/drawing/2014/main" id="{C4397355-94DC-4FE4-BB99-7C11163DBF65}"/>
               </a:ext>
             </a:extLst>
           </p:cNvPr>
@@ -10000,7 +10000,7 @@
           <p:cNvPr id="37" name="Permissions · data boundaries">
             <a:extLst xmlns:a="http://schemas.openxmlformats.org/drawingml/2006/main">
               <a:ext uri="{FF2B5EF4-FFF2-40B4-BE49-F238E27FC236}">
-                <a16:creationId xmlns:a16="http://schemas.microsoft.com/office/drawing/2014/main" id="{8E39DE99-9880-4F7D-B7CB-5DCAFCD2571B}"/>
+                <a16:creationId xmlns:a16="http://schemas.microsoft.com/office/drawing/2014/main" id="{2EB960C3-E4C8-412A-8528-AE1C24F11AB9}"/>
               </a:ext>
             </a:extLst>
           </p:cNvPr>
@@ -10057,7 +10057,7 @@
           <p:cNvPr id="38" name="Editable boundary">
             <a:extLst xmlns:a="http://schemas.openxmlformats.org/drawingml/2006/main">
               <a:ext uri="{FF2B5EF4-FFF2-40B4-BE49-F238E27FC236}">
-                <a16:creationId xmlns:a16="http://schemas.microsoft.com/office/drawing/2014/main" id="{69079702-073A-43CA-B47F-E73C3D1DC56B}"/>
+                <a16:creationId xmlns:a16="http://schemas.microsoft.com/office/drawing/2014/main" id="{4895A30A-456F-4A68-B10B-9F95538F65EA}"/>
               </a:ext>
             </a:extLst>
           </p:cNvPr>
@@ -10090,7 +10090,7 @@
           <p:cNvPr id="39" name="RetentionOK">
             <a:extLst xmlns:a="http://schemas.openxmlformats.org/drawingml/2006/main">
               <a:ext uri="{FF2B5EF4-FFF2-40B4-BE49-F238E27FC236}">
-                <a16:creationId xmlns:a16="http://schemas.microsoft.com/office/drawing/2014/main" id="{4C5C5BC0-2684-40E2-BC65-17201DDBB1B0}"/>
+                <a16:creationId xmlns:a16="http://schemas.microsoft.com/office/drawing/2014/main" id="{BB5FC411-B2D9-4826-99A8-3673A813FFD0}"/>
               </a:ext>
             </a:extLst>
           </p:cNvPr>
@@ -10147,7 +10147,7 @@
           <p:cNvPr id="40" name="Independent regression and adversarial tests">
             <a:extLst xmlns:a="http://schemas.openxmlformats.org/drawingml/2006/main">
               <a:ext uri="{FF2B5EF4-FFF2-40B4-BE49-F238E27FC236}">
-                <a16:creationId xmlns:a16="http://schemas.microsoft.com/office/drawing/2014/main" id="{30B9F9DF-DDFB-45BE-9B1F-DCB67FA9FAE2}"/>
+                <a16:creationId xmlns:a16="http://schemas.microsoft.com/office/drawing/2014/main" id="{CDF05929-8471-4BE7-B01F-7AA1288EB103}"/>
               </a:ext>
             </a:extLst>
           </p:cNvPr>
@@ -10204,7 +10204,7 @@
           <p:cNvPr id="41" name="Editable flow path">
             <a:extLst xmlns:a="http://schemas.openxmlformats.org/drawingml/2006/main">
               <a:ext uri="{FF2B5EF4-FFF2-40B4-BE49-F238E27FC236}">
-                <a16:creationId xmlns:a16="http://schemas.microsoft.com/office/drawing/2014/main" id="{E4C8C147-01A3-4CD9-A509-A8B3C56AA012}"/>
+                <a16:creationId xmlns:a16="http://schemas.microsoft.com/office/drawing/2014/main" id="{B9E8CB5A-9C46-415F-BC22-E3CEDECA5B65}"/>
               </a:ext>
             </a:extLst>
           </p:cNvPr>
@@ -10244,7 +10244,7 @@
           <p:cNvPr id="42" name="Editable arrowhead">
             <a:extLst xmlns:a="http://schemas.openxmlformats.org/drawingml/2006/main">
               <a:ext uri="{FF2B5EF4-FFF2-40B4-BE49-F238E27FC236}">
-                <a16:creationId xmlns:a16="http://schemas.microsoft.com/office/drawing/2014/main" id="{AEA5FF0B-81DA-47CF-AA1C-7D396FF56231}"/>
+                <a16:creationId xmlns:a16="http://schemas.microsoft.com/office/drawing/2014/main" id="{6AD17306-DD71-4CAD-9DA4-CFB1034D866D}"/>
               </a:ext>
             </a:extLst>
           </p:cNvPr>
@@ -10287,7 +10287,7 @@
           <p:cNvPr id="43" name="fail / unknown">
             <a:extLst xmlns:a="http://schemas.openxmlformats.org/drawingml/2006/main">
               <a:ext uri="{FF2B5EF4-FFF2-40B4-BE49-F238E27FC236}">
-                <a16:creationId xmlns:a16="http://schemas.microsoft.com/office/drawing/2014/main" id="{CA3FAB48-E37A-4CA7-A97A-899EF83A0925}"/>
+                <a16:creationId xmlns:a16="http://schemas.microsoft.com/office/drawing/2014/main" id="{C0D82FE0-28BB-4691-8A06-3306DA43F8BF}"/>
               </a:ext>
             </a:extLst>
           </p:cNvPr>
@@ -10344,7 +10344,7 @@
           <p:cNvPr id="44" name="Editable flow path">
             <a:extLst xmlns:a="http://schemas.openxmlformats.org/drawingml/2006/main">
               <a:ext uri="{FF2B5EF4-FFF2-40B4-BE49-F238E27FC236}">
-                <a16:creationId xmlns:a16="http://schemas.microsoft.com/office/drawing/2014/main" id="{6EAC2030-D91F-4051-AA3C-9FC8121DA0D1}"/>
+                <a16:creationId xmlns:a16="http://schemas.microsoft.com/office/drawing/2014/main" id="{925CF941-5351-4E4E-80D3-A0137B1E2854}"/>
               </a:ext>
             </a:extLst>
           </p:cNvPr>
@@ -10384,7 +10384,7 @@
           <p:cNvPr id="45" name="Editable arrowhead">
             <a:extLst xmlns:a="http://schemas.openxmlformats.org/drawingml/2006/main">
               <a:ext uri="{FF2B5EF4-FFF2-40B4-BE49-F238E27FC236}">
-                <a16:creationId xmlns:a16="http://schemas.microsoft.com/office/drawing/2014/main" id="{8FC9CA01-A74C-4DC8-B7E5-9746A0FEA046}"/>
+                <a16:creationId xmlns:a16="http://schemas.microsoft.com/office/drawing/2014/main" id="{B14997BC-7C66-4EB0-95C1-1273958FF527}"/>
               </a:ext>
             </a:extLst>
           </p:cNvPr>
@@ -10427,7 +10427,7 @@
           <p:cNvPr id="46" name="retest">
             <a:extLst xmlns:a="http://schemas.openxmlformats.org/drawingml/2006/main">
               <a:ext uri="{FF2B5EF4-FFF2-40B4-BE49-F238E27FC236}">
-                <a16:creationId xmlns:a16="http://schemas.microsoft.com/office/drawing/2014/main" id="{474936C5-A333-4C5D-BB8E-E9BBB94A7E58}"/>
+                <a16:creationId xmlns:a16="http://schemas.microsoft.com/office/drawing/2014/main" id="{FFBDF5E9-913D-4FEF-955D-90C5051D8671}"/>
               </a:ext>
             </a:extLst>
           </p:cNvPr>
@@ -10484,7 +10484,7 @@
           <p:cNvPr id="47" name="Editable boundary">
             <a:extLst xmlns:a="http://schemas.openxmlformats.org/drawingml/2006/main">
               <a:ext uri="{FF2B5EF4-FFF2-40B4-BE49-F238E27FC236}">
-                <a16:creationId xmlns:a16="http://schemas.microsoft.com/office/drawing/2014/main" id="{34B5E1F9-1ED7-479F-84DA-4BF6574DD747}"/>
+                <a16:creationId xmlns:a16="http://schemas.microsoft.com/office/drawing/2014/main" id="{0B41DAEB-1AB0-4C56-A2AE-9330857EA6E2}"/>
               </a:ext>
             </a:extLst>
           </p:cNvPr>
@@ -10502,7 +10502,7 @@
             <a:avLst/>
           </a:prstGeom>
           <a:solidFill xmlns:a="http://schemas.openxmlformats.org/drawingml/2006/main">
-            <a:srgbClr val="F7F7F7"/>
+            <a:srgbClr val="F8F8F8"/>
           </a:solidFill>
           <a:ln xmlns:a="http://schemas.openxmlformats.org/drawingml/2006/main" w="19050">
             <a:solidFill>
@@ -10517,7 +10517,7 @@
           <p:cNvPr id="48" name="Repair update or guardrails">
             <a:extLst xmlns:a="http://schemas.openxmlformats.org/drawingml/2006/main">
               <a:ext uri="{FF2B5EF4-FFF2-40B4-BE49-F238E27FC236}">
-                <a16:creationId xmlns:a16="http://schemas.microsoft.com/office/drawing/2014/main" id="{95548F1D-6107-4481-89A9-DD3B4DB54E58}"/>
+                <a16:creationId xmlns:a16="http://schemas.microsoft.com/office/drawing/2014/main" id="{1C851D41-F68E-41C2-B661-E47575758F6E}"/>
               </a:ext>
             </a:extLst>
           </p:cNvPr>
@@ -10574,7 +10574,7 @@
           <p:cNvPr id="49" name="Keep requirements unchanged">
             <a:extLst xmlns:a="http://schemas.openxmlformats.org/drawingml/2006/main">
               <a:ext uri="{FF2B5EF4-FFF2-40B4-BE49-F238E27FC236}">
-                <a16:creationId xmlns:a16="http://schemas.microsoft.com/office/drawing/2014/main" id="{979EF774-E1ED-4BBB-A40A-68D9D0AC0E33}"/>
+                <a16:creationId xmlns:a16="http://schemas.microsoft.com/office/drawing/2014/main" id="{03B411A3-A4C4-4492-AD19-0BD6D8AED0EC}"/>
               </a:ext>
             </a:extLst>
           </p:cNvPr>
@@ -10631,7 +10631,7 @@
           <p:cNvPr id="50" name="checked">
             <a:extLst xmlns:a="http://schemas.openxmlformats.org/drawingml/2006/main">
               <a:ext uri="{FF2B5EF4-FFF2-40B4-BE49-F238E27FC236}">
-                <a16:creationId xmlns:a16="http://schemas.microsoft.com/office/drawing/2014/main" id="{43AE3F2B-86BD-4314-BF0D-41375CA8857B}"/>
+                <a16:creationId xmlns:a16="http://schemas.microsoft.com/office/drawing/2014/main" id="{3B14544F-5376-415F-8EDF-6FD599F3618F}"/>
               </a:ext>
             </a:extLst>
           </p:cNvPr>
@@ -10688,7 +10688,7 @@
           <p:cNvPr id="51" name="evidence">
             <a:extLst xmlns:a="http://schemas.openxmlformats.org/drawingml/2006/main">
               <a:ext uri="{FF2B5EF4-FFF2-40B4-BE49-F238E27FC236}">
-                <a16:creationId xmlns:a16="http://schemas.microsoft.com/office/drawing/2014/main" id="{7D044282-8183-45F7-9F3D-E77ACAA550DD}"/>
+                <a16:creationId xmlns:a16="http://schemas.microsoft.com/office/drawing/2014/main" id="{147E1FA6-831D-4FEB-BCF4-288E20F2BCF4}"/>
               </a:ext>
             </a:extLst>
           </p:cNvPr>
@@ -10745,7 +10745,7 @@
           <p:cNvPr id="52" name="Editable flow path">
             <a:extLst xmlns:a="http://schemas.openxmlformats.org/drawingml/2006/main">
               <a:ext uri="{FF2B5EF4-FFF2-40B4-BE49-F238E27FC236}">
-                <a16:creationId xmlns:a16="http://schemas.microsoft.com/office/drawing/2014/main" id="{CC2EE4AB-F8DF-426E-955D-F557463F7E1E}"/>
+                <a16:creationId xmlns:a16="http://schemas.microsoft.com/office/drawing/2014/main" id="{74694343-84F8-4B46-938A-8AEF92A15DB2}"/>
               </a:ext>
             </a:extLst>
           </p:cNvPr>
@@ -10785,7 +10785,7 @@
           <p:cNvPr id="53" name="Editable arrowhead">
             <a:extLst xmlns:a="http://schemas.openxmlformats.org/drawingml/2006/main">
               <a:ext uri="{FF2B5EF4-FFF2-40B4-BE49-F238E27FC236}">
-                <a16:creationId xmlns:a16="http://schemas.microsoft.com/office/drawing/2014/main" id="{32D5DEA4-1C23-4EB0-9320-D31AD0305A56}"/>
+                <a16:creationId xmlns:a16="http://schemas.microsoft.com/office/drawing/2014/main" id="{ADE87577-D86E-4025-BEB2-DC46EDC7E20D}"/>
               </a:ext>
             </a:extLst>
           </p:cNvPr>
@@ -10828,7 +10828,7 @@
           <p:cNvPr id="54" name="Editable boundary">
             <a:extLst xmlns:a="http://schemas.openxmlformats.org/drawingml/2006/main">
               <a:ext uri="{FF2B5EF4-FFF2-40B4-BE49-F238E27FC236}">
-                <a16:creationId xmlns:a16="http://schemas.microsoft.com/office/drawing/2014/main" id="{210F9C41-B37A-4B9B-9B98-C2AA6AF36E39}"/>
+                <a16:creationId xmlns:a16="http://schemas.microsoft.com/office/drawing/2014/main" id="{187744EE-CDCE-4A46-965C-5F211291AF79}"/>
               </a:ext>
             </a:extLst>
           </p:cNvPr>
@@ -10846,7 +10846,7 @@
             <a:avLst/>
           </a:prstGeom>
           <a:solidFill xmlns:a="http://schemas.openxmlformats.org/drawingml/2006/main">
-            <a:srgbClr val="F7F7F7"/>
+            <a:srgbClr val="F8F8F8"/>
           </a:solidFill>
           <a:ln xmlns:a="http://schemas.openxmlformats.org/drawingml/2006/main" w="19050">
             <a:solidFill>
@@ -10861,7 +10861,7 @@
           <p:cNvPr id="55" name="Update gate">
             <a:extLst xmlns:a="http://schemas.openxmlformats.org/drawingml/2006/main">
               <a:ext uri="{FF2B5EF4-FFF2-40B4-BE49-F238E27FC236}">
-                <a16:creationId xmlns:a16="http://schemas.microsoft.com/office/drawing/2014/main" id="{BD0CBB12-1BC6-4EC1-981C-7F4B140EFEDC}"/>
+                <a16:creationId xmlns:a16="http://schemas.microsoft.com/office/drawing/2014/main" id="{2B501CD4-047F-457A-B11A-3032454A459C}"/>
               </a:ext>
             </a:extLst>
           </p:cNvPr>
@@ -10918,7 +10918,7 @@
           <p:cNvPr id="56" name="Accept(Δ*) :=">
             <a:extLst xmlns:a="http://schemas.openxmlformats.org/drawingml/2006/main">
               <a:ext uri="{FF2B5EF4-FFF2-40B4-BE49-F238E27FC236}">
-                <a16:creationId xmlns:a16="http://schemas.microsoft.com/office/drawing/2014/main" id="{89EF14EF-131C-45EE-8874-2E98C0D89F68}"/>
+                <a16:creationId xmlns:a16="http://schemas.microsoft.com/office/drawing/2014/main" id="{8A3F9E71-1308-4473-AC37-85224CE60489}"/>
               </a:ext>
             </a:extLst>
           </p:cNvPr>
@@ -10975,7 +10975,7 @@
           <p:cNvPr id="57" name="PolicyOK ∧ RetentionOK">
             <a:extLst xmlns:a="http://schemas.openxmlformats.org/drawingml/2006/main">
               <a:ext uri="{FF2B5EF4-FFF2-40B4-BE49-F238E27FC236}">
-                <a16:creationId xmlns:a16="http://schemas.microsoft.com/office/drawing/2014/main" id="{2387D19A-9B83-4ABF-A649-6CB0E14E4932}"/>
+                <a16:creationId xmlns:a16="http://schemas.microsoft.com/office/drawing/2014/main" id="{9FB3DB50-E5C3-4479-BB8A-A263FF6C402D}"/>
               </a:ext>
             </a:extLst>
           </p:cNvPr>
@@ -11032,7 +11032,7 @@
           <p:cNvPr id="58" name="Release the checked version only">
             <a:extLst xmlns:a="http://schemas.openxmlformats.org/drawingml/2006/main">
               <a:ext uri="{FF2B5EF4-FFF2-40B4-BE49-F238E27FC236}">
-                <a16:creationId xmlns:a16="http://schemas.microsoft.com/office/drawing/2014/main" id="{46B3E663-E6FE-457C-BC29-DB5319A47D0E}"/>
+                <a16:creationId xmlns:a16="http://schemas.microsoft.com/office/drawing/2014/main" id="{E39CA9E9-D74C-4F29-8B46-42DEBA5C0080}"/>
               </a:ext>
             </a:extLst>
           </p:cNvPr>
@@ -11089,7 +11089,7 @@
           <p:cNvPr id="59" name="Editable flow path">
             <a:extLst xmlns:a="http://schemas.openxmlformats.org/drawingml/2006/main">
               <a:ext uri="{FF2B5EF4-FFF2-40B4-BE49-F238E27FC236}">
-                <a16:creationId xmlns:a16="http://schemas.microsoft.com/office/drawing/2014/main" id="{3451B0BD-C597-44E2-A422-13326F7D9232}"/>
+                <a16:creationId xmlns:a16="http://schemas.microsoft.com/office/drawing/2014/main" id="{7EB1AFD8-5337-4C81-9117-B65D4D8C6AF3}"/>
               </a:ext>
             </a:extLst>
           </p:cNvPr>
@@ -11129,7 +11129,7 @@
           <p:cNvPr id="60" name="Editable flow path">
             <a:extLst xmlns:a="http://schemas.openxmlformats.org/drawingml/2006/main">
               <a:ext uri="{FF2B5EF4-FFF2-40B4-BE49-F238E27FC236}">
-                <a16:creationId xmlns:a16="http://schemas.microsoft.com/office/drawing/2014/main" id="{0CBC1869-645A-48FC-8ECC-E7301ACAED1C}"/>
+                <a16:creationId xmlns:a16="http://schemas.microsoft.com/office/drawing/2014/main" id="{40C77FD8-3FA3-4A59-94C0-48FA36B90F49}"/>
               </a:ext>
             </a:extLst>
           </p:cNvPr>
@@ -11172,7 +11172,7 @@
           <p:cNvPr id="61" name="Editable arrowhead">
             <a:extLst xmlns:a="http://schemas.openxmlformats.org/drawingml/2006/main">
               <a:ext uri="{FF2B5EF4-FFF2-40B4-BE49-F238E27FC236}">
-                <a16:creationId xmlns:a16="http://schemas.microsoft.com/office/drawing/2014/main" id="{45F0A5A1-4326-4E83-B5FB-B223666C89B6}"/>
+                <a16:creationId xmlns:a16="http://schemas.microsoft.com/office/drawing/2014/main" id="{94FD7D26-1AB8-4D50-9939-5540F046B1D4}"/>
               </a:ext>
             </a:extLst>
           </p:cNvPr>
@@ -11215,7 +11215,7 @@
           <p:cNvPr id="62" name="Editable flow path">
             <a:extLst xmlns:a="http://schemas.openxmlformats.org/drawingml/2006/main">
               <a:ext uri="{FF2B5EF4-FFF2-40B4-BE49-F238E27FC236}">
-                <a16:creationId xmlns:a16="http://schemas.microsoft.com/office/drawing/2014/main" id="{112B0DD4-F768-4F1D-8062-8CE34F31B825}"/>
+                <a16:creationId xmlns:a16="http://schemas.microsoft.com/office/drawing/2014/main" id="{9AD237A0-326F-45F8-99FB-D3C1A81A1C61}"/>
               </a:ext>
             </a:extLst>
           </p:cNvPr>
@@ -11258,7 +11258,7 @@
           <p:cNvPr id="63" name="Editable arrowhead">
             <a:extLst xmlns:a="http://schemas.openxmlformats.org/drawingml/2006/main">
               <a:ext uri="{FF2B5EF4-FFF2-40B4-BE49-F238E27FC236}">
-                <a16:creationId xmlns:a16="http://schemas.microsoft.com/office/drawing/2014/main" id="{5A681F1D-1225-49C1-9B1E-50ACD323A634}"/>
+                <a16:creationId xmlns:a16="http://schemas.microsoft.com/office/drawing/2014/main" id="{6E20CA9E-ACC8-44ED-BC8B-1017FB05EDAD}"/>
               </a:ext>
             </a:extLst>
           </p:cNvPr>
@@ -11301,7 +11301,7 @@
           <p:cNvPr id="64" name="pass">
             <a:extLst xmlns:a="http://schemas.openxmlformats.org/drawingml/2006/main">
               <a:ext uri="{FF2B5EF4-FFF2-40B4-BE49-F238E27FC236}">
-                <a16:creationId xmlns:a16="http://schemas.microsoft.com/office/drawing/2014/main" id="{56F0EDBB-A267-4475-9334-7C6A04F43317}"/>
+                <a16:creationId xmlns:a16="http://schemas.microsoft.com/office/drawing/2014/main" id="{CE3BE94F-8A5C-4101-81B1-8DA6EA0D8BD4}"/>
               </a:ext>
             </a:extLst>
           </p:cNvPr>
@@ -11358,7 +11358,7 @@
           <p:cNvPr id="65" name="fail / unknown">
             <a:extLst xmlns:a="http://schemas.openxmlformats.org/drawingml/2006/main">
               <a:ext uri="{FF2B5EF4-FFF2-40B4-BE49-F238E27FC236}">
-                <a16:creationId xmlns:a16="http://schemas.microsoft.com/office/drawing/2014/main" id="{D56A0151-87EA-41AF-AE83-E3B980C3468A}"/>
+                <a16:creationId xmlns:a16="http://schemas.microsoft.com/office/drawing/2014/main" id="{B4AE5254-C67A-4C16-BA65-3324575064C5}"/>
               </a:ext>
             </a:extLst>
           </p:cNvPr>
@@ -11415,7 +11415,7 @@
           <p:cNvPr id="66" name="Editable boundary">
             <a:extLst xmlns:a="http://schemas.openxmlformats.org/drawingml/2006/main">
               <a:ext uri="{FF2B5EF4-FFF2-40B4-BE49-F238E27FC236}">
-                <a16:creationId xmlns:a16="http://schemas.microsoft.com/office/drawing/2014/main" id="{E87D9F24-C3DD-4E97-B693-EB3482D68ADB}"/>
+                <a16:creationId xmlns:a16="http://schemas.microsoft.com/office/drawing/2014/main" id="{EA2F7F10-FC30-4695-857E-492EF2D2889C}"/>
               </a:ext>
             </a:extLst>
           </p:cNvPr>
@@ -11433,7 +11433,7 @@
             <a:avLst/>
           </a:prstGeom>
           <a:solidFill xmlns:a="http://schemas.openxmlformats.org/drawingml/2006/main">
-            <a:srgbClr val="F7F7F7"/>
+            <a:srgbClr val="F8F8F8"/>
           </a:solidFill>
           <a:ln xmlns:a="http://schemas.openxmlformats.org/drawingml/2006/main" w="19050">
             <a:solidFill>
@@ -11448,7 +11448,7 @@
           <p:cNvPr id="67" name="Editable boundary">
             <a:extLst xmlns:a="http://schemas.openxmlformats.org/drawingml/2006/main">
               <a:ext uri="{FF2B5EF4-FFF2-40B4-BE49-F238E27FC236}">
-                <a16:creationId xmlns:a16="http://schemas.microsoft.com/office/drawing/2014/main" id="{B302A6C3-616C-41EC-A9D5-72DB9E63D13C}"/>
+                <a16:creationId xmlns:a16="http://schemas.microsoft.com/office/drawing/2014/main" id="{4CABDB87-D198-4D41-B980-0FD30E6E7DA4}"/>
               </a:ext>
             </a:extLst>
           </p:cNvPr>
@@ -11466,7 +11466,7 @@
             <a:avLst/>
           </a:prstGeom>
           <a:solidFill xmlns:a="http://schemas.openxmlformats.org/drawingml/2006/main">
-            <a:srgbClr val="F7F7F7"/>
+            <a:srgbClr val="F8F8F8"/>
           </a:solidFill>
           <a:ln xmlns:a="http://schemas.openxmlformats.org/drawingml/2006/main" w="19050">
             <a:solidFill>
@@ -11481,7 +11481,7 @@
           <p:cNvPr id="68" name="Apply Δ*">
             <a:extLst xmlns:a="http://schemas.openxmlformats.org/drawingml/2006/main">
               <a:ext uri="{FF2B5EF4-FFF2-40B4-BE49-F238E27FC236}">
-                <a16:creationId xmlns:a16="http://schemas.microsoft.com/office/drawing/2014/main" id="{ECC47E22-8479-48A5-B6BA-E77AB13667AF}"/>
+                <a16:creationId xmlns:a16="http://schemas.microsoft.com/office/drawing/2014/main" id="{B0EBAABE-FB9D-4C61-9E2C-CBDA58E91904}"/>
               </a:ext>
             </a:extLst>
           </p:cNvPr>
@@ -11538,7 +11538,7 @@
           <p:cNvPr id="69" name="Retain Sₜ">
             <a:extLst xmlns:a="http://schemas.openxmlformats.org/drawingml/2006/main">
               <a:ext uri="{FF2B5EF4-FFF2-40B4-BE49-F238E27FC236}">
-                <a16:creationId xmlns:a16="http://schemas.microsoft.com/office/drawing/2014/main" id="{8929A462-EE45-4E4E-8F1C-5384D7E64223}"/>
+                <a16:creationId xmlns:a16="http://schemas.microsoft.com/office/drawing/2014/main" id="{C0347FE4-77A1-4DEF-9737-9D516CC244BE}"/>
               </a:ext>
             </a:extLst>
           </p:cNvPr>
@@ -11595,7 +11595,7 @@
           <p:cNvPr id="70" name="Editable boundary">
             <a:extLst xmlns:a="http://schemas.openxmlformats.org/drawingml/2006/main">
               <a:ext uri="{FF2B5EF4-FFF2-40B4-BE49-F238E27FC236}">
-                <a16:creationId xmlns:a16="http://schemas.microsoft.com/office/drawing/2014/main" id="{F5B51800-C2DF-4309-B895-B0685FF546CA}"/>
+                <a16:creationId xmlns:a16="http://schemas.microsoft.com/office/drawing/2014/main" id="{532CF414-B7A6-4088-BC2A-8579DD2E375E}"/>
               </a:ext>
             </a:extLst>
           </p:cNvPr>
@@ -11613,7 +11613,7 @@
             <a:avLst/>
           </a:prstGeom>
           <a:solidFill xmlns:a="http://schemas.openxmlformats.org/drawingml/2006/main">
-            <a:srgbClr val="F7F7F7"/>
+            <a:srgbClr val="F8F8F8"/>
           </a:solidFill>
           <a:ln xmlns:a="http://schemas.openxmlformats.org/drawingml/2006/main" w="19050">
             <a:solidFill>
@@ -11628,7 +11628,7 @@
           <p:cNvPr id="71" name="On acceptance:">
             <a:extLst xmlns:a="http://schemas.openxmlformats.org/drawingml/2006/main">
               <a:ext uri="{FF2B5EF4-FFF2-40B4-BE49-F238E27FC236}">
-                <a16:creationId xmlns:a16="http://schemas.microsoft.com/office/drawing/2014/main" id="{070720BA-7024-4041-9761-22A26BD1B39B}"/>
+                <a16:creationId xmlns:a16="http://schemas.microsoft.com/office/drawing/2014/main" id="{E631219E-4F85-451E-BF88-0C03F32FB24A}"/>
               </a:ext>
             </a:extLst>
           </p:cNvPr>
@@ -11685,7 +11685,7 @@
           <p:cNvPr id="72" name="Sₜ₊₁ = Update(Sₜ, Δ*)">
             <a:extLst xmlns:a="http://schemas.openxmlformats.org/drawingml/2006/main">
               <a:ext uri="{FF2B5EF4-FFF2-40B4-BE49-F238E27FC236}">
-                <a16:creationId xmlns:a16="http://schemas.microsoft.com/office/drawing/2014/main" id="{76065F6F-61BF-4ACD-8685-D85EC1092FFE}"/>
+                <a16:creationId xmlns:a16="http://schemas.microsoft.com/office/drawing/2014/main" id="{DD08EE9C-AB43-4DBB-8C8C-171081CD6D46}"/>
               </a:ext>
             </a:extLst>
           </p:cNvPr>
@@ -11742,7 +11742,7 @@
           <p:cNvPr id="73" name="Δ*: checked change, including needed guardrail repairs">
             <a:extLst xmlns:a="http://schemas.openxmlformats.org/drawingml/2006/main">
               <a:ext uri="{FF2B5EF4-FFF2-40B4-BE49-F238E27FC236}">
-                <a16:creationId xmlns:a16="http://schemas.microsoft.com/office/drawing/2014/main" id="{DAB5C180-915D-4502-853E-64866B3B922D}"/>
+                <a16:creationId xmlns:a16="http://schemas.microsoft.com/office/drawing/2014/main" id="{90AB649C-3D27-428D-B776-5C7069248C77}"/>
               </a:ext>
             </a:extLst>
           </p:cNvPr>
@@ -11799,7 +11799,7 @@
           <p:cNvPr id="74" name="Editable flow path">
             <a:extLst xmlns:a="http://schemas.openxmlformats.org/drawingml/2006/main">
               <a:ext uri="{FF2B5EF4-FFF2-40B4-BE49-F238E27FC236}">
-                <a16:creationId xmlns:a16="http://schemas.microsoft.com/office/drawing/2014/main" id="{6A15C399-B537-4BDB-9F26-0A99101906D3}"/>
+                <a16:creationId xmlns:a16="http://schemas.microsoft.com/office/drawing/2014/main" id="{726C121F-C4B3-4EDE-BCC7-344AFB45600A}"/>
               </a:ext>
             </a:extLst>
           </p:cNvPr>
@@ -11848,7 +11848,7 @@
           <p:cNvPr id="75" name="Editable arrowhead">
             <a:extLst xmlns:a="http://schemas.openxmlformats.org/drawingml/2006/main">
               <a:ext uri="{FF2B5EF4-FFF2-40B4-BE49-F238E27FC236}">
-                <a16:creationId xmlns:a16="http://schemas.microsoft.com/office/drawing/2014/main" id="{1774A751-928E-4A84-B620-C746AFE61932}"/>
+                <a16:creationId xmlns:a16="http://schemas.microsoft.com/office/drawing/2014/main" id="{7308698E-5301-4C16-B06D-839229A16FA5}"/>
               </a:ext>
             </a:extLst>
           </p:cNvPr>
@@ -11891,7 +11891,7 @@
           <p:cNvPr id="76" name="Editable boundary">
             <a:extLst xmlns:a="http://schemas.openxmlformats.org/drawingml/2006/main">
               <a:ext uri="{FF2B5EF4-FFF2-40B4-BE49-F238E27FC236}">
-                <a16:creationId xmlns:a16="http://schemas.microsoft.com/office/drawing/2014/main" id="{D9C3E981-2DF1-4636-AB5E-ECC002552416}"/>
+                <a16:creationId xmlns:a16="http://schemas.microsoft.com/office/drawing/2014/main" id="{85E62C60-6449-4EFD-9DDF-E789584D67BC}"/>
               </a:ext>
             </a:extLst>
           </p:cNvPr>
@@ -11924,7 +11924,7 @@
           <p:cNvPr id="77" name="Revalidate at every update">
             <a:extLst xmlns:a="http://schemas.openxmlformats.org/drawingml/2006/main">
               <a:ext uri="{FF2B5EF4-FFF2-40B4-BE49-F238E27FC236}">
-                <a16:creationId xmlns:a16="http://schemas.microsoft.com/office/drawing/2014/main" id="{E87FE3E2-45BE-4D70-B27D-B00A7482CD7F}"/>
+                <a16:creationId xmlns:a16="http://schemas.microsoft.com/office/drawing/2014/main" id="{A89E1E4A-933E-4931-B996-6E02B0CC78D1}"/>
               </a:ext>
             </a:extLst>
           </p:cNvPr>
@@ -11981,7 +11981,7 @@
           <p:cNvPr id="78" name="Protection requirements stay fixed; guardrail implementations ma">
             <a:extLst xmlns:a="http://schemas.openxmlformats.org/drawingml/2006/main">
               <a:ext uri="{FF2B5EF4-FFF2-40B4-BE49-F238E27FC236}">
-                <a16:creationId xmlns:a16="http://schemas.microsoft.com/office/drawing/2014/main" id="{0FCC610E-5AAD-4CE0-978A-9236234D389A}"/>
+                <a16:creationId xmlns:a16="http://schemas.microsoft.com/office/drawing/2014/main" id="{3BB9C4EA-EA61-4108-AFD4-1308DD5AFB4A}"/>
               </a:ext>
             </a:extLst>
           </p:cNvPr>
@@ -12036,7 +12036,7 @@
     </p:spTree>
     <p:extLst>
       <p:ext uri="{BB962C8B-B14F-4D97-AF65-F5344CB8AC3E}">
-        <p14:creationId xmlns:p14="http://schemas.microsoft.com/office/powerpoint/2010/main" val="91042657"/>
+        <p14:creationId xmlns:p14="http://schemas.microsoft.com/office/powerpoint/2010/main" val="303363959"/>
       </p:ext>
     </p:extLst>
   </p:cSld>
@@ -12067,7 +12067,7 @@
           <p:cNvPr id="79" name="III. Authorization Across Delegated Workflows">
             <a:extLst xmlns:a="http://schemas.openxmlformats.org/drawingml/2006/main">
               <a:ext uri="{FF2B5EF4-FFF2-40B4-BE49-F238E27FC236}">
-                <a16:creationId xmlns:a16="http://schemas.microsoft.com/office/drawing/2014/main" id="{0C4735B5-C95B-4782-A687-A7D0D7EA01DD}"/>
+                <a16:creationId xmlns:a16="http://schemas.microsoft.com/office/drawing/2014/main" id="{6F262E94-1ECF-4906-841A-37EE352E6419}"/>
               </a:ext>
             </a:extLst>
           </p:cNvPr>
@@ -12124,7 +12124,7 @@
           <p:cNvPr id="2" name="A private report can leak through a delegated email draft.">
             <a:extLst xmlns:a="http://schemas.openxmlformats.org/drawingml/2006/main">
               <a:ext uri="{FF2B5EF4-FFF2-40B4-BE49-F238E27FC236}">
-                <a16:creationId xmlns:a16="http://schemas.microsoft.com/office/drawing/2014/main" id="{FB58DF01-A2E2-4BE0-9C41-952D8CE8319E}"/>
+                <a16:creationId xmlns:a16="http://schemas.microsoft.com/office/drawing/2014/main" id="{315DE7C8-DB53-4710-AB88-FB0797D4E250}"/>
               </a:ext>
             </a:extLst>
           </p:cNvPr>
@@ -12181,7 +12181,7 @@
           <p:cNvPr id="3" name="Editable boundary">
             <a:extLst xmlns:a="http://schemas.openxmlformats.org/drawingml/2006/main">
               <a:ext uri="{FF2B5EF4-FFF2-40B4-BE49-F238E27FC236}">
-                <a16:creationId xmlns:a16="http://schemas.microsoft.com/office/drawing/2014/main" id="{4B47C68C-7312-42FD-97CE-D3344330FE82}"/>
+                <a16:creationId xmlns:a16="http://schemas.microsoft.com/office/drawing/2014/main" id="{FDF80871-5E4D-4E42-91CB-9044121E4787}"/>
               </a:ext>
             </a:extLst>
           </p:cNvPr>
@@ -12214,7 +12214,7 @@
           <p:cNvPr id="4" name="Editable boundary">
             <a:extLst xmlns:a="http://schemas.openxmlformats.org/drawingml/2006/main">
               <a:ext uri="{FF2B5EF4-FFF2-40B4-BE49-F238E27FC236}">
-                <a16:creationId xmlns:a16="http://schemas.microsoft.com/office/drawing/2014/main" id="{82936CDD-FA30-462A-9927-AA4E290621A1}"/>
+                <a16:creationId xmlns:a16="http://schemas.microsoft.com/office/drawing/2014/main" id="{68BB0D91-5D79-445A-98C9-9D261E2C91C5}"/>
               </a:ext>
             </a:extLst>
           </p:cNvPr>
@@ -12247,7 +12247,7 @@
           <p:cNvPr id="5" name="Editable boundary">
             <a:extLst xmlns:a="http://schemas.openxmlformats.org/drawingml/2006/main">
               <a:ext uri="{FF2B5EF4-FFF2-40B4-BE49-F238E27FC236}">
-                <a16:creationId xmlns:a16="http://schemas.microsoft.com/office/drawing/2014/main" id="{B589B509-A5CB-44F6-908A-A0F6D8F817E7}"/>
+                <a16:creationId xmlns:a16="http://schemas.microsoft.com/office/drawing/2014/main" id="{44D7D46A-63C6-4C9F-923F-394B4A67B3F5}"/>
               </a:ext>
             </a:extLst>
           </p:cNvPr>
@@ -12280,7 +12280,7 @@
           <p:cNvPr id="6" name="Editable boundary">
             <a:extLst xmlns:a="http://schemas.openxmlformats.org/drawingml/2006/main">
               <a:ext uri="{FF2B5EF4-FFF2-40B4-BE49-F238E27FC236}">
-                <a16:creationId xmlns:a16="http://schemas.microsoft.com/office/drawing/2014/main" id="{FE3DB305-28FC-426F-ACEE-F97488E9B747}"/>
+                <a16:creationId xmlns:a16="http://schemas.microsoft.com/office/drawing/2014/main" id="{819B8ED8-9642-4E1E-9AA3-66C4550D7624}"/>
               </a:ext>
             </a:extLst>
           </p:cNvPr>
@@ -12313,7 +12313,7 @@
           <p:cNvPr id="7" name="1">
             <a:extLst xmlns:a="http://schemas.openxmlformats.org/drawingml/2006/main">
               <a:ext uri="{FF2B5EF4-FFF2-40B4-BE49-F238E27FC236}">
-                <a16:creationId xmlns:a16="http://schemas.microsoft.com/office/drawing/2014/main" id="{6B967FDD-AAB8-49C2-A956-15C00C5230CF}"/>
+                <a16:creationId xmlns:a16="http://schemas.microsoft.com/office/drawing/2014/main" id="{A3A24E3A-1AB6-4F6C-A580-BCAE0CD24F6C}"/>
               </a:ext>
             </a:extLst>
           </p:cNvPr>
@@ -12370,7 +12370,7 @@
           <p:cNvPr id="8" name="A concrete handoff">
             <a:extLst xmlns:a="http://schemas.openxmlformats.org/drawingml/2006/main">
               <a:ext uri="{FF2B5EF4-FFF2-40B4-BE49-F238E27FC236}">
-                <a16:creationId xmlns:a16="http://schemas.microsoft.com/office/drawing/2014/main" id="{0F477F9A-F090-4B21-B9DC-500533040FA8}"/>
+                <a16:creationId xmlns:a16="http://schemas.microsoft.com/office/drawing/2014/main" id="{1367AF21-7414-4134-A519-CA5B9D4127AF}"/>
               </a:ext>
             </a:extLst>
           </p:cNvPr>
@@ -12427,7 +12427,7 @@
           <p:cNvPr id="9" name="Editable boundary">
             <a:extLst xmlns:a="http://schemas.openxmlformats.org/drawingml/2006/main">
               <a:ext uri="{FF2B5EF4-FFF2-40B4-BE49-F238E27FC236}">
-                <a16:creationId xmlns:a16="http://schemas.microsoft.com/office/drawing/2014/main" id="{F669CA2C-2214-4945-B8ED-D48AFE67494D}"/>
+                <a16:creationId xmlns:a16="http://schemas.microsoft.com/office/drawing/2014/main" id="{4C2FC083-A8FD-42E9-9698-42CD4780E3D5}"/>
               </a:ext>
             </a:extLst>
           </p:cNvPr>
@@ -12460,7 +12460,7 @@
           <p:cNvPr id="10" name="2">
             <a:extLst xmlns:a="http://schemas.openxmlformats.org/drawingml/2006/main">
               <a:ext uri="{FF2B5EF4-FFF2-40B4-BE49-F238E27FC236}">
-                <a16:creationId xmlns:a16="http://schemas.microsoft.com/office/drawing/2014/main" id="{6CA00C42-6B77-4BCF-A936-6D3E6F073E22}"/>
+                <a16:creationId xmlns:a16="http://schemas.microsoft.com/office/drawing/2014/main" id="{22CA6685-DA0C-4A94-B358-BDD9F649AD2A}"/>
               </a:ext>
             </a:extLst>
           </p:cNvPr>
@@ -12517,7 +12517,7 @@
           <p:cNvPr id="11" name="Track workflow context">
             <a:extLst xmlns:a="http://schemas.openxmlformats.org/drawingml/2006/main">
               <a:ext uri="{FF2B5EF4-FFF2-40B4-BE49-F238E27FC236}">
-                <a16:creationId xmlns:a16="http://schemas.microsoft.com/office/drawing/2014/main" id="{7C7CE151-6B61-46EE-A13C-064F996EA582}"/>
+                <a16:creationId xmlns:a16="http://schemas.microsoft.com/office/drawing/2014/main" id="{2AC06DD3-933E-487A-8EBF-AFBB544BA356}"/>
               </a:ext>
             </a:extLst>
           </p:cNvPr>
@@ -12574,7 +12574,7 @@
           <p:cNvPr id="12" name="Editable boundary">
             <a:extLst xmlns:a="http://schemas.openxmlformats.org/drawingml/2006/main">
               <a:ext uri="{FF2B5EF4-FFF2-40B4-BE49-F238E27FC236}">
-                <a16:creationId xmlns:a16="http://schemas.microsoft.com/office/drawing/2014/main" id="{4265D084-8B53-4A7E-B00D-205AE9D0B1BF}"/>
+                <a16:creationId xmlns:a16="http://schemas.microsoft.com/office/drawing/2014/main" id="{630A0500-36F4-4557-A43D-1C4CFE94CB55}"/>
               </a:ext>
             </a:extLst>
           </p:cNvPr>
@@ -12607,7 +12607,7 @@
           <p:cNvPr id="13" name="3">
             <a:extLst xmlns:a="http://schemas.openxmlformats.org/drawingml/2006/main">
               <a:ext uri="{FF2B5EF4-FFF2-40B4-BE49-F238E27FC236}">
-                <a16:creationId xmlns:a16="http://schemas.microsoft.com/office/drawing/2014/main" id="{557447D2-F483-4176-B710-AD038AA65D29}"/>
+                <a16:creationId xmlns:a16="http://schemas.microsoft.com/office/drawing/2014/main" id="{F354A345-83E1-403E-859B-CFF3AD180382}"/>
               </a:ext>
             </a:extLst>
           </p:cNvPr>
@@ -12664,7 +12664,7 @@
           <p:cNvPr id="14" name="Enforce and recover">
             <a:extLst xmlns:a="http://schemas.openxmlformats.org/drawingml/2006/main">
               <a:ext uri="{FF2B5EF4-FFF2-40B4-BE49-F238E27FC236}">
-                <a16:creationId xmlns:a16="http://schemas.microsoft.com/office/drawing/2014/main" id="{AC847650-C135-4D0B-9122-229845264DC7}"/>
+                <a16:creationId xmlns:a16="http://schemas.microsoft.com/office/drawing/2014/main" id="{9431E51D-9A92-453D-BD13-D23ADD1C744A}"/>
               </a:ext>
             </a:extLst>
           </p:cNvPr>
@@ -12721,7 +12721,7 @@
           <p:cNvPr id="15" name="Editable boundary">
             <a:extLst xmlns:a="http://schemas.openxmlformats.org/drawingml/2006/main">
               <a:ext uri="{FF2B5EF4-FFF2-40B4-BE49-F238E27FC236}">
-                <a16:creationId xmlns:a16="http://schemas.microsoft.com/office/drawing/2014/main" id="{EF66E149-0887-4D45-8C13-0EA20DF57DAE}"/>
+                <a16:creationId xmlns:a16="http://schemas.microsoft.com/office/drawing/2014/main" id="{85264E2C-F86F-47A7-BB80-5F93F7CC4ECC}"/>
               </a:ext>
             </a:extLst>
           </p:cNvPr>
@@ -12754,7 +12754,7 @@
           <p:cNvPr id="16" name="Approved task">
             <a:extLst xmlns:a="http://schemas.openxmlformats.org/drawingml/2006/main">
               <a:ext uri="{FF2B5EF4-FFF2-40B4-BE49-F238E27FC236}">
-                <a16:creationId xmlns:a16="http://schemas.microsoft.com/office/drawing/2014/main" id="{9AF7A242-547D-47E3-916D-A92DD5C339BD}"/>
+                <a16:creationId xmlns:a16="http://schemas.microsoft.com/office/drawing/2014/main" id="{9042AD81-466D-4417-92C1-C803E3876716}"/>
               </a:ext>
             </a:extLst>
           </p:cNvPr>
@@ -12811,7 +12811,7 @@
           <p:cNvPr id="17" name="Send a sanitized vendor update">
             <a:extLst xmlns:a="http://schemas.openxmlformats.org/drawingml/2006/main">
               <a:ext uri="{FF2B5EF4-FFF2-40B4-BE49-F238E27FC236}">
-                <a16:creationId xmlns:a16="http://schemas.microsoft.com/office/drawing/2014/main" id="{4B3380A1-C8F0-4F3D-AA84-F0E2348F29D5}"/>
+                <a16:creationId xmlns:a16="http://schemas.microsoft.com/office/drawing/2014/main" id="{87EC80B6-1D08-4C29-8206-8396A204761F}"/>
               </a:ext>
             </a:extLst>
           </p:cNvPr>
@@ -12868,7 +12868,7 @@
           <p:cNvPr id="18" name="Keep customer IDs internal">
             <a:extLst xmlns:a="http://schemas.openxmlformats.org/drawingml/2006/main">
               <a:ext uri="{FF2B5EF4-FFF2-40B4-BE49-F238E27FC236}">
-                <a16:creationId xmlns:a16="http://schemas.microsoft.com/office/drawing/2014/main" id="{854FBC62-8B6E-4CAD-BE83-09F464F2E82F}"/>
+                <a16:creationId xmlns:a16="http://schemas.microsoft.com/office/drawing/2014/main" id="{FE8D0DFE-4FD2-4AE1-B9B1-EDDA2E0CEC7E}"/>
               </a:ext>
             </a:extLst>
           </p:cNvPr>
@@ -12925,7 +12925,7 @@
           <p:cNvPr id="19" name="Editable flow path">
             <a:extLst xmlns:a="http://schemas.openxmlformats.org/drawingml/2006/main">
               <a:ext uri="{FF2B5EF4-FFF2-40B4-BE49-F238E27FC236}">
-                <a16:creationId xmlns:a16="http://schemas.microsoft.com/office/drawing/2014/main" id="{967B18AC-7357-4170-B84A-F72EEE46A5E2}"/>
+                <a16:creationId xmlns:a16="http://schemas.microsoft.com/office/drawing/2014/main" id="{9A005351-8011-4436-92CF-2CA70E942E90}"/>
               </a:ext>
             </a:extLst>
           </p:cNvPr>
@@ -12965,7 +12965,7 @@
           <p:cNvPr id="20" name="Editable arrowhead">
             <a:extLst xmlns:a="http://schemas.openxmlformats.org/drawingml/2006/main">
               <a:ext uri="{FF2B5EF4-FFF2-40B4-BE49-F238E27FC236}">
-                <a16:creationId xmlns:a16="http://schemas.microsoft.com/office/drawing/2014/main" id="{941460B7-18E6-430D-A6B5-60EE06AD3725}"/>
+                <a16:creationId xmlns:a16="http://schemas.microsoft.com/office/drawing/2014/main" id="{398AF6A0-6852-4118-9A9F-11509DA62108}"/>
               </a:ext>
             </a:extLst>
           </p:cNvPr>
@@ -13008,7 +13008,7 @@
           <p:cNvPr id="21" name="delegated scope">
             <a:extLst xmlns:a="http://schemas.openxmlformats.org/drawingml/2006/main">
               <a:ext uri="{FF2B5EF4-FFF2-40B4-BE49-F238E27FC236}">
-                <a16:creationId xmlns:a16="http://schemas.microsoft.com/office/drawing/2014/main" id="{3F651E23-7B7E-4B75-819E-227F28120FA8}"/>
+                <a16:creationId xmlns:a16="http://schemas.microsoft.com/office/drawing/2014/main" id="{C2B3C9D6-3E3F-4EB0-A070-03DA96BADF23}"/>
               </a:ext>
             </a:extLst>
           </p:cNvPr>
@@ -13065,7 +13065,7 @@
           <p:cNvPr id="22" name="Editable boundary">
             <a:extLst xmlns:a="http://schemas.openxmlformats.org/drawingml/2006/main">
               <a:ext uri="{FF2B5EF4-FFF2-40B4-BE49-F238E27FC236}">
-                <a16:creationId xmlns:a16="http://schemas.microsoft.com/office/drawing/2014/main" id="{3E48EC6F-0E8E-4B22-B4DF-080B1721BCDE}"/>
+                <a16:creationId xmlns:a16="http://schemas.microsoft.com/office/drawing/2014/main" id="{00ADCF38-B2A6-49E3-9732-CB545E660FCA}"/>
               </a:ext>
             </a:extLst>
           </p:cNvPr>
@@ -13098,7 +13098,7 @@
           <p:cNvPr id="23" name="Agent A: incident analyst">
             <a:extLst xmlns:a="http://schemas.openxmlformats.org/drawingml/2006/main">
               <a:ext uri="{FF2B5EF4-FFF2-40B4-BE49-F238E27FC236}">
-                <a16:creationId xmlns:a16="http://schemas.microsoft.com/office/drawing/2014/main" id="{08911C7E-2C84-4DB5-86FC-BE5F05299513}"/>
+                <a16:creationId xmlns:a16="http://schemas.microsoft.com/office/drawing/2014/main" id="{589F311F-C5A8-4EE3-B023-2927ADB38B78}"/>
               </a:ext>
             </a:extLst>
           </p:cNvPr>
@@ -13155,7 +13155,7 @@
           <p:cNvPr id="24" name="Reads private incident report">
             <a:extLst xmlns:a="http://schemas.openxmlformats.org/drawingml/2006/main">
               <a:ext uri="{FF2B5EF4-FFF2-40B4-BE49-F238E27FC236}">
-                <a16:creationId xmlns:a16="http://schemas.microsoft.com/office/drawing/2014/main" id="{854975D1-DAC0-42BD-A216-79A4BBECEAB2}"/>
+                <a16:creationId xmlns:a16="http://schemas.microsoft.com/office/drawing/2014/main" id="{FD605563-A886-431B-9612-D6B1BC8D7B8B}"/>
               </a:ext>
             </a:extLst>
           </p:cNvPr>
@@ -13212,7 +13212,7 @@
           <p:cNvPr id="25" name="Drafts the vendor update">
             <a:extLst xmlns:a="http://schemas.openxmlformats.org/drawingml/2006/main">
               <a:ext uri="{FF2B5EF4-FFF2-40B4-BE49-F238E27FC236}">
-                <a16:creationId xmlns:a16="http://schemas.microsoft.com/office/drawing/2014/main" id="{1BC76936-634C-46C6-8640-126BCC2E9C22}"/>
+                <a16:creationId xmlns:a16="http://schemas.microsoft.com/office/drawing/2014/main" id="{6AD6F9C7-0257-4BA9-9744-001F2660A040}"/>
               </a:ext>
             </a:extLst>
           </p:cNvPr>
@@ -13269,7 +13269,7 @@
           <p:cNvPr id="26" name="Editable flow path">
             <a:extLst xmlns:a="http://schemas.openxmlformats.org/drawingml/2006/main">
               <a:ext uri="{FF2B5EF4-FFF2-40B4-BE49-F238E27FC236}">
-                <a16:creationId xmlns:a16="http://schemas.microsoft.com/office/drawing/2014/main" id="{FDEB3D6F-AE51-4003-AB0D-D1F3F1C4212F}"/>
+                <a16:creationId xmlns:a16="http://schemas.microsoft.com/office/drawing/2014/main" id="{BAF9A3F4-2917-45D6-B575-E86063DA1CBB}"/>
               </a:ext>
             </a:extLst>
           </p:cNvPr>
@@ -13309,7 +13309,7 @@
           <p:cNvPr id="27" name="Editable arrowhead">
             <a:extLst xmlns:a="http://schemas.openxmlformats.org/drawingml/2006/main">
               <a:ext uri="{FF2B5EF4-FFF2-40B4-BE49-F238E27FC236}">
-                <a16:creationId xmlns:a16="http://schemas.microsoft.com/office/drawing/2014/main" id="{456EBC73-C674-4F33-91C9-E5FBB6B30C2E}"/>
+                <a16:creationId xmlns:a16="http://schemas.microsoft.com/office/drawing/2014/main" id="{D92A3DC3-6EE4-4B31-93B4-18C03C8DC17C}"/>
               </a:ext>
             </a:extLst>
           </p:cNvPr>
@@ -13352,7 +13352,7 @@
           <p:cNvPr id="28" name="Editable boundary">
             <a:extLst xmlns:a="http://schemas.openxmlformats.org/drawingml/2006/main">
               <a:ext uri="{FF2B5EF4-FFF2-40B4-BE49-F238E27FC236}">
-                <a16:creationId xmlns:a16="http://schemas.microsoft.com/office/drawing/2014/main" id="{550130CC-2CB7-4C4E-A375-44F6D5C0C6C5}"/>
+                <a16:creationId xmlns:a16="http://schemas.microsoft.com/office/drawing/2014/main" id="{860C986B-0F0E-40E8-AFCF-4473FBD17FC4}"/>
               </a:ext>
             </a:extLst>
           </p:cNvPr>
@@ -13385,7 +13385,7 @@
           <p:cNvPr id="29" name="Handoff package">
             <a:extLst xmlns:a="http://schemas.openxmlformats.org/drawingml/2006/main">
               <a:ext uri="{FF2B5EF4-FFF2-40B4-BE49-F238E27FC236}">
-                <a16:creationId xmlns:a16="http://schemas.microsoft.com/office/drawing/2014/main" id="{641BC473-7ABF-4458-98E9-4FE0B69F7DF1}"/>
+                <a16:creationId xmlns:a16="http://schemas.microsoft.com/office/drawing/2014/main" id="{7182E373-8802-46B2-AAFF-2126FDDB1B48}"/>
               </a:ext>
             </a:extLst>
           </p:cNvPr>
@@ -13442,7 +13442,7 @@
           <p:cNvPr id="30" name="Task: send the vendor update">
             <a:extLst xmlns:a="http://schemas.openxmlformats.org/drawingml/2006/main">
               <a:ext uri="{FF2B5EF4-FFF2-40B4-BE49-F238E27FC236}">
-                <a16:creationId xmlns:a16="http://schemas.microsoft.com/office/drawing/2014/main" id="{E2A4E0D5-41A2-4BA2-8391-AEFA22C75C34}"/>
+                <a16:creationId xmlns:a16="http://schemas.microsoft.com/office/drawing/2014/main" id="{ABA315E5-693C-4B5C-9219-3E9D494590E3}"/>
               </a:ext>
             </a:extLst>
           </p:cNvPr>
@@ -13499,7 +13499,7 @@
           <p:cNvPr id="31" name="Payload: draft containing customer IDs">
             <a:extLst xmlns:a="http://schemas.openxmlformats.org/drawingml/2006/main">
               <a:ext uri="{FF2B5EF4-FFF2-40B4-BE49-F238E27FC236}">
-                <a16:creationId xmlns:a16="http://schemas.microsoft.com/office/drawing/2014/main" id="{6933BDD8-EAA4-488C-A735-4864C58130CF}"/>
+                <a16:creationId xmlns:a16="http://schemas.microsoft.com/office/drawing/2014/main" id="{210BCD04-FB70-4606-811F-906F10BCAFC9}"/>
               </a:ext>
             </a:extLst>
           </p:cNvPr>
@@ -13556,7 +13556,7 @@
           <p:cNvPr id="32" name="Editable flow path">
             <a:extLst xmlns:a="http://schemas.openxmlformats.org/drawingml/2006/main">
               <a:ext uri="{FF2B5EF4-FFF2-40B4-BE49-F238E27FC236}">
-                <a16:creationId xmlns:a16="http://schemas.microsoft.com/office/drawing/2014/main" id="{A1E449A9-7412-40E4-965A-9A1EE275B9B1}"/>
+                <a16:creationId xmlns:a16="http://schemas.microsoft.com/office/drawing/2014/main" id="{5A48C9B0-7A6C-4423-BA99-9614BF7213DC}"/>
               </a:ext>
             </a:extLst>
           </p:cNvPr>
@@ -13596,7 +13596,7 @@
           <p:cNvPr id="33" name="Editable arrowhead">
             <a:extLst xmlns:a="http://schemas.openxmlformats.org/drawingml/2006/main">
               <a:ext uri="{FF2B5EF4-FFF2-40B4-BE49-F238E27FC236}">
-                <a16:creationId xmlns:a16="http://schemas.microsoft.com/office/drawing/2014/main" id="{3727C483-A7C9-4536-954E-594301E94AED}"/>
+                <a16:creationId xmlns:a16="http://schemas.microsoft.com/office/drawing/2014/main" id="{6A57C6BB-5477-4C09-AAC3-E4D319C7B9E3}"/>
               </a:ext>
             </a:extLst>
           </p:cNvPr>
@@ -13639,7 +13639,7 @@
           <p:cNvPr id="34" name="task + data">
             <a:extLst xmlns:a="http://schemas.openxmlformats.org/drawingml/2006/main">
               <a:ext uri="{FF2B5EF4-FFF2-40B4-BE49-F238E27FC236}">
-                <a16:creationId xmlns:a16="http://schemas.microsoft.com/office/drawing/2014/main" id="{CECE1D9F-F76D-40A3-9264-77D5A93A1616}"/>
+                <a16:creationId xmlns:a16="http://schemas.microsoft.com/office/drawing/2014/main" id="{DFB16F98-5854-401E-88C8-1A761A0331F0}"/>
               </a:ext>
             </a:extLst>
           </p:cNvPr>
@@ -13696,7 +13696,7 @@
           <p:cNvPr id="35" name="Editable boundary">
             <a:extLst xmlns:a="http://schemas.openxmlformats.org/drawingml/2006/main">
               <a:ext uri="{FF2B5EF4-FFF2-40B4-BE49-F238E27FC236}">
-                <a16:creationId xmlns:a16="http://schemas.microsoft.com/office/drawing/2014/main" id="{3D60A484-FE6E-4D00-AC4D-8BA919DBDE12}"/>
+                <a16:creationId xmlns:a16="http://schemas.microsoft.com/office/drawing/2014/main" id="{5958507B-0399-42B6-BB10-8F52A85CA578}"/>
               </a:ext>
             </a:extLst>
           </p:cNvPr>
@@ -13729,7 +13729,7 @@
           <p:cNvPr id="36" name="Agent B: vendor liaison">
             <a:extLst xmlns:a="http://schemas.openxmlformats.org/drawingml/2006/main">
               <a:ext uri="{FF2B5EF4-FFF2-40B4-BE49-F238E27FC236}">
-                <a16:creationId xmlns:a16="http://schemas.microsoft.com/office/drawing/2014/main" id="{502A2E58-9984-4756-9356-21229906733E}"/>
+                <a16:creationId xmlns:a16="http://schemas.microsoft.com/office/drawing/2014/main" id="{6D206B08-AD4E-458C-A067-C04BB8B10AA3}"/>
               </a:ext>
             </a:extLst>
           </p:cNvPr>
@@ -13786,7 +13786,7 @@
           <p:cNvPr id="37" name="Can email the external vendor">
             <a:extLst xmlns:a="http://schemas.openxmlformats.org/drawingml/2006/main">
               <a:ext uri="{FF2B5EF4-FFF2-40B4-BE49-F238E27FC236}">
-                <a16:creationId xmlns:a16="http://schemas.microsoft.com/office/drawing/2014/main" id="{0FC9A0C9-7418-45C8-95BA-CB07C7728EFF}"/>
+                <a16:creationId xmlns:a16="http://schemas.microsoft.com/office/drawing/2014/main" id="{D738894F-0090-4560-8907-E95159FCA51B}"/>
               </a:ext>
             </a:extLst>
           </p:cNvPr>
@@ -13843,7 +13843,7 @@
           <p:cNvPr id="38" name="Uses A’s draft as message content">
             <a:extLst xmlns:a="http://schemas.openxmlformats.org/drawingml/2006/main">
               <a:ext uri="{FF2B5EF4-FFF2-40B4-BE49-F238E27FC236}">
-                <a16:creationId xmlns:a16="http://schemas.microsoft.com/office/drawing/2014/main" id="{C3184E34-15BA-4D2F-8402-43CA461502EC}"/>
+                <a16:creationId xmlns:a16="http://schemas.microsoft.com/office/drawing/2014/main" id="{F2ABEAEE-2A3A-4147-8353-F5AC9E9A2AC2}"/>
               </a:ext>
             </a:extLst>
           </p:cNvPr>
@@ -13900,7 +13900,7 @@
           <p:cNvPr id="39" name="Read access + email access">
             <a:extLst xmlns:a="http://schemas.openxmlformats.org/drawingml/2006/main">
               <a:ext uri="{FF2B5EF4-FFF2-40B4-BE49-F238E27FC236}">
-                <a16:creationId xmlns:a16="http://schemas.microsoft.com/office/drawing/2014/main" id="{5E780CBB-83A9-4166-9380-2360E99B133F}"/>
+                <a16:creationId xmlns:a16="http://schemas.microsoft.com/office/drawing/2014/main" id="{1BDBAA37-AFD8-4D82-BA0E-B5348191BA2B}"/>
               </a:ext>
             </a:extLst>
           </p:cNvPr>
@@ -13957,7 +13957,7 @@
           <p:cNvPr id="40" name="do not authorize disclosure.">
             <a:extLst xmlns:a="http://schemas.openxmlformats.org/drawingml/2006/main">
               <a:ext uri="{FF2B5EF4-FFF2-40B4-BE49-F238E27FC236}">
-                <a16:creationId xmlns:a16="http://schemas.microsoft.com/office/drawing/2014/main" id="{C26E1719-D539-471D-8E28-428DC91A2B0D}"/>
+                <a16:creationId xmlns:a16="http://schemas.microsoft.com/office/drawing/2014/main" id="{1D8A143B-7F83-4E3E-9286-0E3347C23473}"/>
               </a:ext>
             </a:extLst>
           </p:cNvPr>
@@ -14014,7 +14014,7 @@
           <p:cNvPr id="41" name="authority +">
             <a:extLst xmlns:a="http://schemas.openxmlformats.org/drawingml/2006/main">
               <a:ext uri="{FF2B5EF4-FFF2-40B4-BE49-F238E27FC236}">
-                <a16:creationId xmlns:a16="http://schemas.microsoft.com/office/drawing/2014/main" id="{3F7D3473-EC49-461D-988E-5052ADAA360A}"/>
+                <a16:creationId xmlns:a16="http://schemas.microsoft.com/office/drawing/2014/main" id="{42FCADCB-E210-4B33-9AC5-748D3F14616F}"/>
               </a:ext>
             </a:extLst>
           </p:cNvPr>
@@ -14071,7 +14071,7 @@
           <p:cNvPr id="42" name="data lineage">
             <a:extLst xmlns:a="http://schemas.openxmlformats.org/drawingml/2006/main">
               <a:ext uri="{FF2B5EF4-FFF2-40B4-BE49-F238E27FC236}">
-                <a16:creationId xmlns:a16="http://schemas.microsoft.com/office/drawing/2014/main" id="{2B3184E1-9F49-4EAE-B0E3-8056B7190F8A}"/>
+                <a16:creationId xmlns:a16="http://schemas.microsoft.com/office/drawing/2014/main" id="{9C354763-A716-4005-A5E3-9801CDBDD302}"/>
               </a:ext>
             </a:extLst>
           </p:cNvPr>
@@ -14128,7 +14128,7 @@
           <p:cNvPr id="43" name="Editable flow path">
             <a:extLst xmlns:a="http://schemas.openxmlformats.org/drawingml/2006/main">
               <a:ext uri="{FF2B5EF4-FFF2-40B4-BE49-F238E27FC236}">
-                <a16:creationId xmlns:a16="http://schemas.microsoft.com/office/drawing/2014/main" id="{8B29A52C-6DC8-47CC-A5ED-7E38D8841491}"/>
+                <a16:creationId xmlns:a16="http://schemas.microsoft.com/office/drawing/2014/main" id="{26857139-6EE6-4A58-8660-51BE2858241F}"/>
               </a:ext>
             </a:extLst>
           </p:cNvPr>
@@ -14168,7 +14168,7 @@
           <p:cNvPr id="44" name="Editable arrowhead">
             <a:extLst xmlns:a="http://schemas.openxmlformats.org/drawingml/2006/main">
               <a:ext uri="{FF2B5EF4-FFF2-40B4-BE49-F238E27FC236}">
-                <a16:creationId xmlns:a16="http://schemas.microsoft.com/office/drawing/2014/main" id="{EE81C290-D12F-45A1-A15A-51DE298B5AF7}"/>
+                <a16:creationId xmlns:a16="http://schemas.microsoft.com/office/drawing/2014/main" id="{4CE7314E-3DC8-48D1-8E46-1EA8834B0692}"/>
               </a:ext>
             </a:extLst>
           </p:cNvPr>
@@ -14211,7 +14211,7 @@
           <p:cNvPr id="45" name="Editable boundary">
             <a:extLst xmlns:a="http://schemas.openxmlformats.org/drawingml/2006/main">
               <a:ext uri="{FF2B5EF4-FFF2-40B4-BE49-F238E27FC236}">
-                <a16:creationId xmlns:a16="http://schemas.microsoft.com/office/drawing/2014/main" id="{15A9897A-67B0-4062-A61A-5E632B330F29}"/>
+                <a16:creationId xmlns:a16="http://schemas.microsoft.com/office/drawing/2014/main" id="{73A787DC-DFAE-4D48-9E7E-CCB33690398C}"/>
               </a:ext>
             </a:extLst>
           </p:cNvPr>
@@ -14244,7 +14244,7 @@
           <p:cNvPr id="46" name="ScopeOK">
             <a:extLst xmlns:a="http://schemas.openxmlformats.org/drawingml/2006/main">
               <a:ext uri="{FF2B5EF4-FFF2-40B4-BE49-F238E27FC236}">
-                <a16:creationId xmlns:a16="http://schemas.microsoft.com/office/drawing/2014/main" id="{BDBCF0E6-AD41-4C3C-BE96-8248D8614C1F}"/>
+                <a16:creationId xmlns:a16="http://schemas.microsoft.com/office/drawing/2014/main" id="{3E4828E9-8F6A-4C3E-845A-B276F8AD094D}"/>
               </a:ext>
             </a:extLst>
           </p:cNvPr>
@@ -14301,7 +14301,7 @@
           <p:cNvPr id="47" name="Within delegated authority">
             <a:extLst xmlns:a="http://schemas.openxmlformats.org/drawingml/2006/main">
               <a:ext uri="{FF2B5EF4-FFF2-40B4-BE49-F238E27FC236}">
-                <a16:creationId xmlns:a16="http://schemas.microsoft.com/office/drawing/2014/main" id="{715AFD2A-1CDC-493E-B6F6-F187CDC0718C}"/>
+                <a16:creationId xmlns:a16="http://schemas.microsoft.com/office/drawing/2014/main" id="{5FEE6231-D459-4C9B-8D01-1EA8021284E4}"/>
               </a:ext>
             </a:extLst>
           </p:cNvPr>
@@ -14358,7 +14358,7 @@
           <p:cNvPr id="48" name="Editable boundary">
             <a:extLst xmlns:a="http://schemas.openxmlformats.org/drawingml/2006/main">
               <a:ext uri="{FF2B5EF4-FFF2-40B4-BE49-F238E27FC236}">
-                <a16:creationId xmlns:a16="http://schemas.microsoft.com/office/drawing/2014/main" id="{284C4C5E-DB33-43A6-9A90-86358E8AE494}"/>
+                <a16:creationId xmlns:a16="http://schemas.microsoft.com/office/drawing/2014/main" id="{57089C0B-B961-4F32-94AD-DB60B3A67363}"/>
               </a:ext>
             </a:extLst>
           </p:cNvPr>
@@ -14391,7 +14391,7 @@
           <p:cNvPr id="49" name="FlowOK">
             <a:extLst xmlns:a="http://schemas.openxmlformats.org/drawingml/2006/main">
               <a:ext uri="{FF2B5EF4-FFF2-40B4-BE49-F238E27FC236}">
-                <a16:creationId xmlns:a16="http://schemas.microsoft.com/office/drawing/2014/main" id="{41538C13-20DD-4066-92A7-A233BCC6C228}"/>
+                <a16:creationId xmlns:a16="http://schemas.microsoft.com/office/drawing/2014/main" id="{76CCF0FC-153B-459C-9415-1E2D1F85729E}"/>
               </a:ext>
             </a:extLst>
           </p:cNvPr>
@@ -14448,7 +14448,7 @@
           <p:cNvPr id="50" name="Preserves inherited data restrictions">
             <a:extLst xmlns:a="http://schemas.openxmlformats.org/drawingml/2006/main">
               <a:ext uri="{FF2B5EF4-FFF2-40B4-BE49-F238E27FC236}">
-                <a16:creationId xmlns:a16="http://schemas.microsoft.com/office/drawing/2014/main" id="{550EFB6B-C2AE-41A5-8F53-B21A32C77233}"/>
+                <a16:creationId xmlns:a16="http://schemas.microsoft.com/office/drawing/2014/main" id="{A83B359A-EB13-4086-92ED-03FFD25B006F}"/>
               </a:ext>
             </a:extLst>
           </p:cNvPr>
@@ -14505,7 +14505,7 @@
           <p:cNvPr id="51" name="Editable boundary">
             <a:extLst xmlns:a="http://schemas.openxmlformats.org/drawingml/2006/main">
               <a:ext uri="{FF2B5EF4-FFF2-40B4-BE49-F238E27FC236}">
-                <a16:creationId xmlns:a16="http://schemas.microsoft.com/office/drawing/2014/main" id="{E8C9D84E-54DE-4031-8B25-FD47D4D223E9}"/>
+                <a16:creationId xmlns:a16="http://schemas.microsoft.com/office/drawing/2014/main" id="{D2AF6FEB-882D-444B-9FF6-9D11C8203AD3}"/>
               </a:ext>
             </a:extLst>
           </p:cNvPr>
@@ -14538,7 +14538,7 @@
           <p:cNvPr id="52" name="FreshOK">
             <a:extLst xmlns:a="http://schemas.openxmlformats.org/drawingml/2006/main">
               <a:ext uri="{FF2B5EF4-FFF2-40B4-BE49-F238E27FC236}">
-                <a16:creationId xmlns:a16="http://schemas.microsoft.com/office/drawing/2014/main" id="{95BA7AD7-3116-4774-A399-2859E850F9FB}"/>
+                <a16:creationId xmlns:a16="http://schemas.microsoft.com/office/drawing/2014/main" id="{50D5F24F-569D-4701-9060-5330320C8AFC}"/>
               </a:ext>
             </a:extLst>
           </p:cNvPr>
@@ -14595,7 +14595,7 @@
           <p:cNvPr id="53" name="Approval dependencies remain valid">
             <a:extLst xmlns:a="http://schemas.openxmlformats.org/drawingml/2006/main">
               <a:ext uri="{FF2B5EF4-FFF2-40B4-BE49-F238E27FC236}">
-                <a16:creationId xmlns:a16="http://schemas.microsoft.com/office/drawing/2014/main" id="{AE7E4D8F-565B-4046-999D-F26B2BA4DC54}"/>
+                <a16:creationId xmlns:a16="http://schemas.microsoft.com/office/drawing/2014/main" id="{FA670D17-3C5E-456C-A9D8-288CC41CC9DB}"/>
               </a:ext>
             </a:extLst>
           </p:cNvPr>
@@ -14652,7 +14652,7 @@
           <p:cNvPr id="54" name="Revocation or changed context">
             <a:extLst xmlns:a="http://schemas.openxmlformats.org/drawingml/2006/main">
               <a:ext uri="{FF2B5EF4-FFF2-40B4-BE49-F238E27FC236}">
-                <a16:creationId xmlns:a16="http://schemas.microsoft.com/office/drawing/2014/main" id="{6E4406FF-4C4A-4BDF-B1AF-C4BC711C7575}"/>
+                <a16:creationId xmlns:a16="http://schemas.microsoft.com/office/drawing/2014/main" id="{1C179D43-8560-4564-9F93-DDF588CEC54C}"/>
               </a:ext>
             </a:extLst>
           </p:cNvPr>
@@ -14709,7 +14709,7 @@
           <p:cNvPr id="55" name="triggers revalidation.">
             <a:extLst xmlns:a="http://schemas.openxmlformats.org/drawingml/2006/main">
               <a:ext uri="{FF2B5EF4-FFF2-40B4-BE49-F238E27FC236}">
-                <a16:creationId xmlns:a16="http://schemas.microsoft.com/office/drawing/2014/main" id="{20A1341D-887F-4A44-8CD2-9F79832594D8}"/>
+                <a16:creationId xmlns:a16="http://schemas.microsoft.com/office/drawing/2014/main" id="{8637980F-F20E-4053-9F60-55B8E6487029}"/>
               </a:ext>
             </a:extLst>
           </p:cNvPr>
@@ -14766,7 +14766,7 @@
           <p:cNvPr id="56" name="current">
             <a:extLst xmlns:a="http://schemas.openxmlformats.org/drawingml/2006/main">
               <a:ext uri="{FF2B5EF4-FFF2-40B4-BE49-F238E27FC236}">
-                <a16:creationId xmlns:a16="http://schemas.microsoft.com/office/drawing/2014/main" id="{B0C137ED-A810-4093-9549-7304E978FB12}"/>
+                <a16:creationId xmlns:a16="http://schemas.microsoft.com/office/drawing/2014/main" id="{B8766E72-5A54-4E95-AB95-25DCDC28CAFB}"/>
               </a:ext>
             </a:extLst>
           </p:cNvPr>
@@ -14823,7 +14823,7 @@
           <p:cNvPr id="57" name="context c">
             <a:extLst xmlns:a="http://schemas.openxmlformats.org/drawingml/2006/main">
               <a:ext uri="{FF2B5EF4-FFF2-40B4-BE49-F238E27FC236}">
-                <a16:creationId xmlns:a16="http://schemas.microsoft.com/office/drawing/2014/main" id="{830E0D75-AB4A-43CA-993A-6A26E49F3982}"/>
+                <a16:creationId xmlns:a16="http://schemas.microsoft.com/office/drawing/2014/main" id="{51E3077C-0EAA-44B7-A01F-1CA17AA89B3A}"/>
               </a:ext>
             </a:extLst>
           </p:cNvPr>
@@ -14880,7 +14880,7 @@
           <p:cNvPr id="58" name="Editable flow path">
             <a:extLst xmlns:a="http://schemas.openxmlformats.org/drawingml/2006/main">
               <a:ext uri="{FF2B5EF4-FFF2-40B4-BE49-F238E27FC236}">
-                <a16:creationId xmlns:a16="http://schemas.microsoft.com/office/drawing/2014/main" id="{C09361EF-97C8-4B0A-B360-94534B612392}"/>
+                <a16:creationId xmlns:a16="http://schemas.microsoft.com/office/drawing/2014/main" id="{9FA0C2F5-77E4-4846-BEA6-5C7A0B332302}"/>
               </a:ext>
             </a:extLst>
           </p:cNvPr>
@@ -14920,7 +14920,7 @@
           <p:cNvPr id="59" name="Editable arrowhead">
             <a:extLst xmlns:a="http://schemas.openxmlformats.org/drawingml/2006/main">
               <a:ext uri="{FF2B5EF4-FFF2-40B4-BE49-F238E27FC236}">
-                <a16:creationId xmlns:a16="http://schemas.microsoft.com/office/drawing/2014/main" id="{CD034A46-46E7-438F-AE4B-03355145F7F2}"/>
+                <a16:creationId xmlns:a16="http://schemas.microsoft.com/office/drawing/2014/main" id="{7DC1332A-7A89-42D6-8697-8A0450104D21}"/>
               </a:ext>
             </a:extLst>
           </p:cNvPr>
@@ -14963,7 +14963,7 @@
           <p:cNvPr id="60" name="Editable boundary">
             <a:extLst xmlns:a="http://schemas.openxmlformats.org/drawingml/2006/main">
               <a:ext uri="{FF2B5EF4-FFF2-40B4-BE49-F238E27FC236}">
-                <a16:creationId xmlns:a16="http://schemas.microsoft.com/office/drawing/2014/main" id="{DE5ECD0A-8C7F-4B53-B2FF-74DC290A487C}"/>
+                <a16:creationId xmlns:a16="http://schemas.microsoft.com/office/drawing/2014/main" id="{D2CBD10D-F08D-41FA-876C-44CB64B3BBA9}"/>
               </a:ext>
             </a:extLst>
           </p:cNvPr>
@@ -14996,7 +14996,7 @@
           <p:cNvPr id="61" name="Workflow authorization rule">
             <a:extLst xmlns:a="http://schemas.openxmlformats.org/drawingml/2006/main">
               <a:ext uri="{FF2B5EF4-FFF2-40B4-BE49-F238E27FC236}">
-                <a16:creationId xmlns:a16="http://schemas.microsoft.com/office/drawing/2014/main" id="{48F97CB7-996A-4410-8449-E4F9A26C32CD}"/>
+                <a16:creationId xmlns:a16="http://schemas.microsoft.com/office/drawing/2014/main" id="{D5096615-51C7-4DB4-A0A5-C8D998F72476}"/>
               </a:ext>
             </a:extLst>
           </p:cNvPr>
@@ -15053,7 +15053,7 @@
           <p:cNvPr id="62" name="Allow(a, c) :=">
             <a:extLst xmlns:a="http://schemas.openxmlformats.org/drawingml/2006/main">
               <a:ext uri="{FF2B5EF4-FFF2-40B4-BE49-F238E27FC236}">
-                <a16:creationId xmlns:a16="http://schemas.microsoft.com/office/drawing/2014/main" id="{E42C10FC-0277-4496-BAC3-B28F5F872F83}"/>
+                <a16:creationId xmlns:a16="http://schemas.microsoft.com/office/drawing/2014/main" id="{6DC4EE89-FB08-485C-BC3D-51C3F1C4741F}"/>
               </a:ext>
             </a:extLst>
           </p:cNvPr>
@@ -15110,7 +15110,7 @@
           <p:cNvPr id="63" name="ScopeOK ∧ FlowOK ∧ FreshOK">
             <a:extLst xmlns:a="http://schemas.openxmlformats.org/drawingml/2006/main">
               <a:ext uri="{FF2B5EF4-FFF2-40B4-BE49-F238E27FC236}">
-                <a16:creationId xmlns:a16="http://schemas.microsoft.com/office/drawing/2014/main" id="{26EEB8F3-09A8-4482-8EEB-47D8206C0B45}"/>
+                <a16:creationId xmlns:a16="http://schemas.microsoft.com/office/drawing/2014/main" id="{36DFD45B-E3F0-4C85-832E-F131194673DB}"/>
               </a:ext>
             </a:extLst>
           </p:cNvPr>
@@ -15167,7 +15167,7 @@
           <p:cNvPr id="64" name="a: next delegated action">
             <a:extLst xmlns:a="http://schemas.openxmlformats.org/drawingml/2006/main">
               <a:ext uri="{FF2B5EF4-FFF2-40B4-BE49-F238E27FC236}">
-                <a16:creationId xmlns:a16="http://schemas.microsoft.com/office/drawing/2014/main" id="{2722C27B-94A6-4804-BAFC-988470DCE8F7}"/>
+                <a16:creationId xmlns:a16="http://schemas.microsoft.com/office/drawing/2014/main" id="{E87F8AB7-3535-4FC8-8BE9-CC237635494D}"/>
               </a:ext>
             </a:extLst>
           </p:cNvPr>
@@ -15224,7 +15224,7 @@
           <p:cNvPr id="65" name="c: current workflow context">
             <a:extLst xmlns:a="http://schemas.openxmlformats.org/drawingml/2006/main">
               <a:ext uri="{FF2B5EF4-FFF2-40B4-BE49-F238E27FC236}">
-                <a16:creationId xmlns:a16="http://schemas.microsoft.com/office/drawing/2014/main" id="{9B0B9AAB-DD3B-4E50-96DB-00D22B1FD1DE}"/>
+                <a16:creationId xmlns:a16="http://schemas.microsoft.com/office/drawing/2014/main" id="{BE542BE7-7101-4CBE-B5FF-4B25740B5A2E}"/>
               </a:ext>
             </a:extLst>
           </p:cNvPr>
@@ -15281,7 +15281,7 @@
           <p:cNvPr id="66" name="Editable flow path">
             <a:extLst xmlns:a="http://schemas.openxmlformats.org/drawingml/2006/main">
               <a:ext uri="{FF2B5EF4-FFF2-40B4-BE49-F238E27FC236}">
-                <a16:creationId xmlns:a16="http://schemas.microsoft.com/office/drawing/2014/main" id="{69C724D2-4A8A-4DFC-8920-84F7EABD1660}"/>
+                <a16:creationId xmlns:a16="http://schemas.microsoft.com/office/drawing/2014/main" id="{6932D516-2136-44BC-BC86-CB5D6E1060C4}"/>
               </a:ext>
             </a:extLst>
           </p:cNvPr>
@@ -15321,7 +15321,7 @@
           <p:cNvPr id="67" name="Editable flow path">
             <a:extLst xmlns:a="http://schemas.openxmlformats.org/drawingml/2006/main">
               <a:ext uri="{FF2B5EF4-FFF2-40B4-BE49-F238E27FC236}">
-                <a16:creationId xmlns:a16="http://schemas.microsoft.com/office/drawing/2014/main" id="{3590FB98-DBB4-448A-87F3-21E014D5CF66}"/>
+                <a16:creationId xmlns:a16="http://schemas.microsoft.com/office/drawing/2014/main" id="{45C5AE37-B0BC-4CF7-A31B-D5A67ECBF412}"/>
               </a:ext>
             </a:extLst>
           </p:cNvPr>
@@ -15364,7 +15364,7 @@
           <p:cNvPr id="68" name="Editable arrowhead">
             <a:extLst xmlns:a="http://schemas.openxmlformats.org/drawingml/2006/main">
               <a:ext uri="{FF2B5EF4-FFF2-40B4-BE49-F238E27FC236}">
-                <a16:creationId xmlns:a16="http://schemas.microsoft.com/office/drawing/2014/main" id="{F055FF8E-6AEC-4883-B3C5-A1B8427B59B8}"/>
+                <a16:creationId xmlns:a16="http://schemas.microsoft.com/office/drawing/2014/main" id="{3CE72E18-1680-47C4-90F0-D64B634F78A3}"/>
               </a:ext>
             </a:extLst>
           </p:cNvPr>
@@ -15407,7 +15407,7 @@
           <p:cNvPr id="69" name="Editable flow path">
             <a:extLst xmlns:a="http://schemas.openxmlformats.org/drawingml/2006/main">
               <a:ext uri="{FF2B5EF4-FFF2-40B4-BE49-F238E27FC236}">
-                <a16:creationId xmlns:a16="http://schemas.microsoft.com/office/drawing/2014/main" id="{E325B8FC-9B98-4ABC-B586-392C446058F5}"/>
+                <a16:creationId xmlns:a16="http://schemas.microsoft.com/office/drawing/2014/main" id="{43A210D6-2DCF-405E-A1A0-F2C784C6D346}"/>
               </a:ext>
             </a:extLst>
           </p:cNvPr>
@@ -15450,7 +15450,7 @@
           <p:cNvPr id="70" name="Editable arrowhead">
             <a:extLst xmlns:a="http://schemas.openxmlformats.org/drawingml/2006/main">
               <a:ext uri="{FF2B5EF4-FFF2-40B4-BE49-F238E27FC236}">
-                <a16:creationId xmlns:a16="http://schemas.microsoft.com/office/drawing/2014/main" id="{1E213D40-AA00-4198-B460-CBB1C9B2B012}"/>
+                <a16:creationId xmlns:a16="http://schemas.microsoft.com/office/drawing/2014/main" id="{DE46DC41-5B39-4410-9BEF-6AFEF943D5A4}"/>
               </a:ext>
             </a:extLst>
           </p:cNvPr>
@@ -15493,7 +15493,7 @@
           <p:cNvPr id="71" name="all pass">
             <a:extLst xmlns:a="http://schemas.openxmlformats.org/drawingml/2006/main">
               <a:ext uri="{FF2B5EF4-FFF2-40B4-BE49-F238E27FC236}">
-                <a16:creationId xmlns:a16="http://schemas.microsoft.com/office/drawing/2014/main" id="{88401182-D586-4054-A682-A5EE75634819}"/>
+                <a16:creationId xmlns:a16="http://schemas.microsoft.com/office/drawing/2014/main" id="{A49C5350-7778-45BA-98F7-464D4854A30A}"/>
               </a:ext>
             </a:extLst>
           </p:cNvPr>
@@ -15550,7 +15550,7 @@
           <p:cNvPr id="72" name="false / unknown">
             <a:extLst xmlns:a="http://schemas.openxmlformats.org/drawingml/2006/main">
               <a:ext uri="{FF2B5EF4-FFF2-40B4-BE49-F238E27FC236}">
-                <a16:creationId xmlns:a16="http://schemas.microsoft.com/office/drawing/2014/main" id="{5C547C09-50B1-4FB2-B003-AFD95C12A8A4}"/>
+                <a16:creationId xmlns:a16="http://schemas.microsoft.com/office/drawing/2014/main" id="{7DA7971E-1376-439C-935D-7D213AEE4A4D}"/>
               </a:ext>
             </a:extLst>
           </p:cNvPr>
@@ -15607,7 +15607,7 @@
           <p:cNvPr id="73" name="Editable boundary">
             <a:extLst xmlns:a="http://schemas.openxmlformats.org/drawingml/2006/main">
               <a:ext uri="{FF2B5EF4-FFF2-40B4-BE49-F238E27FC236}">
-                <a16:creationId xmlns:a16="http://schemas.microsoft.com/office/drawing/2014/main" id="{1FEB19D9-DF29-470D-9E25-AB4707FD6E4B}"/>
+                <a16:creationId xmlns:a16="http://schemas.microsoft.com/office/drawing/2014/main" id="{D7EDDBA0-1B09-4672-A856-86CCD08B5E61}"/>
               </a:ext>
             </a:extLst>
           </p:cNvPr>
@@ -15640,7 +15640,7 @@
           <p:cNvPr id="74" name="Editable boundary">
             <a:extLst xmlns:a="http://schemas.openxmlformats.org/drawingml/2006/main">
               <a:ext uri="{FF2B5EF4-FFF2-40B4-BE49-F238E27FC236}">
-                <a16:creationId xmlns:a16="http://schemas.microsoft.com/office/drawing/2014/main" id="{687244A6-2EEE-4859-8FA0-DB7BD734BE57}"/>
+                <a16:creationId xmlns:a16="http://schemas.microsoft.com/office/drawing/2014/main" id="{345F3CF3-A942-4AC1-B398-43D1C690000C}"/>
               </a:ext>
             </a:extLst>
           </p:cNvPr>
@@ -15673,7 +15673,7 @@
           <p:cNvPr id="75" name="Execute">
             <a:extLst xmlns:a="http://schemas.openxmlformats.org/drawingml/2006/main">
               <a:ext uri="{FF2B5EF4-FFF2-40B4-BE49-F238E27FC236}">
-                <a16:creationId xmlns:a16="http://schemas.microsoft.com/office/drawing/2014/main" id="{117CBBCF-0961-43EF-9DFC-78FBF7CFB540}"/>
+                <a16:creationId xmlns:a16="http://schemas.microsoft.com/office/drawing/2014/main" id="{0233C998-D4B5-47AD-A15C-4FB1CE7FB43F}"/>
               </a:ext>
             </a:extLst>
           </p:cNvPr>
@@ -15730,7 +15730,7 @@
           <p:cNvPr id="76" name="Suspend / replan">
             <a:extLst xmlns:a="http://schemas.openxmlformats.org/drawingml/2006/main">
               <a:ext uri="{FF2B5EF4-FFF2-40B4-BE49-F238E27FC236}">
-                <a16:creationId xmlns:a16="http://schemas.microsoft.com/office/drawing/2014/main" id="{239BCCC4-2963-44A3-82BE-A5A5EA7D6C83}"/>
+                <a16:creationId xmlns:a16="http://schemas.microsoft.com/office/drawing/2014/main" id="{3528DC1C-F1B6-4284-A3B3-AD1057C068E3}"/>
               </a:ext>
             </a:extLst>
           </p:cNvPr>
@@ -15787,7 +15787,7 @@
           <p:cNvPr id="77" name="Revalidate affected work; preserve valid progress.">
             <a:extLst xmlns:a="http://schemas.openxmlformats.org/drawingml/2006/main">
               <a:ext uri="{FF2B5EF4-FFF2-40B4-BE49-F238E27FC236}">
-                <a16:creationId xmlns:a16="http://schemas.microsoft.com/office/drawing/2014/main" id="{CF32905C-5CF7-4550-8BEE-8009AF3EF3A8}"/>
+                <a16:creationId xmlns:a16="http://schemas.microsoft.com/office/drawing/2014/main" id="{E4D5742C-0022-4FBC-B127-9E925CCD09A2}"/>
               </a:ext>
             </a:extLst>
           </p:cNvPr>
@@ -15844,7 +15844,7 @@
           <p:cNvPr id="78" name="Guarantees depend on captured effects and trusted enforcement.">
             <a:extLst xmlns:a="http://schemas.openxmlformats.org/drawingml/2006/main">
               <a:ext uri="{FF2B5EF4-FFF2-40B4-BE49-F238E27FC236}">
-                <a16:creationId xmlns:a16="http://schemas.microsoft.com/office/drawing/2014/main" id="{FC0E3EFD-88E5-4641-8EC6-532B162E6290}"/>
+                <a16:creationId xmlns:a16="http://schemas.microsoft.com/office/drawing/2014/main" id="{360FF40E-29A1-4386-9843-9F8E00CDF344}"/>
               </a:ext>
             </a:extLst>
           </p:cNvPr>
@@ -15899,7 +15899,7 @@
     </p:spTree>
     <p:extLst>
       <p:ext uri="{BB962C8B-B14F-4D97-AF65-F5344CB8AC3E}">
-        <p14:creationId xmlns:p14="http://schemas.microsoft.com/office/powerpoint/2010/main" val="1277759237"/>
+        <p14:creationId xmlns:p14="http://schemas.microsoft.com/office/powerpoint/2010/main" val="1267069358"/>
       </p:ext>
     </p:extLst>
   </p:cSld>

</xml_diff>